<commit_message>
Assemble final classroom series with supported openings and cold retests
</commit_message>
<xml_diff>
--- a/Boek 2 - Kosten, opbrengsten, elasticiteit en surplus/edities/chat-2026/bronnen/H1/paragrafen/2.1.3 Marginale kosten en marginale opbrengsten/2.1.3 Marginale kosten en marginale opbrengsten – presentatie.pptx
+++ b/Boek 2 - Kosten, opbrengsten, elasticiteit en surplus/edities/chat-2026/bronnen/H1/paragrafen/2.1.3 Marginale kosten en marginale opbrengsten/2.1.3 Marginale kosten en marginale opbrengsten – presentatie.pptx
@@ -2,39 +2,39 @@
 <file path=ppt/presentation.xml><?xml version="1.0" encoding="utf-8"?>
 <p:presentation xmlns:p="http://schemas.openxmlformats.org/presentationml/2006/main">
   <p:sldMasterIdLst>
-    <p:sldMasterId xmlns:r="http://schemas.openxmlformats.org/officeDocument/2006/relationships" id="2147483648" r:id="R142ae510e8d040e7"/>
+    <p:sldMasterId xmlns:r="http://schemas.openxmlformats.org/officeDocument/2006/relationships" id="2147483648" r:id="R4c9100fbbe26475a"/>
   </p:sldMasterIdLst>
   <p:notesMasterIdLst>
-    <p:notesMasterId xmlns:r="http://schemas.openxmlformats.org/officeDocument/2006/relationships" r:id="Rbb5fc7533a2b49c4"/>
+    <p:notesMasterId xmlns:r="http://schemas.openxmlformats.org/officeDocument/2006/relationships" r:id="R0e4637d30c844d42"/>
   </p:notesMasterIdLst>
   <p:sldIdLst>
-    <p:sldId xmlns:r="http://schemas.openxmlformats.org/officeDocument/2006/relationships" id="256" r:id="Rb9915d821cc24feb"/>
-    <p:sldId xmlns:r="http://schemas.openxmlformats.org/officeDocument/2006/relationships" id="257" r:id="Recaac865a7784949"/>
-    <p:sldId xmlns:r="http://schemas.openxmlformats.org/officeDocument/2006/relationships" id="258" r:id="R138bc7d10293439b"/>
-    <p:sldId xmlns:r="http://schemas.openxmlformats.org/officeDocument/2006/relationships" id="259" r:id="Rbc4d5669f41847a1"/>
-    <p:sldId xmlns:r="http://schemas.openxmlformats.org/officeDocument/2006/relationships" id="260" r:id="Raead62ab6f4e449f"/>
-    <p:sldId xmlns:r="http://schemas.openxmlformats.org/officeDocument/2006/relationships" id="261" r:id="R15b54e1d7d4d4215"/>
-    <p:sldId xmlns:r="http://schemas.openxmlformats.org/officeDocument/2006/relationships" id="262" r:id="Rdd4c6b05a5c54cdd"/>
-    <p:sldId xmlns:r="http://schemas.openxmlformats.org/officeDocument/2006/relationships" id="263" r:id="R0a5e2e0bfe4b4035"/>
-    <p:sldId xmlns:r="http://schemas.openxmlformats.org/officeDocument/2006/relationships" id="264" r:id="Rd2cebb5f269e4dfc"/>
-    <p:sldId xmlns:r="http://schemas.openxmlformats.org/officeDocument/2006/relationships" id="265" r:id="Ra2b3d5e360564989"/>
-    <p:sldId xmlns:r="http://schemas.openxmlformats.org/officeDocument/2006/relationships" id="266" r:id="R341edb3fb3b44c9c"/>
-    <p:sldId xmlns:r="http://schemas.openxmlformats.org/officeDocument/2006/relationships" id="267" r:id="R52b0f50e03b34a3b"/>
-    <p:sldId xmlns:r="http://schemas.openxmlformats.org/officeDocument/2006/relationships" id="268" r:id="R847301296b4d42aa"/>
-    <p:sldId xmlns:r="http://schemas.openxmlformats.org/officeDocument/2006/relationships" id="269" r:id="Rb5f385abcff64b8f"/>
-    <p:sldId xmlns:r="http://schemas.openxmlformats.org/officeDocument/2006/relationships" id="270" r:id="Rc19665748c1d476c"/>
-    <p:sldId xmlns:r="http://schemas.openxmlformats.org/officeDocument/2006/relationships" id="271" r:id="Rf5618fd3b54f4c2c"/>
-    <p:sldId xmlns:r="http://schemas.openxmlformats.org/officeDocument/2006/relationships" id="272" r:id="Raf3fe1f58a59478f"/>
-    <p:sldId xmlns:r="http://schemas.openxmlformats.org/officeDocument/2006/relationships" id="273" r:id="R0c987ebec1204bc6"/>
-    <p:sldId xmlns:r="http://schemas.openxmlformats.org/officeDocument/2006/relationships" id="274" r:id="R0d6d25388da44444"/>
-    <p:sldId xmlns:r="http://schemas.openxmlformats.org/officeDocument/2006/relationships" id="275" r:id="R684a8cc5fa4443ff"/>
-    <p:sldId xmlns:r="http://schemas.openxmlformats.org/officeDocument/2006/relationships" id="276" r:id="Rc262c2ef2b454c4d"/>
-    <p:sldId xmlns:r="http://schemas.openxmlformats.org/officeDocument/2006/relationships" id="277" r:id="Rf84345ce0b9546c5"/>
-    <p:sldId xmlns:r="http://schemas.openxmlformats.org/officeDocument/2006/relationships" id="278" r:id="R07e7d05c4f194fe5"/>
-    <p:sldId xmlns:r="http://schemas.openxmlformats.org/officeDocument/2006/relationships" id="279" r:id="Re777c992b12c4522"/>
-    <p:sldId xmlns:r="http://schemas.openxmlformats.org/officeDocument/2006/relationships" id="280" r:id="Rfcd0a2a80d0047f7"/>
-    <p:sldId xmlns:r="http://schemas.openxmlformats.org/officeDocument/2006/relationships" id="281" r:id="R8c9f4d2df5c345a1"/>
-    <p:sldId xmlns:r="http://schemas.openxmlformats.org/officeDocument/2006/relationships" id="282" r:id="R75e92c77f0814a44"/>
+    <p:sldId xmlns:r="http://schemas.openxmlformats.org/officeDocument/2006/relationships" id="256" r:id="R5a9b97f34473420b"/>
+    <p:sldId xmlns:r="http://schemas.openxmlformats.org/officeDocument/2006/relationships" id="257" r:id="R3bea31d5cbcb428d"/>
+    <p:sldId xmlns:r="http://schemas.openxmlformats.org/officeDocument/2006/relationships" id="258" r:id="R2e85d66ccc974caf"/>
+    <p:sldId xmlns:r="http://schemas.openxmlformats.org/officeDocument/2006/relationships" id="259" r:id="Rf5e9fd49d2574c62"/>
+    <p:sldId xmlns:r="http://schemas.openxmlformats.org/officeDocument/2006/relationships" id="260" r:id="R69ce43944e34486b"/>
+    <p:sldId xmlns:r="http://schemas.openxmlformats.org/officeDocument/2006/relationships" id="261" r:id="R7092b499e2db456a"/>
+    <p:sldId xmlns:r="http://schemas.openxmlformats.org/officeDocument/2006/relationships" id="262" r:id="Rc24a89b1edcf467f"/>
+    <p:sldId xmlns:r="http://schemas.openxmlformats.org/officeDocument/2006/relationships" id="263" r:id="R1d626f25b0194445"/>
+    <p:sldId xmlns:r="http://schemas.openxmlformats.org/officeDocument/2006/relationships" id="264" r:id="Rbf94237e59af4bb3"/>
+    <p:sldId xmlns:r="http://schemas.openxmlformats.org/officeDocument/2006/relationships" id="265" r:id="R4a89bcded6cc49af"/>
+    <p:sldId xmlns:r="http://schemas.openxmlformats.org/officeDocument/2006/relationships" id="266" r:id="R50432cc25b764998"/>
+    <p:sldId xmlns:r="http://schemas.openxmlformats.org/officeDocument/2006/relationships" id="267" r:id="R7dfb7bdaad2c48c5"/>
+    <p:sldId xmlns:r="http://schemas.openxmlformats.org/officeDocument/2006/relationships" id="268" r:id="R570a031be4044791"/>
+    <p:sldId xmlns:r="http://schemas.openxmlformats.org/officeDocument/2006/relationships" id="269" r:id="Rbce39af9170a4a44"/>
+    <p:sldId xmlns:r="http://schemas.openxmlformats.org/officeDocument/2006/relationships" id="270" r:id="Rc014ee4ddb5b4b96"/>
+    <p:sldId xmlns:r="http://schemas.openxmlformats.org/officeDocument/2006/relationships" id="271" r:id="R3622cc0fe1e74326"/>
+    <p:sldId xmlns:r="http://schemas.openxmlformats.org/officeDocument/2006/relationships" id="272" r:id="R4d6354743e2f4532"/>
+    <p:sldId xmlns:r="http://schemas.openxmlformats.org/officeDocument/2006/relationships" id="273" r:id="R360de586175e4204"/>
+    <p:sldId xmlns:r="http://schemas.openxmlformats.org/officeDocument/2006/relationships" id="274" r:id="Rc521c236bb1c4cfa"/>
+    <p:sldId xmlns:r="http://schemas.openxmlformats.org/officeDocument/2006/relationships" id="275" r:id="R2e569dca162547d3"/>
+    <p:sldId xmlns:r="http://schemas.openxmlformats.org/officeDocument/2006/relationships" id="276" r:id="R60fd2ab4f84e463c"/>
+    <p:sldId xmlns:r="http://schemas.openxmlformats.org/officeDocument/2006/relationships" id="277" r:id="R3d83d44a862c40e2"/>
+    <p:sldId xmlns:r="http://schemas.openxmlformats.org/officeDocument/2006/relationships" id="278" r:id="Rbbd8f9d502ab497b"/>
+    <p:sldId xmlns:r="http://schemas.openxmlformats.org/officeDocument/2006/relationships" id="279" r:id="Refb15ac3eef740e8"/>
+    <p:sldId xmlns:r="http://schemas.openxmlformats.org/officeDocument/2006/relationships" id="280" r:id="Rd6787d9a6e6843d2"/>
+    <p:sldId xmlns:r="http://schemas.openxmlformats.org/officeDocument/2006/relationships" id="281" r:id="R3df69bc2799c4838"/>
+    <p:sldId xmlns:r="http://schemas.openxmlformats.org/officeDocument/2006/relationships" id="282" r:id="Rc9f2a129bc234e68"/>
   </p:sldIdLst>
   <p:sldSz cx="15240000" cy="8572500"/>
   <p:notesSz cx="6858000" cy="9144000"/>
@@ -493,7 +493,7 @@
           <a:p xmlns:a="http://schemas.openxmlformats.org/drawingml/2006/main">
             <a:r>
               <a:rPr sz="1400"/>
-              <a:t>Start en terugblik: Opgave 1 gebruikt TK en GTK uit §2.1.1, dia 4 en 7–9, en winst uit §2.1.2, dia 4. MK en delen door de verandering in Q zijn nieuw. Lees bij opgave 2 de definitie en tabelstappen op p. 19–20. Laat leerlingen bij deze verkenning aanwijzen welke uitleg zij gebruiken en hun twijfel noteren. Verwacht de nieuwe bewerking nog niet zonder steun. Bij terugkeer naar dit overzicht vóór het basiswerk: laat leerlingen opgave 2 opnieuw proberen na de uitleg, bespreek hun redenering en geef zo nodig extra steun. Dit is een verkennende start, geen toets van al beheerste nieuwe leerstof.</a:t>
+              <a:t>Start en terugblik: Opgave 1 gebruikt TK uit §2.1.1, dia 4, en TO en winst uit §2.1.2, dia 3–4. MK en delen door de verandering in Q zijn nieuw. Lees bij opgave 2 de definitie en tabelstappen op p. 19–20. Laat leerlingen bij deze verkenning aanwijzen welke uitleg zij gebruiken en hun twijfel noteren. Verwacht de nieuwe bewerking nog niet zonder steun. Bij terugkeer naar dit overzicht vóór het basiswerk: laat leerlingen opgave 2 opnieuw proberen na de uitleg, bespreek hun redenering en geef zo nodig extra steun. Dit is een verkennende start, geen toets van al beheerste nieuwe leerstof.</a:t>
             </a:r>
           </a:p>
           <a:p xmlns:a="http://schemas.openxmlformats.org/drawingml/2006/main">
@@ -1160,7 +1160,7 @@
           <a:p xmlns:a="http://schemas.openxmlformats.org/drawingml/2006/main">
             <a:r>
               <a:rPr sz="1400"/>
-              <a:t>Start en terugblik: Opgave 1 gebruikt TK en GTK uit §2.1.1, dia 4 en 7–9, en winst uit §2.1.2, dia 4. MK en delen door de verandering in Q zijn nieuw. Lees bij opgave 2 de definitie en tabelstappen op p. 19–20. Laat leerlingen bij deze verkenning aanwijzen welke uitleg zij gebruiken en hun twijfel noteren. Verwacht de nieuwe bewerking nog niet zonder steun. Bij terugkeer naar dit overzicht vóór het basiswerk: laat leerlingen opgave 2 opnieuw proberen na de uitleg, bespreek hun redenering en geef zo nodig extra steun. Dit is een verkennende start, geen toets van al beheerste nieuwe leerstof.</a:t>
+              <a:t>Start en terugblik: Opgave 1 gebruikt TK uit §2.1.1, dia 4, en TO en winst uit §2.1.2, dia 3–4. MK en delen door de verandering in Q zijn nieuw. Lees bij opgave 2 de definitie en tabelstappen op p. 19–20. Laat leerlingen bij deze verkenning aanwijzen welke uitleg zij gebruiken en hun twijfel noteren. Verwacht de nieuwe bewerking nog niet zonder steun. Bij terugkeer naar dit overzicht vóór het basiswerk: laat leerlingen opgave 2 opnieuw proberen na de uitleg, bespreek hun redenering en geef zo nodig extra steun. Dit is een verkennende start, geen toets van al beheerste nieuwe leerstof.</a:t>
             </a:r>
           </a:p>
           <a:p xmlns:a="http://schemas.openxmlformats.org/drawingml/2006/main">
@@ -3006,7 +3006,7 @@
           <a:p xmlns:a="http://schemas.openxmlformats.org/drawingml/2006/main">
             <a:r>
               <a:rPr sz="1400"/>
-              <a:t>Start en terugblik: Opgave 1 gebruikt TK en GTK uit §2.1.1, dia 4 en 7–9, en winst uit §2.1.2, dia 4. MK en delen door de verandering in Q zijn nieuw. Lees bij opgave 2 de definitie en tabelstappen op p. 19–20. Laat leerlingen bij deze verkenning aanwijzen welke uitleg zij gebruiken en hun twijfel noteren. Verwacht de nieuwe bewerking nog niet zonder steun. Bij terugkeer naar dit overzicht vóór het basiswerk: laat leerlingen opgave 2 opnieuw proberen na de uitleg, bespreek hun redenering en geef zo nodig extra steun. Dit is een verkennende start, geen toets van al beheerste nieuwe leerstof.</a:t>
+              <a:t>Start en terugblik: Opgave 1 gebruikt TK uit §2.1.1, dia 4, en TO en winst uit §2.1.2, dia 3–4. MK en delen door de verandering in Q zijn nieuw. Lees bij opgave 2 de definitie en tabelstappen op p. 19–20. Laat leerlingen bij deze verkenning aanwijzen welke uitleg zij gebruiken en hun twijfel noteren. Verwacht de nieuwe bewerking nog niet zonder steun. Bij terugkeer naar dit overzicht vóór het basiswerk: laat leerlingen opgave 2 opnieuw proberen na de uitleg, bespreek hun redenering en geef zo nodig extra steun. Dit is een verkennende start, geen toets van al beheerste nieuwe leerstof.</a:t>
             </a:r>
           </a:p>
           <a:p xmlns:a="http://schemas.openxmlformats.org/drawingml/2006/main">
@@ -4039,7 +4039,7 @@
   </p:cSld>
   <p:clrMap bg1="lt1" tx1="dk1" bg2="lt2" tx2="dk2" accent1="accent1" accent2="accent2" accent3="accent3" accent4="accent4" accent5="accent5" accent6="accent6" hlink="hlink" folHlink="folHlink"/>
   <p:sldLayoutIdLst>
-    <p:sldLayoutId xmlns:r="http://schemas.openxmlformats.org/officeDocument/2006/relationships" id="2147483649" r:id="R78750bc1a1054d13"/>
+    <p:sldLayoutId xmlns:r="http://schemas.openxmlformats.org/officeDocument/2006/relationships" id="2147483649" r:id="Rd4de3ba369e94b61"/>
   </p:sldLayoutIdLst>
   <p:txStyles>
     <p:titleStyle>
@@ -4590,7 +4590,7 @@
           <p:cNvPr id="29" name="Deze les: §2.1.3 Marginale kosten en marginale opbrengsten">
             <a:extLst xmlns:a="http://schemas.openxmlformats.org/drawingml/2006/main">
               <a:ext uri="{FF2B5EF4-FFF2-40B4-BE49-F238E27FC236}">
-                <a16:creationId xmlns:a16="http://schemas.microsoft.com/office/drawing/2014/main" id="{1BF5E978-8D94-4A03-9F21-FF5570E992B1}"/>
+                <a16:creationId xmlns:a16="http://schemas.microsoft.com/office/drawing/2014/main" id="{2DDE432B-8C2D-47FD-879D-13126F1A5AA4}"/>
               </a:ext>
             </a:extLst>
           </p:cNvPr>
@@ -4647,7 +4647,7 @@
           <p:cNvPr id="2" name="">
             <a:extLst xmlns:a="http://schemas.openxmlformats.org/drawingml/2006/main">
               <a:ext uri="{FF2B5EF4-FFF2-40B4-BE49-F238E27FC236}">
-                <a16:creationId xmlns:a16="http://schemas.microsoft.com/office/drawing/2014/main" id="{4C1AC348-4CFD-46DB-BFE8-B972DA559621}"/>
+                <a16:creationId xmlns:a16="http://schemas.microsoft.com/office/drawing/2014/main" id="{219C3019-FF73-4412-A4C4-9F9B00F79F99}"/>
               </a:ext>
             </a:extLst>
           </p:cNvPr>
@@ -4676,7 +4676,7 @@
           <p:cNvPr id="3" name="§2.1.3 Marginale kosten en marginale opbrengsten">
             <a:extLst xmlns:a="http://schemas.openxmlformats.org/drawingml/2006/main">
               <a:ext uri="{FF2B5EF4-FFF2-40B4-BE49-F238E27FC236}">
-                <a16:creationId xmlns:a16="http://schemas.microsoft.com/office/drawing/2014/main" id="{AE4631E7-F46D-44BB-A7D5-07B55BC9BE84}"/>
+                <a16:creationId xmlns:a16="http://schemas.microsoft.com/office/drawing/2014/main" id="{982463E5-BDDA-43F7-9F75-36D5574F5B00}"/>
               </a:ext>
             </a:extLst>
           </p:cNvPr>
@@ -4733,7 +4733,7 @@
           <p:cNvPr id="4" name="slide-number">
             <a:extLst xmlns:a="http://schemas.openxmlformats.org/drawingml/2006/main">
               <a:ext uri="{FF2B5EF4-FFF2-40B4-BE49-F238E27FC236}">
-                <a16:creationId xmlns:a16="http://schemas.microsoft.com/office/drawing/2014/main" id="{20EFC866-38FA-478A-AE89-C8A2AC046247}"/>
+                <a16:creationId xmlns:a16="http://schemas.microsoft.com/office/drawing/2014/main" id="{CBDEC459-19DC-430E-8B7A-E5655D36D2AB}"/>
               </a:ext>
             </a:extLst>
           </p:cNvPr>
@@ -4790,7 +4790,7 @@
           <p:cNvPr id="5" name="phase">
             <a:extLst xmlns:a="http://schemas.openxmlformats.org/drawingml/2006/main">
               <a:ext uri="{FF2B5EF4-FFF2-40B4-BE49-F238E27FC236}">
-                <a16:creationId xmlns:a16="http://schemas.microsoft.com/office/drawing/2014/main" id="{D5DC18A1-00E0-4967-86B2-5B894E6DC3DD}"/>
+                <a16:creationId xmlns:a16="http://schemas.microsoft.com/office/drawing/2014/main" id="{18C2A3AF-8931-420C-9242-CEEBC539AADF}"/>
               </a:ext>
             </a:extLst>
           </p:cNvPr>
@@ -4847,7 +4847,7 @@
           <p:cNvPr id="6" name="Lesroute">
             <a:extLst xmlns:a="http://schemas.openxmlformats.org/drawingml/2006/main">
               <a:ext uri="{FF2B5EF4-FFF2-40B4-BE49-F238E27FC236}">
-                <a16:creationId xmlns:a16="http://schemas.microsoft.com/office/drawing/2014/main" id="{927950D2-7005-4C01-9401-54091FB35E01}"/>
+                <a16:creationId xmlns:a16="http://schemas.microsoft.com/office/drawing/2014/main" id="{44239CC6-5F04-499E-BA22-4FC1C8512DA0}"/>
               </a:ext>
             </a:extLst>
           </p:cNvPr>
@@ -4904,7 +4904,7 @@
           <p:cNvPr id="7" name="route-number-1">
             <a:extLst xmlns:a="http://schemas.openxmlformats.org/drawingml/2006/main">
               <a:ext uri="{FF2B5EF4-FFF2-40B4-BE49-F238E27FC236}">
-                <a16:creationId xmlns:a16="http://schemas.microsoft.com/office/drawing/2014/main" id="{B8EED2CA-7A9F-4703-BB5D-33A3F3002B0E}"/>
+                <a16:creationId xmlns:a16="http://schemas.microsoft.com/office/drawing/2014/main" id="{25E0221B-DDC0-4A08-B34A-90260453DB37}"/>
               </a:ext>
             </a:extLst>
           </p:cNvPr>
@@ -4961,7 +4961,7 @@
           <p:cNvPr id="8" name="route-1">
             <a:extLst xmlns:a="http://schemas.openxmlformats.org/drawingml/2006/main">
               <a:ext uri="{FF2B5EF4-FFF2-40B4-BE49-F238E27FC236}">
-                <a16:creationId xmlns:a16="http://schemas.microsoft.com/office/drawing/2014/main" id="{A9FDC8DB-AE99-4615-8610-C4A0AE7ECBE2}"/>
+                <a16:creationId xmlns:a16="http://schemas.microsoft.com/office/drawing/2014/main" id="{9CC624F1-89A8-4315-8804-C57B830220E3}"/>
               </a:ext>
             </a:extLst>
           </p:cNvPr>
@@ -5018,7 +5018,7 @@
           <p:cNvPr id="9" name="route-number-2">
             <a:extLst xmlns:a="http://schemas.openxmlformats.org/drawingml/2006/main">
               <a:ext uri="{FF2B5EF4-FFF2-40B4-BE49-F238E27FC236}">
-                <a16:creationId xmlns:a16="http://schemas.microsoft.com/office/drawing/2014/main" id="{E914B5ED-5520-4AF4-A51D-04FC86CDCBA1}"/>
+                <a16:creationId xmlns:a16="http://schemas.microsoft.com/office/drawing/2014/main" id="{910C54EA-7E7C-4A72-8A34-79E3935CE8BD}"/>
               </a:ext>
             </a:extLst>
           </p:cNvPr>
@@ -5075,7 +5075,7 @@
           <p:cNvPr id="10" name="route-2">
             <a:extLst xmlns:a="http://schemas.openxmlformats.org/drawingml/2006/main">
               <a:ext uri="{FF2B5EF4-FFF2-40B4-BE49-F238E27FC236}">
-                <a16:creationId xmlns:a16="http://schemas.microsoft.com/office/drawing/2014/main" id="{BC5F0193-1D84-4459-B6C0-B30D9980CFC9}"/>
+                <a16:creationId xmlns:a16="http://schemas.microsoft.com/office/drawing/2014/main" id="{BABB5312-1D53-4B27-B1BD-2F8EA3937F2A}"/>
               </a:ext>
             </a:extLst>
           </p:cNvPr>
@@ -5132,7 +5132,7 @@
           <p:cNvPr id="11" name="route-number-3">
             <a:extLst xmlns:a="http://schemas.openxmlformats.org/drawingml/2006/main">
               <a:ext uri="{FF2B5EF4-FFF2-40B4-BE49-F238E27FC236}">
-                <a16:creationId xmlns:a16="http://schemas.microsoft.com/office/drawing/2014/main" id="{24C075EB-4A33-49B5-B8C4-AF69BB89484A}"/>
+                <a16:creationId xmlns:a16="http://schemas.microsoft.com/office/drawing/2014/main" id="{B645935D-A3C4-4EB2-9214-FCDF77CB9321}"/>
               </a:ext>
             </a:extLst>
           </p:cNvPr>
@@ -5189,7 +5189,7 @@
           <p:cNvPr id="12" name="route-3">
             <a:extLst xmlns:a="http://schemas.openxmlformats.org/drawingml/2006/main">
               <a:ext uri="{FF2B5EF4-FFF2-40B4-BE49-F238E27FC236}">
-                <a16:creationId xmlns:a16="http://schemas.microsoft.com/office/drawing/2014/main" id="{E69EB84A-B70C-4C6E-8CDA-ED5136C70A0D}"/>
+                <a16:creationId xmlns:a16="http://schemas.microsoft.com/office/drawing/2014/main" id="{40530565-5E74-4E8A-AB71-9F8FEDFECBA1}"/>
               </a:ext>
             </a:extLst>
           </p:cNvPr>
@@ -5246,7 +5246,7 @@
           <p:cNvPr id="13" name="route-number-4">
             <a:extLst xmlns:a="http://schemas.openxmlformats.org/drawingml/2006/main">
               <a:ext uri="{FF2B5EF4-FFF2-40B4-BE49-F238E27FC236}">
-                <a16:creationId xmlns:a16="http://schemas.microsoft.com/office/drawing/2014/main" id="{54110C87-8E1B-4131-A5F4-902E4A16FC8E}"/>
+                <a16:creationId xmlns:a16="http://schemas.microsoft.com/office/drawing/2014/main" id="{39C20D84-B341-451C-A3BA-E0186619EBAC}"/>
               </a:ext>
             </a:extLst>
           </p:cNvPr>
@@ -5303,7 +5303,7 @@
           <p:cNvPr id="14" name="route-4">
             <a:extLst xmlns:a="http://schemas.openxmlformats.org/drawingml/2006/main">
               <a:ext uri="{FF2B5EF4-FFF2-40B4-BE49-F238E27FC236}">
-                <a16:creationId xmlns:a16="http://schemas.microsoft.com/office/drawing/2014/main" id="{E943ED67-D920-448D-969D-38023A00903A}"/>
+                <a16:creationId xmlns:a16="http://schemas.microsoft.com/office/drawing/2014/main" id="{17F95989-BAD4-4F19-9C63-84B0415CAE88}"/>
               </a:ext>
             </a:extLst>
           </p:cNvPr>
@@ -5360,7 +5360,7 @@
           <p:cNvPr id="15" name="route-number-5">
             <a:extLst xmlns:a="http://schemas.openxmlformats.org/drawingml/2006/main">
               <a:ext uri="{FF2B5EF4-FFF2-40B4-BE49-F238E27FC236}">
-                <a16:creationId xmlns:a16="http://schemas.microsoft.com/office/drawing/2014/main" id="{A358FA14-08A8-4DE9-84C7-4C871F982500}"/>
+                <a16:creationId xmlns:a16="http://schemas.microsoft.com/office/drawing/2014/main" id="{6E4B62EA-2E49-4B2A-A034-1E69F8F18A2A}"/>
               </a:ext>
             </a:extLst>
           </p:cNvPr>
@@ -5417,7 +5417,7 @@
           <p:cNvPr id="16" name="route-5">
             <a:extLst xmlns:a="http://schemas.openxmlformats.org/drawingml/2006/main">
               <a:ext uri="{FF2B5EF4-FFF2-40B4-BE49-F238E27FC236}">
-                <a16:creationId xmlns:a16="http://schemas.microsoft.com/office/drawing/2014/main" id="{FF94877D-C372-42F1-98E5-3DB0C9BCD246}"/>
+                <a16:creationId xmlns:a16="http://schemas.microsoft.com/office/drawing/2014/main" id="{E21FC1E6-96BE-4F45-B961-D6EBA77209BF}"/>
               </a:ext>
             </a:extLst>
           </p:cNvPr>
@@ -5474,7 +5474,7 @@
           <p:cNvPr id="17" name="route-number-6">
             <a:extLst xmlns:a="http://schemas.openxmlformats.org/drawingml/2006/main">
               <a:ext uri="{FF2B5EF4-FFF2-40B4-BE49-F238E27FC236}">
-                <a16:creationId xmlns:a16="http://schemas.microsoft.com/office/drawing/2014/main" id="{2B13C518-BCCA-437C-93B9-8C5E656974F1}"/>
+                <a16:creationId xmlns:a16="http://schemas.microsoft.com/office/drawing/2014/main" id="{E84D78BC-0CBF-4B20-9A16-EF8017ED4844}"/>
               </a:ext>
             </a:extLst>
           </p:cNvPr>
@@ -5531,7 +5531,7 @@
           <p:cNvPr id="18" name="route-6">
             <a:extLst xmlns:a="http://schemas.openxmlformats.org/drawingml/2006/main">
               <a:ext uri="{FF2B5EF4-FFF2-40B4-BE49-F238E27FC236}">
-                <a16:creationId xmlns:a16="http://schemas.microsoft.com/office/drawing/2014/main" id="{64317ABB-5C42-4AA3-854A-180E20C5E90D}"/>
+                <a16:creationId xmlns:a16="http://schemas.microsoft.com/office/drawing/2014/main" id="{76843162-DC2C-4155-943B-FF9A90731E48}"/>
               </a:ext>
             </a:extLst>
           </p:cNvPr>
@@ -5588,7 +5588,7 @@
           <p:cNvPr id="19" name="route-number-7">
             <a:extLst xmlns:a="http://schemas.openxmlformats.org/drawingml/2006/main">
               <a:ext uri="{FF2B5EF4-FFF2-40B4-BE49-F238E27FC236}">
-                <a16:creationId xmlns:a16="http://schemas.microsoft.com/office/drawing/2014/main" id="{8BC051DA-2CD7-4513-A968-41CF16D8875D}"/>
+                <a16:creationId xmlns:a16="http://schemas.microsoft.com/office/drawing/2014/main" id="{A963A5EB-A0AF-42BE-8538-A93F11CD9604}"/>
               </a:ext>
             </a:extLst>
           </p:cNvPr>
@@ -5645,7 +5645,7 @@
           <p:cNvPr id="20" name="route-7">
             <a:extLst xmlns:a="http://schemas.openxmlformats.org/drawingml/2006/main">
               <a:ext uri="{FF2B5EF4-FFF2-40B4-BE49-F238E27FC236}">
-                <a16:creationId xmlns:a16="http://schemas.microsoft.com/office/drawing/2014/main" id="{931E81C1-A7EA-47AE-8916-637BBFD896BF}"/>
+                <a16:creationId xmlns:a16="http://schemas.microsoft.com/office/drawing/2014/main" id="{8B839F37-4193-475F-8AD9-FDA7651FB53B}"/>
               </a:ext>
             </a:extLst>
           </p:cNvPr>
@@ -5702,7 +5702,7 @@
           <p:cNvPr id="21" name="Lesdoelen">
             <a:extLst xmlns:a="http://schemas.openxmlformats.org/drawingml/2006/main">
               <a:ext uri="{FF2B5EF4-FFF2-40B4-BE49-F238E27FC236}">
-                <a16:creationId xmlns:a16="http://schemas.microsoft.com/office/drawing/2014/main" id="{9CDC6A28-9E1D-4091-BAD7-468B53211E4E}"/>
+                <a16:creationId xmlns:a16="http://schemas.microsoft.com/office/drawing/2014/main" id="{3DA3C7F9-AC93-4615-B843-A68C2A5AC9AE}"/>
               </a:ext>
             </a:extLst>
           </p:cNvPr>
@@ -5759,7 +5759,7 @@
           <p:cNvPr id="22" name="overview-goals">
             <a:extLst xmlns:a="http://schemas.openxmlformats.org/drawingml/2006/main">
               <a:ext uri="{FF2B5EF4-FFF2-40B4-BE49-F238E27FC236}">
-                <a16:creationId xmlns:a16="http://schemas.microsoft.com/office/drawing/2014/main" id="{ED324B69-A94A-4E9D-B8E9-C5BC23534210}"/>
+                <a16:creationId xmlns:a16="http://schemas.microsoft.com/office/drawing/2014/main" id="{117F2E00-B7B5-4FE9-8631-476C517D7A64}"/>
               </a:ext>
             </a:extLst>
           </p:cNvPr>
@@ -5862,7 +5862,7 @@
           <p:cNvPr id="23" name="">
             <a:extLst xmlns:a="http://schemas.openxmlformats.org/drawingml/2006/main">
               <a:ext uri="{FF2B5EF4-FFF2-40B4-BE49-F238E27FC236}">
-                <a16:creationId xmlns:a16="http://schemas.microsoft.com/office/drawing/2014/main" id="{7B9C764B-DE5F-4FDC-9B51-C351726DE083}"/>
+                <a16:creationId xmlns:a16="http://schemas.microsoft.com/office/drawing/2014/main" id="{3B5D72DD-91BE-482A-9F3C-0ED734266202}"/>
               </a:ext>
             </a:extLst>
           </p:cNvPr>
@@ -5891,7 +5891,7 @@
           <p:cNvPr id="24" name="Startopdracht">
             <a:extLst xmlns:a="http://schemas.openxmlformats.org/drawingml/2006/main">
               <a:ext uri="{FF2B5EF4-FFF2-40B4-BE49-F238E27FC236}">
-                <a16:creationId xmlns:a16="http://schemas.microsoft.com/office/drawing/2014/main" id="{D93B558F-8666-4E1C-9468-876BF6DA46E9}"/>
+                <a16:creationId xmlns:a16="http://schemas.microsoft.com/office/drawing/2014/main" id="{58606E1F-E4C1-404F-9702-577BFD62BC5E}"/>
               </a:ext>
             </a:extLst>
           </p:cNvPr>
@@ -5948,7 +5948,7 @@
           <p:cNvPr id="25" name="overview-start">
             <a:extLst xmlns:a="http://schemas.openxmlformats.org/drawingml/2006/main">
               <a:ext uri="{FF2B5EF4-FFF2-40B4-BE49-F238E27FC236}">
-                <a16:creationId xmlns:a16="http://schemas.microsoft.com/office/drawing/2014/main" id="{A2970E5B-C27C-4BA5-B6AB-A045CFE8EFCE}"/>
+                <a16:creationId xmlns:a16="http://schemas.microsoft.com/office/drawing/2014/main" id="{70F8CED9-B847-4869-8CCF-B87823E8ADCB}"/>
               </a:ext>
             </a:extLst>
           </p:cNvPr>
@@ -6028,7 +6028,7 @@
           <p:cNvPr id="26" name="">
             <a:extLst xmlns:a="http://schemas.openxmlformats.org/drawingml/2006/main">
               <a:ext uri="{FF2B5EF4-FFF2-40B4-BE49-F238E27FC236}">
-                <a16:creationId xmlns:a16="http://schemas.microsoft.com/office/drawing/2014/main" id="{5304A2D1-F1EA-4E98-9C42-99E885D964FF}"/>
+                <a16:creationId xmlns:a16="http://schemas.microsoft.com/office/drawing/2014/main" id="{4C7E35C5-3C70-45A6-AD4F-090872151E06}"/>
               </a:ext>
             </a:extLst>
           </p:cNvPr>
@@ -6057,7 +6057,7 @@
           <p:cNvPr id="27" name="Huiswerk">
             <a:extLst xmlns:a="http://schemas.openxmlformats.org/drawingml/2006/main">
               <a:ext uri="{FF2B5EF4-FFF2-40B4-BE49-F238E27FC236}">
-                <a16:creationId xmlns:a16="http://schemas.microsoft.com/office/drawing/2014/main" id="{B4AFFCDF-4F23-4066-BF2E-91AD941866DD}"/>
+                <a16:creationId xmlns:a16="http://schemas.microsoft.com/office/drawing/2014/main" id="{9F66AA7B-F445-4304-A847-616915A67700}"/>
               </a:ext>
             </a:extLst>
           </p:cNvPr>
@@ -6114,7 +6114,7 @@
           <p:cNvPr id="28" name="overview-homework">
             <a:extLst xmlns:a="http://schemas.openxmlformats.org/drawingml/2006/main">
               <a:ext uri="{FF2B5EF4-FFF2-40B4-BE49-F238E27FC236}">
-                <a16:creationId xmlns:a16="http://schemas.microsoft.com/office/drawing/2014/main" id="{C2683149-9618-4B50-9C1C-537A9A2F0DF2}"/>
+                <a16:creationId xmlns:a16="http://schemas.microsoft.com/office/drawing/2014/main" id="{92CD3700-C487-441B-AECC-CC65421E6A29}"/>
               </a:ext>
             </a:extLst>
           </p:cNvPr>
@@ -6261,7 +6261,7 @@
     </p:spTree>
     <p:extLst>
       <p:ext uri="{BB962C8B-B14F-4D97-AF65-F5344CB8AC3E}">
-        <p14:creationId xmlns:p14="http://schemas.microsoft.com/office/powerpoint/2010/main" val="1418349692"/>
+        <p14:creationId xmlns:p14="http://schemas.microsoft.com/office/powerpoint/2010/main" val="1167688785"/>
       </p:ext>
     </p:extLst>
   </p:cSld>
@@ -6292,7 +6292,7 @@
           <p:cNvPr id="9" name="Even grote stappen · Stijgende MK">
             <a:extLst xmlns:a="http://schemas.openxmlformats.org/drawingml/2006/main">
               <a:ext uri="{FF2B5EF4-FFF2-40B4-BE49-F238E27FC236}">
-                <a16:creationId xmlns:a16="http://schemas.microsoft.com/office/drawing/2014/main" id="{4C7A848A-9327-4E11-8A8C-C8FDAA7B03AE}"/>
+                <a16:creationId xmlns:a16="http://schemas.microsoft.com/office/drawing/2014/main" id="{BF85DE45-76DD-41B2-B421-D204CB2C0FD8}"/>
               </a:ext>
             </a:extLst>
           </p:cNvPr>
@@ -6349,7 +6349,7 @@
           <p:cNvPr id="2" name="">
             <a:extLst xmlns:a="http://schemas.openxmlformats.org/drawingml/2006/main">
               <a:ext uri="{FF2B5EF4-FFF2-40B4-BE49-F238E27FC236}">
-                <a16:creationId xmlns:a16="http://schemas.microsoft.com/office/drawing/2014/main" id="{00A78058-B660-44AA-B7AD-4320FBDD5031}"/>
+                <a16:creationId xmlns:a16="http://schemas.microsoft.com/office/drawing/2014/main" id="{FA4ECBC3-52FD-4046-B795-F66656A8E496}"/>
               </a:ext>
             </a:extLst>
           </p:cNvPr>
@@ -6378,7 +6378,7 @@
           <p:cNvPr id="3" name="§2.1.3 Marginale kosten en marginale opbrengsten">
             <a:extLst xmlns:a="http://schemas.openxmlformats.org/drawingml/2006/main">
               <a:ext uri="{FF2B5EF4-FFF2-40B4-BE49-F238E27FC236}">
-                <a16:creationId xmlns:a16="http://schemas.microsoft.com/office/drawing/2014/main" id="{556BDAE8-643D-4B24-8BAD-D00B60E1288E}"/>
+                <a16:creationId xmlns:a16="http://schemas.microsoft.com/office/drawing/2014/main" id="{6BFB883B-CCDF-445E-9903-D7D2A0C8B571}"/>
               </a:ext>
             </a:extLst>
           </p:cNvPr>
@@ -6435,7 +6435,7 @@
           <p:cNvPr id="4" name="slide-number">
             <a:extLst xmlns:a="http://schemas.openxmlformats.org/drawingml/2006/main">
               <a:ext uri="{FF2B5EF4-FFF2-40B4-BE49-F238E27FC236}">
-                <a16:creationId xmlns:a16="http://schemas.microsoft.com/office/drawing/2014/main" id="{08C5CE19-C598-4595-A71D-0523636FA9A1}"/>
+                <a16:creationId xmlns:a16="http://schemas.microsoft.com/office/drawing/2014/main" id="{9D694183-98EF-4B82-9DE7-F5D86B27B859}"/>
               </a:ext>
             </a:extLst>
           </p:cNvPr>
@@ -6492,7 +6492,7 @@
           <p:cNvPr id="5" name="Uitlegvoorbeeld — niet uit het boek · Studio Reliëf">
             <a:extLst xmlns:a="http://schemas.openxmlformats.org/drawingml/2006/main">
               <a:ext uri="{FF2B5EF4-FFF2-40B4-BE49-F238E27FC236}">
-                <a16:creationId xmlns:a16="http://schemas.microsoft.com/office/drawing/2014/main" id="{FED228D9-54D6-437C-8206-A17189D1165C}"/>
+                <a16:creationId xmlns:a16="http://schemas.microsoft.com/office/drawing/2014/main" id="{6881A3FB-5F74-46E6-9DA9-DA17EB3ACDAB}"/>
               </a:ext>
             </a:extLst>
           </p:cNvPr>
@@ -6868,7 +6868,7 @@
           <p:cNvPr id="7" name="MK: € 4 → € 12 → € 20 per extra tegel">
             <a:extLst xmlns:a="http://schemas.openxmlformats.org/drawingml/2006/main">
               <a:ext uri="{FF2B5EF4-FFF2-40B4-BE49-F238E27FC236}">
-                <a16:creationId xmlns:a16="http://schemas.microsoft.com/office/drawing/2014/main" id="{147CB5A0-BE52-4F85-9CD5-60258F515305}"/>
+                <a16:creationId xmlns:a16="http://schemas.microsoft.com/office/drawing/2014/main" id="{F1C6623F-05B9-4660-B574-789419279677}"/>
               </a:ext>
             </a:extLst>
           </p:cNvPr>
@@ -6925,7 +6925,7 @@
           <p:cNvPr id="8" name="MO: steeds 52 / 2 = € 26 per extra tegel">
             <a:extLst xmlns:a="http://schemas.openxmlformats.org/drawingml/2006/main">
               <a:ext uri="{FF2B5EF4-FFF2-40B4-BE49-F238E27FC236}">
-                <a16:creationId xmlns:a16="http://schemas.microsoft.com/office/drawing/2014/main" id="{7D3C9B78-0B38-47B2-87D4-04F76A572C4D}"/>
+                <a16:creationId xmlns:a16="http://schemas.microsoft.com/office/drawing/2014/main" id="{307D4F2A-9BA8-4167-8D8F-2204FF8DE0D9}"/>
               </a:ext>
             </a:extLst>
           </p:cNvPr>
@@ -6980,7 +6980,7 @@
     </p:spTree>
     <p:extLst>
       <p:ext uri="{BB962C8B-B14F-4D97-AF65-F5344CB8AC3E}">
-        <p14:creationId xmlns:p14="http://schemas.microsoft.com/office/powerpoint/2010/main" val="674636257"/>
+        <p14:creationId xmlns:p14="http://schemas.microsoft.com/office/powerpoint/2010/main" val="241841256"/>
       </p:ext>
     </p:extLst>
   </p:cSld>
@@ -7011,7 +7011,7 @@
           <p:cNvPr id="8" name="GTK en MK · Alle tegels of extra tegels">
             <a:extLst xmlns:a="http://schemas.openxmlformats.org/drawingml/2006/main">
               <a:ext uri="{FF2B5EF4-FFF2-40B4-BE49-F238E27FC236}">
-                <a16:creationId xmlns:a16="http://schemas.microsoft.com/office/drawing/2014/main" id="{7FA3B883-152C-4E3B-90C8-3AE6C9863B11}"/>
+                <a16:creationId xmlns:a16="http://schemas.microsoft.com/office/drawing/2014/main" id="{D96C1F93-6E3C-483A-89F8-0B2FD588B1D1}"/>
               </a:ext>
             </a:extLst>
           </p:cNvPr>
@@ -7068,7 +7068,7 @@
           <p:cNvPr id="2" name="">
             <a:extLst xmlns:a="http://schemas.openxmlformats.org/drawingml/2006/main">
               <a:ext uri="{FF2B5EF4-FFF2-40B4-BE49-F238E27FC236}">
-                <a16:creationId xmlns:a16="http://schemas.microsoft.com/office/drawing/2014/main" id="{D34E319A-2B65-4AEA-90DE-EE25A3C227E9}"/>
+                <a16:creationId xmlns:a16="http://schemas.microsoft.com/office/drawing/2014/main" id="{0D844BCB-9CAF-42FF-B7C3-118893087F6B}"/>
               </a:ext>
             </a:extLst>
           </p:cNvPr>
@@ -7097,7 +7097,7 @@
           <p:cNvPr id="3" name="§2.1.3 Marginale kosten en marginale opbrengsten">
             <a:extLst xmlns:a="http://schemas.openxmlformats.org/drawingml/2006/main">
               <a:ext uri="{FF2B5EF4-FFF2-40B4-BE49-F238E27FC236}">
-                <a16:creationId xmlns:a16="http://schemas.microsoft.com/office/drawing/2014/main" id="{B12ECB36-261F-43C7-BF20-026008E4FA0F}"/>
+                <a16:creationId xmlns:a16="http://schemas.microsoft.com/office/drawing/2014/main" id="{4F9A85CA-92C7-413C-B903-3C2522D8BDDD}"/>
               </a:ext>
             </a:extLst>
           </p:cNvPr>
@@ -7154,7 +7154,7 @@
           <p:cNvPr id="4" name="slide-number">
             <a:extLst xmlns:a="http://schemas.openxmlformats.org/drawingml/2006/main">
               <a:ext uri="{FF2B5EF4-FFF2-40B4-BE49-F238E27FC236}">
-                <a16:creationId xmlns:a16="http://schemas.microsoft.com/office/drawing/2014/main" id="{1DA94C48-90CF-42FF-AFF8-DF06BFC99749}"/>
+                <a16:creationId xmlns:a16="http://schemas.microsoft.com/office/drawing/2014/main" id="{A52FD3DC-339A-458F-B6E7-ABDD4E9DD537}"/>
               </a:ext>
             </a:extLst>
           </p:cNvPr>
@@ -7211,7 +7211,7 @@
           <p:cNvPr id="5" name="Uitlegvoorbeeld — niet uit het boek · Studio Reliëf">
             <a:extLst xmlns:a="http://schemas.openxmlformats.org/drawingml/2006/main">
               <a:ext uri="{FF2B5EF4-FFF2-40B4-BE49-F238E27FC236}">
-                <a16:creationId xmlns:a16="http://schemas.microsoft.com/office/drawing/2014/main" id="{BD07E61C-6678-4C99-8A53-D22A9D532732}"/>
+                <a16:creationId xmlns:a16="http://schemas.microsoft.com/office/drawing/2014/main" id="{04324AA9-108E-4203-B0A1-5126CCCF85B8}"/>
               </a:ext>
             </a:extLst>
           </p:cNvPr>
@@ -7661,7 +7661,7 @@
           <p:cNvPr id="7" name="€ 20 per extra tegel: gemiddeld over de stap 4 → 6.">
             <a:extLst xmlns:a="http://schemas.openxmlformats.org/drawingml/2006/main">
               <a:ext uri="{FF2B5EF4-FFF2-40B4-BE49-F238E27FC236}">
-                <a16:creationId xmlns:a16="http://schemas.microsoft.com/office/drawing/2014/main" id="{EF645461-0E16-40BE-9ABB-BD1DD3DE22BB}"/>
+                <a16:creationId xmlns:a16="http://schemas.microsoft.com/office/drawing/2014/main" id="{A0A70FC4-651C-4822-8188-8FDE8097B661}"/>
               </a:ext>
             </a:extLst>
           </p:cNvPr>
@@ -7716,7 +7716,7 @@
     </p:spTree>
     <p:extLst>
       <p:ext uri="{BB962C8B-B14F-4D97-AF65-F5344CB8AC3E}">
-        <p14:creationId xmlns:p14="http://schemas.microsoft.com/office/powerpoint/2010/main" val="420622600"/>
+        <p14:creationId xmlns:p14="http://schemas.microsoft.com/office/powerpoint/2010/main" val="1670918897"/>
       </p:ext>
     </p:extLst>
   </p:cSld>
@@ -7747,7 +7747,7 @@
           <p:cNvPr id="9" name="Korte controle · Welke betekenis klopt?">
             <a:extLst xmlns:a="http://schemas.openxmlformats.org/drawingml/2006/main">
               <a:ext uri="{FF2B5EF4-FFF2-40B4-BE49-F238E27FC236}">
-                <a16:creationId xmlns:a16="http://schemas.microsoft.com/office/drawing/2014/main" id="{B8C12CB6-13D9-4439-9416-945AF9CDCA17}"/>
+                <a16:creationId xmlns:a16="http://schemas.microsoft.com/office/drawing/2014/main" id="{FFD74181-6977-4679-A3CC-BC039CEEE481}"/>
               </a:ext>
             </a:extLst>
           </p:cNvPr>
@@ -7804,7 +7804,7 @@
           <p:cNvPr id="2" name="">
             <a:extLst xmlns:a="http://schemas.openxmlformats.org/drawingml/2006/main">
               <a:ext uri="{FF2B5EF4-FFF2-40B4-BE49-F238E27FC236}">
-                <a16:creationId xmlns:a16="http://schemas.microsoft.com/office/drawing/2014/main" id="{7746321D-D7BE-44FC-86A8-A6428467C7FD}"/>
+                <a16:creationId xmlns:a16="http://schemas.microsoft.com/office/drawing/2014/main" id="{A476B542-088D-40BA-9C1C-521A76A6D442}"/>
               </a:ext>
             </a:extLst>
           </p:cNvPr>
@@ -7833,7 +7833,7 @@
           <p:cNvPr id="3" name="§2.1.3 Marginale kosten en marginale opbrengsten">
             <a:extLst xmlns:a="http://schemas.openxmlformats.org/drawingml/2006/main">
               <a:ext uri="{FF2B5EF4-FFF2-40B4-BE49-F238E27FC236}">
-                <a16:creationId xmlns:a16="http://schemas.microsoft.com/office/drawing/2014/main" id="{8D24E389-03B5-4CF0-920F-BD84042B1FF3}"/>
+                <a16:creationId xmlns:a16="http://schemas.microsoft.com/office/drawing/2014/main" id="{9B789911-5EBA-4C0A-9973-C4FEE4B2EA57}"/>
               </a:ext>
             </a:extLst>
           </p:cNvPr>
@@ -7890,7 +7890,7 @@
           <p:cNvPr id="4" name="slide-number">
             <a:extLst xmlns:a="http://schemas.openxmlformats.org/drawingml/2006/main">
               <a:ext uri="{FF2B5EF4-FFF2-40B4-BE49-F238E27FC236}">
-                <a16:creationId xmlns:a16="http://schemas.microsoft.com/office/drawing/2014/main" id="{041FE349-A476-43D9-927A-7A36E9CB409E}"/>
+                <a16:creationId xmlns:a16="http://schemas.microsoft.com/office/drawing/2014/main" id="{2E5DC022-6495-40F0-93FF-C43C43CEB2EA}"/>
               </a:ext>
             </a:extLst>
           </p:cNvPr>
@@ -7947,7 +7947,7 @@
           <p:cNvPr id="5" name="Uitlegvoorbeeld — niet uit het boek · Studio Reliëf">
             <a:extLst xmlns:a="http://schemas.openxmlformats.org/drawingml/2006/main">
               <a:ext uri="{FF2B5EF4-FFF2-40B4-BE49-F238E27FC236}">
-                <a16:creationId xmlns:a16="http://schemas.microsoft.com/office/drawing/2014/main" id="{CD230AC6-187C-4677-A719-04038DDE8458}"/>
+                <a16:creationId xmlns:a16="http://schemas.microsoft.com/office/drawing/2014/main" id="{8B5A13AE-9305-490E-A10F-74D77F5A6725}"/>
               </a:ext>
             </a:extLst>
           </p:cNvPr>
@@ -8004,7 +8004,7 @@
           <p:cNvPr id="6" name="Bij Q = 6 staat MK = € 20.">
             <a:extLst xmlns:a="http://schemas.openxmlformats.org/drawingml/2006/main">
               <a:ext uri="{FF2B5EF4-FFF2-40B4-BE49-F238E27FC236}">
-                <a16:creationId xmlns:a16="http://schemas.microsoft.com/office/drawing/2014/main" id="{EAAECEA8-EF14-4245-9BC1-EFB801594D85}"/>
+                <a16:creationId xmlns:a16="http://schemas.microsoft.com/office/drawing/2014/main" id="{1059CCA6-6628-4223-815C-BA65DAD6D1B8}"/>
               </a:ext>
             </a:extLst>
           </p:cNvPr>
@@ -8061,7 +8061,7 @@
           <p:cNvPr id="7" name="“Dus de zesde tegel kost precies € 20 extra.”">
             <a:extLst xmlns:a="http://schemas.openxmlformats.org/drawingml/2006/main">
               <a:ext uri="{FF2B5EF4-FFF2-40B4-BE49-F238E27FC236}">
-                <a16:creationId xmlns:a16="http://schemas.microsoft.com/office/drawing/2014/main" id="{17772190-FBC0-43F1-9385-63C68CFE2849}"/>
+                <a16:creationId xmlns:a16="http://schemas.microsoft.com/office/drawing/2014/main" id="{EAEE49EF-3D17-4325-9A21-7E643CF5166B}"/>
               </a:ext>
             </a:extLst>
           </p:cNvPr>
@@ -8118,7 +8118,7 @@
           <p:cNvPr id="8" name="Klopt dit? Noem de stap, het extra totaal&#10;en het aantal extra teg">
             <a:extLst xmlns:a="http://schemas.openxmlformats.org/drawingml/2006/main">
               <a:ext uri="{FF2B5EF4-FFF2-40B4-BE49-F238E27FC236}">
-                <a16:creationId xmlns:a16="http://schemas.microsoft.com/office/drawing/2014/main" id="{C4E0B98B-75A5-49E8-B1C6-163227CC60F8}"/>
+                <a16:creationId xmlns:a16="http://schemas.microsoft.com/office/drawing/2014/main" id="{9B31AF20-5758-42C6-BA1B-A555183DBA7A}"/>
               </a:ext>
             </a:extLst>
           </p:cNvPr>
@@ -8196,7 +8196,7 @@
     </p:spTree>
     <p:extLst>
       <p:ext uri="{BB962C8B-B14F-4D97-AF65-F5344CB8AC3E}">
-        <p14:creationId xmlns:p14="http://schemas.microsoft.com/office/powerpoint/2010/main" val="910027021"/>
+        <p14:creationId xmlns:p14="http://schemas.microsoft.com/office/powerpoint/2010/main" val="1934426172"/>
       </p:ext>
     </p:extLst>
   </p:cSld>
@@ -8227,7 +8227,7 @@
           <p:cNvPr id="10" name="Korte controle · Welke betekenis klopt?">
             <a:extLst xmlns:a="http://schemas.openxmlformats.org/drawingml/2006/main">
               <a:ext uri="{FF2B5EF4-FFF2-40B4-BE49-F238E27FC236}">
-                <a16:creationId xmlns:a16="http://schemas.microsoft.com/office/drawing/2014/main" id="{C7A544B0-E7DA-4200-AF5E-EB4A5BA4565A}"/>
+                <a16:creationId xmlns:a16="http://schemas.microsoft.com/office/drawing/2014/main" id="{9441BE48-2CD3-4A2E-86D7-D2F594633B2B}"/>
               </a:ext>
             </a:extLst>
           </p:cNvPr>
@@ -8284,7 +8284,7 @@
           <p:cNvPr id="2" name="">
             <a:extLst xmlns:a="http://schemas.openxmlformats.org/drawingml/2006/main">
               <a:ext uri="{FF2B5EF4-FFF2-40B4-BE49-F238E27FC236}">
-                <a16:creationId xmlns:a16="http://schemas.microsoft.com/office/drawing/2014/main" id="{B48BC451-B0AE-4E33-B396-D851E564EFF6}"/>
+                <a16:creationId xmlns:a16="http://schemas.microsoft.com/office/drawing/2014/main" id="{283C9866-6D87-4B8A-A183-2AAF5D481E0E}"/>
               </a:ext>
             </a:extLst>
           </p:cNvPr>
@@ -8313,7 +8313,7 @@
           <p:cNvPr id="3" name="§2.1.3 Marginale kosten en marginale opbrengsten">
             <a:extLst xmlns:a="http://schemas.openxmlformats.org/drawingml/2006/main">
               <a:ext uri="{FF2B5EF4-FFF2-40B4-BE49-F238E27FC236}">
-                <a16:creationId xmlns:a16="http://schemas.microsoft.com/office/drawing/2014/main" id="{8B3E1AAB-5B1A-4C93-ACD8-920CCE33270B}"/>
+                <a16:creationId xmlns:a16="http://schemas.microsoft.com/office/drawing/2014/main" id="{E28A96D9-F627-49C6-B80C-7C6CECA23FFC}"/>
               </a:ext>
             </a:extLst>
           </p:cNvPr>
@@ -8370,7 +8370,7 @@
           <p:cNvPr id="4" name="slide-number">
             <a:extLst xmlns:a="http://schemas.openxmlformats.org/drawingml/2006/main">
               <a:ext uri="{FF2B5EF4-FFF2-40B4-BE49-F238E27FC236}">
-                <a16:creationId xmlns:a16="http://schemas.microsoft.com/office/drawing/2014/main" id="{80E405A3-3438-4BCA-BA56-067DC9089648}"/>
+                <a16:creationId xmlns:a16="http://schemas.microsoft.com/office/drawing/2014/main" id="{81A71277-A060-496D-B898-DD9E44313F47}"/>
               </a:ext>
             </a:extLst>
           </p:cNvPr>
@@ -8427,7 +8427,7 @@
           <p:cNvPr id="5" name="Uitlegvoorbeeld — niet uit het boek · Studio Reliëf">
             <a:extLst xmlns:a="http://schemas.openxmlformats.org/drawingml/2006/main">
               <a:ext uri="{FF2B5EF4-FFF2-40B4-BE49-F238E27FC236}">
-                <a16:creationId xmlns:a16="http://schemas.microsoft.com/office/drawing/2014/main" id="{91CD72A0-9E33-4DF1-B16C-C3062EA26EF7}"/>
+                <a16:creationId xmlns:a16="http://schemas.microsoft.com/office/drawing/2014/main" id="{3ACD019D-B148-4E39-ADF8-F4EEF4A841C0}"/>
               </a:ext>
             </a:extLst>
           </p:cNvPr>
@@ -8484,7 +8484,7 @@
           <p:cNvPr id="6" name="Bij Q = 6 staat MK = € 20.">
             <a:extLst xmlns:a="http://schemas.openxmlformats.org/drawingml/2006/main">
               <a:ext uri="{FF2B5EF4-FFF2-40B4-BE49-F238E27FC236}">
-                <a16:creationId xmlns:a16="http://schemas.microsoft.com/office/drawing/2014/main" id="{C853037D-13DD-4AFC-929A-7242C2031AA1}"/>
+                <a16:creationId xmlns:a16="http://schemas.microsoft.com/office/drawing/2014/main" id="{C82553DE-38AE-4395-ADF3-DB90E6DFC91A}"/>
               </a:ext>
             </a:extLst>
           </p:cNvPr>
@@ -8541,7 +8541,7 @@
           <p:cNvPr id="7" name="“Dus de zesde tegel kost precies € 20 extra.”">
             <a:extLst xmlns:a="http://schemas.openxmlformats.org/drawingml/2006/main">
               <a:ext uri="{FF2B5EF4-FFF2-40B4-BE49-F238E27FC236}">
-                <a16:creationId xmlns:a16="http://schemas.microsoft.com/office/drawing/2014/main" id="{79054948-348C-4BBA-AEEF-1194CCA539D8}"/>
+                <a16:creationId xmlns:a16="http://schemas.microsoft.com/office/drawing/2014/main" id="{7F6A9831-D50B-45CA-9E17-9056B01782FC}"/>
               </a:ext>
             </a:extLst>
           </p:cNvPr>
@@ -8598,7 +8598,7 @@
           <p:cNvPr id="8" name="Onjuist: de stap loopt van 4 naar 6 tegels.">
             <a:extLst xmlns:a="http://schemas.openxmlformats.org/drawingml/2006/main">
               <a:ext uri="{FF2B5EF4-FFF2-40B4-BE49-F238E27FC236}">
-                <a16:creationId xmlns:a16="http://schemas.microsoft.com/office/drawing/2014/main" id="{2FA9F3D4-FF3C-411F-B31C-601EC4F64C72}"/>
+                <a16:creationId xmlns:a16="http://schemas.microsoft.com/office/drawing/2014/main" id="{4DF65401-20CB-401F-A3F4-1D87972E0650}"/>
               </a:ext>
             </a:extLst>
           </p:cNvPr>
@@ -8655,7 +8655,7 @@
           <p:cNvPr id="9" name="Samen € 40 extra kosten voor twee extra tegels:&#10;gemiddeld € 20 pe">
             <a:extLst xmlns:a="http://schemas.openxmlformats.org/drawingml/2006/main">
               <a:ext uri="{FF2B5EF4-FFF2-40B4-BE49-F238E27FC236}">
-                <a16:creationId xmlns:a16="http://schemas.microsoft.com/office/drawing/2014/main" id="{33055331-3CB6-4534-88D2-0088A3DEC966}"/>
+                <a16:creationId xmlns:a16="http://schemas.microsoft.com/office/drawing/2014/main" id="{15CFEC38-EDF6-47CF-802A-8BA3AEEE5049}"/>
               </a:ext>
             </a:extLst>
           </p:cNvPr>
@@ -8733,7 +8733,7 @@
     </p:spTree>
     <p:extLst>
       <p:ext uri="{BB962C8B-B14F-4D97-AF65-F5344CB8AC3E}">
-        <p14:creationId xmlns:p14="http://schemas.microsoft.com/office/powerpoint/2010/main" val="1007033381"/>
+        <p14:creationId xmlns:p14="http://schemas.microsoft.com/office/powerpoint/2010/main" val="2057701331"/>
       </p:ext>
     </p:extLst>
   </p:cSld>
@@ -8764,7 +8764,7 @@
           <p:cNvPr id="29" name="Deze les: §2.1.3 Marginale kosten en marginale opbrengsten">
             <a:extLst xmlns:a="http://schemas.openxmlformats.org/drawingml/2006/main">
               <a:ext uri="{FF2B5EF4-FFF2-40B4-BE49-F238E27FC236}">
-                <a16:creationId xmlns:a16="http://schemas.microsoft.com/office/drawing/2014/main" id="{CF327E28-694C-4654-932C-EC614D6DDBFC}"/>
+                <a16:creationId xmlns:a16="http://schemas.microsoft.com/office/drawing/2014/main" id="{A764E4F1-C4DE-4B1B-A2FB-D14CAD886419}"/>
               </a:ext>
             </a:extLst>
           </p:cNvPr>
@@ -8821,7 +8821,7 @@
           <p:cNvPr id="2" name="">
             <a:extLst xmlns:a="http://schemas.openxmlformats.org/drawingml/2006/main">
               <a:ext uri="{FF2B5EF4-FFF2-40B4-BE49-F238E27FC236}">
-                <a16:creationId xmlns:a16="http://schemas.microsoft.com/office/drawing/2014/main" id="{82134E81-EC7E-41A0-A0AB-8345FE54215D}"/>
+                <a16:creationId xmlns:a16="http://schemas.microsoft.com/office/drawing/2014/main" id="{81A9EBF0-F972-4AA0-96F7-8CEEEB5B2D4A}"/>
               </a:ext>
             </a:extLst>
           </p:cNvPr>
@@ -8850,7 +8850,7 @@
           <p:cNvPr id="3" name="§2.1.3 Marginale kosten en marginale opbrengsten">
             <a:extLst xmlns:a="http://schemas.openxmlformats.org/drawingml/2006/main">
               <a:ext uri="{FF2B5EF4-FFF2-40B4-BE49-F238E27FC236}">
-                <a16:creationId xmlns:a16="http://schemas.microsoft.com/office/drawing/2014/main" id="{84B92407-881F-422B-85F2-9FE7DD608075}"/>
+                <a16:creationId xmlns:a16="http://schemas.microsoft.com/office/drawing/2014/main" id="{663F2E55-F5A5-418E-A1CC-9556D7AC3F0F}"/>
               </a:ext>
             </a:extLst>
           </p:cNvPr>
@@ -8907,7 +8907,7 @@
           <p:cNvPr id="4" name="slide-number">
             <a:extLst xmlns:a="http://schemas.openxmlformats.org/drawingml/2006/main">
               <a:ext uri="{FF2B5EF4-FFF2-40B4-BE49-F238E27FC236}">
-                <a16:creationId xmlns:a16="http://schemas.microsoft.com/office/drawing/2014/main" id="{2ABD9E23-FA89-4093-B890-1E9AB19FB92A}"/>
+                <a16:creationId xmlns:a16="http://schemas.microsoft.com/office/drawing/2014/main" id="{0AF723A9-D245-4DE8-B422-4B92D8BA1F7C}"/>
               </a:ext>
             </a:extLst>
           </p:cNvPr>
@@ -8964,7 +8964,7 @@
           <p:cNvPr id="5" name="phase">
             <a:extLst xmlns:a="http://schemas.openxmlformats.org/drawingml/2006/main">
               <a:ext uri="{FF2B5EF4-FFF2-40B4-BE49-F238E27FC236}">
-                <a16:creationId xmlns:a16="http://schemas.microsoft.com/office/drawing/2014/main" id="{CF4ED4D8-0EB1-41DC-A88F-6A5D5190EAF0}"/>
+                <a16:creationId xmlns:a16="http://schemas.microsoft.com/office/drawing/2014/main" id="{043B7F52-5ED9-4AB4-9E7D-FE6B66D0DCE2}"/>
               </a:ext>
             </a:extLst>
           </p:cNvPr>
@@ -9021,7 +9021,7 @@
           <p:cNvPr id="6" name="Lesroute">
             <a:extLst xmlns:a="http://schemas.openxmlformats.org/drawingml/2006/main">
               <a:ext uri="{FF2B5EF4-FFF2-40B4-BE49-F238E27FC236}">
-                <a16:creationId xmlns:a16="http://schemas.microsoft.com/office/drawing/2014/main" id="{E8EF7B68-C6D1-4B33-A507-DAD89DE88C0B}"/>
+                <a16:creationId xmlns:a16="http://schemas.microsoft.com/office/drawing/2014/main" id="{C6342001-4897-4106-8F25-28EC12AC8CA3}"/>
               </a:ext>
             </a:extLst>
           </p:cNvPr>
@@ -9078,7 +9078,7 @@
           <p:cNvPr id="7" name="route-number-1">
             <a:extLst xmlns:a="http://schemas.openxmlformats.org/drawingml/2006/main">
               <a:ext uri="{FF2B5EF4-FFF2-40B4-BE49-F238E27FC236}">
-                <a16:creationId xmlns:a16="http://schemas.microsoft.com/office/drawing/2014/main" id="{B10B5FD7-E5E0-4F86-A875-6B630AEC11E3}"/>
+                <a16:creationId xmlns:a16="http://schemas.microsoft.com/office/drawing/2014/main" id="{09F96DD0-9A81-4479-AB89-630AA60DFCC1}"/>
               </a:ext>
             </a:extLst>
           </p:cNvPr>
@@ -9135,7 +9135,7 @@
           <p:cNvPr id="8" name="route-1">
             <a:extLst xmlns:a="http://schemas.openxmlformats.org/drawingml/2006/main">
               <a:ext uri="{FF2B5EF4-FFF2-40B4-BE49-F238E27FC236}">
-                <a16:creationId xmlns:a16="http://schemas.microsoft.com/office/drawing/2014/main" id="{031B31FE-0D69-480F-A5E5-5B49AB6690A6}"/>
+                <a16:creationId xmlns:a16="http://schemas.microsoft.com/office/drawing/2014/main" id="{28B4EC71-5D05-4363-A9A3-D58211F9ED92}"/>
               </a:ext>
             </a:extLst>
           </p:cNvPr>
@@ -9192,7 +9192,7 @@
           <p:cNvPr id="9" name="route-number-2">
             <a:extLst xmlns:a="http://schemas.openxmlformats.org/drawingml/2006/main">
               <a:ext uri="{FF2B5EF4-FFF2-40B4-BE49-F238E27FC236}">
-                <a16:creationId xmlns:a16="http://schemas.microsoft.com/office/drawing/2014/main" id="{ADFF5279-9653-444B-B4DD-A2E2FCD121EA}"/>
+                <a16:creationId xmlns:a16="http://schemas.microsoft.com/office/drawing/2014/main" id="{74F85B36-2D39-4F51-BB68-C3B42E3B7FF9}"/>
               </a:ext>
             </a:extLst>
           </p:cNvPr>
@@ -9249,7 +9249,7 @@
           <p:cNvPr id="10" name="route-2">
             <a:extLst xmlns:a="http://schemas.openxmlformats.org/drawingml/2006/main">
               <a:ext uri="{FF2B5EF4-FFF2-40B4-BE49-F238E27FC236}">
-                <a16:creationId xmlns:a16="http://schemas.microsoft.com/office/drawing/2014/main" id="{323CDED4-2C9A-48FC-AF9A-D1D6421612B7}"/>
+                <a16:creationId xmlns:a16="http://schemas.microsoft.com/office/drawing/2014/main" id="{5658AF74-A9F8-46CF-A2A1-4CCCB9B6140A}"/>
               </a:ext>
             </a:extLst>
           </p:cNvPr>
@@ -9306,7 +9306,7 @@
           <p:cNvPr id="11" name="route-number-3">
             <a:extLst xmlns:a="http://schemas.openxmlformats.org/drawingml/2006/main">
               <a:ext uri="{FF2B5EF4-FFF2-40B4-BE49-F238E27FC236}">
-                <a16:creationId xmlns:a16="http://schemas.microsoft.com/office/drawing/2014/main" id="{2FA49EAA-81C8-4E9C-BE84-7B7B7E609516}"/>
+                <a16:creationId xmlns:a16="http://schemas.microsoft.com/office/drawing/2014/main" id="{0B8F34D0-A041-4039-9971-BC0DBBEAC102}"/>
               </a:ext>
             </a:extLst>
           </p:cNvPr>
@@ -9363,7 +9363,7 @@
           <p:cNvPr id="12" name="route-3">
             <a:extLst xmlns:a="http://schemas.openxmlformats.org/drawingml/2006/main">
               <a:ext uri="{FF2B5EF4-FFF2-40B4-BE49-F238E27FC236}">
-                <a16:creationId xmlns:a16="http://schemas.microsoft.com/office/drawing/2014/main" id="{94FA2142-26B9-4D27-A171-7B46DFF78B0D}"/>
+                <a16:creationId xmlns:a16="http://schemas.microsoft.com/office/drawing/2014/main" id="{776EC612-A565-48E7-B8FA-24E3C1A1684F}"/>
               </a:ext>
             </a:extLst>
           </p:cNvPr>
@@ -9420,7 +9420,7 @@
           <p:cNvPr id="13" name="route-number-4">
             <a:extLst xmlns:a="http://schemas.openxmlformats.org/drawingml/2006/main">
               <a:ext uri="{FF2B5EF4-FFF2-40B4-BE49-F238E27FC236}">
-                <a16:creationId xmlns:a16="http://schemas.microsoft.com/office/drawing/2014/main" id="{BFEE8749-503E-49AD-8AED-9CAA8677BB60}"/>
+                <a16:creationId xmlns:a16="http://schemas.microsoft.com/office/drawing/2014/main" id="{F9834616-CC0C-4B39-BA3F-84A24D16C0DB}"/>
               </a:ext>
             </a:extLst>
           </p:cNvPr>
@@ -9477,7 +9477,7 @@
           <p:cNvPr id="14" name="route-4">
             <a:extLst xmlns:a="http://schemas.openxmlformats.org/drawingml/2006/main">
               <a:ext uri="{FF2B5EF4-FFF2-40B4-BE49-F238E27FC236}">
-                <a16:creationId xmlns:a16="http://schemas.microsoft.com/office/drawing/2014/main" id="{2C8841D1-09BD-4E69-8C88-0EEC466BB5BC}"/>
+                <a16:creationId xmlns:a16="http://schemas.microsoft.com/office/drawing/2014/main" id="{1A2DE0FD-648C-4378-AFF3-17BD4CAAEBE1}"/>
               </a:ext>
             </a:extLst>
           </p:cNvPr>
@@ -9534,7 +9534,7 @@
           <p:cNvPr id="15" name="route-number-5">
             <a:extLst xmlns:a="http://schemas.openxmlformats.org/drawingml/2006/main">
               <a:ext uri="{FF2B5EF4-FFF2-40B4-BE49-F238E27FC236}">
-                <a16:creationId xmlns:a16="http://schemas.microsoft.com/office/drawing/2014/main" id="{FAE0BCC4-8FB7-401F-B55B-E5547117EC70}"/>
+                <a16:creationId xmlns:a16="http://schemas.microsoft.com/office/drawing/2014/main" id="{FFF3EAFC-8976-46C0-A751-5DD872A19570}"/>
               </a:ext>
             </a:extLst>
           </p:cNvPr>
@@ -9591,7 +9591,7 @@
           <p:cNvPr id="16" name="route-5">
             <a:extLst xmlns:a="http://schemas.openxmlformats.org/drawingml/2006/main">
               <a:ext uri="{FF2B5EF4-FFF2-40B4-BE49-F238E27FC236}">
-                <a16:creationId xmlns:a16="http://schemas.microsoft.com/office/drawing/2014/main" id="{4426E48A-AAAC-409B-BCD4-ADFBEEB4F17F}"/>
+                <a16:creationId xmlns:a16="http://schemas.microsoft.com/office/drawing/2014/main" id="{27605702-F571-44DC-B6E4-15E7756B4F65}"/>
               </a:ext>
             </a:extLst>
           </p:cNvPr>
@@ -9648,7 +9648,7 @@
           <p:cNvPr id="17" name="route-number-6">
             <a:extLst xmlns:a="http://schemas.openxmlformats.org/drawingml/2006/main">
               <a:ext uri="{FF2B5EF4-FFF2-40B4-BE49-F238E27FC236}">
-                <a16:creationId xmlns:a16="http://schemas.microsoft.com/office/drawing/2014/main" id="{5318C4AA-E3FC-4A40-B271-8DC0C93ADBBD}"/>
+                <a16:creationId xmlns:a16="http://schemas.microsoft.com/office/drawing/2014/main" id="{532DE08E-D644-444D-B8BC-8DD458A46A0C}"/>
               </a:ext>
             </a:extLst>
           </p:cNvPr>
@@ -9705,7 +9705,7 @@
           <p:cNvPr id="18" name="route-6">
             <a:extLst xmlns:a="http://schemas.openxmlformats.org/drawingml/2006/main">
               <a:ext uri="{FF2B5EF4-FFF2-40B4-BE49-F238E27FC236}">
-                <a16:creationId xmlns:a16="http://schemas.microsoft.com/office/drawing/2014/main" id="{082F3BDC-C961-4206-970F-DCEF3A5547F8}"/>
+                <a16:creationId xmlns:a16="http://schemas.microsoft.com/office/drawing/2014/main" id="{C2AA9260-22D1-4B7A-9EEA-0638FA6AF686}"/>
               </a:ext>
             </a:extLst>
           </p:cNvPr>
@@ -9762,7 +9762,7 @@
           <p:cNvPr id="19" name="route-number-7">
             <a:extLst xmlns:a="http://schemas.openxmlformats.org/drawingml/2006/main">
               <a:ext uri="{FF2B5EF4-FFF2-40B4-BE49-F238E27FC236}">
-                <a16:creationId xmlns:a16="http://schemas.microsoft.com/office/drawing/2014/main" id="{9FB01F0D-772A-46C4-8B23-C1784F632000}"/>
+                <a16:creationId xmlns:a16="http://schemas.microsoft.com/office/drawing/2014/main" id="{397B1D54-07E6-439E-B7DA-92D1425ADA9D}"/>
               </a:ext>
             </a:extLst>
           </p:cNvPr>
@@ -9819,7 +9819,7 @@
           <p:cNvPr id="20" name="route-7">
             <a:extLst xmlns:a="http://schemas.openxmlformats.org/drawingml/2006/main">
               <a:ext uri="{FF2B5EF4-FFF2-40B4-BE49-F238E27FC236}">
-                <a16:creationId xmlns:a16="http://schemas.microsoft.com/office/drawing/2014/main" id="{38ED45EC-2354-4D8E-8E0B-ACEF40AB5125}"/>
+                <a16:creationId xmlns:a16="http://schemas.microsoft.com/office/drawing/2014/main" id="{3A925FF2-A123-4924-9B97-FA519675AFA5}"/>
               </a:ext>
             </a:extLst>
           </p:cNvPr>
@@ -9876,7 +9876,7 @@
           <p:cNvPr id="21" name="Lesdoelen">
             <a:extLst xmlns:a="http://schemas.openxmlformats.org/drawingml/2006/main">
               <a:ext uri="{FF2B5EF4-FFF2-40B4-BE49-F238E27FC236}">
-                <a16:creationId xmlns:a16="http://schemas.microsoft.com/office/drawing/2014/main" id="{F490900A-7A46-4ED1-A08F-3CCFB022D2F2}"/>
+                <a16:creationId xmlns:a16="http://schemas.microsoft.com/office/drawing/2014/main" id="{60D7F8BA-131D-4ACA-A6B7-126730A49754}"/>
               </a:ext>
             </a:extLst>
           </p:cNvPr>
@@ -9933,7 +9933,7 @@
           <p:cNvPr id="22" name="overview-goals">
             <a:extLst xmlns:a="http://schemas.openxmlformats.org/drawingml/2006/main">
               <a:ext uri="{FF2B5EF4-FFF2-40B4-BE49-F238E27FC236}">
-                <a16:creationId xmlns:a16="http://schemas.microsoft.com/office/drawing/2014/main" id="{09B6E7DF-DA47-4EAC-A9E3-5F4BE95A33B1}"/>
+                <a16:creationId xmlns:a16="http://schemas.microsoft.com/office/drawing/2014/main" id="{07626E5B-0198-411D-AB43-4C46754629FC}"/>
               </a:ext>
             </a:extLst>
           </p:cNvPr>
@@ -10036,7 +10036,7 @@
           <p:cNvPr id="23" name="">
             <a:extLst xmlns:a="http://schemas.openxmlformats.org/drawingml/2006/main">
               <a:ext uri="{FF2B5EF4-FFF2-40B4-BE49-F238E27FC236}">
-                <a16:creationId xmlns:a16="http://schemas.microsoft.com/office/drawing/2014/main" id="{130D1532-4932-42FB-9EC7-E516E88593D9}"/>
+                <a16:creationId xmlns:a16="http://schemas.microsoft.com/office/drawing/2014/main" id="{F9EF4444-DFBE-4FF6-B092-ECD4080B1435}"/>
               </a:ext>
             </a:extLst>
           </p:cNvPr>
@@ -10065,7 +10065,7 @@
           <p:cNvPr id="24" name="Startopdracht">
             <a:extLst xmlns:a="http://schemas.openxmlformats.org/drawingml/2006/main">
               <a:ext uri="{FF2B5EF4-FFF2-40B4-BE49-F238E27FC236}">
-                <a16:creationId xmlns:a16="http://schemas.microsoft.com/office/drawing/2014/main" id="{F02275EB-D2C2-437A-A6D2-40E29B4B1DB4}"/>
+                <a16:creationId xmlns:a16="http://schemas.microsoft.com/office/drawing/2014/main" id="{6B6AA147-B820-44FD-BF2A-9ED6534B7D98}"/>
               </a:ext>
             </a:extLst>
           </p:cNvPr>
@@ -10122,7 +10122,7 @@
           <p:cNvPr id="25" name="overview-start">
             <a:extLst xmlns:a="http://schemas.openxmlformats.org/drawingml/2006/main">
               <a:ext uri="{FF2B5EF4-FFF2-40B4-BE49-F238E27FC236}">
-                <a16:creationId xmlns:a16="http://schemas.microsoft.com/office/drawing/2014/main" id="{52F8E287-281D-46FA-91BE-64FDC31C1D66}"/>
+                <a16:creationId xmlns:a16="http://schemas.microsoft.com/office/drawing/2014/main" id="{FD0FD248-1FE7-4C52-B11B-E16524B79761}"/>
               </a:ext>
             </a:extLst>
           </p:cNvPr>
@@ -10202,7 +10202,7 @@
           <p:cNvPr id="26" name="">
             <a:extLst xmlns:a="http://schemas.openxmlformats.org/drawingml/2006/main">
               <a:ext uri="{FF2B5EF4-FFF2-40B4-BE49-F238E27FC236}">
-                <a16:creationId xmlns:a16="http://schemas.microsoft.com/office/drawing/2014/main" id="{0533D072-CF5E-4AA4-9B1C-B8D699ECEAAB}"/>
+                <a16:creationId xmlns:a16="http://schemas.microsoft.com/office/drawing/2014/main" id="{449D41BA-F9DD-43CC-8A8A-9A4346C259D8}"/>
               </a:ext>
             </a:extLst>
           </p:cNvPr>
@@ -10231,7 +10231,7 @@
           <p:cNvPr id="27" name="Huiswerk">
             <a:extLst xmlns:a="http://schemas.openxmlformats.org/drawingml/2006/main">
               <a:ext uri="{FF2B5EF4-FFF2-40B4-BE49-F238E27FC236}">
-                <a16:creationId xmlns:a16="http://schemas.microsoft.com/office/drawing/2014/main" id="{09770A92-30B8-46FF-A794-5237F2253973}"/>
+                <a16:creationId xmlns:a16="http://schemas.microsoft.com/office/drawing/2014/main" id="{A5617DD7-6697-408F-B80E-E18D5E8148F3}"/>
               </a:ext>
             </a:extLst>
           </p:cNvPr>
@@ -10288,7 +10288,7 @@
           <p:cNvPr id="28" name="overview-homework">
             <a:extLst xmlns:a="http://schemas.openxmlformats.org/drawingml/2006/main">
               <a:ext uri="{FF2B5EF4-FFF2-40B4-BE49-F238E27FC236}">
-                <a16:creationId xmlns:a16="http://schemas.microsoft.com/office/drawing/2014/main" id="{4DD8BD5B-7AAD-458F-81AD-9F9DED9260D1}"/>
+                <a16:creationId xmlns:a16="http://schemas.microsoft.com/office/drawing/2014/main" id="{E3F9C741-7F13-4BC6-A7B8-4571D161DAE2}"/>
               </a:ext>
             </a:extLst>
           </p:cNvPr>
@@ -10435,7 +10435,7 @@
     </p:spTree>
     <p:extLst>
       <p:ext uri="{BB962C8B-B14F-4D97-AF65-F5344CB8AC3E}">
-        <p14:creationId xmlns:p14="http://schemas.microsoft.com/office/powerpoint/2010/main" val="1656983505"/>
+        <p14:creationId xmlns:p14="http://schemas.microsoft.com/office/powerpoint/2010/main" val="911134334"/>
       </p:ext>
     </p:extLst>
   </p:cSld>
@@ -10466,7 +10466,7 @@
           <p:cNvPr id="8" name="Opgave 7 · Linea en Curva">
             <a:extLst xmlns:a="http://schemas.openxmlformats.org/drawingml/2006/main">
               <a:ext uri="{FF2B5EF4-FFF2-40B4-BE49-F238E27FC236}">
-                <a16:creationId xmlns:a16="http://schemas.microsoft.com/office/drawing/2014/main" id="{28177880-7343-48DC-8791-AD8F5EAEE71B}"/>
+                <a16:creationId xmlns:a16="http://schemas.microsoft.com/office/drawing/2014/main" id="{2B5AE212-3FF1-41FF-A870-9A3A33963857}"/>
               </a:ext>
             </a:extLst>
           </p:cNvPr>
@@ -10523,7 +10523,7 @@
           <p:cNvPr id="2" name="">
             <a:extLst xmlns:a="http://schemas.openxmlformats.org/drawingml/2006/main">
               <a:ext uri="{FF2B5EF4-FFF2-40B4-BE49-F238E27FC236}">
-                <a16:creationId xmlns:a16="http://schemas.microsoft.com/office/drawing/2014/main" id="{4F6F0E0C-EEFF-4BBC-AE21-B86EB4174D96}"/>
+                <a16:creationId xmlns:a16="http://schemas.microsoft.com/office/drawing/2014/main" id="{7BC001A1-5C5A-422D-AAED-704E601FBDD6}"/>
               </a:ext>
             </a:extLst>
           </p:cNvPr>
@@ -10552,7 +10552,7 @@
           <p:cNvPr id="3" name="§2.1.3 · Opgave 7 · Linea en Curva · Boekpagina 26">
             <a:extLst xmlns:a="http://schemas.openxmlformats.org/drawingml/2006/main">
               <a:ext uri="{FF2B5EF4-FFF2-40B4-BE49-F238E27FC236}">
-                <a16:creationId xmlns:a16="http://schemas.microsoft.com/office/drawing/2014/main" id="{7E40E588-6C10-461B-A00D-E714C25C4F2A}"/>
+                <a16:creationId xmlns:a16="http://schemas.microsoft.com/office/drawing/2014/main" id="{08B87F96-077A-450B-9663-8890B2677904}"/>
               </a:ext>
             </a:extLst>
           </p:cNvPr>
@@ -10609,7 +10609,7 @@
           <p:cNvPr id="4" name="slide-number">
             <a:extLst xmlns:a="http://schemas.openxmlformats.org/drawingml/2006/main">
               <a:ext uri="{FF2B5EF4-FFF2-40B4-BE49-F238E27FC236}">
-                <a16:creationId xmlns:a16="http://schemas.microsoft.com/office/drawing/2014/main" id="{CD1FBE7F-E009-4D84-911C-B4C97114E377}"/>
+                <a16:creationId xmlns:a16="http://schemas.microsoft.com/office/drawing/2014/main" id="{D4524162-9969-4D88-BBA6-9695646FCF1C}"/>
               </a:ext>
             </a:extLst>
           </p:cNvPr>
@@ -10937,7 +10937,7 @@
           <p:cNvPr id="6" name="Q: producten per week. Totale bedragen: euro per week.">
             <a:extLst xmlns:a="http://schemas.openxmlformats.org/drawingml/2006/main">
               <a:ext uri="{FF2B5EF4-FFF2-40B4-BE49-F238E27FC236}">
-                <a16:creationId xmlns:a16="http://schemas.microsoft.com/office/drawing/2014/main" id="{E70FB670-5071-4CE8-ABA7-E3FB3A3D21CC}"/>
+                <a16:creationId xmlns:a16="http://schemas.microsoft.com/office/drawing/2014/main" id="{02194C7C-F725-4D95-8778-485941EC5D6D}"/>
               </a:ext>
             </a:extLst>
           </p:cNvPr>
@@ -10994,7 +10994,7 @@
           <p:cNvPr id="7" name="Bereken MK en MO per extra product over iedere tabelstap.&#10;Zet de ">
             <a:extLst xmlns:a="http://schemas.openxmlformats.org/drawingml/2006/main">
               <a:ext uri="{FF2B5EF4-FFF2-40B4-BE49-F238E27FC236}">
-                <a16:creationId xmlns:a16="http://schemas.microsoft.com/office/drawing/2014/main" id="{93787DB2-B39E-4815-BD5E-8BE34F50AEE6}"/>
+                <a16:creationId xmlns:a16="http://schemas.microsoft.com/office/drawing/2014/main" id="{67597A33-D748-425F-8336-6A34567845D0}"/>
               </a:ext>
             </a:extLst>
           </p:cNvPr>
@@ -11095,7 +11095,7 @@
     </p:spTree>
     <p:extLst>
       <p:ext uri="{BB962C8B-B14F-4D97-AF65-F5344CB8AC3E}">
-        <p14:creationId xmlns:p14="http://schemas.microsoft.com/office/powerpoint/2010/main" val="1952694868"/>
+        <p14:creationId xmlns:p14="http://schemas.microsoft.com/office/powerpoint/2010/main" val="54276767"/>
       </p:ext>
     </p:extLst>
   </p:cSld>
@@ -11126,7 +11126,7 @@
           <p:cNvPr id="9" name="Opgave 7 · Invultabel Linea">
             <a:extLst xmlns:a="http://schemas.openxmlformats.org/drawingml/2006/main">
               <a:ext uri="{FF2B5EF4-FFF2-40B4-BE49-F238E27FC236}">
-                <a16:creationId xmlns:a16="http://schemas.microsoft.com/office/drawing/2014/main" id="{F03EC3A2-286D-4004-BF29-4480027108E4}"/>
+                <a16:creationId xmlns:a16="http://schemas.microsoft.com/office/drawing/2014/main" id="{CFB01969-2F4D-4C92-BDAF-F18C1160C1A1}"/>
               </a:ext>
             </a:extLst>
           </p:cNvPr>
@@ -11183,7 +11183,7 @@
           <p:cNvPr id="2" name="">
             <a:extLst xmlns:a="http://schemas.openxmlformats.org/drawingml/2006/main">
               <a:ext uri="{FF2B5EF4-FFF2-40B4-BE49-F238E27FC236}">
-                <a16:creationId xmlns:a16="http://schemas.microsoft.com/office/drawing/2014/main" id="{A9B9450D-3D7D-439F-AAA7-043D7E96C3F3}"/>
+                <a16:creationId xmlns:a16="http://schemas.microsoft.com/office/drawing/2014/main" id="{D41E5C4B-0912-4061-9B91-B7093D98565C}"/>
               </a:ext>
             </a:extLst>
           </p:cNvPr>
@@ -11212,7 +11212,7 @@
           <p:cNvPr id="3" name="§2.1.3 · Opgave 7 · Linea en Curva · Boekpagina 26">
             <a:extLst xmlns:a="http://schemas.openxmlformats.org/drawingml/2006/main">
               <a:ext uri="{FF2B5EF4-FFF2-40B4-BE49-F238E27FC236}">
-                <a16:creationId xmlns:a16="http://schemas.microsoft.com/office/drawing/2014/main" id="{421DF01C-47B9-49F4-AD0D-A8B1B2805B62}"/>
+                <a16:creationId xmlns:a16="http://schemas.microsoft.com/office/drawing/2014/main" id="{FF5393B7-2236-495F-B8D9-EDE20E89333B}"/>
               </a:ext>
             </a:extLst>
           </p:cNvPr>
@@ -11269,7 +11269,7 @@
           <p:cNvPr id="4" name="slide-number">
             <a:extLst xmlns:a="http://schemas.openxmlformats.org/drawingml/2006/main">
               <a:ext uri="{FF2B5EF4-FFF2-40B4-BE49-F238E27FC236}">
-                <a16:creationId xmlns:a16="http://schemas.microsoft.com/office/drawing/2014/main" id="{3C6E73D0-89EB-4C4C-BFD9-B760B87BE2BE}"/>
+                <a16:creationId xmlns:a16="http://schemas.microsoft.com/office/drawing/2014/main" id="{72CD6A72-C1BF-4AE1-9FA1-54E76DC7ECE0}"/>
               </a:ext>
             </a:extLst>
           </p:cNvPr>
@@ -11326,7 +11326,7 @@
           <p:cNvPr id="5" name="TK = 200 + 3Q     TO = 8Q">
             <a:extLst xmlns:a="http://schemas.openxmlformats.org/drawingml/2006/main">
               <a:ext uri="{FF2B5EF4-FFF2-40B4-BE49-F238E27FC236}">
-                <a16:creationId xmlns:a16="http://schemas.microsoft.com/office/drawing/2014/main" id="{3216075A-CBBF-4C78-9A94-F06ED429C512}"/>
+                <a16:creationId xmlns:a16="http://schemas.microsoft.com/office/drawing/2014/main" id="{64C8B5A0-CE30-4DD8-A401-D5417E91BF4C}"/>
               </a:ext>
             </a:extLst>
           </p:cNvPr>
@@ -11383,7 +11383,7 @@
           <p:cNvPr id="6" name="Q: producten per week · TK, TO en winst: euro per week">
             <a:extLst xmlns:a="http://schemas.openxmlformats.org/drawingml/2006/main">
               <a:ext uri="{FF2B5EF4-FFF2-40B4-BE49-F238E27FC236}">
-                <a16:creationId xmlns:a16="http://schemas.microsoft.com/office/drawing/2014/main" id="{645A2E43-A5F6-41C1-84A5-D2F4728C1C2B}"/>
+                <a16:creationId xmlns:a16="http://schemas.microsoft.com/office/drawing/2014/main" id="{B8D5A8D6-ED49-4456-B764-F4AAABBDD152}"/>
               </a:ext>
             </a:extLst>
           </p:cNvPr>
@@ -12222,7 +12222,7 @@
           <p:cNvPr id="8" name="MK en MO: per extra product, vanaf de vorige tabelrij.">
             <a:extLst xmlns:a="http://schemas.openxmlformats.org/drawingml/2006/main">
               <a:ext uri="{FF2B5EF4-FFF2-40B4-BE49-F238E27FC236}">
-                <a16:creationId xmlns:a16="http://schemas.microsoft.com/office/drawing/2014/main" id="{F3B18846-B096-4E6C-9A4A-649D8B8FB775}"/>
+                <a16:creationId xmlns:a16="http://schemas.microsoft.com/office/drawing/2014/main" id="{BE77D747-0348-419D-ACD5-B40276F48E82}"/>
               </a:ext>
             </a:extLst>
           </p:cNvPr>
@@ -12277,7 +12277,7 @@
     </p:spTree>
     <p:extLst>
       <p:ext uri="{BB962C8B-B14F-4D97-AF65-F5344CB8AC3E}">
-        <p14:creationId xmlns:p14="http://schemas.microsoft.com/office/powerpoint/2010/main" val="1023868329"/>
+        <p14:creationId xmlns:p14="http://schemas.microsoft.com/office/powerpoint/2010/main" val="1635028388"/>
       </p:ext>
     </p:extLst>
   </p:cSld>
@@ -12308,7 +12308,7 @@
           <p:cNvPr id="9" name="Opgave 7 · Invultabel Curva">
             <a:extLst xmlns:a="http://schemas.openxmlformats.org/drawingml/2006/main">
               <a:ext uri="{FF2B5EF4-FFF2-40B4-BE49-F238E27FC236}">
-                <a16:creationId xmlns:a16="http://schemas.microsoft.com/office/drawing/2014/main" id="{CD00D29C-1C11-42E3-9C8E-4E1E990BCA6F}"/>
+                <a16:creationId xmlns:a16="http://schemas.microsoft.com/office/drawing/2014/main" id="{67741AF7-1C16-4CD4-B046-73F74718AFB9}"/>
               </a:ext>
             </a:extLst>
           </p:cNvPr>
@@ -12365,7 +12365,7 @@
           <p:cNvPr id="2" name="">
             <a:extLst xmlns:a="http://schemas.openxmlformats.org/drawingml/2006/main">
               <a:ext uri="{FF2B5EF4-FFF2-40B4-BE49-F238E27FC236}">
-                <a16:creationId xmlns:a16="http://schemas.microsoft.com/office/drawing/2014/main" id="{B7500B8D-DB8C-46FE-B5DE-A68CA900509B}"/>
+                <a16:creationId xmlns:a16="http://schemas.microsoft.com/office/drawing/2014/main" id="{165AC46C-1285-4E5C-B2AE-CD13C0E56CB3}"/>
               </a:ext>
             </a:extLst>
           </p:cNvPr>
@@ -12394,7 +12394,7 @@
           <p:cNvPr id="3" name="§2.1.3 · Opgave 7 · Linea en Curva · Boekpagina 26">
             <a:extLst xmlns:a="http://schemas.openxmlformats.org/drawingml/2006/main">
               <a:ext uri="{FF2B5EF4-FFF2-40B4-BE49-F238E27FC236}">
-                <a16:creationId xmlns:a16="http://schemas.microsoft.com/office/drawing/2014/main" id="{A7FDCC51-9633-46A0-BEBC-94E16F18CF00}"/>
+                <a16:creationId xmlns:a16="http://schemas.microsoft.com/office/drawing/2014/main" id="{A147D764-7FC5-49FF-8F75-8549F6FEAF79}"/>
               </a:ext>
             </a:extLst>
           </p:cNvPr>
@@ -12451,7 +12451,7 @@
           <p:cNvPr id="4" name="slide-number">
             <a:extLst xmlns:a="http://schemas.openxmlformats.org/drawingml/2006/main">
               <a:ext uri="{FF2B5EF4-FFF2-40B4-BE49-F238E27FC236}">
-                <a16:creationId xmlns:a16="http://schemas.microsoft.com/office/drawing/2014/main" id="{EB4784FA-4EF7-47A1-B2B7-AA93AA650669}"/>
+                <a16:creationId xmlns:a16="http://schemas.microsoft.com/office/drawing/2014/main" id="{81769645-F8D4-4BEC-8C6E-67AF5270149E}"/>
               </a:ext>
             </a:extLst>
           </p:cNvPr>
@@ -12508,7 +12508,7 @@
           <p:cNvPr id="5" name="TK = 100 + Q²     TO = 30Q">
             <a:extLst xmlns:a="http://schemas.openxmlformats.org/drawingml/2006/main">
               <a:ext uri="{FF2B5EF4-FFF2-40B4-BE49-F238E27FC236}">
-                <a16:creationId xmlns:a16="http://schemas.microsoft.com/office/drawing/2014/main" id="{D0972188-E3C1-41BB-83BC-3B3AE30B2192}"/>
+                <a16:creationId xmlns:a16="http://schemas.microsoft.com/office/drawing/2014/main" id="{FDFC95EE-89F0-417B-9EDE-8D39F3883BD5}"/>
               </a:ext>
             </a:extLst>
           </p:cNvPr>
@@ -12565,7 +12565,7 @@
           <p:cNvPr id="6" name="Q: producten per week · TK, TO en winst: euro per week">
             <a:extLst xmlns:a="http://schemas.openxmlformats.org/drawingml/2006/main">
               <a:ext uri="{FF2B5EF4-FFF2-40B4-BE49-F238E27FC236}">
-                <a16:creationId xmlns:a16="http://schemas.microsoft.com/office/drawing/2014/main" id="{4392E346-B287-4EE5-BF3E-169EB91A05D4}"/>
+                <a16:creationId xmlns:a16="http://schemas.microsoft.com/office/drawing/2014/main" id="{6F14A278-029B-48D0-AC74-6ECB5CAD6E81}"/>
               </a:ext>
             </a:extLst>
           </p:cNvPr>
@@ -13404,7 +13404,7 @@
           <p:cNvPr id="8" name="MK en MO: per extra product, vanaf de vorige tabelrij.">
             <a:extLst xmlns:a="http://schemas.openxmlformats.org/drawingml/2006/main">
               <a:ext uri="{FF2B5EF4-FFF2-40B4-BE49-F238E27FC236}">
-                <a16:creationId xmlns:a16="http://schemas.microsoft.com/office/drawing/2014/main" id="{84103817-97F0-4D93-982E-5A62C56EE3FC}"/>
+                <a16:creationId xmlns:a16="http://schemas.microsoft.com/office/drawing/2014/main" id="{CE9846FF-C626-4BFF-81C8-72C614BC796C}"/>
               </a:ext>
             </a:extLst>
           </p:cNvPr>
@@ -13459,7 +13459,7 @@
     </p:spTree>
     <p:extLst>
       <p:ext uri="{BB962C8B-B14F-4D97-AF65-F5344CB8AC3E}">
-        <p14:creationId xmlns:p14="http://schemas.microsoft.com/office/powerpoint/2010/main" val="562988334"/>
+        <p14:creationId xmlns:p14="http://schemas.microsoft.com/office/powerpoint/2010/main" val="1038953858"/>
       </p:ext>
     </p:extLst>
   </p:cSld>
@@ -13490,7 +13490,7 @@
           <p:cNvPr id="10" name="Opgave 7 · Deelvragen a, b en c">
             <a:extLst xmlns:a="http://schemas.openxmlformats.org/drawingml/2006/main">
               <a:ext uri="{FF2B5EF4-FFF2-40B4-BE49-F238E27FC236}">
-                <a16:creationId xmlns:a16="http://schemas.microsoft.com/office/drawing/2014/main" id="{F557560D-B5F9-4166-82D5-EDBAF16630DF}"/>
+                <a16:creationId xmlns:a16="http://schemas.microsoft.com/office/drawing/2014/main" id="{991FA4C1-14FB-459B-A91B-23A210B84DFA}"/>
               </a:ext>
             </a:extLst>
           </p:cNvPr>
@@ -13547,7 +13547,7 @@
           <p:cNvPr id="2" name="">
             <a:extLst xmlns:a="http://schemas.openxmlformats.org/drawingml/2006/main">
               <a:ext uri="{FF2B5EF4-FFF2-40B4-BE49-F238E27FC236}">
-                <a16:creationId xmlns:a16="http://schemas.microsoft.com/office/drawing/2014/main" id="{9B56064C-15D1-4B87-9CC1-6BD818AD8FB9}"/>
+                <a16:creationId xmlns:a16="http://schemas.microsoft.com/office/drawing/2014/main" id="{951F4F9F-373F-4DF9-9E6C-BCF1A9360FA0}"/>
               </a:ext>
             </a:extLst>
           </p:cNvPr>
@@ -13576,7 +13576,7 @@
           <p:cNvPr id="3" name="§2.1.3 · Opgave 7 · Linea en Curva · Boekpagina 26">
             <a:extLst xmlns:a="http://schemas.openxmlformats.org/drawingml/2006/main">
               <a:ext uri="{FF2B5EF4-FFF2-40B4-BE49-F238E27FC236}">
-                <a16:creationId xmlns:a16="http://schemas.microsoft.com/office/drawing/2014/main" id="{1602DD4F-23E2-43F6-8E49-0925DABC7BF0}"/>
+                <a16:creationId xmlns:a16="http://schemas.microsoft.com/office/drawing/2014/main" id="{C41AE917-4AC6-4BC1-93CF-B8EB1785550D}"/>
               </a:ext>
             </a:extLst>
           </p:cNvPr>
@@ -13633,7 +13633,7 @@
           <p:cNvPr id="4" name="slide-number">
             <a:extLst xmlns:a="http://schemas.openxmlformats.org/drawingml/2006/main">
               <a:ext uri="{FF2B5EF4-FFF2-40B4-BE49-F238E27FC236}">
-                <a16:creationId xmlns:a16="http://schemas.microsoft.com/office/drawing/2014/main" id="{4B8CD210-1818-4DEF-B82D-913BC203B4B6}"/>
+                <a16:creationId xmlns:a16="http://schemas.microsoft.com/office/drawing/2014/main" id="{A2A185F8-33E1-4503-BFFA-90D0BC9A6284}"/>
               </a:ext>
             </a:extLst>
           </p:cNvPr>
@@ -13690,7 +13690,7 @@
           <p:cNvPr id="5" name="a) Vul bij Linea de winstkolom in.">
             <a:extLst xmlns:a="http://schemas.openxmlformats.org/drawingml/2006/main">
               <a:ext uri="{FF2B5EF4-FFF2-40B4-BE49-F238E27FC236}">
-                <a16:creationId xmlns:a16="http://schemas.microsoft.com/office/drawing/2014/main" id="{1766BFCC-9364-4772-8F04-1E8C18584F23}"/>
+                <a16:creationId xmlns:a16="http://schemas.microsoft.com/office/drawing/2014/main" id="{F9F9BB17-85BF-4B34-A3A5-247974913580}"/>
               </a:ext>
             </a:extLst>
           </p:cNvPr>
@@ -13747,7 +13747,7 @@
           <p:cNvPr id="6" name="">
             <a:extLst xmlns:a="http://schemas.openxmlformats.org/drawingml/2006/main">
               <a:ext uri="{FF2B5EF4-FFF2-40B4-BE49-F238E27FC236}">
-                <a16:creationId xmlns:a16="http://schemas.microsoft.com/office/drawing/2014/main" id="{3718F7BA-D875-43B4-9FDE-D709C970586B}"/>
+                <a16:creationId xmlns:a16="http://schemas.microsoft.com/office/drawing/2014/main" id="{41AE312F-E95F-43F7-8930-0F27023308C0}"/>
               </a:ext>
             </a:extLst>
           </p:cNvPr>
@@ -13776,7 +13776,7 @@
           <p:cNvPr id="7" name="b) Bereken voor Linea MK en MO over de eerste stap. Laat teller e">
             <a:extLst xmlns:a="http://schemas.openxmlformats.org/drawingml/2006/main">
               <a:ext uri="{FF2B5EF4-FFF2-40B4-BE49-F238E27FC236}">
-                <a16:creationId xmlns:a16="http://schemas.microsoft.com/office/drawing/2014/main" id="{D2F613BF-D648-4826-8439-B495DD9CA973}"/>
+                <a16:creationId xmlns:a16="http://schemas.microsoft.com/office/drawing/2014/main" id="{85721137-3807-41D7-9D16-8E61486E1270}"/>
               </a:ext>
             </a:extLst>
           </p:cNvPr>
@@ -13833,7 +13833,7 @@
           <p:cNvPr id="8" name="">
             <a:extLst xmlns:a="http://schemas.openxmlformats.org/drawingml/2006/main">
               <a:ext uri="{FF2B5EF4-FFF2-40B4-BE49-F238E27FC236}">
-                <a16:creationId xmlns:a16="http://schemas.microsoft.com/office/drawing/2014/main" id="{48F014BB-8F19-4DCD-A177-905FA207752D}"/>
+                <a16:creationId xmlns:a16="http://schemas.microsoft.com/office/drawing/2014/main" id="{CD15D23F-2A5E-4D89-BBB4-5D19B78AF9EC}"/>
               </a:ext>
             </a:extLst>
           </p:cNvPr>
@@ -13862,7 +13862,7 @@
           <p:cNvPr id="9" name="c) Leg uit waarom MO bij Linea constant is.">
             <a:extLst xmlns:a="http://schemas.openxmlformats.org/drawingml/2006/main">
               <a:ext uri="{FF2B5EF4-FFF2-40B4-BE49-F238E27FC236}">
-                <a16:creationId xmlns:a16="http://schemas.microsoft.com/office/drawing/2014/main" id="{5CA2C55F-331A-4F11-8DC3-497ABDB79F20}"/>
+                <a16:creationId xmlns:a16="http://schemas.microsoft.com/office/drawing/2014/main" id="{1E441F2B-F609-4A8E-B193-D5822C5D0B29}"/>
               </a:ext>
             </a:extLst>
           </p:cNvPr>
@@ -13917,7 +13917,7 @@
     </p:spTree>
     <p:extLst>
       <p:ext uri="{BB962C8B-B14F-4D97-AF65-F5344CB8AC3E}">
-        <p14:creationId xmlns:p14="http://schemas.microsoft.com/office/powerpoint/2010/main" val="572236156"/>
+        <p14:creationId xmlns:p14="http://schemas.microsoft.com/office/powerpoint/2010/main" val="2008792917"/>
       </p:ext>
     </p:extLst>
   </p:cSld>
@@ -13948,7 +13948,7 @@
           <p:cNvPr id="8" name="Opgave 7 · Deelvragen d en e">
             <a:extLst xmlns:a="http://schemas.openxmlformats.org/drawingml/2006/main">
               <a:ext uri="{FF2B5EF4-FFF2-40B4-BE49-F238E27FC236}">
-                <a16:creationId xmlns:a16="http://schemas.microsoft.com/office/drawing/2014/main" id="{352B9753-6CF5-4FFF-8608-6C85AF7A5776}"/>
+                <a16:creationId xmlns:a16="http://schemas.microsoft.com/office/drawing/2014/main" id="{DE12B090-D601-46FD-956B-90DB2E88AA80}"/>
               </a:ext>
             </a:extLst>
           </p:cNvPr>
@@ -14005,7 +14005,7 @@
           <p:cNvPr id="2" name="">
             <a:extLst xmlns:a="http://schemas.openxmlformats.org/drawingml/2006/main">
               <a:ext uri="{FF2B5EF4-FFF2-40B4-BE49-F238E27FC236}">
-                <a16:creationId xmlns:a16="http://schemas.microsoft.com/office/drawing/2014/main" id="{DBFC345F-BDE6-4349-8C2A-75CF1FBB02C8}"/>
+                <a16:creationId xmlns:a16="http://schemas.microsoft.com/office/drawing/2014/main" id="{52F57AB4-3472-4746-A5AB-B1FD234FF361}"/>
               </a:ext>
             </a:extLst>
           </p:cNvPr>
@@ -14034,7 +14034,7 @@
           <p:cNvPr id="3" name="§2.1.3 · Opgave 7 · Linea en Curva · Boekpagina 26">
             <a:extLst xmlns:a="http://schemas.openxmlformats.org/drawingml/2006/main">
               <a:ext uri="{FF2B5EF4-FFF2-40B4-BE49-F238E27FC236}">
-                <a16:creationId xmlns:a16="http://schemas.microsoft.com/office/drawing/2014/main" id="{B56860FA-9776-41DF-8D60-F01472CD80C7}"/>
+                <a16:creationId xmlns:a16="http://schemas.microsoft.com/office/drawing/2014/main" id="{4B1F9703-A398-449F-8D8F-843040139C7F}"/>
               </a:ext>
             </a:extLst>
           </p:cNvPr>
@@ -14091,7 +14091,7 @@
           <p:cNvPr id="4" name="slide-number">
             <a:extLst xmlns:a="http://schemas.openxmlformats.org/drawingml/2006/main">
               <a:ext uri="{FF2B5EF4-FFF2-40B4-BE49-F238E27FC236}">
-                <a16:creationId xmlns:a16="http://schemas.microsoft.com/office/drawing/2014/main" id="{19BC43F4-F15C-414A-892A-2B8E6EAE67E2}"/>
+                <a16:creationId xmlns:a16="http://schemas.microsoft.com/office/drawing/2014/main" id="{16477A72-B85D-4336-97D5-45D7FD870154}"/>
               </a:ext>
             </a:extLst>
           </p:cNvPr>
@@ -14148,7 +14148,7 @@
           <p:cNvPr id="5" name="d) Bereken voor Curva MK over de drie stappen en MO over de eerst">
             <a:extLst xmlns:a="http://schemas.openxmlformats.org/drawingml/2006/main">
               <a:ext uri="{FF2B5EF4-FFF2-40B4-BE49-F238E27FC236}">
-                <a16:creationId xmlns:a16="http://schemas.microsoft.com/office/drawing/2014/main" id="{A531883F-5BCF-4313-BFC9-60FCACB610CE}"/>
+                <a16:creationId xmlns:a16="http://schemas.microsoft.com/office/drawing/2014/main" id="{D21E2ACB-49EC-4AC6-8FCB-03B69F9229F5}"/>
               </a:ext>
             </a:extLst>
           </p:cNvPr>
@@ -14205,7 +14205,7 @@
           <p:cNvPr id="6" name="">
             <a:extLst xmlns:a="http://schemas.openxmlformats.org/drawingml/2006/main">
               <a:ext uri="{FF2B5EF4-FFF2-40B4-BE49-F238E27FC236}">
-                <a16:creationId xmlns:a16="http://schemas.microsoft.com/office/drawing/2014/main" id="{1381C6FE-30D2-402C-84A4-53D1399224AF}"/>
+                <a16:creationId xmlns:a16="http://schemas.microsoft.com/office/drawing/2014/main" id="{E8975481-EFE2-4DF7-B5A7-1B7A843BA10C}"/>
               </a:ext>
             </a:extLst>
           </p:cNvPr>
@@ -14234,7 +14234,7 @@
           <p:cNvPr id="7" name="e) Vergelijk de MK-patronen. Leg uit wat MK en MO per extra produ">
             <a:extLst xmlns:a="http://schemas.openxmlformats.org/drawingml/2006/main">
               <a:ext uri="{FF2B5EF4-FFF2-40B4-BE49-F238E27FC236}">
-                <a16:creationId xmlns:a16="http://schemas.microsoft.com/office/drawing/2014/main" id="{9B793A93-F045-4E69-9C91-6D41D43910EF}"/>
+                <a16:creationId xmlns:a16="http://schemas.microsoft.com/office/drawing/2014/main" id="{F0595668-8A7D-4599-8A40-2C1C3D583482}"/>
               </a:ext>
             </a:extLst>
           </p:cNvPr>
@@ -14289,7 +14289,7 @@
     </p:spTree>
     <p:extLst>
       <p:ext uri="{BB962C8B-B14F-4D97-AF65-F5344CB8AC3E}">
-        <p14:creationId xmlns:p14="http://schemas.microsoft.com/office/powerpoint/2010/main" val="744800095"/>
+        <p14:creationId xmlns:p14="http://schemas.microsoft.com/office/powerpoint/2010/main" val="367201983"/>
       </p:ext>
     </p:extLst>
   </p:cSld>
@@ -14320,7 +14320,7 @@
           <p:cNvPr id="13" name="Wat kun je na deze les?">
             <a:extLst xmlns:a="http://schemas.openxmlformats.org/drawingml/2006/main">
               <a:ext uri="{FF2B5EF4-FFF2-40B4-BE49-F238E27FC236}">
-                <a16:creationId xmlns:a16="http://schemas.microsoft.com/office/drawing/2014/main" id="{029B60E5-DD2E-4B6D-8B95-FAA6C8A1DFF0}"/>
+                <a16:creationId xmlns:a16="http://schemas.microsoft.com/office/drawing/2014/main" id="{CCA20E45-64DD-4CED-9513-C0DAD09FAE5A}"/>
               </a:ext>
             </a:extLst>
           </p:cNvPr>
@@ -14377,7 +14377,7 @@
           <p:cNvPr id="2" name="">
             <a:extLst xmlns:a="http://schemas.openxmlformats.org/drawingml/2006/main">
               <a:ext uri="{FF2B5EF4-FFF2-40B4-BE49-F238E27FC236}">
-                <a16:creationId xmlns:a16="http://schemas.microsoft.com/office/drawing/2014/main" id="{1C30D4F5-7656-4EC6-816E-F6C674E6E64A}"/>
+                <a16:creationId xmlns:a16="http://schemas.microsoft.com/office/drawing/2014/main" id="{58255C21-A2DA-41A1-A8AD-B8FD0CC7B22E}"/>
               </a:ext>
             </a:extLst>
           </p:cNvPr>
@@ -14406,7 +14406,7 @@
           <p:cNvPr id="3" name="§2.1.3 Marginale kosten en marginale opbrengsten">
             <a:extLst xmlns:a="http://schemas.openxmlformats.org/drawingml/2006/main">
               <a:ext uri="{FF2B5EF4-FFF2-40B4-BE49-F238E27FC236}">
-                <a16:creationId xmlns:a16="http://schemas.microsoft.com/office/drawing/2014/main" id="{7D65ED5C-13F0-4E7C-ADA8-1AD02D91C29D}"/>
+                <a16:creationId xmlns:a16="http://schemas.microsoft.com/office/drawing/2014/main" id="{17666149-4007-42F9-8D4B-1B2F4B89D91B}"/>
               </a:ext>
             </a:extLst>
           </p:cNvPr>
@@ -14463,7 +14463,7 @@
           <p:cNvPr id="4" name="slide-number">
             <a:extLst xmlns:a="http://schemas.openxmlformats.org/drawingml/2006/main">
               <a:ext uri="{FF2B5EF4-FFF2-40B4-BE49-F238E27FC236}">
-                <a16:creationId xmlns:a16="http://schemas.microsoft.com/office/drawing/2014/main" id="{9A3A9B81-A608-42B2-B1B5-1CA1FBDE54BB}"/>
+                <a16:creationId xmlns:a16="http://schemas.microsoft.com/office/drawing/2014/main" id="{1A9A4A3C-F130-48D7-A6A5-9B5BCECC2FED}"/>
               </a:ext>
             </a:extLst>
           </p:cNvPr>
@@ -14520,7 +14520,7 @@
           <p:cNvPr id="5" name="Berekenen">
             <a:extLst xmlns:a="http://schemas.openxmlformats.org/drawingml/2006/main">
               <a:ext uri="{FF2B5EF4-FFF2-40B4-BE49-F238E27FC236}">
-                <a16:creationId xmlns:a16="http://schemas.microsoft.com/office/drawing/2014/main" id="{8B4BAC84-D9B2-4B4D-AE56-0D290B4CA397}"/>
+                <a16:creationId xmlns:a16="http://schemas.microsoft.com/office/drawing/2014/main" id="{632C1880-5606-434A-AD5A-67D432FF6A89}"/>
               </a:ext>
             </a:extLst>
           </p:cNvPr>
@@ -14577,7 +14577,7 @@
           <p:cNvPr id="6" name="Winst binnen één rij; MK en MO tussen twee rijen.">
             <a:extLst xmlns:a="http://schemas.openxmlformats.org/drawingml/2006/main">
               <a:ext uri="{FF2B5EF4-FFF2-40B4-BE49-F238E27FC236}">
-                <a16:creationId xmlns:a16="http://schemas.microsoft.com/office/drawing/2014/main" id="{BD2AADFB-4C40-45C6-AAC1-571E6B2BD8F6}"/>
+                <a16:creationId xmlns:a16="http://schemas.microsoft.com/office/drawing/2014/main" id="{D882CEC8-A0DD-4513-AD42-B4A3F10FB682}"/>
               </a:ext>
             </a:extLst>
           </p:cNvPr>
@@ -14634,7 +14634,7 @@
           <p:cNvPr id="7" name="">
             <a:extLst xmlns:a="http://schemas.openxmlformats.org/drawingml/2006/main">
               <a:ext uri="{FF2B5EF4-FFF2-40B4-BE49-F238E27FC236}">
-                <a16:creationId xmlns:a16="http://schemas.microsoft.com/office/drawing/2014/main" id="{378415F5-3EFD-4818-A910-7F3F90DEB37F}"/>
+                <a16:creationId xmlns:a16="http://schemas.microsoft.com/office/drawing/2014/main" id="{CE58325B-A27C-473D-9465-8CDA76BD0A60}"/>
               </a:ext>
             </a:extLst>
           </p:cNvPr>
@@ -14663,7 +14663,7 @@
           <p:cNvPr id="8" name="Vergelijken">
             <a:extLst xmlns:a="http://schemas.openxmlformats.org/drawingml/2006/main">
               <a:ext uri="{FF2B5EF4-FFF2-40B4-BE49-F238E27FC236}">
-                <a16:creationId xmlns:a16="http://schemas.microsoft.com/office/drawing/2014/main" id="{4AE61E45-9731-49B1-B54A-CBD8DF1983B4}"/>
+                <a16:creationId xmlns:a16="http://schemas.microsoft.com/office/drawing/2014/main" id="{AAAE11FA-D6AD-4CB3-84E9-E62FD0BE9939}"/>
               </a:ext>
             </a:extLst>
           </p:cNvPr>
@@ -14720,7 +14720,7 @@
           <p:cNvPr id="9" name="Constante en stijgende MK herkennen; constante MO verklaren.">
             <a:extLst xmlns:a="http://schemas.openxmlformats.org/drawingml/2006/main">
               <a:ext uri="{FF2B5EF4-FFF2-40B4-BE49-F238E27FC236}">
-                <a16:creationId xmlns:a16="http://schemas.microsoft.com/office/drawing/2014/main" id="{FB1D2ED5-112F-49F2-85FA-894F9721B735}"/>
+                <a16:creationId xmlns:a16="http://schemas.microsoft.com/office/drawing/2014/main" id="{10C9B2F3-C59E-4015-BE12-7AC73864EE2A}"/>
               </a:ext>
             </a:extLst>
           </p:cNvPr>
@@ -14777,7 +14777,7 @@
           <p:cNvPr id="10" name="">
             <a:extLst xmlns:a="http://schemas.openxmlformats.org/drawingml/2006/main">
               <a:ext uri="{FF2B5EF4-FFF2-40B4-BE49-F238E27FC236}">
-                <a16:creationId xmlns:a16="http://schemas.microsoft.com/office/drawing/2014/main" id="{D21C3E16-E660-40F6-B359-C42E1A03B2EF}"/>
+                <a16:creationId xmlns:a16="http://schemas.microsoft.com/office/drawing/2014/main" id="{69A0B3CA-A539-407A-BBB4-57D10310D1F0}"/>
               </a:ext>
             </a:extLst>
           </p:cNvPr>
@@ -14806,7 +14806,7 @@
           <p:cNvPr id="11" name="Uitleggen">
             <a:extLst xmlns:a="http://schemas.openxmlformats.org/drawingml/2006/main">
               <a:ext uri="{FF2B5EF4-FFF2-40B4-BE49-F238E27FC236}">
-                <a16:creationId xmlns:a16="http://schemas.microsoft.com/office/drawing/2014/main" id="{8F196847-1FBD-4FE2-9809-D764CB8A594F}"/>
+                <a16:creationId xmlns:a16="http://schemas.microsoft.com/office/drawing/2014/main" id="{91BC54AA-453D-411D-86EA-DEF1D1C29074}"/>
               </a:ext>
             </a:extLst>
           </p:cNvPr>
@@ -14863,7 +14863,7 @@
           <p:cNvPr id="12" name="De hele tabelstap en de eenheid noemen; gemiddeld van marginaal o">
             <a:extLst xmlns:a="http://schemas.openxmlformats.org/drawingml/2006/main">
               <a:ext uri="{FF2B5EF4-FFF2-40B4-BE49-F238E27FC236}">
-                <a16:creationId xmlns:a16="http://schemas.microsoft.com/office/drawing/2014/main" id="{E9AA9694-ED66-42B0-A0C0-6A9F347635F0}"/>
+                <a16:creationId xmlns:a16="http://schemas.microsoft.com/office/drawing/2014/main" id="{A172D2E7-0F32-4F51-ABAD-4512FB0468C9}"/>
               </a:ext>
             </a:extLst>
           </p:cNvPr>
@@ -14918,7 +14918,7 @@
     </p:spTree>
     <p:extLst>
       <p:ext uri="{BB962C8B-B14F-4D97-AF65-F5344CB8AC3E}">
-        <p14:creationId xmlns:p14="http://schemas.microsoft.com/office/powerpoint/2010/main" val="789619079"/>
+        <p14:creationId xmlns:p14="http://schemas.microsoft.com/office/powerpoint/2010/main" val="1061659902"/>
       </p:ext>
     </p:extLst>
   </p:cSld>
@@ -14949,7 +14949,7 @@
           <p:cNvPr id="8" name="Opgave 7a · Winst bij Linea">
             <a:extLst xmlns:a="http://schemas.openxmlformats.org/drawingml/2006/main">
               <a:ext uri="{FF2B5EF4-FFF2-40B4-BE49-F238E27FC236}">
-                <a16:creationId xmlns:a16="http://schemas.microsoft.com/office/drawing/2014/main" id="{9E06C6DD-E6F3-44D8-9EB0-BDFD555E6416}"/>
+                <a16:creationId xmlns:a16="http://schemas.microsoft.com/office/drawing/2014/main" id="{F3F400CC-92DA-4181-A9F7-4CB6E072670C}"/>
               </a:ext>
             </a:extLst>
           </p:cNvPr>
@@ -15006,7 +15006,7 @@
           <p:cNvPr id="2" name="">
             <a:extLst xmlns:a="http://schemas.openxmlformats.org/drawingml/2006/main">
               <a:ext uri="{FF2B5EF4-FFF2-40B4-BE49-F238E27FC236}">
-                <a16:creationId xmlns:a16="http://schemas.microsoft.com/office/drawing/2014/main" id="{01406AF7-ACAB-4EFC-BA80-282C32566ECD}"/>
+                <a16:creationId xmlns:a16="http://schemas.microsoft.com/office/drawing/2014/main" id="{A430856D-22F4-479B-A673-6721B71B6285}"/>
               </a:ext>
             </a:extLst>
           </p:cNvPr>
@@ -15035,7 +15035,7 @@
           <p:cNvPr id="3" name="§2.1.3 · Opgave 7 · Linea en Curva · Boekpagina 26">
             <a:extLst xmlns:a="http://schemas.openxmlformats.org/drawingml/2006/main">
               <a:ext uri="{FF2B5EF4-FFF2-40B4-BE49-F238E27FC236}">
-                <a16:creationId xmlns:a16="http://schemas.microsoft.com/office/drawing/2014/main" id="{E79A00E3-4F09-47DA-BF79-49CD116B8614}"/>
+                <a16:creationId xmlns:a16="http://schemas.microsoft.com/office/drawing/2014/main" id="{B658340C-9FE4-476B-96CA-22EE6984465D}"/>
               </a:ext>
             </a:extLst>
           </p:cNvPr>
@@ -15092,7 +15092,7 @@
           <p:cNvPr id="4" name="slide-number">
             <a:extLst xmlns:a="http://schemas.openxmlformats.org/drawingml/2006/main">
               <a:ext uri="{FF2B5EF4-FFF2-40B4-BE49-F238E27FC236}">
-                <a16:creationId xmlns:a16="http://schemas.microsoft.com/office/drawing/2014/main" id="{15AFC252-55D7-46FF-AEBE-7E46102ABDC0}"/>
+                <a16:creationId xmlns:a16="http://schemas.microsoft.com/office/drawing/2014/main" id="{9BBD1E86-983B-4BE7-9343-92350FB87B6E}"/>
               </a:ext>
             </a:extLst>
           </p:cNvPr>
@@ -15149,7 +15149,7 @@
           <p:cNvPr id="5" name="Winst = TO − TK">
             <a:extLst xmlns:a="http://schemas.openxmlformats.org/drawingml/2006/main">
               <a:ext uri="{FF2B5EF4-FFF2-40B4-BE49-F238E27FC236}">
-                <a16:creationId xmlns:a16="http://schemas.microsoft.com/office/drawing/2014/main" id="{2D9C069B-0B8C-4C7E-93CE-72B2C20B2EC5}"/>
+                <a16:creationId xmlns:a16="http://schemas.microsoft.com/office/drawing/2014/main" id="{6A5880C4-80BF-4E2C-95D1-34E798D00FAB}"/>
               </a:ext>
             </a:extLst>
           </p:cNvPr>
@@ -15599,7 +15599,7 @@
           <p:cNvPr id="7" name="In elke getoonde rij: TO &lt; TK, dus verlies.">
             <a:extLst xmlns:a="http://schemas.openxmlformats.org/drawingml/2006/main">
               <a:ext uri="{FF2B5EF4-FFF2-40B4-BE49-F238E27FC236}">
-                <a16:creationId xmlns:a16="http://schemas.microsoft.com/office/drawing/2014/main" id="{72DBDAB5-FEF0-4945-8298-463446358608}"/>
+                <a16:creationId xmlns:a16="http://schemas.microsoft.com/office/drawing/2014/main" id="{0DC96574-0568-4EFA-B1C2-666EAE597221}"/>
               </a:ext>
             </a:extLst>
           </p:cNvPr>
@@ -15654,7 +15654,7 @@
     </p:spTree>
     <p:extLst>
       <p:ext uri="{BB962C8B-B14F-4D97-AF65-F5344CB8AC3E}">
-        <p14:creationId xmlns:p14="http://schemas.microsoft.com/office/powerpoint/2010/main" val="110626321"/>
+        <p14:creationId xmlns:p14="http://schemas.microsoft.com/office/powerpoint/2010/main" val="1554430333"/>
       </p:ext>
     </p:extLst>
   </p:cSld>
@@ -15685,7 +15685,7 @@
           <p:cNvPr id="12" name="Opgave 7b · Linea, stap 0 → 10">
             <a:extLst xmlns:a="http://schemas.openxmlformats.org/drawingml/2006/main">
               <a:ext uri="{FF2B5EF4-FFF2-40B4-BE49-F238E27FC236}">
-                <a16:creationId xmlns:a16="http://schemas.microsoft.com/office/drawing/2014/main" id="{2049F4CA-F15B-401E-A388-3939892CC169}"/>
+                <a16:creationId xmlns:a16="http://schemas.microsoft.com/office/drawing/2014/main" id="{1FB4CCFC-E50C-42D3-99A9-A87197FB8B4C}"/>
               </a:ext>
             </a:extLst>
           </p:cNvPr>
@@ -15742,7 +15742,7 @@
           <p:cNvPr id="2" name="">
             <a:extLst xmlns:a="http://schemas.openxmlformats.org/drawingml/2006/main">
               <a:ext uri="{FF2B5EF4-FFF2-40B4-BE49-F238E27FC236}">
-                <a16:creationId xmlns:a16="http://schemas.microsoft.com/office/drawing/2014/main" id="{66BE35F5-F97E-4922-B193-638A247DCC5E}"/>
+                <a16:creationId xmlns:a16="http://schemas.microsoft.com/office/drawing/2014/main" id="{DA24E712-B457-4727-9B24-05A0D3AF58D0}"/>
               </a:ext>
             </a:extLst>
           </p:cNvPr>
@@ -15771,7 +15771,7 @@
           <p:cNvPr id="3" name="§2.1.3 · Opgave 7 · Linea en Curva · Boekpagina 26">
             <a:extLst xmlns:a="http://schemas.openxmlformats.org/drawingml/2006/main">
               <a:ext uri="{FF2B5EF4-FFF2-40B4-BE49-F238E27FC236}">
-                <a16:creationId xmlns:a16="http://schemas.microsoft.com/office/drawing/2014/main" id="{DFF09E79-6F7C-4967-9315-940FCA0BCA93}"/>
+                <a16:creationId xmlns:a16="http://schemas.microsoft.com/office/drawing/2014/main" id="{CFE383D8-6504-44E0-8296-63F30BF0C196}"/>
               </a:ext>
             </a:extLst>
           </p:cNvPr>
@@ -15828,7 +15828,7 @@
           <p:cNvPr id="4" name="slide-number">
             <a:extLst xmlns:a="http://schemas.openxmlformats.org/drawingml/2006/main">
               <a:ext uri="{FF2B5EF4-FFF2-40B4-BE49-F238E27FC236}">
-                <a16:creationId xmlns:a16="http://schemas.microsoft.com/office/drawing/2014/main" id="{A1F62DCD-33A0-42FA-B6B4-9A59A2568C2D}"/>
+                <a16:creationId xmlns:a16="http://schemas.microsoft.com/office/drawing/2014/main" id="{CAF3BB4E-E7C6-4E30-A4D0-AB7ACBCAB4B5}"/>
               </a:ext>
             </a:extLst>
           </p:cNvPr>
@@ -15885,7 +15885,7 @@
           <p:cNvPr id="5" name="ΔQ = 10 − 0 = 10 extra producten">
             <a:extLst xmlns:a="http://schemas.openxmlformats.org/drawingml/2006/main">
               <a:ext uri="{FF2B5EF4-FFF2-40B4-BE49-F238E27FC236}">
-                <a16:creationId xmlns:a16="http://schemas.microsoft.com/office/drawing/2014/main" id="{A94B4364-A6EA-41E4-9A26-5F1405D070DA}"/>
+                <a16:creationId xmlns:a16="http://schemas.microsoft.com/office/drawing/2014/main" id="{B1675C85-C9F4-4496-9194-E9F823F93526}"/>
               </a:ext>
             </a:extLst>
           </p:cNvPr>
@@ -15942,7 +15942,7 @@
           <p:cNvPr id="6" name="MK = ΔTK / ΔQ">
             <a:extLst xmlns:a="http://schemas.openxmlformats.org/drawingml/2006/main">
               <a:ext uri="{FF2B5EF4-FFF2-40B4-BE49-F238E27FC236}">
-                <a16:creationId xmlns:a16="http://schemas.microsoft.com/office/drawing/2014/main" id="{D3DA1F93-020D-4DA1-BB0B-075D60CC26D7}"/>
+                <a16:creationId xmlns:a16="http://schemas.microsoft.com/office/drawing/2014/main" id="{388794F0-F769-4C78-B6B4-4F6E2B2577C3}"/>
               </a:ext>
             </a:extLst>
           </p:cNvPr>
@@ -15999,7 +15999,7 @@
           <p:cNvPr id="7" name="= (230 − 200) / (10 − 0) = 30 / 10">
             <a:extLst xmlns:a="http://schemas.openxmlformats.org/drawingml/2006/main">
               <a:ext uri="{FF2B5EF4-FFF2-40B4-BE49-F238E27FC236}">
-                <a16:creationId xmlns:a16="http://schemas.microsoft.com/office/drawing/2014/main" id="{BBECD11E-1A0D-4515-B594-3CA323184FAA}"/>
+                <a16:creationId xmlns:a16="http://schemas.microsoft.com/office/drawing/2014/main" id="{A9B286CD-E8E5-4882-9C3A-100BC5E62D0B}"/>
               </a:ext>
             </a:extLst>
           </p:cNvPr>
@@ -16056,7 +16056,7 @@
           <p:cNvPr id="8" name="= € 3 per extra product">
             <a:extLst xmlns:a="http://schemas.openxmlformats.org/drawingml/2006/main">
               <a:ext uri="{FF2B5EF4-FFF2-40B4-BE49-F238E27FC236}">
-                <a16:creationId xmlns:a16="http://schemas.microsoft.com/office/drawing/2014/main" id="{C8BF1E0C-32DA-4C5A-8193-9CC6F6B3886B}"/>
+                <a16:creationId xmlns:a16="http://schemas.microsoft.com/office/drawing/2014/main" id="{2AA983FD-6407-4412-B560-72A1BDC16976}"/>
               </a:ext>
             </a:extLst>
           </p:cNvPr>
@@ -16113,7 +16113,7 @@
           <p:cNvPr id="9" name="">
             <a:extLst xmlns:a="http://schemas.openxmlformats.org/drawingml/2006/main">
               <a:ext uri="{FF2B5EF4-FFF2-40B4-BE49-F238E27FC236}">
-                <a16:creationId xmlns:a16="http://schemas.microsoft.com/office/drawing/2014/main" id="{FDF76316-EDC7-426C-8CE4-8797880E1C95}"/>
+                <a16:creationId xmlns:a16="http://schemas.microsoft.com/office/drawing/2014/main" id="{81D7083D-AAD6-4C49-BADB-F09F0B68BFC7}"/>
               </a:ext>
             </a:extLst>
           </p:cNvPr>
@@ -16142,7 +16142,7 @@
           <p:cNvPr id="10" name="MO = ΔTO / ΔQ">
             <a:extLst xmlns:a="http://schemas.openxmlformats.org/drawingml/2006/main">
               <a:ext uri="{FF2B5EF4-FFF2-40B4-BE49-F238E27FC236}">
-                <a16:creationId xmlns:a16="http://schemas.microsoft.com/office/drawing/2014/main" id="{4D505172-F4B8-4696-8522-836EAC70F68A}"/>
+                <a16:creationId xmlns:a16="http://schemas.microsoft.com/office/drawing/2014/main" id="{3E85CAE2-B0E1-455B-A679-3718FB520831}"/>
               </a:ext>
             </a:extLst>
           </p:cNvPr>
@@ -16199,7 +16199,7 @@
           <p:cNvPr id="11" name="= (80 − 0) / (10 − 0) = € 8 per extra product">
             <a:extLst xmlns:a="http://schemas.openxmlformats.org/drawingml/2006/main">
               <a:ext uri="{FF2B5EF4-FFF2-40B4-BE49-F238E27FC236}">
-                <a16:creationId xmlns:a16="http://schemas.microsoft.com/office/drawing/2014/main" id="{2254D386-D8FA-4516-9BEB-1DC4B0AFFFC0}"/>
+                <a16:creationId xmlns:a16="http://schemas.microsoft.com/office/drawing/2014/main" id="{C64F365D-8D8D-4CD4-8712-F1633B77B2CB}"/>
               </a:ext>
             </a:extLst>
           </p:cNvPr>
@@ -16254,7 +16254,7 @@
     </p:spTree>
     <p:extLst>
       <p:ext uri="{BB962C8B-B14F-4D97-AF65-F5344CB8AC3E}">
-        <p14:creationId xmlns:p14="http://schemas.microsoft.com/office/powerpoint/2010/main" val="204121421"/>
+        <p14:creationId xmlns:p14="http://schemas.microsoft.com/office/powerpoint/2010/main" val="2070321507"/>
       </p:ext>
     </p:extLst>
   </p:cSld>
@@ -16285,7 +16285,7 @@
           <p:cNvPr id="9" name="Opgave 7b–c · Linea volledig">
             <a:extLst xmlns:a="http://schemas.openxmlformats.org/drawingml/2006/main">
               <a:ext uri="{FF2B5EF4-FFF2-40B4-BE49-F238E27FC236}">
-                <a16:creationId xmlns:a16="http://schemas.microsoft.com/office/drawing/2014/main" id="{DDCEDF5D-A900-4225-8911-5FF76941CD9E}"/>
+                <a16:creationId xmlns:a16="http://schemas.microsoft.com/office/drawing/2014/main" id="{131CEB2E-0528-46C3-B512-8E7688147900}"/>
               </a:ext>
             </a:extLst>
           </p:cNvPr>
@@ -16342,7 +16342,7 @@
           <p:cNvPr id="2" name="">
             <a:extLst xmlns:a="http://schemas.openxmlformats.org/drawingml/2006/main">
               <a:ext uri="{FF2B5EF4-FFF2-40B4-BE49-F238E27FC236}">
-                <a16:creationId xmlns:a16="http://schemas.microsoft.com/office/drawing/2014/main" id="{FA99F46C-77F2-4903-91B2-DC02AC555EF8}"/>
+                <a16:creationId xmlns:a16="http://schemas.microsoft.com/office/drawing/2014/main" id="{B9F86CE5-D58B-4C87-B997-F96271F7C3A1}"/>
               </a:ext>
             </a:extLst>
           </p:cNvPr>
@@ -16371,7 +16371,7 @@
           <p:cNvPr id="3" name="§2.1.3 · Opgave 7 · Linea en Curva · Boekpagina 26">
             <a:extLst xmlns:a="http://schemas.openxmlformats.org/drawingml/2006/main">
               <a:ext uri="{FF2B5EF4-FFF2-40B4-BE49-F238E27FC236}">
-                <a16:creationId xmlns:a16="http://schemas.microsoft.com/office/drawing/2014/main" id="{9E0BB4E9-DD5A-48F8-A540-51F491D44CF0}"/>
+                <a16:creationId xmlns:a16="http://schemas.microsoft.com/office/drawing/2014/main" id="{33FFC839-48F6-4D00-91C8-91C3F166B034}"/>
               </a:ext>
             </a:extLst>
           </p:cNvPr>
@@ -16428,7 +16428,7 @@
           <p:cNvPr id="4" name="slide-number">
             <a:extLst xmlns:a="http://schemas.openxmlformats.org/drawingml/2006/main">
               <a:ext uri="{FF2B5EF4-FFF2-40B4-BE49-F238E27FC236}">
-                <a16:creationId xmlns:a16="http://schemas.microsoft.com/office/drawing/2014/main" id="{B2A91340-0ED8-4392-8699-309C7EC72C0E}"/>
+                <a16:creationId xmlns:a16="http://schemas.microsoft.com/office/drawing/2014/main" id="{E72ECEF8-0F03-4C72-A184-3B2700DB03A8}"/>
               </a:ext>
             </a:extLst>
           </p:cNvPr>
@@ -16485,7 +16485,7 @@
           <p:cNvPr id="5" name="Q: producten per week · TK, TO en winst: euro per week">
             <a:extLst xmlns:a="http://schemas.openxmlformats.org/drawingml/2006/main">
               <a:ext uri="{FF2B5EF4-FFF2-40B4-BE49-F238E27FC236}">
-                <a16:creationId xmlns:a16="http://schemas.microsoft.com/office/drawing/2014/main" id="{A47F7AEB-567F-4A6F-AA5E-04D2D82DF50B}"/>
+                <a16:creationId xmlns:a16="http://schemas.microsoft.com/office/drawing/2014/main" id="{0B8C07D1-0329-461D-B09A-473406C6172B}"/>
               </a:ext>
             </a:extLst>
           </p:cNvPr>
@@ -17324,7 +17324,7 @@
           <p:cNvPr id="7" name="Elke stap: MK = 30 / 10 = 3 en MO = 80 / 10 = 8">
             <a:extLst xmlns:a="http://schemas.openxmlformats.org/drawingml/2006/main">
               <a:ext uri="{FF2B5EF4-FFF2-40B4-BE49-F238E27FC236}">
-                <a16:creationId xmlns:a16="http://schemas.microsoft.com/office/drawing/2014/main" id="{CC1AB36C-9F0E-4173-90B8-D6837E38677D}"/>
+                <a16:creationId xmlns:a16="http://schemas.microsoft.com/office/drawing/2014/main" id="{0D18CBA2-49E6-4F79-9ABC-C4EE8AFE9BEF}"/>
               </a:ext>
             </a:extLst>
           </p:cNvPr>
@@ -17381,7 +17381,7 @@
           <p:cNvPr id="8" name="MO blijft € 8: ieder extra product wordt voor € 8 verkocht.">
             <a:extLst xmlns:a="http://schemas.openxmlformats.org/drawingml/2006/main">
               <a:ext uri="{FF2B5EF4-FFF2-40B4-BE49-F238E27FC236}">
-                <a16:creationId xmlns:a16="http://schemas.microsoft.com/office/drawing/2014/main" id="{E4A1E71B-E108-4DCA-A0FE-92EE4C3F9739}"/>
+                <a16:creationId xmlns:a16="http://schemas.microsoft.com/office/drawing/2014/main" id="{F04EC868-1873-47E6-86C9-D3556E9776FA}"/>
               </a:ext>
             </a:extLst>
           </p:cNvPr>
@@ -17436,7 +17436,7 @@
     </p:spTree>
     <p:extLst>
       <p:ext uri="{BB962C8B-B14F-4D97-AF65-F5344CB8AC3E}">
-        <p14:creationId xmlns:p14="http://schemas.microsoft.com/office/powerpoint/2010/main" val="670197082"/>
+        <p14:creationId xmlns:p14="http://schemas.microsoft.com/office/powerpoint/2010/main" val="2048027322"/>
       </p:ext>
     </p:extLst>
   </p:cSld>
@@ -17467,7 +17467,7 @@
           <p:cNvPr id="8" name="Opgave 7d · Drie MK-berekeningen bij Curva">
             <a:extLst xmlns:a="http://schemas.openxmlformats.org/drawingml/2006/main">
               <a:ext uri="{FF2B5EF4-FFF2-40B4-BE49-F238E27FC236}">
-                <a16:creationId xmlns:a16="http://schemas.microsoft.com/office/drawing/2014/main" id="{BD3CA0A7-C2E3-42FE-8548-D18AE2B2B093}"/>
+                <a16:creationId xmlns:a16="http://schemas.microsoft.com/office/drawing/2014/main" id="{718A5711-3F5E-478C-A681-7D0898256A44}"/>
               </a:ext>
             </a:extLst>
           </p:cNvPr>
@@ -17524,7 +17524,7 @@
           <p:cNvPr id="2" name="">
             <a:extLst xmlns:a="http://schemas.openxmlformats.org/drawingml/2006/main">
               <a:ext uri="{FF2B5EF4-FFF2-40B4-BE49-F238E27FC236}">
-                <a16:creationId xmlns:a16="http://schemas.microsoft.com/office/drawing/2014/main" id="{FF5B4A7A-A2C8-4FF5-8CFD-4E1BB5C98B6C}"/>
+                <a16:creationId xmlns:a16="http://schemas.microsoft.com/office/drawing/2014/main" id="{FD382662-5C99-434D-B5DE-163914A2D7D6}"/>
               </a:ext>
             </a:extLst>
           </p:cNvPr>
@@ -17553,7 +17553,7 @@
           <p:cNvPr id="3" name="§2.1.3 · Opgave 7 · Linea en Curva · Boekpagina 26">
             <a:extLst xmlns:a="http://schemas.openxmlformats.org/drawingml/2006/main">
               <a:ext uri="{FF2B5EF4-FFF2-40B4-BE49-F238E27FC236}">
-                <a16:creationId xmlns:a16="http://schemas.microsoft.com/office/drawing/2014/main" id="{93E88D0D-ED97-4C89-A4D5-34AC7D9E4E41}"/>
+                <a16:creationId xmlns:a16="http://schemas.microsoft.com/office/drawing/2014/main" id="{B3161E36-4A7C-4155-8DC6-35F9A1820574}"/>
               </a:ext>
             </a:extLst>
           </p:cNvPr>
@@ -17610,7 +17610,7 @@
           <p:cNvPr id="4" name="slide-number">
             <a:extLst xmlns:a="http://schemas.openxmlformats.org/drawingml/2006/main">
               <a:ext uri="{FF2B5EF4-FFF2-40B4-BE49-F238E27FC236}">
-                <a16:creationId xmlns:a16="http://schemas.microsoft.com/office/drawing/2014/main" id="{122B2A51-47A5-4784-99FF-CE6F8A20F667}"/>
+                <a16:creationId xmlns:a16="http://schemas.microsoft.com/office/drawing/2014/main" id="{7FCE1215-7F2F-4E41-A91D-64459C071158}"/>
               </a:ext>
             </a:extLst>
           </p:cNvPr>
@@ -17667,7 +17667,7 @@
           <p:cNvPr id="5" name="MK = ΔTK / ΔQ · elke stap bevat 5 extra producten">
             <a:extLst xmlns:a="http://schemas.openxmlformats.org/drawingml/2006/main">
               <a:ext uri="{FF2B5EF4-FFF2-40B4-BE49-F238E27FC236}">
-                <a16:creationId xmlns:a16="http://schemas.microsoft.com/office/drawing/2014/main" id="{5043F97E-EC04-4A61-9F9D-A117F13F1026}"/>
+                <a16:creationId xmlns:a16="http://schemas.microsoft.com/office/drawing/2014/main" id="{0D2134F0-DDB3-4713-BDDC-ECAF5192442F}"/>
               </a:ext>
             </a:extLst>
           </p:cNvPr>
@@ -18043,7 +18043,7 @@
           <p:cNvPr id="7" name="Extra kosten per groep: € 25 → € 75 → € 125">
             <a:extLst xmlns:a="http://schemas.openxmlformats.org/drawingml/2006/main">
               <a:ext uri="{FF2B5EF4-FFF2-40B4-BE49-F238E27FC236}">
-                <a16:creationId xmlns:a16="http://schemas.microsoft.com/office/drawing/2014/main" id="{D2C96400-DE85-4FAA-BA40-A2884653C7A5}"/>
+                <a16:creationId xmlns:a16="http://schemas.microsoft.com/office/drawing/2014/main" id="{019734C3-46C8-49CB-A282-9EA1DD5B0F91}"/>
               </a:ext>
             </a:extLst>
           </p:cNvPr>
@@ -18098,7 +18098,7 @@
     </p:spTree>
     <p:extLst>
       <p:ext uri="{BB962C8B-B14F-4D97-AF65-F5344CB8AC3E}">
-        <p14:creationId xmlns:p14="http://schemas.microsoft.com/office/powerpoint/2010/main" val="1077293015"/>
+        <p14:creationId xmlns:p14="http://schemas.microsoft.com/office/powerpoint/2010/main" val="1397134243"/>
       </p:ext>
     </p:extLst>
   </p:cSld>
@@ -18129,7 +18129,7 @@
           <p:cNvPr id="10" name="Opgave 7d · MO bij Curva">
             <a:extLst xmlns:a="http://schemas.openxmlformats.org/drawingml/2006/main">
               <a:ext uri="{FF2B5EF4-FFF2-40B4-BE49-F238E27FC236}">
-                <a16:creationId xmlns:a16="http://schemas.microsoft.com/office/drawing/2014/main" id="{C547685D-3849-41A4-A486-449C0D6D441C}"/>
+                <a16:creationId xmlns:a16="http://schemas.microsoft.com/office/drawing/2014/main" id="{445059E4-2EB2-4DD1-AADA-93D81725D398}"/>
               </a:ext>
             </a:extLst>
           </p:cNvPr>
@@ -18186,7 +18186,7 @@
           <p:cNvPr id="2" name="">
             <a:extLst xmlns:a="http://schemas.openxmlformats.org/drawingml/2006/main">
               <a:ext uri="{FF2B5EF4-FFF2-40B4-BE49-F238E27FC236}">
-                <a16:creationId xmlns:a16="http://schemas.microsoft.com/office/drawing/2014/main" id="{F0B249D6-67AF-4C1D-A684-7473EDBB3907}"/>
+                <a16:creationId xmlns:a16="http://schemas.microsoft.com/office/drawing/2014/main" id="{AAEED014-EE3E-4AE9-8697-0CCB8512A4CB}"/>
               </a:ext>
             </a:extLst>
           </p:cNvPr>
@@ -18215,7 +18215,7 @@
           <p:cNvPr id="3" name="§2.1.3 · Opgave 7 · Linea en Curva · Boekpagina 26">
             <a:extLst xmlns:a="http://schemas.openxmlformats.org/drawingml/2006/main">
               <a:ext uri="{FF2B5EF4-FFF2-40B4-BE49-F238E27FC236}">
-                <a16:creationId xmlns:a16="http://schemas.microsoft.com/office/drawing/2014/main" id="{9FEEB3FB-292A-45C7-A161-5BB73525B9F4}"/>
+                <a16:creationId xmlns:a16="http://schemas.microsoft.com/office/drawing/2014/main" id="{FB8971AE-8C26-4148-BFCF-DAF3979F38B0}"/>
               </a:ext>
             </a:extLst>
           </p:cNvPr>
@@ -18272,7 +18272,7 @@
           <p:cNvPr id="4" name="slide-number">
             <a:extLst xmlns:a="http://schemas.openxmlformats.org/drawingml/2006/main">
               <a:ext uri="{FF2B5EF4-FFF2-40B4-BE49-F238E27FC236}">
-                <a16:creationId xmlns:a16="http://schemas.microsoft.com/office/drawing/2014/main" id="{F3E70016-0CBC-4E98-8F93-21446F8CADEE}"/>
+                <a16:creationId xmlns:a16="http://schemas.microsoft.com/office/drawing/2014/main" id="{E844E834-8335-4697-9A97-D2FEA365CEA4}"/>
               </a:ext>
             </a:extLst>
           </p:cNvPr>
@@ -18329,7 +18329,7 @@
           <p:cNvPr id="5" name="Eerste stap: 0 → 5 producten per week">
             <a:extLst xmlns:a="http://schemas.openxmlformats.org/drawingml/2006/main">
               <a:ext uri="{FF2B5EF4-FFF2-40B4-BE49-F238E27FC236}">
-                <a16:creationId xmlns:a16="http://schemas.microsoft.com/office/drawing/2014/main" id="{91CAAD3C-560C-411E-B11D-5ECDD66A0C99}"/>
+                <a16:creationId xmlns:a16="http://schemas.microsoft.com/office/drawing/2014/main" id="{8E25C3B6-1907-45DB-91A5-79D8BDF0FDFC}"/>
               </a:ext>
             </a:extLst>
           </p:cNvPr>
@@ -18386,7 +18386,7 @@
           <p:cNvPr id="6" name="MO = ΔTO / ΔQ">
             <a:extLst xmlns:a="http://schemas.openxmlformats.org/drawingml/2006/main">
               <a:ext uri="{FF2B5EF4-FFF2-40B4-BE49-F238E27FC236}">
-                <a16:creationId xmlns:a16="http://schemas.microsoft.com/office/drawing/2014/main" id="{027FCBB8-E746-44F2-AAC2-8A593F18803C}"/>
+                <a16:creationId xmlns:a16="http://schemas.microsoft.com/office/drawing/2014/main" id="{962BCD69-237B-43BA-A7EB-731179378396}"/>
               </a:ext>
             </a:extLst>
           </p:cNvPr>
@@ -18443,7 +18443,7 @@
           <p:cNvPr id="7" name="= (150 − 0) / (5 − 0) = 150 / 5">
             <a:extLst xmlns:a="http://schemas.openxmlformats.org/drawingml/2006/main">
               <a:ext uri="{FF2B5EF4-FFF2-40B4-BE49-F238E27FC236}">
-                <a16:creationId xmlns:a16="http://schemas.microsoft.com/office/drawing/2014/main" id="{F8CE686A-4307-4B72-81DE-9A3035542BE5}"/>
+                <a16:creationId xmlns:a16="http://schemas.microsoft.com/office/drawing/2014/main" id="{D334CF08-4F04-428B-92AF-3F7A28286626}"/>
               </a:ext>
             </a:extLst>
           </p:cNvPr>
@@ -18500,7 +18500,7 @@
           <p:cNvPr id="8" name="= € 30 per extra product">
             <a:extLst xmlns:a="http://schemas.openxmlformats.org/drawingml/2006/main">
               <a:ext uri="{FF2B5EF4-FFF2-40B4-BE49-F238E27FC236}">
-                <a16:creationId xmlns:a16="http://schemas.microsoft.com/office/drawing/2014/main" id="{F2695260-231E-40B3-9F9C-E54A0E17F3DA}"/>
+                <a16:creationId xmlns:a16="http://schemas.microsoft.com/office/drawing/2014/main" id="{7894F875-A1E6-4076-87D6-E02C1E2F10D6}"/>
               </a:ext>
             </a:extLst>
           </p:cNvPr>
@@ -18557,7 +18557,7 @@
           <p:cNvPr id="9" name="Ook in de volgende stappen: € 150 extra voor 5 extra producten.">
             <a:extLst xmlns:a="http://schemas.openxmlformats.org/drawingml/2006/main">
               <a:ext uri="{FF2B5EF4-FFF2-40B4-BE49-F238E27FC236}">
-                <a16:creationId xmlns:a16="http://schemas.microsoft.com/office/drawing/2014/main" id="{5DC4DD18-648A-4404-B047-D63D964A6A4C}"/>
+                <a16:creationId xmlns:a16="http://schemas.microsoft.com/office/drawing/2014/main" id="{674B1D9F-B2E1-407A-941B-A7A3CFA4FC93}"/>
               </a:ext>
             </a:extLst>
           </p:cNvPr>
@@ -18612,7 +18612,7 @@
     </p:spTree>
     <p:extLst>
       <p:ext uri="{BB962C8B-B14F-4D97-AF65-F5344CB8AC3E}">
-        <p14:creationId xmlns:p14="http://schemas.microsoft.com/office/powerpoint/2010/main" val="1950997030"/>
+        <p14:creationId xmlns:p14="http://schemas.microsoft.com/office/powerpoint/2010/main" val="781397519"/>
       </p:ext>
     </p:extLst>
   </p:cSld>
@@ -18643,7 +18643,7 @@
           <p:cNvPr id="9" name="Opgave 7d · Curva volledig">
             <a:extLst xmlns:a="http://schemas.openxmlformats.org/drawingml/2006/main">
               <a:ext uri="{FF2B5EF4-FFF2-40B4-BE49-F238E27FC236}">
-                <a16:creationId xmlns:a16="http://schemas.microsoft.com/office/drawing/2014/main" id="{2F36943A-2964-427F-A91B-BCC7170B9544}"/>
+                <a16:creationId xmlns:a16="http://schemas.microsoft.com/office/drawing/2014/main" id="{12F282BB-626A-4EB9-A8C1-EB1373AF4450}"/>
               </a:ext>
             </a:extLst>
           </p:cNvPr>
@@ -18700,7 +18700,7 @@
           <p:cNvPr id="2" name="">
             <a:extLst xmlns:a="http://schemas.openxmlformats.org/drawingml/2006/main">
               <a:ext uri="{FF2B5EF4-FFF2-40B4-BE49-F238E27FC236}">
-                <a16:creationId xmlns:a16="http://schemas.microsoft.com/office/drawing/2014/main" id="{876AEC55-6733-444F-A009-58E61ED5B65C}"/>
+                <a16:creationId xmlns:a16="http://schemas.microsoft.com/office/drawing/2014/main" id="{83FEA671-8DB8-4508-8FE8-F7CCFB744850}"/>
               </a:ext>
             </a:extLst>
           </p:cNvPr>
@@ -18729,7 +18729,7 @@
           <p:cNvPr id="3" name="§2.1.3 · Opgave 7 · Linea en Curva · Boekpagina 26">
             <a:extLst xmlns:a="http://schemas.openxmlformats.org/drawingml/2006/main">
               <a:ext uri="{FF2B5EF4-FFF2-40B4-BE49-F238E27FC236}">
-                <a16:creationId xmlns:a16="http://schemas.microsoft.com/office/drawing/2014/main" id="{0259F389-4C30-4181-ABA6-0BC591C61C97}"/>
+                <a16:creationId xmlns:a16="http://schemas.microsoft.com/office/drawing/2014/main" id="{BAD2D99B-557A-49F8-AC34-D3D7E1174DFE}"/>
               </a:ext>
             </a:extLst>
           </p:cNvPr>
@@ -18786,7 +18786,7 @@
           <p:cNvPr id="4" name="slide-number">
             <a:extLst xmlns:a="http://schemas.openxmlformats.org/drawingml/2006/main">
               <a:ext uri="{FF2B5EF4-FFF2-40B4-BE49-F238E27FC236}">
-                <a16:creationId xmlns:a16="http://schemas.microsoft.com/office/drawing/2014/main" id="{7039F490-0063-49F2-9BC1-E5FBE02DB9AB}"/>
+                <a16:creationId xmlns:a16="http://schemas.microsoft.com/office/drawing/2014/main" id="{5BB49289-AD47-4E8B-A8EC-A2F390FB004E}"/>
               </a:ext>
             </a:extLst>
           </p:cNvPr>
@@ -18843,7 +18843,7 @@
           <p:cNvPr id="5" name="Q: producten per week · TK, TO en winst: euro per week">
             <a:extLst xmlns:a="http://schemas.openxmlformats.org/drawingml/2006/main">
               <a:ext uri="{FF2B5EF4-FFF2-40B4-BE49-F238E27FC236}">
-                <a16:creationId xmlns:a16="http://schemas.microsoft.com/office/drawing/2014/main" id="{0687A069-7B83-4C56-984C-CF40230300F7}"/>
+                <a16:creationId xmlns:a16="http://schemas.microsoft.com/office/drawing/2014/main" id="{FC28CCC2-0442-4B2F-B5CE-F2A64566E44A}"/>
               </a:ext>
             </a:extLst>
           </p:cNvPr>
@@ -19682,7 +19682,7 @@
           <p:cNvPr id="7" name="Bij Q = 15 staat de uitkomst van de stap 10 → 15.">
             <a:extLst xmlns:a="http://schemas.openxmlformats.org/drawingml/2006/main">
               <a:ext uri="{FF2B5EF4-FFF2-40B4-BE49-F238E27FC236}">
-                <a16:creationId xmlns:a16="http://schemas.microsoft.com/office/drawing/2014/main" id="{5A473EF1-3B19-4D7D-980B-25651B9C95E7}"/>
+                <a16:creationId xmlns:a16="http://schemas.microsoft.com/office/drawing/2014/main" id="{66977B9F-79C0-44F1-89B3-EE977525E0E6}"/>
               </a:ext>
             </a:extLst>
           </p:cNvPr>
@@ -19739,7 +19739,7 @@
           <p:cNvPr id="8" name="Controle: 5 × € 25 = € 125 extra kosten in die stap.">
             <a:extLst xmlns:a="http://schemas.openxmlformats.org/drawingml/2006/main">
               <a:ext uri="{FF2B5EF4-FFF2-40B4-BE49-F238E27FC236}">
-                <a16:creationId xmlns:a16="http://schemas.microsoft.com/office/drawing/2014/main" id="{CB2D8761-A1B5-4B86-9C1A-FA198501F951}"/>
+                <a16:creationId xmlns:a16="http://schemas.microsoft.com/office/drawing/2014/main" id="{63142DD2-F580-48BF-ABD6-3F2617C9E5A6}"/>
               </a:ext>
             </a:extLst>
           </p:cNvPr>
@@ -19794,7 +19794,7 @@
     </p:spTree>
     <p:extLst>
       <p:ext uri="{BB962C8B-B14F-4D97-AF65-F5344CB8AC3E}">
-        <p14:creationId xmlns:p14="http://schemas.microsoft.com/office/powerpoint/2010/main" val="99776867"/>
+        <p14:creationId xmlns:p14="http://schemas.microsoft.com/office/powerpoint/2010/main" val="1365677912"/>
       </p:ext>
     </p:extLst>
   </p:cSld>
@@ -19825,7 +19825,7 @@
           <p:cNvPr id="9" name="Opgave 7e · Patronen en betekenis">
             <a:extLst xmlns:a="http://schemas.openxmlformats.org/drawingml/2006/main">
               <a:ext uri="{FF2B5EF4-FFF2-40B4-BE49-F238E27FC236}">
-                <a16:creationId xmlns:a16="http://schemas.microsoft.com/office/drawing/2014/main" id="{58A235A5-CB28-48C6-83EA-1B7B91BAD682}"/>
+                <a16:creationId xmlns:a16="http://schemas.microsoft.com/office/drawing/2014/main" id="{2D62BC89-27CA-4A94-8E21-A6B45AA2A8E8}"/>
               </a:ext>
             </a:extLst>
           </p:cNvPr>
@@ -19882,7 +19882,7 @@
           <p:cNvPr id="2" name="">
             <a:extLst xmlns:a="http://schemas.openxmlformats.org/drawingml/2006/main">
               <a:ext uri="{FF2B5EF4-FFF2-40B4-BE49-F238E27FC236}">
-                <a16:creationId xmlns:a16="http://schemas.microsoft.com/office/drawing/2014/main" id="{6E685F13-6FB4-4808-A831-294DF3EB538B}"/>
+                <a16:creationId xmlns:a16="http://schemas.microsoft.com/office/drawing/2014/main" id="{028FADD2-9A79-4B78-AB1C-80E3C24DBDBB}"/>
               </a:ext>
             </a:extLst>
           </p:cNvPr>
@@ -19911,7 +19911,7 @@
           <p:cNvPr id="3" name="§2.1.3 · Opgave 7 · Linea en Curva · Boekpagina 26">
             <a:extLst xmlns:a="http://schemas.openxmlformats.org/drawingml/2006/main">
               <a:ext uri="{FF2B5EF4-FFF2-40B4-BE49-F238E27FC236}">
-                <a16:creationId xmlns:a16="http://schemas.microsoft.com/office/drawing/2014/main" id="{827D0721-1802-499E-94F4-43E19AE850C0}"/>
+                <a16:creationId xmlns:a16="http://schemas.microsoft.com/office/drawing/2014/main" id="{93DDBD74-DBA2-4BFE-876C-84190CDDC8B4}"/>
               </a:ext>
             </a:extLst>
           </p:cNvPr>
@@ -19968,7 +19968,7 @@
           <p:cNvPr id="4" name="slide-number">
             <a:extLst xmlns:a="http://schemas.openxmlformats.org/drawingml/2006/main">
               <a:ext uri="{FF2B5EF4-FFF2-40B4-BE49-F238E27FC236}">
-                <a16:creationId xmlns:a16="http://schemas.microsoft.com/office/drawing/2014/main" id="{6B1569F1-7910-4DDC-9762-C0F92A8232DF}"/>
+                <a16:creationId xmlns:a16="http://schemas.microsoft.com/office/drawing/2014/main" id="{CEEE607C-47AB-4B70-A62C-80BE9BBDE297}"/>
               </a:ext>
             </a:extLst>
           </p:cNvPr>
@@ -20270,7 +20270,7 @@
           <p:cNvPr id="6" name="MK: extra totale kosten / extra producten">
             <a:extLst xmlns:a="http://schemas.openxmlformats.org/drawingml/2006/main">
               <a:ext uri="{FF2B5EF4-FFF2-40B4-BE49-F238E27FC236}">
-                <a16:creationId xmlns:a16="http://schemas.microsoft.com/office/drawing/2014/main" id="{E029F59F-3878-41E1-9228-81E45E5FDB11}"/>
+                <a16:creationId xmlns:a16="http://schemas.microsoft.com/office/drawing/2014/main" id="{989C0663-BA75-4E67-994D-B5E8B94ADD01}"/>
               </a:ext>
             </a:extLst>
           </p:cNvPr>
@@ -20327,7 +20327,7 @@
           <p:cNvPr id="7" name="MO: extra totale opbrengst / extra verkochte producten">
             <a:extLst xmlns:a="http://schemas.openxmlformats.org/drawingml/2006/main">
               <a:ext uri="{FF2B5EF4-FFF2-40B4-BE49-F238E27FC236}">
-                <a16:creationId xmlns:a16="http://schemas.microsoft.com/office/drawing/2014/main" id="{7DD3BC88-56BF-4C29-A5F6-1B5FB9748207}"/>
+                <a16:creationId xmlns:a16="http://schemas.microsoft.com/office/drawing/2014/main" id="{C693EDED-E565-44B9-9E3F-732F56C566D1}"/>
               </a:ext>
             </a:extLst>
           </p:cNvPr>
@@ -20384,7 +20384,7 @@
           <p:cNvPr id="8" name="Beide uitkomsten beschrijven de hele genoemde tabelstap.">
             <a:extLst xmlns:a="http://schemas.openxmlformats.org/drawingml/2006/main">
               <a:ext uri="{FF2B5EF4-FFF2-40B4-BE49-F238E27FC236}">
-                <a16:creationId xmlns:a16="http://schemas.microsoft.com/office/drawing/2014/main" id="{BBD99C5B-D23B-4022-8C8D-96713B7D32B2}"/>
+                <a16:creationId xmlns:a16="http://schemas.microsoft.com/office/drawing/2014/main" id="{8382A37C-2B8C-4CFE-902A-67D30F11B85E}"/>
               </a:ext>
             </a:extLst>
           </p:cNvPr>
@@ -20439,7 +20439,7 @@
     </p:spTree>
     <p:extLst>
       <p:ext uri="{BB962C8B-B14F-4D97-AF65-F5344CB8AC3E}">
-        <p14:creationId xmlns:p14="http://schemas.microsoft.com/office/powerpoint/2010/main" val="1230145393"/>
+        <p14:creationId xmlns:p14="http://schemas.microsoft.com/office/powerpoint/2010/main" val="112250354"/>
       </p:ext>
     </p:extLst>
   </p:cSld>
@@ -20470,7 +20470,7 @@
           <p:cNvPr id="29" name="Deze les: §2.1.3 Marginale kosten en marginale opbrengsten">
             <a:extLst xmlns:a="http://schemas.openxmlformats.org/drawingml/2006/main">
               <a:ext uri="{FF2B5EF4-FFF2-40B4-BE49-F238E27FC236}">
-                <a16:creationId xmlns:a16="http://schemas.microsoft.com/office/drawing/2014/main" id="{CAB88119-0A66-452B-AB20-EAA5862A8219}"/>
+                <a16:creationId xmlns:a16="http://schemas.microsoft.com/office/drawing/2014/main" id="{0C5BCF3C-1376-4FAB-B59C-D6E3D134E349}"/>
               </a:ext>
             </a:extLst>
           </p:cNvPr>
@@ -20527,7 +20527,7 @@
           <p:cNvPr id="2" name="">
             <a:extLst xmlns:a="http://schemas.openxmlformats.org/drawingml/2006/main">
               <a:ext uri="{FF2B5EF4-FFF2-40B4-BE49-F238E27FC236}">
-                <a16:creationId xmlns:a16="http://schemas.microsoft.com/office/drawing/2014/main" id="{ED0BDB4C-2AEC-4F32-B65E-ED93AC7EA418}"/>
+                <a16:creationId xmlns:a16="http://schemas.microsoft.com/office/drawing/2014/main" id="{89DD467D-3627-4B82-BB5C-08879D57B226}"/>
               </a:ext>
             </a:extLst>
           </p:cNvPr>
@@ -20556,7 +20556,7 @@
           <p:cNvPr id="3" name="§2.1.3 Marginale kosten en marginale opbrengsten">
             <a:extLst xmlns:a="http://schemas.openxmlformats.org/drawingml/2006/main">
               <a:ext uri="{FF2B5EF4-FFF2-40B4-BE49-F238E27FC236}">
-                <a16:creationId xmlns:a16="http://schemas.microsoft.com/office/drawing/2014/main" id="{E41DD8CD-ACE2-4998-BADB-55C77F8B9A21}"/>
+                <a16:creationId xmlns:a16="http://schemas.microsoft.com/office/drawing/2014/main" id="{91E14084-046D-4200-9A03-B00033E3D1F6}"/>
               </a:ext>
             </a:extLst>
           </p:cNvPr>
@@ -20613,7 +20613,7 @@
           <p:cNvPr id="4" name="slide-number">
             <a:extLst xmlns:a="http://schemas.openxmlformats.org/drawingml/2006/main">
               <a:ext uri="{FF2B5EF4-FFF2-40B4-BE49-F238E27FC236}">
-                <a16:creationId xmlns:a16="http://schemas.microsoft.com/office/drawing/2014/main" id="{4EC9E474-75C3-4EBC-950A-AA520DC554A3}"/>
+                <a16:creationId xmlns:a16="http://schemas.microsoft.com/office/drawing/2014/main" id="{5B4E4921-4148-4625-AC42-A1D743C95DDB}"/>
               </a:ext>
             </a:extLst>
           </p:cNvPr>
@@ -20670,7 +20670,7 @@
           <p:cNvPr id="5" name="phase">
             <a:extLst xmlns:a="http://schemas.openxmlformats.org/drawingml/2006/main">
               <a:ext uri="{FF2B5EF4-FFF2-40B4-BE49-F238E27FC236}">
-                <a16:creationId xmlns:a16="http://schemas.microsoft.com/office/drawing/2014/main" id="{9FD91369-478E-4964-9386-E71B572E8187}"/>
+                <a16:creationId xmlns:a16="http://schemas.microsoft.com/office/drawing/2014/main" id="{2260C801-7320-4DFE-966F-76E7AF2C620B}"/>
               </a:ext>
             </a:extLst>
           </p:cNvPr>
@@ -20727,7 +20727,7 @@
           <p:cNvPr id="6" name="Lesroute">
             <a:extLst xmlns:a="http://schemas.openxmlformats.org/drawingml/2006/main">
               <a:ext uri="{FF2B5EF4-FFF2-40B4-BE49-F238E27FC236}">
-                <a16:creationId xmlns:a16="http://schemas.microsoft.com/office/drawing/2014/main" id="{87286D1F-EF5C-4E27-9955-AFA27E182081}"/>
+                <a16:creationId xmlns:a16="http://schemas.microsoft.com/office/drawing/2014/main" id="{94B3177A-0B3C-40C6-AD43-05007135139B}"/>
               </a:ext>
             </a:extLst>
           </p:cNvPr>
@@ -20784,7 +20784,7 @@
           <p:cNvPr id="7" name="route-number-1">
             <a:extLst xmlns:a="http://schemas.openxmlformats.org/drawingml/2006/main">
               <a:ext uri="{FF2B5EF4-FFF2-40B4-BE49-F238E27FC236}">
-                <a16:creationId xmlns:a16="http://schemas.microsoft.com/office/drawing/2014/main" id="{F657A20C-F766-47A5-B062-636164DC4BC8}"/>
+                <a16:creationId xmlns:a16="http://schemas.microsoft.com/office/drawing/2014/main" id="{B061E072-9D3E-40A3-AAF9-01BE354384F7}"/>
               </a:ext>
             </a:extLst>
           </p:cNvPr>
@@ -20841,7 +20841,7 @@
           <p:cNvPr id="8" name="route-1">
             <a:extLst xmlns:a="http://schemas.openxmlformats.org/drawingml/2006/main">
               <a:ext uri="{FF2B5EF4-FFF2-40B4-BE49-F238E27FC236}">
-                <a16:creationId xmlns:a16="http://schemas.microsoft.com/office/drawing/2014/main" id="{05D435B8-DF2D-44FC-8F25-2C269A4ABE27}"/>
+                <a16:creationId xmlns:a16="http://schemas.microsoft.com/office/drawing/2014/main" id="{3518B66C-DA56-4D71-9AB4-BDBA543F5E18}"/>
               </a:ext>
             </a:extLst>
           </p:cNvPr>
@@ -20898,7 +20898,7 @@
           <p:cNvPr id="9" name="route-number-2">
             <a:extLst xmlns:a="http://schemas.openxmlformats.org/drawingml/2006/main">
               <a:ext uri="{FF2B5EF4-FFF2-40B4-BE49-F238E27FC236}">
-                <a16:creationId xmlns:a16="http://schemas.microsoft.com/office/drawing/2014/main" id="{C21A5C5C-304D-4585-BB27-B27813D47BF8}"/>
+                <a16:creationId xmlns:a16="http://schemas.microsoft.com/office/drawing/2014/main" id="{9BC75BC8-B086-4C4A-AA04-08C38AC8AC0B}"/>
               </a:ext>
             </a:extLst>
           </p:cNvPr>
@@ -20955,7 +20955,7 @@
           <p:cNvPr id="10" name="route-2">
             <a:extLst xmlns:a="http://schemas.openxmlformats.org/drawingml/2006/main">
               <a:ext uri="{FF2B5EF4-FFF2-40B4-BE49-F238E27FC236}">
-                <a16:creationId xmlns:a16="http://schemas.microsoft.com/office/drawing/2014/main" id="{FFF3F18E-7765-4123-BF75-9D7545C88ADA}"/>
+                <a16:creationId xmlns:a16="http://schemas.microsoft.com/office/drawing/2014/main" id="{25A26268-E054-4C50-95F8-69AC079A50BC}"/>
               </a:ext>
             </a:extLst>
           </p:cNvPr>
@@ -21012,7 +21012,7 @@
           <p:cNvPr id="11" name="route-number-3">
             <a:extLst xmlns:a="http://schemas.openxmlformats.org/drawingml/2006/main">
               <a:ext uri="{FF2B5EF4-FFF2-40B4-BE49-F238E27FC236}">
-                <a16:creationId xmlns:a16="http://schemas.microsoft.com/office/drawing/2014/main" id="{AA6F30B1-3F1C-44E9-B243-518F3783A6EA}"/>
+                <a16:creationId xmlns:a16="http://schemas.microsoft.com/office/drawing/2014/main" id="{13CC00B1-B2F6-4A26-9CCB-4D70F729DFFC}"/>
               </a:ext>
             </a:extLst>
           </p:cNvPr>
@@ -21069,7 +21069,7 @@
           <p:cNvPr id="12" name="route-3">
             <a:extLst xmlns:a="http://schemas.openxmlformats.org/drawingml/2006/main">
               <a:ext uri="{FF2B5EF4-FFF2-40B4-BE49-F238E27FC236}">
-                <a16:creationId xmlns:a16="http://schemas.microsoft.com/office/drawing/2014/main" id="{1962B42D-70E2-4309-A68D-C4812D79D332}"/>
+                <a16:creationId xmlns:a16="http://schemas.microsoft.com/office/drawing/2014/main" id="{F129F067-CFC3-4540-918E-7B60B513951A}"/>
               </a:ext>
             </a:extLst>
           </p:cNvPr>
@@ -21126,7 +21126,7 @@
           <p:cNvPr id="13" name="route-number-4">
             <a:extLst xmlns:a="http://schemas.openxmlformats.org/drawingml/2006/main">
               <a:ext uri="{FF2B5EF4-FFF2-40B4-BE49-F238E27FC236}">
-                <a16:creationId xmlns:a16="http://schemas.microsoft.com/office/drawing/2014/main" id="{F30831F0-E9F6-4D5D-90A6-188A58E39648}"/>
+                <a16:creationId xmlns:a16="http://schemas.microsoft.com/office/drawing/2014/main" id="{F3A804A4-F92A-4C2A-A2B6-CD57961766BD}"/>
               </a:ext>
             </a:extLst>
           </p:cNvPr>
@@ -21183,7 +21183,7 @@
           <p:cNvPr id="14" name="route-4">
             <a:extLst xmlns:a="http://schemas.openxmlformats.org/drawingml/2006/main">
               <a:ext uri="{FF2B5EF4-FFF2-40B4-BE49-F238E27FC236}">
-                <a16:creationId xmlns:a16="http://schemas.microsoft.com/office/drawing/2014/main" id="{C2863957-CE1B-47C3-B122-A5A329820B2F}"/>
+                <a16:creationId xmlns:a16="http://schemas.microsoft.com/office/drawing/2014/main" id="{A389006E-F224-47E8-B467-2EF78B69A51C}"/>
               </a:ext>
             </a:extLst>
           </p:cNvPr>
@@ -21240,7 +21240,7 @@
           <p:cNvPr id="15" name="route-number-5">
             <a:extLst xmlns:a="http://schemas.openxmlformats.org/drawingml/2006/main">
               <a:ext uri="{FF2B5EF4-FFF2-40B4-BE49-F238E27FC236}">
-                <a16:creationId xmlns:a16="http://schemas.microsoft.com/office/drawing/2014/main" id="{ED5D27D6-EC2E-4B50-A712-7D39056793AD}"/>
+                <a16:creationId xmlns:a16="http://schemas.microsoft.com/office/drawing/2014/main" id="{8B273A04-6EDD-45D8-9EB0-C0E96C6E0E13}"/>
               </a:ext>
             </a:extLst>
           </p:cNvPr>
@@ -21297,7 +21297,7 @@
           <p:cNvPr id="16" name="route-5">
             <a:extLst xmlns:a="http://schemas.openxmlformats.org/drawingml/2006/main">
               <a:ext uri="{FF2B5EF4-FFF2-40B4-BE49-F238E27FC236}">
-                <a16:creationId xmlns:a16="http://schemas.microsoft.com/office/drawing/2014/main" id="{CA71DD5F-5D97-4A37-BCA1-75A6BC6080CD}"/>
+                <a16:creationId xmlns:a16="http://schemas.microsoft.com/office/drawing/2014/main" id="{B79C89A7-BE0D-4611-9A36-A1A4240BC8AD}"/>
               </a:ext>
             </a:extLst>
           </p:cNvPr>
@@ -21354,7 +21354,7 @@
           <p:cNvPr id="17" name="route-number-6">
             <a:extLst xmlns:a="http://schemas.openxmlformats.org/drawingml/2006/main">
               <a:ext uri="{FF2B5EF4-FFF2-40B4-BE49-F238E27FC236}">
-                <a16:creationId xmlns:a16="http://schemas.microsoft.com/office/drawing/2014/main" id="{CAAB727A-6A61-4A9B-8FA5-9D19D5502124}"/>
+                <a16:creationId xmlns:a16="http://schemas.microsoft.com/office/drawing/2014/main" id="{C3ADF5C1-BCCC-4B74-B1C8-75604F03F657}"/>
               </a:ext>
             </a:extLst>
           </p:cNvPr>
@@ -21411,7 +21411,7 @@
           <p:cNvPr id="18" name="route-6">
             <a:extLst xmlns:a="http://schemas.openxmlformats.org/drawingml/2006/main">
               <a:ext uri="{FF2B5EF4-FFF2-40B4-BE49-F238E27FC236}">
-                <a16:creationId xmlns:a16="http://schemas.microsoft.com/office/drawing/2014/main" id="{E360602D-E572-44DA-BF39-547444AC15AE}"/>
+                <a16:creationId xmlns:a16="http://schemas.microsoft.com/office/drawing/2014/main" id="{C3B1F2B4-3BAF-45DE-AE11-7CAFFAC09A2B}"/>
               </a:ext>
             </a:extLst>
           </p:cNvPr>
@@ -21468,7 +21468,7 @@
           <p:cNvPr id="19" name="route-number-7">
             <a:extLst xmlns:a="http://schemas.openxmlformats.org/drawingml/2006/main">
               <a:ext uri="{FF2B5EF4-FFF2-40B4-BE49-F238E27FC236}">
-                <a16:creationId xmlns:a16="http://schemas.microsoft.com/office/drawing/2014/main" id="{B5B1E6A2-C26F-49D4-94D8-8A37DE8C9C51}"/>
+                <a16:creationId xmlns:a16="http://schemas.microsoft.com/office/drawing/2014/main" id="{E9D83D55-AAFC-4B03-9F37-0CD7070E4FC4}"/>
               </a:ext>
             </a:extLst>
           </p:cNvPr>
@@ -21525,7 +21525,7 @@
           <p:cNvPr id="20" name="route-7">
             <a:extLst xmlns:a="http://schemas.openxmlformats.org/drawingml/2006/main">
               <a:ext uri="{FF2B5EF4-FFF2-40B4-BE49-F238E27FC236}">
-                <a16:creationId xmlns:a16="http://schemas.microsoft.com/office/drawing/2014/main" id="{DA7AA10A-FF57-4E97-AED8-FA72FBC548F0}"/>
+                <a16:creationId xmlns:a16="http://schemas.microsoft.com/office/drawing/2014/main" id="{B0B0A06C-3F09-42D9-82ED-B79B0220CF93}"/>
               </a:ext>
             </a:extLst>
           </p:cNvPr>
@@ -21582,7 +21582,7 @@
           <p:cNvPr id="21" name="Lesdoelen">
             <a:extLst xmlns:a="http://schemas.openxmlformats.org/drawingml/2006/main">
               <a:ext uri="{FF2B5EF4-FFF2-40B4-BE49-F238E27FC236}">
-                <a16:creationId xmlns:a16="http://schemas.microsoft.com/office/drawing/2014/main" id="{67248BCE-2A51-4ADE-AD7D-F33BF904D569}"/>
+                <a16:creationId xmlns:a16="http://schemas.microsoft.com/office/drawing/2014/main" id="{60ACF909-E449-487F-A785-8B58152D0F1D}"/>
               </a:ext>
             </a:extLst>
           </p:cNvPr>
@@ -21639,7 +21639,7 @@
           <p:cNvPr id="22" name="overview-goals">
             <a:extLst xmlns:a="http://schemas.openxmlformats.org/drawingml/2006/main">
               <a:ext uri="{FF2B5EF4-FFF2-40B4-BE49-F238E27FC236}">
-                <a16:creationId xmlns:a16="http://schemas.microsoft.com/office/drawing/2014/main" id="{44204C13-007B-45AB-B65F-A7C2414E65D4}"/>
+                <a16:creationId xmlns:a16="http://schemas.microsoft.com/office/drawing/2014/main" id="{0A256A6A-3CEA-4F70-86C2-EDA85BACDD84}"/>
               </a:ext>
             </a:extLst>
           </p:cNvPr>
@@ -21742,7 +21742,7 @@
           <p:cNvPr id="23" name="">
             <a:extLst xmlns:a="http://schemas.openxmlformats.org/drawingml/2006/main">
               <a:ext uri="{FF2B5EF4-FFF2-40B4-BE49-F238E27FC236}">
-                <a16:creationId xmlns:a16="http://schemas.microsoft.com/office/drawing/2014/main" id="{FA5E8BF9-76CE-4DAF-BEA5-BE64614AD628}"/>
+                <a16:creationId xmlns:a16="http://schemas.microsoft.com/office/drawing/2014/main" id="{FAC1C7FD-902E-4AF6-A55A-C2BC311AC803}"/>
               </a:ext>
             </a:extLst>
           </p:cNvPr>
@@ -21771,7 +21771,7 @@
           <p:cNvPr id="24" name="Startopdracht">
             <a:extLst xmlns:a="http://schemas.openxmlformats.org/drawingml/2006/main">
               <a:ext uri="{FF2B5EF4-FFF2-40B4-BE49-F238E27FC236}">
-                <a16:creationId xmlns:a16="http://schemas.microsoft.com/office/drawing/2014/main" id="{A7E9FA3C-373E-4E57-ABDD-62CC4DC419F3}"/>
+                <a16:creationId xmlns:a16="http://schemas.microsoft.com/office/drawing/2014/main" id="{74A4BE80-0761-4DC8-A328-F16EDE3507BF}"/>
               </a:ext>
             </a:extLst>
           </p:cNvPr>
@@ -21828,7 +21828,7 @@
           <p:cNvPr id="25" name="overview-start">
             <a:extLst xmlns:a="http://schemas.openxmlformats.org/drawingml/2006/main">
               <a:ext uri="{FF2B5EF4-FFF2-40B4-BE49-F238E27FC236}">
-                <a16:creationId xmlns:a16="http://schemas.microsoft.com/office/drawing/2014/main" id="{B7428821-71B8-4774-921F-029AF369AABE}"/>
+                <a16:creationId xmlns:a16="http://schemas.microsoft.com/office/drawing/2014/main" id="{AFA24F10-B6E6-43AC-9771-CE7EA4E293A3}"/>
               </a:ext>
             </a:extLst>
           </p:cNvPr>
@@ -21908,7 +21908,7 @@
           <p:cNvPr id="26" name="">
             <a:extLst xmlns:a="http://schemas.openxmlformats.org/drawingml/2006/main">
               <a:ext uri="{FF2B5EF4-FFF2-40B4-BE49-F238E27FC236}">
-                <a16:creationId xmlns:a16="http://schemas.microsoft.com/office/drawing/2014/main" id="{3CDF6DD2-1FFC-48C3-8622-6823C1323658}"/>
+                <a16:creationId xmlns:a16="http://schemas.microsoft.com/office/drawing/2014/main" id="{237FB9C8-2FC3-487E-9E6E-135C7CEFE2C6}"/>
               </a:ext>
             </a:extLst>
           </p:cNvPr>
@@ -21937,7 +21937,7 @@
           <p:cNvPr id="27" name="Huiswerk">
             <a:extLst xmlns:a="http://schemas.openxmlformats.org/drawingml/2006/main">
               <a:ext uri="{FF2B5EF4-FFF2-40B4-BE49-F238E27FC236}">
-                <a16:creationId xmlns:a16="http://schemas.microsoft.com/office/drawing/2014/main" id="{E909F3DE-5EEE-423A-AE89-1CA0B7129DA2}"/>
+                <a16:creationId xmlns:a16="http://schemas.microsoft.com/office/drawing/2014/main" id="{8F59D4E0-38F2-41A4-8B60-17418A2C5B81}"/>
               </a:ext>
             </a:extLst>
           </p:cNvPr>
@@ -21994,7 +21994,7 @@
           <p:cNvPr id="28" name="overview-homework">
             <a:extLst xmlns:a="http://schemas.openxmlformats.org/drawingml/2006/main">
               <a:ext uri="{FF2B5EF4-FFF2-40B4-BE49-F238E27FC236}">
-                <a16:creationId xmlns:a16="http://schemas.microsoft.com/office/drawing/2014/main" id="{4DDF334C-6892-453D-BA79-66431012920A}"/>
+                <a16:creationId xmlns:a16="http://schemas.microsoft.com/office/drawing/2014/main" id="{410A5A11-A189-4818-9A83-2991D749194E}"/>
               </a:ext>
             </a:extLst>
           </p:cNvPr>
@@ -22141,7 +22141,7 @@
     </p:spTree>
     <p:extLst>
       <p:ext uri="{BB962C8B-B14F-4D97-AF65-F5344CB8AC3E}">
-        <p14:creationId xmlns:p14="http://schemas.microsoft.com/office/powerpoint/2010/main" val="568006362"/>
+        <p14:creationId xmlns:p14="http://schemas.microsoft.com/office/powerpoint/2010/main" val="735021047"/>
       </p:ext>
     </p:extLst>
   </p:cSld>
@@ -22172,7 +22172,7 @@
           <p:cNvPr id="8" name="Marginaal: het bedrag per extra product">
             <a:extLst xmlns:a="http://schemas.openxmlformats.org/drawingml/2006/main">
               <a:ext uri="{FF2B5EF4-FFF2-40B4-BE49-F238E27FC236}">
-                <a16:creationId xmlns:a16="http://schemas.microsoft.com/office/drawing/2014/main" id="{3E5AECFB-40FB-47A3-BE84-190E9B63DE7D}"/>
+                <a16:creationId xmlns:a16="http://schemas.microsoft.com/office/drawing/2014/main" id="{712D401A-D6FF-4436-8553-1E2FE1E3C2E4}"/>
               </a:ext>
             </a:extLst>
           </p:cNvPr>
@@ -22229,7 +22229,7 @@
           <p:cNvPr id="2" name="">
             <a:extLst xmlns:a="http://schemas.openxmlformats.org/drawingml/2006/main">
               <a:ext uri="{FF2B5EF4-FFF2-40B4-BE49-F238E27FC236}">
-                <a16:creationId xmlns:a16="http://schemas.microsoft.com/office/drawing/2014/main" id="{691E4EFF-7D4C-4047-B39E-3AF607720827}"/>
+                <a16:creationId xmlns:a16="http://schemas.microsoft.com/office/drawing/2014/main" id="{1D86F0CD-6036-4898-97CD-FD4B78C1972A}"/>
               </a:ext>
             </a:extLst>
           </p:cNvPr>
@@ -22258,7 +22258,7 @@
           <p:cNvPr id="3" name="§2.1.3 Marginale kosten en marginale opbrengsten">
             <a:extLst xmlns:a="http://schemas.openxmlformats.org/drawingml/2006/main">
               <a:ext uri="{FF2B5EF4-FFF2-40B4-BE49-F238E27FC236}">
-                <a16:creationId xmlns:a16="http://schemas.microsoft.com/office/drawing/2014/main" id="{1D5DD0B1-7A29-49E4-9486-D4BDE5ED3AA8}"/>
+                <a16:creationId xmlns:a16="http://schemas.microsoft.com/office/drawing/2014/main" id="{6A07B7CF-3D50-46E0-A409-BDB1FF42D13C}"/>
               </a:ext>
             </a:extLst>
           </p:cNvPr>
@@ -22315,7 +22315,7 @@
           <p:cNvPr id="4" name="slide-number">
             <a:extLst xmlns:a="http://schemas.openxmlformats.org/drawingml/2006/main">
               <a:ext uri="{FF2B5EF4-FFF2-40B4-BE49-F238E27FC236}">
-                <a16:creationId xmlns:a16="http://schemas.microsoft.com/office/drawing/2014/main" id="{35FBB363-AE09-4CED-8709-05C40578E6F4}"/>
+                <a16:creationId xmlns:a16="http://schemas.microsoft.com/office/drawing/2014/main" id="{0DEA2FE2-8F68-481F-B62B-87229BA62667}"/>
               </a:ext>
             </a:extLst>
           </p:cNvPr>
@@ -22617,7 +22617,7 @@
           <p:cNvPr id="6" name="Δ = verandering = nieuw − oud">
             <a:extLst xmlns:a="http://schemas.openxmlformats.org/drawingml/2006/main">
               <a:ext uri="{FF2B5EF4-FFF2-40B4-BE49-F238E27FC236}">
-                <a16:creationId xmlns:a16="http://schemas.microsoft.com/office/drawing/2014/main" id="{296D18E9-620C-4A5C-BA5A-0E6883798DE2}"/>
+                <a16:creationId xmlns:a16="http://schemas.microsoft.com/office/drawing/2014/main" id="{B6E3CBAA-CEE4-49D6-87F8-76EB18F09FCD}"/>
               </a:ext>
             </a:extLst>
           </p:cNvPr>
@@ -22674,7 +22674,7 @@
           <p:cNvPr id="7" name="Dezelfde periode · dezelfde tabelstap">
             <a:extLst xmlns:a="http://schemas.openxmlformats.org/drawingml/2006/main">
               <a:ext uri="{FF2B5EF4-FFF2-40B4-BE49-F238E27FC236}">
-                <a16:creationId xmlns:a16="http://schemas.microsoft.com/office/drawing/2014/main" id="{45274E2C-405E-4329-B9C1-A3F558080F43}"/>
+                <a16:creationId xmlns:a16="http://schemas.microsoft.com/office/drawing/2014/main" id="{0A62408C-9AE6-4615-B7F0-2B82C2D962C7}"/>
               </a:ext>
             </a:extLst>
           </p:cNvPr>
@@ -22729,7 +22729,7 @@
     </p:spTree>
     <p:extLst>
       <p:ext uri="{BB962C8B-B14F-4D97-AF65-F5344CB8AC3E}">
-        <p14:creationId xmlns:p14="http://schemas.microsoft.com/office/powerpoint/2010/main" val="1381718354"/>
+        <p14:creationId xmlns:p14="http://schemas.microsoft.com/office/powerpoint/2010/main" val="120005115"/>
       </p:ext>
     </p:extLst>
   </p:cSld>
@@ -22760,7 +22760,7 @@
           <p:cNvPr id="10" name="TasDruk · De gegevens">
             <a:extLst xmlns:a="http://schemas.openxmlformats.org/drawingml/2006/main">
               <a:ext uri="{FF2B5EF4-FFF2-40B4-BE49-F238E27FC236}">
-                <a16:creationId xmlns:a16="http://schemas.microsoft.com/office/drawing/2014/main" id="{35C40ECC-6808-46AC-B6E2-C0CBB72A39CF}"/>
+                <a16:creationId xmlns:a16="http://schemas.microsoft.com/office/drawing/2014/main" id="{FD6B6126-C963-4E1C-9782-8BACE5BE859F}"/>
               </a:ext>
             </a:extLst>
           </p:cNvPr>
@@ -22817,7 +22817,7 @@
           <p:cNvPr id="2" name="">
             <a:extLst xmlns:a="http://schemas.openxmlformats.org/drawingml/2006/main">
               <a:ext uri="{FF2B5EF4-FFF2-40B4-BE49-F238E27FC236}">
-                <a16:creationId xmlns:a16="http://schemas.microsoft.com/office/drawing/2014/main" id="{8EAA396C-A650-4FA1-91E0-FC53A389D0DA}"/>
+                <a16:creationId xmlns:a16="http://schemas.microsoft.com/office/drawing/2014/main" id="{76ACBD82-42C0-41C4-947B-B42B79EBE174}"/>
               </a:ext>
             </a:extLst>
           </p:cNvPr>
@@ -22846,7 +22846,7 @@
           <p:cNvPr id="3" name="§2.1.3 Marginale kosten en marginale opbrengsten">
             <a:extLst xmlns:a="http://schemas.openxmlformats.org/drawingml/2006/main">
               <a:ext uri="{FF2B5EF4-FFF2-40B4-BE49-F238E27FC236}">
-                <a16:creationId xmlns:a16="http://schemas.microsoft.com/office/drawing/2014/main" id="{1700B004-F9A9-4C29-8B33-AE34624D1708}"/>
+                <a16:creationId xmlns:a16="http://schemas.microsoft.com/office/drawing/2014/main" id="{199F60F1-2B63-4E9F-A444-6A6067D9B0B6}"/>
               </a:ext>
             </a:extLst>
           </p:cNvPr>
@@ -22903,7 +22903,7 @@
           <p:cNvPr id="4" name="slide-number">
             <a:extLst xmlns:a="http://schemas.openxmlformats.org/drawingml/2006/main">
               <a:ext uri="{FF2B5EF4-FFF2-40B4-BE49-F238E27FC236}">
-                <a16:creationId xmlns:a16="http://schemas.microsoft.com/office/drawing/2014/main" id="{46071527-62F0-4663-8758-815CB07BEBC1}"/>
+                <a16:creationId xmlns:a16="http://schemas.microsoft.com/office/drawing/2014/main" id="{0C03EBEA-395A-486A-8ED6-F7AD356D46B7}"/>
               </a:ext>
             </a:extLst>
           </p:cNvPr>
@@ -22960,7 +22960,7 @@
           <p:cNvPr id="5" name="Uitlegvoorbeeld — niet uit het boek · TasDruk">
             <a:extLst xmlns:a="http://schemas.openxmlformats.org/drawingml/2006/main">
               <a:ext uri="{FF2B5EF4-FFF2-40B4-BE49-F238E27FC236}">
-                <a16:creationId xmlns:a16="http://schemas.microsoft.com/office/drawing/2014/main" id="{A50AD77A-A1A4-409C-8AE8-9C969FD98D7E}"/>
+                <a16:creationId xmlns:a16="http://schemas.microsoft.com/office/drawing/2014/main" id="{3F587A39-721A-4889-985F-22821A2566FD}"/>
               </a:ext>
             </a:extLst>
           </p:cNvPr>
@@ -23017,7 +23017,7 @@
           <p:cNvPr id="6" name="Bedrukte tassen: TK = 72 + 4Q en TO = 11Q">
             <a:extLst xmlns:a="http://schemas.openxmlformats.org/drawingml/2006/main">
               <a:ext uri="{FF2B5EF4-FFF2-40B4-BE49-F238E27FC236}">
-                <a16:creationId xmlns:a16="http://schemas.microsoft.com/office/drawing/2014/main" id="{EB78B308-BFBD-47C5-B702-47D1674B25E5}"/>
+                <a16:creationId xmlns:a16="http://schemas.microsoft.com/office/drawing/2014/main" id="{68671FC5-2D5C-451E-97A3-E6EF6D40CBC6}"/>
               </a:ext>
             </a:extLst>
           </p:cNvPr>
@@ -23074,7 +23074,7 @@
           <p:cNvPr id="7" name="Q: tassen per week. Capaciteit: 12. Alle tassen worden verkocht.">
             <a:extLst xmlns:a="http://schemas.openxmlformats.org/drawingml/2006/main">
               <a:ext uri="{FF2B5EF4-FFF2-40B4-BE49-F238E27FC236}">
-                <a16:creationId xmlns:a16="http://schemas.microsoft.com/office/drawing/2014/main" id="{10108D97-B810-4BEE-BF4F-0C470BAF706F}"/>
+                <a16:creationId xmlns:a16="http://schemas.microsoft.com/office/drawing/2014/main" id="{D18DF81F-5F91-47FC-8980-79949355B8BD}"/>
               </a:ext>
             </a:extLst>
           </p:cNvPr>
@@ -23450,7 +23450,7 @@
           <p:cNvPr id="9" name="Let op: eerst 4 extra tassen, daarna 8 extra tassen.">
             <a:extLst xmlns:a="http://schemas.openxmlformats.org/drawingml/2006/main">
               <a:ext uri="{FF2B5EF4-FFF2-40B4-BE49-F238E27FC236}">
-                <a16:creationId xmlns:a16="http://schemas.microsoft.com/office/drawing/2014/main" id="{8F1DBCA0-113A-465C-B440-34DD83A3E15B}"/>
+                <a16:creationId xmlns:a16="http://schemas.microsoft.com/office/drawing/2014/main" id="{B07F837F-EDFB-4E5E-A4BB-778629345594}"/>
               </a:ext>
             </a:extLst>
           </p:cNvPr>
@@ -23505,7 +23505,7 @@
     </p:spTree>
     <p:extLst>
       <p:ext uri="{BB962C8B-B14F-4D97-AF65-F5344CB8AC3E}">
-        <p14:creationId xmlns:p14="http://schemas.microsoft.com/office/powerpoint/2010/main" val="757945760"/>
+        <p14:creationId xmlns:p14="http://schemas.microsoft.com/office/powerpoint/2010/main" val="422225986"/>
       </p:ext>
     </p:extLst>
   </p:cSld>
@@ -23536,7 +23536,7 @@
           <p:cNvPr id="10" name="Winst · Opbrengst min alle kosten">
             <a:extLst xmlns:a="http://schemas.openxmlformats.org/drawingml/2006/main">
               <a:ext uri="{FF2B5EF4-FFF2-40B4-BE49-F238E27FC236}">
-                <a16:creationId xmlns:a16="http://schemas.microsoft.com/office/drawing/2014/main" id="{D3582B73-36C8-4AC2-BC66-598822E99FA8}"/>
+                <a16:creationId xmlns:a16="http://schemas.microsoft.com/office/drawing/2014/main" id="{BC8B236E-260A-4814-BBC5-EB2EBF234D1B}"/>
               </a:ext>
             </a:extLst>
           </p:cNvPr>
@@ -23593,7 +23593,7 @@
           <p:cNvPr id="2" name="">
             <a:extLst xmlns:a="http://schemas.openxmlformats.org/drawingml/2006/main">
               <a:ext uri="{FF2B5EF4-FFF2-40B4-BE49-F238E27FC236}">
-                <a16:creationId xmlns:a16="http://schemas.microsoft.com/office/drawing/2014/main" id="{278AC876-4761-4897-BB1A-A9BBF24F9C66}"/>
+                <a16:creationId xmlns:a16="http://schemas.microsoft.com/office/drawing/2014/main" id="{97B16CB2-5798-4D77-A73E-0AAD533F0B61}"/>
               </a:ext>
             </a:extLst>
           </p:cNvPr>
@@ -23622,7 +23622,7 @@
           <p:cNvPr id="3" name="§2.1.3 Marginale kosten en marginale opbrengsten">
             <a:extLst xmlns:a="http://schemas.openxmlformats.org/drawingml/2006/main">
               <a:ext uri="{FF2B5EF4-FFF2-40B4-BE49-F238E27FC236}">
-                <a16:creationId xmlns:a16="http://schemas.microsoft.com/office/drawing/2014/main" id="{514DB438-EA17-4E55-AD49-50B105F6525B}"/>
+                <a16:creationId xmlns:a16="http://schemas.microsoft.com/office/drawing/2014/main" id="{995DEF34-427A-419F-9792-A4E0CC629A56}"/>
               </a:ext>
             </a:extLst>
           </p:cNvPr>
@@ -23679,7 +23679,7 @@
           <p:cNvPr id="4" name="slide-number">
             <a:extLst xmlns:a="http://schemas.openxmlformats.org/drawingml/2006/main">
               <a:ext uri="{FF2B5EF4-FFF2-40B4-BE49-F238E27FC236}">
-                <a16:creationId xmlns:a16="http://schemas.microsoft.com/office/drawing/2014/main" id="{9958D919-A206-4D78-9C1C-BF66BE185FDC}"/>
+                <a16:creationId xmlns:a16="http://schemas.microsoft.com/office/drawing/2014/main" id="{8111BFC0-D590-44B5-9A1D-2EEFD21787E9}"/>
               </a:ext>
             </a:extLst>
           </p:cNvPr>
@@ -23736,7 +23736,7 @@
           <p:cNvPr id="5" name="Uitlegvoorbeeld — niet uit het boek · TasDruk">
             <a:extLst xmlns:a="http://schemas.openxmlformats.org/drawingml/2006/main">
               <a:ext uri="{FF2B5EF4-FFF2-40B4-BE49-F238E27FC236}">
-                <a16:creationId xmlns:a16="http://schemas.microsoft.com/office/drawing/2014/main" id="{B0C17DD7-DA82-4781-B9FC-C264D0BECB3E}"/>
+                <a16:creationId xmlns:a16="http://schemas.microsoft.com/office/drawing/2014/main" id="{B23D037E-19CF-445A-925F-E29981A2ECFD}"/>
               </a:ext>
             </a:extLst>
           </p:cNvPr>
@@ -23793,7 +23793,7 @@
           <p:cNvPr id="6" name="Bij 4 tassen per week">
             <a:extLst xmlns:a="http://schemas.openxmlformats.org/drawingml/2006/main">
               <a:ext uri="{FF2B5EF4-FFF2-40B4-BE49-F238E27FC236}">
-                <a16:creationId xmlns:a16="http://schemas.microsoft.com/office/drawing/2014/main" id="{9D676625-7533-4718-8C01-2749F0D5DBCD}"/>
+                <a16:creationId xmlns:a16="http://schemas.microsoft.com/office/drawing/2014/main" id="{E942DEF7-F554-459F-A6FE-C38DAA6F4D80}"/>
               </a:ext>
             </a:extLst>
           </p:cNvPr>
@@ -23850,7 +23850,7 @@
           <p:cNvPr id="7" name="Winst = TO − TK">
             <a:extLst xmlns:a="http://schemas.openxmlformats.org/drawingml/2006/main">
               <a:ext uri="{FF2B5EF4-FFF2-40B4-BE49-F238E27FC236}">
-                <a16:creationId xmlns:a16="http://schemas.microsoft.com/office/drawing/2014/main" id="{6E00C6C5-9FA2-46D4-9ACD-CBC14E3748A7}"/>
+                <a16:creationId xmlns:a16="http://schemas.microsoft.com/office/drawing/2014/main" id="{1AE6381B-2662-458A-A6C6-E8B09FD29165}"/>
               </a:ext>
             </a:extLst>
           </p:cNvPr>
@@ -23907,7 +23907,7 @@
           <p:cNvPr id="8" name="= 44 − 88 = −€ 44 per week">
             <a:extLst xmlns:a="http://schemas.openxmlformats.org/drawingml/2006/main">
               <a:ext uri="{FF2B5EF4-FFF2-40B4-BE49-F238E27FC236}">
-                <a16:creationId xmlns:a16="http://schemas.microsoft.com/office/drawing/2014/main" id="{C49BD224-EB94-4DF9-9F86-103E6CA13877}"/>
+                <a16:creationId xmlns:a16="http://schemas.microsoft.com/office/drawing/2014/main" id="{4D22658E-770A-4063-A036-20A002497084}"/>
               </a:ext>
             </a:extLst>
           </p:cNvPr>
@@ -24378,7 +24378,7 @@
     </p:spTree>
     <p:extLst>
       <p:ext uri="{BB962C8B-B14F-4D97-AF65-F5344CB8AC3E}">
-        <p14:creationId xmlns:p14="http://schemas.microsoft.com/office/powerpoint/2010/main" val="845067161"/>
+        <p14:creationId xmlns:p14="http://schemas.microsoft.com/office/powerpoint/2010/main" val="1513222279"/>
       </p:ext>
     </p:extLst>
   </p:cSld>
@@ -24409,7 +24409,7 @@
           <p:cNvPr id="10" name="MK · Eerst het verschil, dan delen">
             <a:extLst xmlns:a="http://schemas.openxmlformats.org/drawingml/2006/main">
               <a:ext uri="{FF2B5EF4-FFF2-40B4-BE49-F238E27FC236}">
-                <a16:creationId xmlns:a16="http://schemas.microsoft.com/office/drawing/2014/main" id="{A6232615-E8CE-4CA0-B83E-76A793D4E213}"/>
+                <a16:creationId xmlns:a16="http://schemas.microsoft.com/office/drawing/2014/main" id="{A493BA8A-C1CD-404D-B2B5-9262E00CA5AE}"/>
               </a:ext>
             </a:extLst>
           </p:cNvPr>
@@ -24466,7 +24466,7 @@
           <p:cNvPr id="2" name="">
             <a:extLst xmlns:a="http://schemas.openxmlformats.org/drawingml/2006/main">
               <a:ext uri="{FF2B5EF4-FFF2-40B4-BE49-F238E27FC236}">
-                <a16:creationId xmlns:a16="http://schemas.microsoft.com/office/drawing/2014/main" id="{84D7073D-1A93-452E-B5FF-06252C7B2EDF}"/>
+                <a16:creationId xmlns:a16="http://schemas.microsoft.com/office/drawing/2014/main" id="{50AA86A4-0BEE-4F8A-96DC-4727C08EEC53}"/>
               </a:ext>
             </a:extLst>
           </p:cNvPr>
@@ -24495,7 +24495,7 @@
           <p:cNvPr id="3" name="§2.1.3 Marginale kosten en marginale opbrengsten">
             <a:extLst xmlns:a="http://schemas.openxmlformats.org/drawingml/2006/main">
               <a:ext uri="{FF2B5EF4-FFF2-40B4-BE49-F238E27FC236}">
-                <a16:creationId xmlns:a16="http://schemas.microsoft.com/office/drawing/2014/main" id="{B0C1CD7B-353D-4E05-9105-4AA5738BF9BD}"/>
+                <a16:creationId xmlns:a16="http://schemas.microsoft.com/office/drawing/2014/main" id="{2CF857AF-179F-4EA3-8694-0D6ABC2FDD01}"/>
               </a:ext>
             </a:extLst>
           </p:cNvPr>
@@ -24552,7 +24552,7 @@
           <p:cNvPr id="4" name="slide-number">
             <a:extLst xmlns:a="http://schemas.openxmlformats.org/drawingml/2006/main">
               <a:ext uri="{FF2B5EF4-FFF2-40B4-BE49-F238E27FC236}">
-                <a16:creationId xmlns:a16="http://schemas.microsoft.com/office/drawing/2014/main" id="{73FB0458-4EEC-4B65-A1A9-8966D6041FF4}"/>
+                <a16:creationId xmlns:a16="http://schemas.microsoft.com/office/drawing/2014/main" id="{88DAD610-D5A7-4656-9037-6AE7B26F874A}"/>
               </a:ext>
             </a:extLst>
           </p:cNvPr>
@@ -24609,7 +24609,7 @@
           <p:cNvPr id="5" name="Uitlegvoorbeeld — niet uit het boek · TasDruk">
             <a:extLst xmlns:a="http://schemas.openxmlformats.org/drawingml/2006/main">
               <a:ext uri="{FF2B5EF4-FFF2-40B4-BE49-F238E27FC236}">
-                <a16:creationId xmlns:a16="http://schemas.microsoft.com/office/drawing/2014/main" id="{9E91366F-F20E-4399-BE77-F9F87EB7A93C}"/>
+                <a16:creationId xmlns:a16="http://schemas.microsoft.com/office/drawing/2014/main" id="{0F36C285-C109-4B06-BDC7-27C5AB1243F9}"/>
               </a:ext>
             </a:extLst>
           </p:cNvPr>
@@ -24911,7 +24911,7 @@
           <p:cNvPr id="7" name="MK = ΔTK / ΔQ = 32 / 8">
             <a:extLst xmlns:a="http://schemas.openxmlformats.org/drawingml/2006/main">
               <a:ext uri="{FF2B5EF4-FFF2-40B4-BE49-F238E27FC236}">
-                <a16:creationId xmlns:a16="http://schemas.microsoft.com/office/drawing/2014/main" id="{F7A6126E-E2D7-421F-AB45-0C82666A5524}"/>
+                <a16:creationId xmlns:a16="http://schemas.microsoft.com/office/drawing/2014/main" id="{22440DE3-B171-4782-9622-451BF80E3F50}"/>
               </a:ext>
             </a:extLst>
           </p:cNvPr>
@@ -24968,7 +24968,7 @@
           <p:cNvPr id="8" name="= € 4 per extra tas in de stap 4 → 12">
             <a:extLst xmlns:a="http://schemas.openxmlformats.org/drawingml/2006/main">
               <a:ext uri="{FF2B5EF4-FFF2-40B4-BE49-F238E27FC236}">
-                <a16:creationId xmlns:a16="http://schemas.microsoft.com/office/drawing/2014/main" id="{16E77B27-0325-4A76-B7D4-2D9B55DEA038}"/>
+                <a16:creationId xmlns:a16="http://schemas.microsoft.com/office/drawing/2014/main" id="{4C969763-F317-4C36-B26C-EE846DD443CE}"/>
               </a:ext>
             </a:extLst>
           </p:cNvPr>
@@ -25025,7 +25025,7 @@
           <p:cNvPr id="9" name="De acht extra tassen kosten samen € 32.">
             <a:extLst xmlns:a="http://schemas.openxmlformats.org/drawingml/2006/main">
               <a:ext uri="{FF2B5EF4-FFF2-40B4-BE49-F238E27FC236}">
-                <a16:creationId xmlns:a16="http://schemas.microsoft.com/office/drawing/2014/main" id="{B1EE081E-A0BD-4AFE-9F4E-90B9F8BA1252}"/>
+                <a16:creationId xmlns:a16="http://schemas.microsoft.com/office/drawing/2014/main" id="{6075ED78-E8EC-47C4-9D3C-DE1E135B6FB4}"/>
               </a:ext>
             </a:extLst>
           </p:cNvPr>
@@ -25080,7 +25080,7 @@
     </p:spTree>
     <p:extLst>
       <p:ext uri="{BB962C8B-B14F-4D97-AF65-F5344CB8AC3E}">
-        <p14:creationId xmlns:p14="http://schemas.microsoft.com/office/powerpoint/2010/main" val="281317151"/>
+        <p14:creationId xmlns:p14="http://schemas.microsoft.com/office/powerpoint/2010/main" val="2066740335"/>
       </p:ext>
     </p:extLst>
   </p:cSld>
@@ -25111,7 +25111,7 @@
           <p:cNvPr id="12" name="MO · De extra opbrengst per extra tas">
             <a:extLst xmlns:a="http://schemas.openxmlformats.org/drawingml/2006/main">
               <a:ext uri="{FF2B5EF4-FFF2-40B4-BE49-F238E27FC236}">
-                <a16:creationId xmlns:a16="http://schemas.microsoft.com/office/drawing/2014/main" id="{1354D926-136F-46E4-AD2E-FBA3A957ACEB}"/>
+                <a16:creationId xmlns:a16="http://schemas.microsoft.com/office/drawing/2014/main" id="{6C9490E5-7486-4751-8834-BB8EB26D4839}"/>
               </a:ext>
             </a:extLst>
           </p:cNvPr>
@@ -25168,7 +25168,7 @@
           <p:cNvPr id="2" name="">
             <a:extLst xmlns:a="http://schemas.openxmlformats.org/drawingml/2006/main">
               <a:ext uri="{FF2B5EF4-FFF2-40B4-BE49-F238E27FC236}">
-                <a16:creationId xmlns:a16="http://schemas.microsoft.com/office/drawing/2014/main" id="{1AA8B643-F40B-44FB-8480-C49961B684EB}"/>
+                <a16:creationId xmlns:a16="http://schemas.microsoft.com/office/drawing/2014/main" id="{7AB21E31-5145-4532-9F91-347B61ADA279}"/>
               </a:ext>
             </a:extLst>
           </p:cNvPr>
@@ -25197,7 +25197,7 @@
           <p:cNvPr id="3" name="§2.1.3 Marginale kosten en marginale opbrengsten">
             <a:extLst xmlns:a="http://schemas.openxmlformats.org/drawingml/2006/main">
               <a:ext uri="{FF2B5EF4-FFF2-40B4-BE49-F238E27FC236}">
-                <a16:creationId xmlns:a16="http://schemas.microsoft.com/office/drawing/2014/main" id="{8D59A751-2B17-4FFF-B819-C843AA728842}"/>
+                <a16:creationId xmlns:a16="http://schemas.microsoft.com/office/drawing/2014/main" id="{DFFE2FB1-3662-41B8-BD14-EA10A0451ACE}"/>
               </a:ext>
             </a:extLst>
           </p:cNvPr>
@@ -25254,7 +25254,7 @@
           <p:cNvPr id="4" name="slide-number">
             <a:extLst xmlns:a="http://schemas.openxmlformats.org/drawingml/2006/main">
               <a:ext uri="{FF2B5EF4-FFF2-40B4-BE49-F238E27FC236}">
-                <a16:creationId xmlns:a16="http://schemas.microsoft.com/office/drawing/2014/main" id="{64F6366D-3083-4759-BE39-20A20B3743B6}"/>
+                <a16:creationId xmlns:a16="http://schemas.microsoft.com/office/drawing/2014/main" id="{9B5B240F-2F1A-4A98-B033-086B973D2198}"/>
               </a:ext>
             </a:extLst>
           </p:cNvPr>
@@ -25311,7 +25311,7 @@
           <p:cNvPr id="5" name="Uitlegvoorbeeld — niet uit het boek · TasDruk">
             <a:extLst xmlns:a="http://schemas.openxmlformats.org/drawingml/2006/main">
               <a:ext uri="{FF2B5EF4-FFF2-40B4-BE49-F238E27FC236}">
-                <a16:creationId xmlns:a16="http://schemas.microsoft.com/office/drawing/2014/main" id="{7CC381AC-5B06-4A15-A021-EBC96D012799}"/>
+                <a16:creationId xmlns:a16="http://schemas.microsoft.com/office/drawing/2014/main" id="{317C677E-3FE4-4FA0-A4C6-89D84822F6E0}"/>
               </a:ext>
             </a:extLst>
           </p:cNvPr>
@@ -25368,7 +25368,7 @@
           <p:cNvPr id="6" name="Dezelfde stap: 4 → 12 tassen per week">
             <a:extLst xmlns:a="http://schemas.openxmlformats.org/drawingml/2006/main">
               <a:ext uri="{FF2B5EF4-FFF2-40B4-BE49-F238E27FC236}">
-                <a16:creationId xmlns:a16="http://schemas.microsoft.com/office/drawing/2014/main" id="{51ECE971-FB78-4A44-B764-CA043B07BF08}"/>
+                <a16:creationId xmlns:a16="http://schemas.microsoft.com/office/drawing/2014/main" id="{7D58DA52-DAEC-415D-A84B-1B90D8651430}"/>
               </a:ext>
             </a:extLst>
           </p:cNvPr>
@@ -25425,7 +25425,7 @@
           <p:cNvPr id="7" name="ΔTO = 132 − 44 = € 88">
             <a:extLst xmlns:a="http://schemas.openxmlformats.org/drawingml/2006/main">
               <a:ext uri="{FF2B5EF4-FFF2-40B4-BE49-F238E27FC236}">
-                <a16:creationId xmlns:a16="http://schemas.microsoft.com/office/drawing/2014/main" id="{E2E5EB59-FE7A-4279-9300-C548EC8B6C8B}"/>
+                <a16:creationId xmlns:a16="http://schemas.microsoft.com/office/drawing/2014/main" id="{5EDF3392-0593-418F-84EC-FAD3C5A18363}"/>
               </a:ext>
             </a:extLst>
           </p:cNvPr>
@@ -25482,7 +25482,7 @@
           <p:cNvPr id="8" name="MO = ΔTO / ΔQ = 88 / 8">
             <a:extLst xmlns:a="http://schemas.openxmlformats.org/drawingml/2006/main">
               <a:ext uri="{FF2B5EF4-FFF2-40B4-BE49-F238E27FC236}">
-                <a16:creationId xmlns:a16="http://schemas.microsoft.com/office/drawing/2014/main" id="{A3D9BBEC-9711-46AA-A8B0-2CD820C61D54}"/>
+                <a16:creationId xmlns:a16="http://schemas.microsoft.com/office/drawing/2014/main" id="{92C3C0E9-A710-4B98-A23F-04892F066FCC}"/>
               </a:ext>
             </a:extLst>
           </p:cNvPr>
@@ -25539,7 +25539,7 @@
           <p:cNvPr id="9" name="= € 11 per extra verkochte tas">
             <a:extLst xmlns:a="http://schemas.openxmlformats.org/drawingml/2006/main">
               <a:ext uri="{FF2B5EF4-FFF2-40B4-BE49-F238E27FC236}">
-                <a16:creationId xmlns:a16="http://schemas.microsoft.com/office/drawing/2014/main" id="{174CDC22-55E4-4103-99A8-A78189F925B9}"/>
+                <a16:creationId xmlns:a16="http://schemas.microsoft.com/office/drawing/2014/main" id="{EF1AFF9C-2B08-4AFD-8339-5B5EAA1A656B}"/>
               </a:ext>
             </a:extLst>
           </p:cNvPr>
@@ -25596,7 +25596,7 @@
           <p:cNvPr id="10" name="">
             <a:extLst xmlns:a="http://schemas.openxmlformats.org/drawingml/2006/main">
               <a:ext uri="{FF2B5EF4-FFF2-40B4-BE49-F238E27FC236}">
-                <a16:creationId xmlns:a16="http://schemas.microsoft.com/office/drawing/2014/main" id="{7191529E-6EA1-4EB2-A790-673EE4849D73}"/>
+                <a16:creationId xmlns:a16="http://schemas.microsoft.com/office/drawing/2014/main" id="{2C79E74E-7B47-40E7-AB34-B24735672621}"/>
               </a:ext>
             </a:extLst>
           </p:cNvPr>
@@ -25625,7 +25625,7 @@
           <p:cNvPr id="11" name="Vaste verkoopprijs → constante MO">
             <a:extLst xmlns:a="http://schemas.openxmlformats.org/drawingml/2006/main">
               <a:ext uri="{FF2B5EF4-FFF2-40B4-BE49-F238E27FC236}">
-                <a16:creationId xmlns:a16="http://schemas.microsoft.com/office/drawing/2014/main" id="{3418D224-F307-43B8-BFD4-60A4398D0963}"/>
+                <a16:creationId xmlns:a16="http://schemas.microsoft.com/office/drawing/2014/main" id="{D6088D8F-4B96-42AB-BEFE-F4A76426D6D8}"/>
               </a:ext>
             </a:extLst>
           </p:cNvPr>
@@ -25680,7 +25680,7 @@
     </p:spTree>
     <p:extLst>
       <p:ext uri="{BB962C8B-B14F-4D97-AF65-F5344CB8AC3E}">
-        <p14:creationId xmlns:p14="http://schemas.microsoft.com/office/powerpoint/2010/main" val="311413088"/>
+        <p14:creationId xmlns:p14="http://schemas.microsoft.com/office/powerpoint/2010/main" val="1625705347"/>
       </p:ext>
     </p:extLst>
   </p:cSld>
@@ -25711,7 +25711,7 @@
           <p:cNvPr id="9" name="Elke uitkomst hoort bij een tabelstap">
             <a:extLst xmlns:a="http://schemas.openxmlformats.org/drawingml/2006/main">
               <a:ext uri="{FF2B5EF4-FFF2-40B4-BE49-F238E27FC236}">
-                <a16:creationId xmlns:a16="http://schemas.microsoft.com/office/drawing/2014/main" id="{11D4A78C-392F-4360-BF3A-007B8784150E}"/>
+                <a16:creationId xmlns:a16="http://schemas.microsoft.com/office/drawing/2014/main" id="{94C790E3-F46E-4B95-A634-1CA54DDDE9AA}"/>
               </a:ext>
             </a:extLst>
           </p:cNvPr>
@@ -25768,7 +25768,7 @@
           <p:cNvPr id="2" name="">
             <a:extLst xmlns:a="http://schemas.openxmlformats.org/drawingml/2006/main">
               <a:ext uri="{FF2B5EF4-FFF2-40B4-BE49-F238E27FC236}">
-                <a16:creationId xmlns:a16="http://schemas.microsoft.com/office/drawing/2014/main" id="{B7FF70F0-4D5C-4446-B072-5CC367AFCA8F}"/>
+                <a16:creationId xmlns:a16="http://schemas.microsoft.com/office/drawing/2014/main" id="{0DDD276D-4F82-43C8-AEE0-C443901AB4B4}"/>
               </a:ext>
             </a:extLst>
           </p:cNvPr>
@@ -25797,7 +25797,7 @@
           <p:cNvPr id="3" name="§2.1.3 Marginale kosten en marginale opbrengsten">
             <a:extLst xmlns:a="http://schemas.openxmlformats.org/drawingml/2006/main">
               <a:ext uri="{FF2B5EF4-FFF2-40B4-BE49-F238E27FC236}">
-                <a16:creationId xmlns:a16="http://schemas.microsoft.com/office/drawing/2014/main" id="{973E3CD4-0EB9-4F73-A2F0-144EC83E2BA2}"/>
+                <a16:creationId xmlns:a16="http://schemas.microsoft.com/office/drawing/2014/main" id="{066BC84E-E1B4-4D8A-B3B0-833A8973E74B}"/>
               </a:ext>
             </a:extLst>
           </p:cNvPr>
@@ -25854,7 +25854,7 @@
           <p:cNvPr id="4" name="slide-number">
             <a:extLst xmlns:a="http://schemas.openxmlformats.org/drawingml/2006/main">
               <a:ext uri="{FF2B5EF4-FFF2-40B4-BE49-F238E27FC236}">
-                <a16:creationId xmlns:a16="http://schemas.microsoft.com/office/drawing/2014/main" id="{07FEF78C-CD11-4048-89D5-EC0390C17336}"/>
+                <a16:creationId xmlns:a16="http://schemas.microsoft.com/office/drawing/2014/main" id="{A095D077-AD6E-44CC-B828-3E290A0E35C6}"/>
               </a:ext>
             </a:extLst>
           </p:cNvPr>
@@ -25911,7 +25911,7 @@
           <p:cNvPr id="5" name="Uitlegvoorbeeld — niet uit het boek · TasDruk">
             <a:extLst xmlns:a="http://schemas.openxmlformats.org/drawingml/2006/main">
               <a:ext uri="{FF2B5EF4-FFF2-40B4-BE49-F238E27FC236}">
-                <a16:creationId xmlns:a16="http://schemas.microsoft.com/office/drawing/2014/main" id="{9B69C626-C76F-46F3-B76C-474E5A0BEC28}"/>
+                <a16:creationId xmlns:a16="http://schemas.microsoft.com/office/drawing/2014/main" id="{F3E6C7A8-F6B2-476B-8BBA-3B98DF2C7CF6}"/>
               </a:ext>
             </a:extLst>
           </p:cNvPr>
@@ -26481,7 +26481,7 @@
           <p:cNvPr id="7" name="Grotere stap, dezelfde MK en MO">
             <a:extLst xmlns:a="http://schemas.openxmlformats.org/drawingml/2006/main">
               <a:ext uri="{FF2B5EF4-FFF2-40B4-BE49-F238E27FC236}">
-                <a16:creationId xmlns:a16="http://schemas.microsoft.com/office/drawing/2014/main" id="{94907963-B282-43FB-974A-E199A1EF5643}"/>
+                <a16:creationId xmlns:a16="http://schemas.microsoft.com/office/drawing/2014/main" id="{0E007353-E3C6-42D6-B779-F34E0E7595A2}"/>
               </a:ext>
             </a:extLst>
           </p:cNvPr>
@@ -26538,7 +26538,7 @@
           <p:cNvPr id="8" name="Bij de eerste rij: — betekent “geen vorige tabelrij”.">
             <a:extLst xmlns:a="http://schemas.openxmlformats.org/drawingml/2006/main">
               <a:ext uri="{FF2B5EF4-FFF2-40B4-BE49-F238E27FC236}">
-                <a16:creationId xmlns:a16="http://schemas.microsoft.com/office/drawing/2014/main" id="{EDEE2B25-9025-410C-9780-6CC80C8B00AE}"/>
+                <a16:creationId xmlns:a16="http://schemas.microsoft.com/office/drawing/2014/main" id="{233261AE-E21C-4064-AF17-B1E3710B75DE}"/>
               </a:ext>
             </a:extLst>
           </p:cNvPr>
@@ -26593,7 +26593,7 @@
     </p:spTree>
     <p:extLst>
       <p:ext uri="{BB962C8B-B14F-4D97-AF65-F5344CB8AC3E}">
-        <p14:creationId xmlns:p14="http://schemas.microsoft.com/office/powerpoint/2010/main" val="1838238686"/>
+        <p14:creationId xmlns:p14="http://schemas.microsoft.com/office/powerpoint/2010/main" val="782682730"/>
       </p:ext>
     </p:extLst>
   </p:cSld>
@@ -26624,7 +26624,7 @@
           <p:cNvPr id="10" name="Studio Reliëf · Kosten die sneller stijgen">
             <a:extLst xmlns:a="http://schemas.openxmlformats.org/drawingml/2006/main">
               <a:ext uri="{FF2B5EF4-FFF2-40B4-BE49-F238E27FC236}">
-                <a16:creationId xmlns:a16="http://schemas.microsoft.com/office/drawing/2014/main" id="{E2CBCAEF-979C-4220-A90E-CDDDF6DC94A6}"/>
+                <a16:creationId xmlns:a16="http://schemas.microsoft.com/office/drawing/2014/main" id="{602EEB4C-DE7E-495A-BA16-58E3072844A5}"/>
               </a:ext>
             </a:extLst>
           </p:cNvPr>
@@ -26681,7 +26681,7 @@
           <p:cNvPr id="2" name="">
             <a:extLst xmlns:a="http://schemas.openxmlformats.org/drawingml/2006/main">
               <a:ext uri="{FF2B5EF4-FFF2-40B4-BE49-F238E27FC236}">
-                <a16:creationId xmlns:a16="http://schemas.microsoft.com/office/drawing/2014/main" id="{1E43F97F-EEB3-4629-9105-C0AE45140274}"/>
+                <a16:creationId xmlns:a16="http://schemas.microsoft.com/office/drawing/2014/main" id="{9B28982B-7335-48D5-9F2C-DD74B56F822A}"/>
               </a:ext>
             </a:extLst>
           </p:cNvPr>
@@ -26710,7 +26710,7 @@
           <p:cNvPr id="3" name="§2.1.3 Marginale kosten en marginale opbrengsten">
             <a:extLst xmlns:a="http://schemas.openxmlformats.org/drawingml/2006/main">
               <a:ext uri="{FF2B5EF4-FFF2-40B4-BE49-F238E27FC236}">
-                <a16:creationId xmlns:a16="http://schemas.microsoft.com/office/drawing/2014/main" id="{D560F7CF-7427-4F20-90E1-97A7ACC8D7E4}"/>
+                <a16:creationId xmlns:a16="http://schemas.microsoft.com/office/drawing/2014/main" id="{A34E1A6B-5FC1-4715-A328-E952E6B914CD}"/>
               </a:ext>
             </a:extLst>
           </p:cNvPr>
@@ -26767,7 +26767,7 @@
           <p:cNvPr id="4" name="slide-number">
             <a:extLst xmlns:a="http://schemas.openxmlformats.org/drawingml/2006/main">
               <a:ext uri="{FF2B5EF4-FFF2-40B4-BE49-F238E27FC236}">
-                <a16:creationId xmlns:a16="http://schemas.microsoft.com/office/drawing/2014/main" id="{59192B7D-EA72-4A4F-8B9A-26C59C4A450C}"/>
+                <a16:creationId xmlns:a16="http://schemas.microsoft.com/office/drawing/2014/main" id="{88876502-4F30-4FF4-812B-D31905F2D26E}"/>
               </a:ext>
             </a:extLst>
           </p:cNvPr>
@@ -26824,7 +26824,7 @@
           <p:cNvPr id="5" name="Uitlegvoorbeeld — niet uit het boek · Studio Reliëf">
             <a:extLst xmlns:a="http://schemas.openxmlformats.org/drawingml/2006/main">
               <a:ext uri="{FF2B5EF4-FFF2-40B4-BE49-F238E27FC236}">
-                <a16:creationId xmlns:a16="http://schemas.microsoft.com/office/drawing/2014/main" id="{F86E8DE4-58AB-4C04-9B3D-79DB480023C7}"/>
+                <a16:creationId xmlns:a16="http://schemas.microsoft.com/office/drawing/2014/main" id="{FBAABF6D-13A9-4339-9B0C-911C60A7CC08}"/>
               </a:ext>
             </a:extLst>
           </p:cNvPr>
@@ -26881,7 +26881,7 @@
           <p:cNvPr id="6" name="TK = 32 + 2Q²     TO = 26Q">
             <a:extLst xmlns:a="http://schemas.openxmlformats.org/drawingml/2006/main">
               <a:ext uri="{FF2B5EF4-FFF2-40B4-BE49-F238E27FC236}">
-                <a16:creationId xmlns:a16="http://schemas.microsoft.com/office/drawing/2014/main" id="{DC0E4360-F176-4EEA-992C-01F9E07DAD25}"/>
+                <a16:creationId xmlns:a16="http://schemas.microsoft.com/office/drawing/2014/main" id="{9EAC4D3A-CAE8-41CC-88E2-28F78149F600}"/>
               </a:ext>
             </a:extLst>
           </p:cNvPr>
@@ -26938,7 +26938,7 @@
           <p:cNvPr id="7" name="Q: tegels per week. Capaciteit: 6. Alle tegels worden verkocht.">
             <a:extLst xmlns:a="http://schemas.openxmlformats.org/drawingml/2006/main">
               <a:ext uri="{FF2B5EF4-FFF2-40B4-BE49-F238E27FC236}">
-                <a16:creationId xmlns:a16="http://schemas.microsoft.com/office/drawing/2014/main" id="{A24D553D-C0A4-45B5-B6CF-5C1FC9A1118F}"/>
+                <a16:creationId xmlns:a16="http://schemas.microsoft.com/office/drawing/2014/main" id="{4BD1E598-12D0-4ABB-B90D-3B0123D7AE19}"/>
               </a:ext>
             </a:extLst>
           </p:cNvPr>
@@ -27388,7 +27388,7 @@
           <p:cNvPr id="9" name="Bij Q = 4: TK = 32 + 2 × 4² = 32 + 32 = € 64">
             <a:extLst xmlns:a="http://schemas.openxmlformats.org/drawingml/2006/main">
               <a:ext uri="{FF2B5EF4-FFF2-40B4-BE49-F238E27FC236}">
-                <a16:creationId xmlns:a16="http://schemas.microsoft.com/office/drawing/2014/main" id="{B8638D06-1A6D-4FFB-BF98-B428C5400127}"/>
+                <a16:creationId xmlns:a16="http://schemas.microsoft.com/office/drawing/2014/main" id="{0D69E1D2-4214-4BA0-BFFF-8CD6A81022F9}"/>
               </a:ext>
             </a:extLst>
           </p:cNvPr>
@@ -27443,7 +27443,7 @@
     </p:spTree>
     <p:extLst>
       <p:ext uri="{BB962C8B-B14F-4D97-AF65-F5344CB8AC3E}">
-        <p14:creationId xmlns:p14="http://schemas.microsoft.com/office/powerpoint/2010/main" val="896849556"/>
+        <p14:creationId xmlns:p14="http://schemas.microsoft.com/office/powerpoint/2010/main" val="349644981"/>
       </p:ext>
     </p:extLst>
   </p:cSld>

</xml_diff>

<commit_message>
Repair Book 2 classroom slide references and publish current decks
</commit_message>
<xml_diff>
--- a/Boek 2 - Kosten, opbrengsten, elasticiteit en surplus/edities/chat-2026/bronnen/H1/paragrafen/2.1.3 Marginale kosten en marginale opbrengsten/2.1.3 Marginale kosten en marginale opbrengsten – presentatie.pptx
+++ b/Boek 2 - Kosten, opbrengsten, elasticiteit en surplus/edities/chat-2026/bronnen/H1/paragrafen/2.1.3 Marginale kosten en marginale opbrengsten/2.1.3 Marginale kosten en marginale opbrengsten – presentatie.pptx
@@ -2,39 +2,39 @@
 <file path=ppt/presentation.xml><?xml version="1.0" encoding="utf-8"?>
 <p:presentation xmlns:p="http://schemas.openxmlformats.org/presentationml/2006/main">
   <p:sldMasterIdLst>
-    <p:sldMasterId xmlns:r="http://schemas.openxmlformats.org/officeDocument/2006/relationships" id="2147483648" r:id="R4c9100fbbe26475a"/>
+    <p:sldMasterId xmlns:r="http://schemas.openxmlformats.org/officeDocument/2006/relationships" id="2147483648" r:id="R652ce759430c4e2b"/>
   </p:sldMasterIdLst>
   <p:notesMasterIdLst>
-    <p:notesMasterId xmlns:r="http://schemas.openxmlformats.org/officeDocument/2006/relationships" r:id="R0e4637d30c844d42"/>
+    <p:notesMasterId xmlns:r="http://schemas.openxmlformats.org/officeDocument/2006/relationships" r:id="R2c19a764ce0644c7"/>
   </p:notesMasterIdLst>
   <p:sldIdLst>
-    <p:sldId xmlns:r="http://schemas.openxmlformats.org/officeDocument/2006/relationships" id="256" r:id="R5a9b97f34473420b"/>
-    <p:sldId xmlns:r="http://schemas.openxmlformats.org/officeDocument/2006/relationships" id="257" r:id="R3bea31d5cbcb428d"/>
-    <p:sldId xmlns:r="http://schemas.openxmlformats.org/officeDocument/2006/relationships" id="258" r:id="R2e85d66ccc974caf"/>
-    <p:sldId xmlns:r="http://schemas.openxmlformats.org/officeDocument/2006/relationships" id="259" r:id="Rf5e9fd49d2574c62"/>
-    <p:sldId xmlns:r="http://schemas.openxmlformats.org/officeDocument/2006/relationships" id="260" r:id="R69ce43944e34486b"/>
-    <p:sldId xmlns:r="http://schemas.openxmlformats.org/officeDocument/2006/relationships" id="261" r:id="R7092b499e2db456a"/>
-    <p:sldId xmlns:r="http://schemas.openxmlformats.org/officeDocument/2006/relationships" id="262" r:id="Rc24a89b1edcf467f"/>
-    <p:sldId xmlns:r="http://schemas.openxmlformats.org/officeDocument/2006/relationships" id="263" r:id="R1d626f25b0194445"/>
-    <p:sldId xmlns:r="http://schemas.openxmlformats.org/officeDocument/2006/relationships" id="264" r:id="Rbf94237e59af4bb3"/>
-    <p:sldId xmlns:r="http://schemas.openxmlformats.org/officeDocument/2006/relationships" id="265" r:id="R4a89bcded6cc49af"/>
-    <p:sldId xmlns:r="http://schemas.openxmlformats.org/officeDocument/2006/relationships" id="266" r:id="R50432cc25b764998"/>
-    <p:sldId xmlns:r="http://schemas.openxmlformats.org/officeDocument/2006/relationships" id="267" r:id="R7dfb7bdaad2c48c5"/>
-    <p:sldId xmlns:r="http://schemas.openxmlformats.org/officeDocument/2006/relationships" id="268" r:id="R570a031be4044791"/>
-    <p:sldId xmlns:r="http://schemas.openxmlformats.org/officeDocument/2006/relationships" id="269" r:id="Rbce39af9170a4a44"/>
-    <p:sldId xmlns:r="http://schemas.openxmlformats.org/officeDocument/2006/relationships" id="270" r:id="Rc014ee4ddb5b4b96"/>
-    <p:sldId xmlns:r="http://schemas.openxmlformats.org/officeDocument/2006/relationships" id="271" r:id="R3622cc0fe1e74326"/>
-    <p:sldId xmlns:r="http://schemas.openxmlformats.org/officeDocument/2006/relationships" id="272" r:id="R4d6354743e2f4532"/>
-    <p:sldId xmlns:r="http://schemas.openxmlformats.org/officeDocument/2006/relationships" id="273" r:id="R360de586175e4204"/>
-    <p:sldId xmlns:r="http://schemas.openxmlformats.org/officeDocument/2006/relationships" id="274" r:id="Rc521c236bb1c4cfa"/>
-    <p:sldId xmlns:r="http://schemas.openxmlformats.org/officeDocument/2006/relationships" id="275" r:id="R2e569dca162547d3"/>
-    <p:sldId xmlns:r="http://schemas.openxmlformats.org/officeDocument/2006/relationships" id="276" r:id="R60fd2ab4f84e463c"/>
-    <p:sldId xmlns:r="http://schemas.openxmlformats.org/officeDocument/2006/relationships" id="277" r:id="R3d83d44a862c40e2"/>
-    <p:sldId xmlns:r="http://schemas.openxmlformats.org/officeDocument/2006/relationships" id="278" r:id="Rbbd8f9d502ab497b"/>
-    <p:sldId xmlns:r="http://schemas.openxmlformats.org/officeDocument/2006/relationships" id="279" r:id="Refb15ac3eef740e8"/>
-    <p:sldId xmlns:r="http://schemas.openxmlformats.org/officeDocument/2006/relationships" id="280" r:id="Rd6787d9a6e6843d2"/>
-    <p:sldId xmlns:r="http://schemas.openxmlformats.org/officeDocument/2006/relationships" id="281" r:id="R3df69bc2799c4838"/>
-    <p:sldId xmlns:r="http://schemas.openxmlformats.org/officeDocument/2006/relationships" id="282" r:id="Rc9f2a129bc234e68"/>
+    <p:sldId xmlns:r="http://schemas.openxmlformats.org/officeDocument/2006/relationships" id="256" r:id="Rf12debf315854548"/>
+    <p:sldId xmlns:r="http://schemas.openxmlformats.org/officeDocument/2006/relationships" id="257" r:id="Re8631682b29642f6"/>
+    <p:sldId xmlns:r="http://schemas.openxmlformats.org/officeDocument/2006/relationships" id="258" r:id="Rbe213ff9c9864abf"/>
+    <p:sldId xmlns:r="http://schemas.openxmlformats.org/officeDocument/2006/relationships" id="259" r:id="R5af876105ef04b01"/>
+    <p:sldId xmlns:r="http://schemas.openxmlformats.org/officeDocument/2006/relationships" id="260" r:id="R94976a91274344fa"/>
+    <p:sldId xmlns:r="http://schemas.openxmlformats.org/officeDocument/2006/relationships" id="261" r:id="Rbb1e94454997445b"/>
+    <p:sldId xmlns:r="http://schemas.openxmlformats.org/officeDocument/2006/relationships" id="262" r:id="Rdd72a5e505f94142"/>
+    <p:sldId xmlns:r="http://schemas.openxmlformats.org/officeDocument/2006/relationships" id="263" r:id="R2b04324988ce473d"/>
+    <p:sldId xmlns:r="http://schemas.openxmlformats.org/officeDocument/2006/relationships" id="264" r:id="R02b1fd074669452c"/>
+    <p:sldId xmlns:r="http://schemas.openxmlformats.org/officeDocument/2006/relationships" id="265" r:id="Raeba2cb14eda4c94"/>
+    <p:sldId xmlns:r="http://schemas.openxmlformats.org/officeDocument/2006/relationships" id="266" r:id="R9a8752c2fc744595"/>
+    <p:sldId xmlns:r="http://schemas.openxmlformats.org/officeDocument/2006/relationships" id="267" r:id="R32f34fc2177e4f13"/>
+    <p:sldId xmlns:r="http://schemas.openxmlformats.org/officeDocument/2006/relationships" id="268" r:id="R993fadb2e5f24f8b"/>
+    <p:sldId xmlns:r="http://schemas.openxmlformats.org/officeDocument/2006/relationships" id="269" r:id="Rfe9484ad36ba47cc"/>
+    <p:sldId xmlns:r="http://schemas.openxmlformats.org/officeDocument/2006/relationships" id="270" r:id="R131aed310fcd4f51"/>
+    <p:sldId xmlns:r="http://schemas.openxmlformats.org/officeDocument/2006/relationships" id="271" r:id="Rba371cb62d4a4084"/>
+    <p:sldId xmlns:r="http://schemas.openxmlformats.org/officeDocument/2006/relationships" id="272" r:id="R83676a7eef5a4ca1"/>
+    <p:sldId xmlns:r="http://schemas.openxmlformats.org/officeDocument/2006/relationships" id="273" r:id="R5d90481966224a21"/>
+    <p:sldId xmlns:r="http://schemas.openxmlformats.org/officeDocument/2006/relationships" id="274" r:id="Refb7124df2564b0a"/>
+    <p:sldId xmlns:r="http://schemas.openxmlformats.org/officeDocument/2006/relationships" id="275" r:id="R61b3261f949f4fca"/>
+    <p:sldId xmlns:r="http://schemas.openxmlformats.org/officeDocument/2006/relationships" id="276" r:id="R2dff528fe3c34858"/>
+    <p:sldId xmlns:r="http://schemas.openxmlformats.org/officeDocument/2006/relationships" id="277" r:id="R7174db65049d4d64"/>
+    <p:sldId xmlns:r="http://schemas.openxmlformats.org/officeDocument/2006/relationships" id="278" r:id="R8be2ac2036784a7d"/>
+    <p:sldId xmlns:r="http://schemas.openxmlformats.org/officeDocument/2006/relationships" id="279" r:id="R510c13b80a334cdc"/>
+    <p:sldId xmlns:r="http://schemas.openxmlformats.org/officeDocument/2006/relationships" id="280" r:id="R5a3d95c9cb5c47a8"/>
+    <p:sldId xmlns:r="http://schemas.openxmlformats.org/officeDocument/2006/relationships" id="281" r:id="Rf7b972ad664647ab"/>
+    <p:sldId xmlns:r="http://schemas.openxmlformats.org/officeDocument/2006/relationships" id="282" r:id="Rdc6704e9e24c47e4"/>
   </p:sldIdLst>
   <p:sldSz cx="15240000" cy="8572500"/>
   <p:notesSz cx="6858000" cy="9144000"/>
@@ -481,7 +481,7 @@
           <a:p xmlns:a="http://schemas.openxmlformats.org/drawingml/2006/main">
             <a:r>
               <a:rPr sz="1400"/>
-              <a:t>Uitleg: Laat het overzicht staan tijdens startopdracht. Start 1–2: pagina 23. Basis 3–4: pagina 23–24. Zelfstandig 5–6: pagina 24–25. Doel 7: pagina 26. Huiswerk 3, 4, 5, 6 en 7 maken en nakijken. Denkertje 8 en herhaling 9–10 zijn extra. De volledige route hoeft niet binnen één les af; plan vervolgwerktijd.</a:t>
+              <a:t>Uitleg: Laat het overzicht staan tijdens startopdracht. Start 1–2: pagina 24. Basis 3–4: pagina 24–25. Zelfstandig 5–6: pagina 25–26. Doel 7: pagina 27. Huiswerk 3, 4, 5, 6 en 7 maken en nakijken. Denkertje 8 en herhaling 9–10 zijn extra. De volledige route hoeft niet binnen één les af; plan vervolgwerktijd.</a:t>
             </a:r>
           </a:p>
           <a:p xmlns:a="http://schemas.openxmlformats.org/drawingml/2006/main">
@@ -529,13 +529,13 @@
           <a:p xmlns:a="http://schemas.openxmlformats.org/drawingml/2006/main">
             <a:r>
               <a:rPr sz="1400"/>
-              <a:t>Bron: leerlingenboek Boek 2, chatuitgave 2026, gedrukte pagina 23–26. https://github.com/meijer1973/4veco-lessen/blob/f2660032cf7e4e3bbab96cf32863d06a38bd74bc/Boek%202%20-%20Kosten%2C%20opbrengsten%2C%20elasticiteit%20en%20surplus/edities/chat-2026/boek/Boek_2_Compleet.pdf</a:t>
-            </a:r>
-          </a:p>
-          <a:p xmlns:a="http://schemas.openxmlformats.org/drawingml/2006/main">
-            <a:r>
-              <a:rPr sz="1400"/>
-              <a:t>Antwoordmodel: https://github.com/meijer1973/4veco-lessen/blob/f2660032cf7e4e3bbab96cf32863d06a38bd74bc/Boek%202%20-%20Kosten%2C%20opbrengsten%2C%20elasticiteit%20en%20surplus/edities/chat-2026/bronnen/H1/2.1%20Kosten%20en%20opbrengsten%20%E2%80%93%20antwoorden.md</a:t>
+              <a:t>Bron: leerlingenboek Boek 2, chatuitgave 2026, gedrukte pagina 24–27. https://github.com/meijer1973/4veco-lessen/blob/a8940a7a79e22857a3e306a91fe923c48c63e716/Boek%202%20-%20Kosten%2C%20opbrengsten%2C%20elasticiteit%20en%20surplus/edities/chat-2026/boek/Boek_2_Compleet.pdf</a:t>
+            </a:r>
+          </a:p>
+          <a:p xmlns:a="http://schemas.openxmlformats.org/drawingml/2006/main">
+            <a:r>
+              <a:rPr sz="1400"/>
+              <a:t>Antwoordmodel: https://github.com/meijer1973/4veco-lessen/blob/a8940a7a79e22857a3e306a91fe923c48c63e716/Boek%202%20-%20Kosten%2C%20opbrengsten%2C%20elasticiteit%20en%20surplus/edities/chat-2026/bronnen/H1/2.1%20Kosten%20en%20opbrengsten%20%E2%80%93%20antwoorden.md</a:t>
             </a:r>
           </a:p>
           <a:p xmlns:a="http://schemas.openxmlformats.org/drawingml/2006/main">
@@ -660,13 +660,13 @@
           <a:p xmlns:a="http://schemas.openxmlformats.org/drawingml/2006/main">
             <a:r>
               <a:rPr sz="1400"/>
-              <a:t>Bron: leerlingenboek Boek 2, chatuitgave 2026, gedrukte pagina 21–22. https://github.com/meijer1973/4veco-lessen/blob/f2660032cf7e4e3bbab96cf32863d06a38bd74bc/Boek%202%20-%20Kosten%2C%20opbrengsten%2C%20elasticiteit%20en%20surplus/edities/chat-2026/boek/Boek_2_Compleet.pdf</a:t>
-            </a:r>
-          </a:p>
-          <a:p xmlns:a="http://schemas.openxmlformats.org/drawingml/2006/main">
-            <a:r>
-              <a:rPr sz="1400"/>
-              <a:t>Antwoordmodel: https://github.com/meijer1973/4veco-lessen/blob/f2660032cf7e4e3bbab96cf32863d06a38bd74bc/Boek%202%20-%20Kosten%2C%20opbrengsten%2C%20elasticiteit%20en%20surplus/edities/chat-2026/bronnen/H1/2.1%20Kosten%20en%20opbrengsten%20%E2%80%93%20antwoorden.md</a:t>
+              <a:t>Bron: leerlingenboek Boek 2, chatuitgave 2026, gedrukte pagina 21, 23. https://github.com/meijer1973/4veco-lessen/blob/a8940a7a79e22857a3e306a91fe923c48c63e716/Boek%202%20-%20Kosten%2C%20opbrengsten%2C%20elasticiteit%20en%20surplus/edities/chat-2026/boek/Boek_2_Compleet.pdf</a:t>
+            </a:r>
+          </a:p>
+          <a:p xmlns:a="http://schemas.openxmlformats.org/drawingml/2006/main">
+            <a:r>
+              <a:rPr sz="1400"/>
+              <a:t>Antwoordmodel: https://github.com/meijer1973/4veco-lessen/blob/a8940a7a79e22857a3e306a91fe923c48c63e716/Boek%202%20-%20Kosten%2C%20opbrengsten%2C%20elasticiteit%20en%20surplus/edities/chat-2026/bronnen/H1/2.1%20Kosten%20en%20opbrengsten%20%E2%80%93%20antwoorden.md</a:t>
             </a:r>
           </a:p>
           <a:p xmlns:a="http://schemas.openxmlformats.org/drawingml/2006/main">
@@ -791,13 +791,13 @@
           <a:p xmlns:a="http://schemas.openxmlformats.org/drawingml/2006/main">
             <a:r>
               <a:rPr sz="1400"/>
-              <a:t>Bron: leerlingenboek Boek 2, chatuitgave 2026, gedrukte pagina 19, 21. https://github.com/meijer1973/4veco-lessen/blob/f2660032cf7e4e3bbab96cf32863d06a38bd74bc/Boek%202%20-%20Kosten%2C%20opbrengsten%2C%20elasticiteit%20en%20surplus/edities/chat-2026/boek/Boek_2_Compleet.pdf</a:t>
-            </a:r>
-          </a:p>
-          <a:p xmlns:a="http://schemas.openxmlformats.org/drawingml/2006/main">
-            <a:r>
-              <a:rPr sz="1400"/>
-              <a:t>Antwoordmodel: https://github.com/meijer1973/4veco-lessen/blob/f2660032cf7e4e3bbab96cf32863d06a38bd74bc/Boek%202%20-%20Kosten%2C%20opbrengsten%2C%20elasticiteit%20en%20surplus/edities/chat-2026/bronnen/H1/2.1%20Kosten%20en%20opbrengsten%20%E2%80%93%20antwoorden.md</a:t>
+              <a:t>Bron: leerlingenboek Boek 2, chatuitgave 2026, gedrukte pagina 19, 21. https://github.com/meijer1973/4veco-lessen/blob/a8940a7a79e22857a3e306a91fe923c48c63e716/Boek%202%20-%20Kosten%2C%20opbrengsten%2C%20elasticiteit%20en%20surplus/edities/chat-2026/boek/Boek_2_Compleet.pdf</a:t>
+            </a:r>
+          </a:p>
+          <a:p xmlns:a="http://schemas.openxmlformats.org/drawingml/2006/main">
+            <a:r>
+              <a:rPr sz="1400"/>
+              <a:t>Antwoordmodel: https://github.com/meijer1973/4veco-lessen/blob/a8940a7a79e22857a3e306a91fe923c48c63e716/Boek%202%20-%20Kosten%2C%20opbrengsten%2C%20elasticiteit%20en%20surplus/edities/chat-2026/bronnen/H1/2.1%20Kosten%20en%20opbrengsten%20%E2%80%93%20antwoorden.md</a:t>
             </a:r>
           </a:p>
           <a:p xmlns:a="http://schemas.openxmlformats.org/drawingml/2006/main">
@@ -922,13 +922,13 @@
           <a:p xmlns:a="http://schemas.openxmlformats.org/drawingml/2006/main">
             <a:r>
               <a:rPr sz="1400"/>
-              <a:t>Bron: leerlingenboek Boek 2, chatuitgave 2026, gedrukte pagina 19–21. https://github.com/meijer1973/4veco-lessen/blob/f2660032cf7e4e3bbab96cf32863d06a38bd74bc/Boek%202%20-%20Kosten%2C%20opbrengsten%2C%20elasticiteit%20en%20surplus/edities/chat-2026/boek/Boek_2_Compleet.pdf</a:t>
-            </a:r>
-          </a:p>
-          <a:p xmlns:a="http://schemas.openxmlformats.org/drawingml/2006/main">
-            <a:r>
-              <a:rPr sz="1400"/>
-              <a:t>Antwoordmodel: https://github.com/meijer1973/4veco-lessen/blob/f2660032cf7e4e3bbab96cf32863d06a38bd74bc/Boek%202%20-%20Kosten%2C%20opbrengsten%2C%20elasticiteit%20en%20surplus/edities/chat-2026/bronnen/H1/2.1%20Kosten%20en%20opbrengsten%20%E2%80%93%20antwoorden.md</a:t>
+              <a:t>Bron: leerlingenboek Boek 2, chatuitgave 2026, gedrukte pagina 19–21. https://github.com/meijer1973/4veco-lessen/blob/a8940a7a79e22857a3e306a91fe923c48c63e716/Boek%202%20-%20Kosten%2C%20opbrengsten%2C%20elasticiteit%20en%20surplus/edities/chat-2026/boek/Boek_2_Compleet.pdf</a:t>
+            </a:r>
+          </a:p>
+          <a:p xmlns:a="http://schemas.openxmlformats.org/drawingml/2006/main">
+            <a:r>
+              <a:rPr sz="1400"/>
+              <a:t>Antwoordmodel: https://github.com/meijer1973/4veco-lessen/blob/a8940a7a79e22857a3e306a91fe923c48c63e716/Boek%202%20-%20Kosten%2C%20opbrengsten%2C%20elasticiteit%20en%20surplus/edities/chat-2026/bronnen/H1/2.1%20Kosten%20en%20opbrengsten%20%E2%80%93%20antwoorden.md</a:t>
             </a:r>
           </a:p>
           <a:p xmlns:a="http://schemas.openxmlformats.org/drawingml/2006/main">
@@ -1053,13 +1053,13 @@
           <a:p xmlns:a="http://schemas.openxmlformats.org/drawingml/2006/main">
             <a:r>
               <a:rPr sz="1400"/>
-              <a:t>Bron: leerlingenboek Boek 2, chatuitgave 2026, gedrukte pagina 19–21. https://github.com/meijer1973/4veco-lessen/blob/f2660032cf7e4e3bbab96cf32863d06a38bd74bc/Boek%202%20-%20Kosten%2C%20opbrengsten%2C%20elasticiteit%20en%20surplus/edities/chat-2026/boek/Boek_2_Compleet.pdf</a:t>
-            </a:r>
-          </a:p>
-          <a:p xmlns:a="http://schemas.openxmlformats.org/drawingml/2006/main">
-            <a:r>
-              <a:rPr sz="1400"/>
-              <a:t>Antwoordmodel: https://github.com/meijer1973/4veco-lessen/blob/f2660032cf7e4e3bbab96cf32863d06a38bd74bc/Boek%202%20-%20Kosten%2C%20opbrengsten%2C%20elasticiteit%20en%20surplus/edities/chat-2026/bronnen/H1/2.1%20Kosten%20en%20opbrengsten%20%E2%80%93%20antwoorden.md</a:t>
+              <a:t>Bron: leerlingenboek Boek 2, chatuitgave 2026, gedrukte pagina 19–21. https://github.com/meijer1973/4veco-lessen/blob/a8940a7a79e22857a3e306a91fe923c48c63e716/Boek%202%20-%20Kosten%2C%20opbrengsten%2C%20elasticiteit%20en%20surplus/edities/chat-2026/boek/Boek_2_Compleet.pdf</a:t>
+            </a:r>
+          </a:p>
+          <a:p xmlns:a="http://schemas.openxmlformats.org/drawingml/2006/main">
+            <a:r>
+              <a:rPr sz="1400"/>
+              <a:t>Antwoordmodel: https://github.com/meijer1973/4veco-lessen/blob/a8940a7a79e22857a3e306a91fe923c48c63e716/Boek%202%20-%20Kosten%2C%20opbrengsten%2C%20elasticiteit%20en%20surplus/edities/chat-2026/bronnen/H1/2.1%20Kosten%20en%20opbrengsten%20%E2%80%93%20antwoorden.md</a:t>
             </a:r>
           </a:p>
           <a:p xmlns:a="http://schemas.openxmlformats.org/drawingml/2006/main">
@@ -1148,7 +1148,7 @@
           <a:p xmlns:a="http://schemas.openxmlformats.org/drawingml/2006/main">
             <a:r>
               <a:rPr sz="1400"/>
-              <a:t>Uitleg: Laat het overzicht staan tijdens zelfstandig werken. Start 1–2: pagina 23. Basis 3–4: pagina 23–24. Zelfstandig 5–6: pagina 24–25. Doel 7: pagina 26. Huiswerk 3, 4, 5, 6 en 7 maken en nakijken. Denkertje 8 en herhaling 9–10 zijn extra. De volledige route hoeft niet binnen één les af; plan vervolgwerktijd.</a:t>
+              <a:t>Uitleg: Laat het overzicht staan tijdens zelfstandig werken. Start 1–2: pagina 24. Basis 3–4: pagina 24–25. Zelfstandig 5–6: pagina 25–26. Doel 7: pagina 27. Huiswerk 3, 4, 5, 6 en 7 maken en nakijken. Denkertje 8 en herhaling 9–10 zijn extra. De volledige route hoeft niet binnen één les af; plan vervolgwerktijd.</a:t>
             </a:r>
           </a:p>
           <a:p xmlns:a="http://schemas.openxmlformats.org/drawingml/2006/main">
@@ -1196,13 +1196,13 @@
           <a:p xmlns:a="http://schemas.openxmlformats.org/drawingml/2006/main">
             <a:r>
               <a:rPr sz="1400"/>
-              <a:t>Bron: leerlingenboek Boek 2, chatuitgave 2026, gedrukte pagina 23–26. https://github.com/meijer1973/4veco-lessen/blob/f2660032cf7e4e3bbab96cf32863d06a38bd74bc/Boek%202%20-%20Kosten%2C%20opbrengsten%2C%20elasticiteit%20en%20surplus/edities/chat-2026/boek/Boek_2_Compleet.pdf</a:t>
-            </a:r>
-          </a:p>
-          <a:p xmlns:a="http://schemas.openxmlformats.org/drawingml/2006/main">
-            <a:r>
-              <a:rPr sz="1400"/>
-              <a:t>Antwoordmodel: https://github.com/meijer1973/4veco-lessen/blob/f2660032cf7e4e3bbab96cf32863d06a38bd74bc/Boek%202%20-%20Kosten%2C%20opbrengsten%2C%20elasticiteit%20en%20surplus/edities/chat-2026/bronnen/H1/2.1%20Kosten%20en%20opbrengsten%20%E2%80%93%20antwoorden.md</a:t>
+              <a:t>Bron: leerlingenboek Boek 2, chatuitgave 2026, gedrukte pagina 24–27. https://github.com/meijer1973/4veco-lessen/blob/a8940a7a79e22857a3e306a91fe923c48c63e716/Boek%202%20-%20Kosten%2C%20opbrengsten%2C%20elasticiteit%20en%20surplus/edities/chat-2026/boek/Boek_2_Compleet.pdf</a:t>
+            </a:r>
+          </a:p>
+          <a:p xmlns:a="http://schemas.openxmlformats.org/drawingml/2006/main">
+            <a:r>
+              <a:rPr sz="1400"/>
+              <a:t>Antwoordmodel: https://github.com/meijer1973/4veco-lessen/blob/a8940a7a79e22857a3e306a91fe923c48c63e716/Boek%202%20-%20Kosten%2C%20opbrengsten%2C%20elasticiteit%20en%20surplus/edities/chat-2026/bronnen/H1/2.1%20Kosten%20en%20opbrengsten%20%E2%80%93%20antwoorden.md</a:t>
             </a:r>
           </a:p>
           <a:p xmlns:a="http://schemas.openxmlformats.org/drawingml/2006/main">
@@ -1327,13 +1327,13 @@
           <a:p xmlns:a="http://schemas.openxmlformats.org/drawingml/2006/main">
             <a:r>
               <a:rPr sz="1400"/>
-              <a:t>Bron: leerlingenboek Boek 2, chatuitgave 2026, gedrukte pagina 26. https://github.com/meijer1973/4veco-lessen/blob/f2660032cf7e4e3bbab96cf32863d06a38bd74bc/Boek%202%20-%20Kosten%2C%20opbrengsten%2C%20elasticiteit%20en%20surplus/edities/chat-2026/boek/Boek_2_Compleet.pdf</a:t>
-            </a:r>
-          </a:p>
-          <a:p xmlns:a="http://schemas.openxmlformats.org/drawingml/2006/main">
-            <a:r>
-              <a:rPr sz="1400"/>
-              <a:t>Antwoordmodel: https://github.com/meijer1973/4veco-lessen/blob/f2660032cf7e4e3bbab96cf32863d06a38bd74bc/Boek%202%20-%20Kosten%2C%20opbrengsten%2C%20elasticiteit%20en%20surplus/edities/chat-2026/bronnen/H1/2.1%20Kosten%20en%20opbrengsten%20%E2%80%93%20antwoorden.md</a:t>
+              <a:t>Bron: leerlingenboek Boek 2, chatuitgave 2026, gedrukte pagina 27. https://github.com/meijer1973/4veco-lessen/blob/a8940a7a79e22857a3e306a91fe923c48c63e716/Boek%202%20-%20Kosten%2C%20opbrengsten%2C%20elasticiteit%20en%20surplus/edities/chat-2026/boek/Boek_2_Compleet.pdf</a:t>
+            </a:r>
+          </a:p>
+          <a:p xmlns:a="http://schemas.openxmlformats.org/drawingml/2006/main">
+            <a:r>
+              <a:rPr sz="1400"/>
+              <a:t>Antwoordmodel: https://github.com/meijer1973/4veco-lessen/blob/a8940a7a79e22857a3e306a91fe923c48c63e716/Boek%202%20-%20Kosten%2C%20opbrengsten%2C%20elasticiteit%20en%20surplus/edities/chat-2026/bronnen/H1/2.1%20Kosten%20en%20opbrengsten%20%E2%80%93%20antwoorden.md</a:t>
             </a:r>
           </a:p>
           <a:p xmlns:a="http://schemas.openxmlformats.org/drawingml/2006/main">
@@ -1458,13 +1458,13 @@
           <a:p xmlns:a="http://schemas.openxmlformats.org/drawingml/2006/main">
             <a:r>
               <a:rPr sz="1400"/>
-              <a:t>Bron: leerlingenboek Boek 2, chatuitgave 2026, gedrukte pagina 26. https://github.com/meijer1973/4veco-lessen/blob/f2660032cf7e4e3bbab96cf32863d06a38bd74bc/Boek%202%20-%20Kosten%2C%20opbrengsten%2C%20elasticiteit%20en%20surplus/edities/chat-2026/boek/Boek_2_Compleet.pdf</a:t>
-            </a:r>
-          </a:p>
-          <a:p xmlns:a="http://schemas.openxmlformats.org/drawingml/2006/main">
-            <a:r>
-              <a:rPr sz="1400"/>
-              <a:t>Antwoordmodel: https://github.com/meijer1973/4veco-lessen/blob/f2660032cf7e4e3bbab96cf32863d06a38bd74bc/Boek%202%20-%20Kosten%2C%20opbrengsten%2C%20elasticiteit%20en%20surplus/edities/chat-2026/bronnen/H1/2.1%20Kosten%20en%20opbrengsten%20%E2%80%93%20antwoorden.md</a:t>
+              <a:t>Bron: leerlingenboek Boek 2, chatuitgave 2026, gedrukte pagina 27. https://github.com/meijer1973/4veco-lessen/blob/a8940a7a79e22857a3e306a91fe923c48c63e716/Boek%202%20-%20Kosten%2C%20opbrengsten%2C%20elasticiteit%20en%20surplus/edities/chat-2026/boek/Boek_2_Compleet.pdf</a:t>
+            </a:r>
+          </a:p>
+          <a:p xmlns:a="http://schemas.openxmlformats.org/drawingml/2006/main">
+            <a:r>
+              <a:rPr sz="1400"/>
+              <a:t>Antwoordmodel: https://github.com/meijer1973/4veco-lessen/blob/a8940a7a79e22857a3e306a91fe923c48c63e716/Boek%202%20-%20Kosten%2C%20opbrengsten%2C%20elasticiteit%20en%20surplus/edities/chat-2026/bronnen/H1/2.1%20Kosten%20en%20opbrengsten%20%E2%80%93%20antwoorden.md</a:t>
             </a:r>
           </a:p>
           <a:p xmlns:a="http://schemas.openxmlformats.org/drawingml/2006/main">
@@ -1589,13 +1589,13 @@
           <a:p xmlns:a="http://schemas.openxmlformats.org/drawingml/2006/main">
             <a:r>
               <a:rPr sz="1400"/>
-              <a:t>Bron: leerlingenboek Boek 2, chatuitgave 2026, gedrukte pagina 26. https://github.com/meijer1973/4veco-lessen/blob/f2660032cf7e4e3bbab96cf32863d06a38bd74bc/Boek%202%20-%20Kosten%2C%20opbrengsten%2C%20elasticiteit%20en%20surplus/edities/chat-2026/boek/Boek_2_Compleet.pdf</a:t>
-            </a:r>
-          </a:p>
-          <a:p xmlns:a="http://schemas.openxmlformats.org/drawingml/2006/main">
-            <a:r>
-              <a:rPr sz="1400"/>
-              <a:t>Antwoordmodel: https://github.com/meijer1973/4veco-lessen/blob/f2660032cf7e4e3bbab96cf32863d06a38bd74bc/Boek%202%20-%20Kosten%2C%20opbrengsten%2C%20elasticiteit%20en%20surplus/edities/chat-2026/bronnen/H1/2.1%20Kosten%20en%20opbrengsten%20%E2%80%93%20antwoorden.md</a:t>
+              <a:t>Bron: leerlingenboek Boek 2, chatuitgave 2026, gedrukte pagina 27. https://github.com/meijer1973/4veco-lessen/blob/a8940a7a79e22857a3e306a91fe923c48c63e716/Boek%202%20-%20Kosten%2C%20opbrengsten%2C%20elasticiteit%20en%20surplus/edities/chat-2026/boek/Boek_2_Compleet.pdf</a:t>
+            </a:r>
+          </a:p>
+          <a:p xmlns:a="http://schemas.openxmlformats.org/drawingml/2006/main">
+            <a:r>
+              <a:rPr sz="1400"/>
+              <a:t>Antwoordmodel: https://github.com/meijer1973/4veco-lessen/blob/a8940a7a79e22857a3e306a91fe923c48c63e716/Boek%202%20-%20Kosten%2C%20opbrengsten%2C%20elasticiteit%20en%20surplus/edities/chat-2026/bronnen/H1/2.1%20Kosten%20en%20opbrengsten%20%E2%80%93%20antwoorden.md</a:t>
             </a:r>
           </a:p>
           <a:p xmlns:a="http://schemas.openxmlformats.org/drawingml/2006/main">
@@ -1720,13 +1720,13 @@
           <a:p xmlns:a="http://schemas.openxmlformats.org/drawingml/2006/main">
             <a:r>
               <a:rPr sz="1400"/>
-              <a:t>Bron: leerlingenboek Boek 2, chatuitgave 2026, gedrukte pagina 26. https://github.com/meijer1973/4veco-lessen/blob/f2660032cf7e4e3bbab96cf32863d06a38bd74bc/Boek%202%20-%20Kosten%2C%20opbrengsten%2C%20elasticiteit%20en%20surplus/edities/chat-2026/boek/Boek_2_Compleet.pdf</a:t>
-            </a:r>
-          </a:p>
-          <a:p xmlns:a="http://schemas.openxmlformats.org/drawingml/2006/main">
-            <a:r>
-              <a:rPr sz="1400"/>
-              <a:t>Antwoordmodel: https://github.com/meijer1973/4veco-lessen/blob/f2660032cf7e4e3bbab96cf32863d06a38bd74bc/Boek%202%20-%20Kosten%2C%20opbrengsten%2C%20elasticiteit%20en%20surplus/edities/chat-2026/bronnen/H1/2.1%20Kosten%20en%20opbrengsten%20%E2%80%93%20antwoorden.md</a:t>
+              <a:t>Bron: leerlingenboek Boek 2, chatuitgave 2026, gedrukte pagina 27. https://github.com/meijer1973/4veco-lessen/blob/a8940a7a79e22857a3e306a91fe923c48c63e716/Boek%202%20-%20Kosten%2C%20opbrengsten%2C%20elasticiteit%20en%20surplus/edities/chat-2026/boek/Boek_2_Compleet.pdf</a:t>
+            </a:r>
+          </a:p>
+          <a:p xmlns:a="http://schemas.openxmlformats.org/drawingml/2006/main">
+            <a:r>
+              <a:rPr sz="1400"/>
+              <a:t>Antwoordmodel: https://github.com/meijer1973/4veco-lessen/blob/a8940a7a79e22857a3e306a91fe923c48c63e716/Boek%202%20-%20Kosten%2C%20opbrengsten%2C%20elasticiteit%20en%20surplus/edities/chat-2026/bronnen/H1/2.1%20Kosten%20en%20opbrengsten%20%E2%80%93%20antwoorden.md</a:t>
             </a:r>
           </a:p>
           <a:p xmlns:a="http://schemas.openxmlformats.org/drawingml/2006/main">
@@ -1851,13 +1851,13 @@
           <a:p xmlns:a="http://schemas.openxmlformats.org/drawingml/2006/main">
             <a:r>
               <a:rPr sz="1400"/>
-              <a:t>Bron: leerlingenboek Boek 2, chatuitgave 2026, gedrukte pagina 26. https://github.com/meijer1973/4veco-lessen/blob/f2660032cf7e4e3bbab96cf32863d06a38bd74bc/Boek%202%20-%20Kosten%2C%20opbrengsten%2C%20elasticiteit%20en%20surplus/edities/chat-2026/boek/Boek_2_Compleet.pdf</a:t>
-            </a:r>
-          </a:p>
-          <a:p xmlns:a="http://schemas.openxmlformats.org/drawingml/2006/main">
-            <a:r>
-              <a:rPr sz="1400"/>
-              <a:t>Antwoordmodel: https://github.com/meijer1973/4veco-lessen/blob/f2660032cf7e4e3bbab96cf32863d06a38bd74bc/Boek%202%20-%20Kosten%2C%20opbrengsten%2C%20elasticiteit%20en%20surplus/edities/chat-2026/bronnen/H1/2.1%20Kosten%20en%20opbrengsten%20%E2%80%93%20antwoorden.md</a:t>
+              <a:t>Bron: leerlingenboek Boek 2, chatuitgave 2026, gedrukte pagina 27. https://github.com/meijer1973/4veco-lessen/blob/a8940a7a79e22857a3e306a91fe923c48c63e716/Boek%202%20-%20Kosten%2C%20opbrengsten%2C%20elasticiteit%20en%20surplus/edities/chat-2026/boek/Boek_2_Compleet.pdf</a:t>
+            </a:r>
+          </a:p>
+          <a:p xmlns:a="http://schemas.openxmlformats.org/drawingml/2006/main">
+            <a:r>
+              <a:rPr sz="1400"/>
+              <a:t>Antwoordmodel: https://github.com/meijer1973/4veco-lessen/blob/a8940a7a79e22857a3e306a91fe923c48c63e716/Boek%202%20-%20Kosten%2C%20opbrengsten%2C%20elasticiteit%20en%20surplus/edities/chat-2026/bronnen/H1/2.1%20Kosten%20en%20opbrengsten%20%E2%80%93%20antwoorden.md</a:t>
             </a:r>
           </a:p>
           <a:p xmlns:a="http://schemas.openxmlformats.org/drawingml/2006/main">
@@ -1982,13 +1982,13 @@
           <a:p xmlns:a="http://schemas.openxmlformats.org/drawingml/2006/main">
             <a:r>
               <a:rPr sz="1400"/>
-              <a:t>Bron: leerlingenboek Boek 2, chatuitgave 2026, gedrukte pagina 19–22. https://github.com/meijer1973/4veco-lessen/blob/f2660032cf7e4e3bbab96cf32863d06a38bd74bc/Boek%202%20-%20Kosten%2C%20opbrengsten%2C%20elasticiteit%20en%20surplus/edities/chat-2026/boek/Boek_2_Compleet.pdf</a:t>
-            </a:r>
-          </a:p>
-          <a:p xmlns:a="http://schemas.openxmlformats.org/drawingml/2006/main">
-            <a:r>
-              <a:rPr sz="1400"/>
-              <a:t>Antwoordmodel: https://github.com/meijer1973/4veco-lessen/blob/f2660032cf7e4e3bbab96cf32863d06a38bd74bc/Boek%202%20-%20Kosten%2C%20opbrengsten%2C%20elasticiteit%20en%20surplus/edities/chat-2026/bronnen/H1/2.1%20Kosten%20en%20opbrengsten%20%E2%80%93%20antwoorden.md</a:t>
+              <a:t>Bron: leerlingenboek Boek 2, chatuitgave 2026, gedrukte pagina 19–23. https://github.com/meijer1973/4veco-lessen/blob/a8940a7a79e22857a3e306a91fe923c48c63e716/Boek%202%20-%20Kosten%2C%20opbrengsten%2C%20elasticiteit%20en%20surplus/edities/chat-2026/boek/Boek_2_Compleet.pdf</a:t>
+            </a:r>
+          </a:p>
+          <a:p xmlns:a="http://schemas.openxmlformats.org/drawingml/2006/main">
+            <a:r>
+              <a:rPr sz="1400"/>
+              <a:t>Antwoordmodel: https://github.com/meijer1973/4veco-lessen/blob/a8940a7a79e22857a3e306a91fe923c48c63e716/Boek%202%20-%20Kosten%2C%20opbrengsten%2C%20elasticiteit%20en%20surplus/edities/chat-2026/bronnen/H1/2.1%20Kosten%20en%20opbrengsten%20%E2%80%93%20antwoorden.md</a:t>
             </a:r>
           </a:p>
           <a:p xmlns:a="http://schemas.openxmlformats.org/drawingml/2006/main">
@@ -2113,13 +2113,13 @@
           <a:p xmlns:a="http://schemas.openxmlformats.org/drawingml/2006/main">
             <a:r>
               <a:rPr sz="1400"/>
-              <a:t>Bron: leerlingenboek Boek 2, chatuitgave 2026, gedrukte pagina 26. https://github.com/meijer1973/4veco-lessen/blob/f2660032cf7e4e3bbab96cf32863d06a38bd74bc/Boek%202%20-%20Kosten%2C%20opbrengsten%2C%20elasticiteit%20en%20surplus/edities/chat-2026/boek/Boek_2_Compleet.pdf</a:t>
-            </a:r>
-          </a:p>
-          <a:p xmlns:a="http://schemas.openxmlformats.org/drawingml/2006/main">
-            <a:r>
-              <a:rPr sz="1400"/>
-              <a:t>Antwoordmodel: https://github.com/meijer1973/4veco-lessen/blob/f2660032cf7e4e3bbab96cf32863d06a38bd74bc/Boek%202%20-%20Kosten%2C%20opbrengsten%2C%20elasticiteit%20en%20surplus/edities/chat-2026/bronnen/H1/2.1%20Kosten%20en%20opbrengsten%20%E2%80%93%20antwoorden.md</a:t>
+              <a:t>Bron: leerlingenboek Boek 2, chatuitgave 2026, gedrukte pagina 27. https://github.com/meijer1973/4veco-lessen/blob/a8940a7a79e22857a3e306a91fe923c48c63e716/Boek%202%20-%20Kosten%2C%20opbrengsten%2C%20elasticiteit%20en%20surplus/edities/chat-2026/boek/Boek_2_Compleet.pdf</a:t>
+            </a:r>
+          </a:p>
+          <a:p xmlns:a="http://schemas.openxmlformats.org/drawingml/2006/main">
+            <a:r>
+              <a:rPr sz="1400"/>
+              <a:t>Antwoordmodel: https://github.com/meijer1973/4veco-lessen/blob/a8940a7a79e22857a3e306a91fe923c48c63e716/Boek%202%20-%20Kosten%2C%20opbrengsten%2C%20elasticiteit%20en%20surplus/edities/chat-2026/bronnen/H1/2.1%20Kosten%20en%20opbrengsten%20%E2%80%93%20antwoorden.md</a:t>
             </a:r>
           </a:p>
           <a:p xmlns:a="http://schemas.openxmlformats.org/drawingml/2006/main">
@@ -2244,13 +2244,13 @@
           <a:p xmlns:a="http://schemas.openxmlformats.org/drawingml/2006/main">
             <a:r>
               <a:rPr sz="1400"/>
-              <a:t>Bron: leerlingenboek Boek 2, chatuitgave 2026, gedrukte pagina 26. https://github.com/meijer1973/4veco-lessen/blob/f2660032cf7e4e3bbab96cf32863d06a38bd74bc/Boek%202%20-%20Kosten%2C%20opbrengsten%2C%20elasticiteit%20en%20surplus/edities/chat-2026/boek/Boek_2_Compleet.pdf</a:t>
-            </a:r>
-          </a:p>
-          <a:p xmlns:a="http://schemas.openxmlformats.org/drawingml/2006/main">
-            <a:r>
-              <a:rPr sz="1400"/>
-              <a:t>Antwoordmodel: https://github.com/meijer1973/4veco-lessen/blob/f2660032cf7e4e3bbab96cf32863d06a38bd74bc/Boek%202%20-%20Kosten%2C%20opbrengsten%2C%20elasticiteit%20en%20surplus/edities/chat-2026/bronnen/H1/2.1%20Kosten%20en%20opbrengsten%20%E2%80%93%20antwoorden.md</a:t>
+              <a:t>Bron: leerlingenboek Boek 2, chatuitgave 2026, gedrukte pagina 27. https://github.com/meijer1973/4veco-lessen/blob/a8940a7a79e22857a3e306a91fe923c48c63e716/Boek%202%20-%20Kosten%2C%20opbrengsten%2C%20elasticiteit%20en%20surplus/edities/chat-2026/boek/Boek_2_Compleet.pdf</a:t>
+            </a:r>
+          </a:p>
+          <a:p xmlns:a="http://schemas.openxmlformats.org/drawingml/2006/main">
+            <a:r>
+              <a:rPr sz="1400"/>
+              <a:t>Antwoordmodel: https://github.com/meijer1973/4veco-lessen/blob/a8940a7a79e22857a3e306a91fe923c48c63e716/Boek%202%20-%20Kosten%2C%20opbrengsten%2C%20elasticiteit%20en%20surplus/edities/chat-2026/bronnen/H1/2.1%20Kosten%20en%20opbrengsten%20%E2%80%93%20antwoorden.md</a:t>
             </a:r>
           </a:p>
           <a:p xmlns:a="http://schemas.openxmlformats.org/drawingml/2006/main">
@@ -2375,13 +2375,13 @@
           <a:p xmlns:a="http://schemas.openxmlformats.org/drawingml/2006/main">
             <a:r>
               <a:rPr sz="1400"/>
-              <a:t>Bron: leerlingenboek Boek 2, chatuitgave 2026, gedrukte pagina 26. https://github.com/meijer1973/4veco-lessen/blob/f2660032cf7e4e3bbab96cf32863d06a38bd74bc/Boek%202%20-%20Kosten%2C%20opbrengsten%2C%20elasticiteit%20en%20surplus/edities/chat-2026/boek/Boek_2_Compleet.pdf</a:t>
-            </a:r>
-          </a:p>
-          <a:p xmlns:a="http://schemas.openxmlformats.org/drawingml/2006/main">
-            <a:r>
-              <a:rPr sz="1400"/>
-              <a:t>Antwoordmodel: https://github.com/meijer1973/4veco-lessen/blob/f2660032cf7e4e3bbab96cf32863d06a38bd74bc/Boek%202%20-%20Kosten%2C%20opbrengsten%2C%20elasticiteit%20en%20surplus/edities/chat-2026/bronnen/H1/2.1%20Kosten%20en%20opbrengsten%20%E2%80%93%20antwoorden.md</a:t>
+              <a:t>Bron: leerlingenboek Boek 2, chatuitgave 2026, gedrukte pagina 27. https://github.com/meijer1973/4veco-lessen/blob/a8940a7a79e22857a3e306a91fe923c48c63e716/Boek%202%20-%20Kosten%2C%20opbrengsten%2C%20elasticiteit%20en%20surplus/edities/chat-2026/boek/Boek_2_Compleet.pdf</a:t>
+            </a:r>
+          </a:p>
+          <a:p xmlns:a="http://schemas.openxmlformats.org/drawingml/2006/main">
+            <a:r>
+              <a:rPr sz="1400"/>
+              <a:t>Antwoordmodel: https://github.com/meijer1973/4veco-lessen/blob/a8940a7a79e22857a3e306a91fe923c48c63e716/Boek%202%20-%20Kosten%2C%20opbrengsten%2C%20elasticiteit%20en%20surplus/edities/chat-2026/bronnen/H1/2.1%20Kosten%20en%20opbrengsten%20%E2%80%93%20antwoorden.md</a:t>
             </a:r>
           </a:p>
           <a:p xmlns:a="http://schemas.openxmlformats.org/drawingml/2006/main">
@@ -2506,13 +2506,13 @@
           <a:p xmlns:a="http://schemas.openxmlformats.org/drawingml/2006/main">
             <a:r>
               <a:rPr sz="1400"/>
-              <a:t>Bron: leerlingenboek Boek 2, chatuitgave 2026, gedrukte pagina 26. https://github.com/meijer1973/4veco-lessen/blob/f2660032cf7e4e3bbab96cf32863d06a38bd74bc/Boek%202%20-%20Kosten%2C%20opbrengsten%2C%20elasticiteit%20en%20surplus/edities/chat-2026/boek/Boek_2_Compleet.pdf</a:t>
-            </a:r>
-          </a:p>
-          <a:p xmlns:a="http://schemas.openxmlformats.org/drawingml/2006/main">
-            <a:r>
-              <a:rPr sz="1400"/>
-              <a:t>Antwoordmodel: https://github.com/meijer1973/4veco-lessen/blob/f2660032cf7e4e3bbab96cf32863d06a38bd74bc/Boek%202%20-%20Kosten%2C%20opbrengsten%2C%20elasticiteit%20en%20surplus/edities/chat-2026/bronnen/H1/2.1%20Kosten%20en%20opbrengsten%20%E2%80%93%20antwoorden.md</a:t>
+              <a:t>Bron: leerlingenboek Boek 2, chatuitgave 2026, gedrukte pagina 27. https://github.com/meijer1973/4veco-lessen/blob/a8940a7a79e22857a3e306a91fe923c48c63e716/Boek%202%20-%20Kosten%2C%20opbrengsten%2C%20elasticiteit%20en%20surplus/edities/chat-2026/boek/Boek_2_Compleet.pdf</a:t>
+            </a:r>
+          </a:p>
+          <a:p xmlns:a="http://schemas.openxmlformats.org/drawingml/2006/main">
+            <a:r>
+              <a:rPr sz="1400"/>
+              <a:t>Antwoordmodel: https://github.com/meijer1973/4veco-lessen/blob/a8940a7a79e22857a3e306a91fe923c48c63e716/Boek%202%20-%20Kosten%2C%20opbrengsten%2C%20elasticiteit%20en%20surplus/edities/chat-2026/bronnen/H1/2.1%20Kosten%20en%20opbrengsten%20%E2%80%93%20antwoorden.md</a:t>
             </a:r>
           </a:p>
           <a:p xmlns:a="http://schemas.openxmlformats.org/drawingml/2006/main">
@@ -2637,13 +2637,13 @@
           <a:p xmlns:a="http://schemas.openxmlformats.org/drawingml/2006/main">
             <a:r>
               <a:rPr sz="1400"/>
-              <a:t>Bron: leerlingenboek Boek 2, chatuitgave 2026, gedrukte pagina 26. https://github.com/meijer1973/4veco-lessen/blob/f2660032cf7e4e3bbab96cf32863d06a38bd74bc/Boek%202%20-%20Kosten%2C%20opbrengsten%2C%20elasticiteit%20en%20surplus/edities/chat-2026/boek/Boek_2_Compleet.pdf</a:t>
-            </a:r>
-          </a:p>
-          <a:p xmlns:a="http://schemas.openxmlformats.org/drawingml/2006/main">
-            <a:r>
-              <a:rPr sz="1400"/>
-              <a:t>Antwoordmodel: https://github.com/meijer1973/4veco-lessen/blob/f2660032cf7e4e3bbab96cf32863d06a38bd74bc/Boek%202%20-%20Kosten%2C%20opbrengsten%2C%20elasticiteit%20en%20surplus/edities/chat-2026/bronnen/H1/2.1%20Kosten%20en%20opbrengsten%20%E2%80%93%20antwoorden.md</a:t>
+              <a:t>Bron: leerlingenboek Boek 2, chatuitgave 2026, gedrukte pagina 27. https://github.com/meijer1973/4veco-lessen/blob/a8940a7a79e22857a3e306a91fe923c48c63e716/Boek%202%20-%20Kosten%2C%20opbrengsten%2C%20elasticiteit%20en%20surplus/edities/chat-2026/boek/Boek_2_Compleet.pdf</a:t>
+            </a:r>
+          </a:p>
+          <a:p xmlns:a="http://schemas.openxmlformats.org/drawingml/2006/main">
+            <a:r>
+              <a:rPr sz="1400"/>
+              <a:t>Antwoordmodel: https://github.com/meijer1973/4veco-lessen/blob/a8940a7a79e22857a3e306a91fe923c48c63e716/Boek%202%20-%20Kosten%2C%20opbrengsten%2C%20elasticiteit%20en%20surplus/edities/chat-2026/bronnen/H1/2.1%20Kosten%20en%20opbrengsten%20%E2%80%93%20antwoorden.md</a:t>
             </a:r>
           </a:p>
           <a:p xmlns:a="http://schemas.openxmlformats.org/drawingml/2006/main">
@@ -2768,13 +2768,13 @@
           <a:p xmlns:a="http://schemas.openxmlformats.org/drawingml/2006/main">
             <a:r>
               <a:rPr sz="1400"/>
-              <a:t>Bron: leerlingenboek Boek 2, chatuitgave 2026, gedrukte pagina 26. https://github.com/meijer1973/4veco-lessen/blob/f2660032cf7e4e3bbab96cf32863d06a38bd74bc/Boek%202%20-%20Kosten%2C%20opbrengsten%2C%20elasticiteit%20en%20surplus/edities/chat-2026/boek/Boek_2_Compleet.pdf</a:t>
-            </a:r>
-          </a:p>
-          <a:p xmlns:a="http://schemas.openxmlformats.org/drawingml/2006/main">
-            <a:r>
-              <a:rPr sz="1400"/>
-              <a:t>Antwoordmodel: https://github.com/meijer1973/4veco-lessen/blob/f2660032cf7e4e3bbab96cf32863d06a38bd74bc/Boek%202%20-%20Kosten%2C%20opbrengsten%2C%20elasticiteit%20en%20surplus/edities/chat-2026/bronnen/H1/2.1%20Kosten%20en%20opbrengsten%20%E2%80%93%20antwoorden.md</a:t>
+              <a:t>Bron: leerlingenboek Boek 2, chatuitgave 2026, gedrukte pagina 27. https://github.com/meijer1973/4veco-lessen/blob/a8940a7a79e22857a3e306a91fe923c48c63e716/Boek%202%20-%20Kosten%2C%20opbrengsten%2C%20elasticiteit%20en%20surplus/edities/chat-2026/boek/Boek_2_Compleet.pdf</a:t>
+            </a:r>
+          </a:p>
+          <a:p xmlns:a="http://schemas.openxmlformats.org/drawingml/2006/main">
+            <a:r>
+              <a:rPr sz="1400"/>
+              <a:t>Antwoordmodel: https://github.com/meijer1973/4veco-lessen/blob/a8940a7a79e22857a3e306a91fe923c48c63e716/Boek%202%20-%20Kosten%2C%20opbrengsten%2C%20elasticiteit%20en%20surplus/edities/chat-2026/bronnen/H1/2.1%20Kosten%20en%20opbrengsten%20%E2%80%93%20antwoorden.md</a:t>
             </a:r>
           </a:p>
           <a:p xmlns:a="http://schemas.openxmlformats.org/drawingml/2006/main">
@@ -2899,13 +2899,13 @@
           <a:p xmlns:a="http://schemas.openxmlformats.org/drawingml/2006/main">
             <a:r>
               <a:rPr sz="1400"/>
-              <a:t>Bron: leerlingenboek Boek 2, chatuitgave 2026, gedrukte pagina 26. https://github.com/meijer1973/4veco-lessen/blob/f2660032cf7e4e3bbab96cf32863d06a38bd74bc/Boek%202%20-%20Kosten%2C%20opbrengsten%2C%20elasticiteit%20en%20surplus/edities/chat-2026/boek/Boek_2_Compleet.pdf</a:t>
-            </a:r>
-          </a:p>
-          <a:p xmlns:a="http://schemas.openxmlformats.org/drawingml/2006/main">
-            <a:r>
-              <a:rPr sz="1400"/>
-              <a:t>Antwoordmodel: https://github.com/meijer1973/4veco-lessen/blob/f2660032cf7e4e3bbab96cf32863d06a38bd74bc/Boek%202%20-%20Kosten%2C%20opbrengsten%2C%20elasticiteit%20en%20surplus/edities/chat-2026/bronnen/H1/2.1%20Kosten%20en%20opbrengsten%20%E2%80%93%20antwoorden.md</a:t>
+              <a:t>Bron: leerlingenboek Boek 2, chatuitgave 2026, gedrukte pagina 27. https://github.com/meijer1973/4veco-lessen/blob/a8940a7a79e22857a3e306a91fe923c48c63e716/Boek%202%20-%20Kosten%2C%20opbrengsten%2C%20elasticiteit%20en%20surplus/edities/chat-2026/boek/Boek_2_Compleet.pdf</a:t>
+            </a:r>
+          </a:p>
+          <a:p xmlns:a="http://schemas.openxmlformats.org/drawingml/2006/main">
+            <a:r>
+              <a:rPr sz="1400"/>
+              <a:t>Antwoordmodel: https://github.com/meijer1973/4veco-lessen/blob/a8940a7a79e22857a3e306a91fe923c48c63e716/Boek%202%20-%20Kosten%2C%20opbrengsten%2C%20elasticiteit%20en%20surplus/edities/chat-2026/bronnen/H1/2.1%20Kosten%20en%20opbrengsten%20%E2%80%93%20antwoorden.md</a:t>
             </a:r>
           </a:p>
           <a:p xmlns:a="http://schemas.openxmlformats.org/drawingml/2006/main">
@@ -2994,7 +2994,7 @@
           <a:p xmlns:a="http://schemas.openxmlformats.org/drawingml/2006/main">
             <a:r>
               <a:rPr sz="1400"/>
-              <a:t>Uitleg: Laat het overzicht staan tijdens afsluiting / huiswerk. Start 1–2: pagina 23. Basis 3–4: pagina 23–24. Zelfstandig 5–6: pagina 24–25. Doel 7: pagina 26. Huiswerk 3, 4, 5, 6 en 7 maken en nakijken. Denkertje 8 en herhaling 9–10 zijn extra. De volledige route hoeft niet binnen één les af; plan vervolgwerktijd.</a:t>
+              <a:t>Uitleg: Laat het overzicht staan tijdens afsluiting / huiswerk. Start 1–2: pagina 24. Basis 3–4: pagina 24–25. Zelfstandig 5–6: pagina 25–26. Doel 7: pagina 27. Huiswerk 3, 4, 5, 6 en 7 maken en nakijken. Denkertje 8 en herhaling 9–10 zijn extra. De volledige route hoeft niet binnen één les af; plan vervolgwerktijd.</a:t>
             </a:r>
           </a:p>
           <a:p xmlns:a="http://schemas.openxmlformats.org/drawingml/2006/main">
@@ -3042,13 +3042,13 @@
           <a:p xmlns:a="http://schemas.openxmlformats.org/drawingml/2006/main">
             <a:r>
               <a:rPr sz="1400"/>
-              <a:t>Bron: leerlingenboek Boek 2, chatuitgave 2026, gedrukte pagina 23–26. https://github.com/meijer1973/4veco-lessen/blob/f2660032cf7e4e3bbab96cf32863d06a38bd74bc/Boek%202%20-%20Kosten%2C%20opbrengsten%2C%20elasticiteit%20en%20surplus/edities/chat-2026/boek/Boek_2_Compleet.pdf</a:t>
-            </a:r>
-          </a:p>
-          <a:p xmlns:a="http://schemas.openxmlformats.org/drawingml/2006/main">
-            <a:r>
-              <a:rPr sz="1400"/>
-              <a:t>Antwoordmodel: https://github.com/meijer1973/4veco-lessen/blob/f2660032cf7e4e3bbab96cf32863d06a38bd74bc/Boek%202%20-%20Kosten%2C%20opbrengsten%2C%20elasticiteit%20en%20surplus/edities/chat-2026/bronnen/H1/2.1%20Kosten%20en%20opbrengsten%20%E2%80%93%20antwoorden.md</a:t>
+              <a:t>Bron: leerlingenboek Boek 2, chatuitgave 2026, gedrukte pagina 24–27. https://github.com/meijer1973/4veco-lessen/blob/a8940a7a79e22857a3e306a91fe923c48c63e716/Boek%202%20-%20Kosten%2C%20opbrengsten%2C%20elasticiteit%20en%20surplus/edities/chat-2026/boek/Boek_2_Compleet.pdf</a:t>
+            </a:r>
+          </a:p>
+          <a:p xmlns:a="http://schemas.openxmlformats.org/drawingml/2006/main">
+            <a:r>
+              <a:rPr sz="1400"/>
+              <a:t>Antwoordmodel: https://github.com/meijer1973/4veco-lessen/blob/a8940a7a79e22857a3e306a91fe923c48c63e716/Boek%202%20-%20Kosten%2C%20opbrengsten%2C%20elasticiteit%20en%20surplus/edities/chat-2026/bronnen/H1/2.1%20Kosten%20en%20opbrengsten%20%E2%80%93%20antwoorden.md</a:t>
             </a:r>
           </a:p>
           <a:p xmlns:a="http://schemas.openxmlformats.org/drawingml/2006/main">
@@ -3173,13 +3173,13 @@
           <a:p xmlns:a="http://schemas.openxmlformats.org/drawingml/2006/main">
             <a:r>
               <a:rPr sz="1400"/>
-              <a:t>Bron: leerlingenboek Boek 2, chatuitgave 2026, gedrukte pagina 19–20. https://github.com/meijer1973/4veco-lessen/blob/f2660032cf7e4e3bbab96cf32863d06a38bd74bc/Boek%202%20-%20Kosten%2C%20opbrengsten%2C%20elasticiteit%20en%20surplus/edities/chat-2026/boek/Boek_2_Compleet.pdf</a:t>
-            </a:r>
-          </a:p>
-          <a:p xmlns:a="http://schemas.openxmlformats.org/drawingml/2006/main">
-            <a:r>
-              <a:rPr sz="1400"/>
-              <a:t>Antwoordmodel: https://github.com/meijer1973/4veco-lessen/blob/f2660032cf7e4e3bbab96cf32863d06a38bd74bc/Boek%202%20-%20Kosten%2C%20opbrengsten%2C%20elasticiteit%20en%20surplus/edities/chat-2026/bronnen/H1/2.1%20Kosten%20en%20opbrengsten%20%E2%80%93%20antwoorden.md</a:t>
+              <a:t>Bron: leerlingenboek Boek 2, chatuitgave 2026, gedrukte pagina 19–20. https://github.com/meijer1973/4veco-lessen/blob/a8940a7a79e22857a3e306a91fe923c48c63e716/Boek%202%20-%20Kosten%2C%20opbrengsten%2C%20elasticiteit%20en%20surplus/edities/chat-2026/boek/Boek_2_Compleet.pdf</a:t>
+            </a:r>
+          </a:p>
+          <a:p xmlns:a="http://schemas.openxmlformats.org/drawingml/2006/main">
+            <a:r>
+              <a:rPr sz="1400"/>
+              <a:t>Antwoordmodel: https://github.com/meijer1973/4veco-lessen/blob/a8940a7a79e22857a3e306a91fe923c48c63e716/Boek%202%20-%20Kosten%2C%20opbrengsten%2C%20elasticiteit%20en%20surplus/edities/chat-2026/bronnen/H1/2.1%20Kosten%20en%20opbrengsten%20%E2%80%93%20antwoorden.md</a:t>
             </a:r>
           </a:p>
           <a:p xmlns:a="http://schemas.openxmlformats.org/drawingml/2006/main">
@@ -3304,13 +3304,13 @@
           <a:p xmlns:a="http://schemas.openxmlformats.org/drawingml/2006/main">
             <a:r>
               <a:rPr sz="1400"/>
-              <a:t>Bron: leerlingenboek Boek 2, chatuitgave 2026, gedrukte pagina 20, 22. https://github.com/meijer1973/4veco-lessen/blob/f2660032cf7e4e3bbab96cf32863d06a38bd74bc/Boek%202%20-%20Kosten%2C%20opbrengsten%2C%20elasticiteit%20en%20surplus/edities/chat-2026/boek/Boek_2_Compleet.pdf</a:t>
-            </a:r>
-          </a:p>
-          <a:p xmlns:a="http://schemas.openxmlformats.org/drawingml/2006/main">
-            <a:r>
-              <a:rPr sz="1400"/>
-              <a:t>Antwoordmodel: https://github.com/meijer1973/4veco-lessen/blob/f2660032cf7e4e3bbab96cf32863d06a38bd74bc/Boek%202%20-%20Kosten%2C%20opbrengsten%2C%20elasticiteit%20en%20surplus/edities/chat-2026/bronnen/H1/2.1%20Kosten%20en%20opbrengsten%20%E2%80%93%20antwoorden.md</a:t>
+              <a:t>Bron: leerlingenboek Boek 2, chatuitgave 2026, gedrukte pagina 20, 22. https://github.com/meijer1973/4veco-lessen/blob/a8940a7a79e22857a3e306a91fe923c48c63e716/Boek%202%20-%20Kosten%2C%20opbrengsten%2C%20elasticiteit%20en%20surplus/edities/chat-2026/boek/Boek_2_Compleet.pdf</a:t>
+            </a:r>
+          </a:p>
+          <a:p xmlns:a="http://schemas.openxmlformats.org/drawingml/2006/main">
+            <a:r>
+              <a:rPr sz="1400"/>
+              <a:t>Antwoordmodel: https://github.com/meijer1973/4veco-lessen/blob/a8940a7a79e22857a3e306a91fe923c48c63e716/Boek%202%20-%20Kosten%2C%20opbrengsten%2C%20elasticiteit%20en%20surplus/edities/chat-2026/bronnen/H1/2.1%20Kosten%20en%20opbrengsten%20%E2%80%93%20antwoorden.md</a:t>
             </a:r>
           </a:p>
           <a:p xmlns:a="http://schemas.openxmlformats.org/drawingml/2006/main">
@@ -3435,13 +3435,13 @@
           <a:p xmlns:a="http://schemas.openxmlformats.org/drawingml/2006/main">
             <a:r>
               <a:rPr sz="1400"/>
-              <a:t>Bron: leerlingenboek Boek 2, chatuitgave 2026, gedrukte pagina 22. https://github.com/meijer1973/4veco-lessen/blob/f2660032cf7e4e3bbab96cf32863d06a38bd74bc/Boek%202%20-%20Kosten%2C%20opbrengsten%2C%20elasticiteit%20en%20surplus/edities/chat-2026/boek/Boek_2_Compleet.pdf</a:t>
-            </a:r>
-          </a:p>
-          <a:p xmlns:a="http://schemas.openxmlformats.org/drawingml/2006/main">
-            <a:r>
-              <a:rPr sz="1400"/>
-              <a:t>Antwoordmodel: https://github.com/meijer1973/4veco-lessen/blob/f2660032cf7e4e3bbab96cf32863d06a38bd74bc/Boek%202%20-%20Kosten%2C%20opbrengsten%2C%20elasticiteit%20en%20surplus/edities/chat-2026/bronnen/H1/2.1%20Kosten%20en%20opbrengsten%20%E2%80%93%20antwoorden.md</a:t>
+              <a:t>Bron: leerlingenboek Boek 2, chatuitgave 2026, gedrukte pagina 22. https://github.com/meijer1973/4veco-lessen/blob/a8940a7a79e22857a3e306a91fe923c48c63e716/Boek%202%20-%20Kosten%2C%20opbrengsten%2C%20elasticiteit%20en%20surplus/edities/chat-2026/boek/Boek_2_Compleet.pdf</a:t>
+            </a:r>
+          </a:p>
+          <a:p xmlns:a="http://schemas.openxmlformats.org/drawingml/2006/main">
+            <a:r>
+              <a:rPr sz="1400"/>
+              <a:t>Antwoordmodel: https://github.com/meijer1973/4veco-lessen/blob/a8940a7a79e22857a3e306a91fe923c48c63e716/Boek%202%20-%20Kosten%2C%20opbrengsten%2C%20elasticiteit%20en%20surplus/edities/chat-2026/bronnen/H1/2.1%20Kosten%20en%20opbrengsten%20%E2%80%93%20antwoorden.md</a:t>
             </a:r>
           </a:p>
           <a:p xmlns:a="http://schemas.openxmlformats.org/drawingml/2006/main">
@@ -3566,13 +3566,13 @@
           <a:p xmlns:a="http://schemas.openxmlformats.org/drawingml/2006/main">
             <a:r>
               <a:rPr sz="1400"/>
-              <a:t>Bron: leerlingenboek Boek 2, chatuitgave 2026, gedrukte pagina 19–20. https://github.com/meijer1973/4veco-lessen/blob/f2660032cf7e4e3bbab96cf32863d06a38bd74bc/Boek%202%20-%20Kosten%2C%20opbrengsten%2C%20elasticiteit%20en%20surplus/edities/chat-2026/boek/Boek_2_Compleet.pdf</a:t>
-            </a:r>
-          </a:p>
-          <a:p xmlns:a="http://schemas.openxmlformats.org/drawingml/2006/main">
-            <a:r>
-              <a:rPr sz="1400"/>
-              <a:t>Antwoordmodel: https://github.com/meijer1973/4veco-lessen/blob/f2660032cf7e4e3bbab96cf32863d06a38bd74bc/Boek%202%20-%20Kosten%2C%20opbrengsten%2C%20elasticiteit%20en%20surplus/edities/chat-2026/bronnen/H1/2.1%20Kosten%20en%20opbrengsten%20%E2%80%93%20antwoorden.md</a:t>
+              <a:t>Bron: leerlingenboek Boek 2, chatuitgave 2026, gedrukte pagina 19–20. https://github.com/meijer1973/4veco-lessen/blob/a8940a7a79e22857a3e306a91fe923c48c63e716/Boek%202%20-%20Kosten%2C%20opbrengsten%2C%20elasticiteit%20en%20surplus/edities/chat-2026/boek/Boek_2_Compleet.pdf</a:t>
+            </a:r>
+          </a:p>
+          <a:p xmlns:a="http://schemas.openxmlformats.org/drawingml/2006/main">
+            <a:r>
+              <a:rPr sz="1400"/>
+              <a:t>Antwoordmodel: https://github.com/meijer1973/4veco-lessen/blob/a8940a7a79e22857a3e306a91fe923c48c63e716/Boek%202%20-%20Kosten%2C%20opbrengsten%2C%20elasticiteit%20en%20surplus/edities/chat-2026/bronnen/H1/2.1%20Kosten%20en%20opbrengsten%20%E2%80%93%20antwoorden.md</a:t>
             </a:r>
           </a:p>
           <a:p xmlns:a="http://schemas.openxmlformats.org/drawingml/2006/main">
@@ -3697,13 +3697,13 @@
           <a:p xmlns:a="http://schemas.openxmlformats.org/drawingml/2006/main">
             <a:r>
               <a:rPr sz="1400"/>
-              <a:t>Bron: leerlingenboek Boek 2, chatuitgave 2026, gedrukte pagina 20, 22. https://github.com/meijer1973/4veco-lessen/blob/f2660032cf7e4e3bbab96cf32863d06a38bd74bc/Boek%202%20-%20Kosten%2C%20opbrengsten%2C%20elasticiteit%20en%20surplus/edities/chat-2026/boek/Boek_2_Compleet.pdf</a:t>
-            </a:r>
-          </a:p>
-          <a:p xmlns:a="http://schemas.openxmlformats.org/drawingml/2006/main">
-            <a:r>
-              <a:rPr sz="1400"/>
-              <a:t>Antwoordmodel: https://github.com/meijer1973/4veco-lessen/blob/f2660032cf7e4e3bbab96cf32863d06a38bd74bc/Boek%202%20-%20Kosten%2C%20opbrengsten%2C%20elasticiteit%20en%20surplus/edities/chat-2026/bronnen/H1/2.1%20Kosten%20en%20opbrengsten%20%E2%80%93%20antwoorden.md</a:t>
+              <a:t>Bron: leerlingenboek Boek 2, chatuitgave 2026, gedrukte pagina 20, 22. https://github.com/meijer1973/4veco-lessen/blob/a8940a7a79e22857a3e306a91fe923c48c63e716/Boek%202%20-%20Kosten%2C%20opbrengsten%2C%20elasticiteit%20en%20surplus/edities/chat-2026/boek/Boek_2_Compleet.pdf</a:t>
+            </a:r>
+          </a:p>
+          <a:p xmlns:a="http://schemas.openxmlformats.org/drawingml/2006/main">
+            <a:r>
+              <a:rPr sz="1400"/>
+              <a:t>Antwoordmodel: https://github.com/meijer1973/4veco-lessen/blob/a8940a7a79e22857a3e306a91fe923c48c63e716/Boek%202%20-%20Kosten%2C%20opbrengsten%2C%20elasticiteit%20en%20surplus/edities/chat-2026/bronnen/H1/2.1%20Kosten%20en%20opbrengsten%20%E2%80%93%20antwoorden.md</a:t>
             </a:r>
           </a:p>
           <a:p xmlns:a="http://schemas.openxmlformats.org/drawingml/2006/main">
@@ -3828,13 +3828,13 @@
           <a:p xmlns:a="http://schemas.openxmlformats.org/drawingml/2006/main">
             <a:r>
               <a:rPr sz="1400"/>
-              <a:t>Bron: leerlingenboek Boek 2, chatuitgave 2026, gedrukte pagina 20. https://github.com/meijer1973/4veco-lessen/blob/f2660032cf7e4e3bbab96cf32863d06a38bd74bc/Boek%202%20-%20Kosten%2C%20opbrengsten%2C%20elasticiteit%20en%20surplus/edities/chat-2026/boek/Boek_2_Compleet.pdf</a:t>
-            </a:r>
-          </a:p>
-          <a:p xmlns:a="http://schemas.openxmlformats.org/drawingml/2006/main">
-            <a:r>
-              <a:rPr sz="1400"/>
-              <a:t>Antwoordmodel: https://github.com/meijer1973/4veco-lessen/blob/f2660032cf7e4e3bbab96cf32863d06a38bd74bc/Boek%202%20-%20Kosten%2C%20opbrengsten%2C%20elasticiteit%20en%20surplus/edities/chat-2026/bronnen/H1/2.1%20Kosten%20en%20opbrengsten%20%E2%80%93%20antwoorden.md</a:t>
+              <a:t>Bron: leerlingenboek Boek 2, chatuitgave 2026, gedrukte pagina 20. https://github.com/meijer1973/4veco-lessen/blob/a8940a7a79e22857a3e306a91fe923c48c63e716/Boek%202%20-%20Kosten%2C%20opbrengsten%2C%20elasticiteit%20en%20surplus/edities/chat-2026/boek/Boek_2_Compleet.pdf</a:t>
+            </a:r>
+          </a:p>
+          <a:p xmlns:a="http://schemas.openxmlformats.org/drawingml/2006/main">
+            <a:r>
+              <a:rPr sz="1400"/>
+              <a:t>Antwoordmodel: https://github.com/meijer1973/4veco-lessen/blob/a8940a7a79e22857a3e306a91fe923c48c63e716/Boek%202%20-%20Kosten%2C%20opbrengsten%2C%20elasticiteit%20en%20surplus/edities/chat-2026/bronnen/H1/2.1%20Kosten%20en%20opbrengsten%20%E2%80%93%20antwoorden.md</a:t>
             </a:r>
           </a:p>
           <a:p xmlns:a="http://schemas.openxmlformats.org/drawingml/2006/main">
@@ -3959,13 +3959,13 @@
           <a:p xmlns:a="http://schemas.openxmlformats.org/drawingml/2006/main">
             <a:r>
               <a:rPr sz="1400"/>
-              <a:t>Bron: leerlingenboek Boek 2, chatuitgave 2026, gedrukte pagina 21–22. https://github.com/meijer1973/4veco-lessen/blob/f2660032cf7e4e3bbab96cf32863d06a38bd74bc/Boek%202%20-%20Kosten%2C%20opbrengsten%2C%20elasticiteit%20en%20surplus/edities/chat-2026/boek/Boek_2_Compleet.pdf</a:t>
-            </a:r>
-          </a:p>
-          <a:p xmlns:a="http://schemas.openxmlformats.org/drawingml/2006/main">
-            <a:r>
-              <a:rPr sz="1400"/>
-              <a:t>Antwoordmodel: https://github.com/meijer1973/4veco-lessen/blob/f2660032cf7e4e3bbab96cf32863d06a38bd74bc/Boek%202%20-%20Kosten%2C%20opbrengsten%2C%20elasticiteit%20en%20surplus/edities/chat-2026/bronnen/H1/2.1%20Kosten%20en%20opbrengsten%20%E2%80%93%20antwoorden.md</a:t>
+              <a:t>Bron: leerlingenboek Boek 2, chatuitgave 2026, gedrukte pagina 21, 23. https://github.com/meijer1973/4veco-lessen/blob/a8940a7a79e22857a3e306a91fe923c48c63e716/Boek%202%20-%20Kosten%2C%20opbrengsten%2C%20elasticiteit%20en%20surplus/edities/chat-2026/boek/Boek_2_Compleet.pdf</a:t>
+            </a:r>
+          </a:p>
+          <a:p xmlns:a="http://schemas.openxmlformats.org/drawingml/2006/main">
+            <a:r>
+              <a:rPr sz="1400"/>
+              <a:t>Antwoordmodel: https://github.com/meijer1973/4veco-lessen/blob/a8940a7a79e22857a3e306a91fe923c48c63e716/Boek%202%20-%20Kosten%2C%20opbrengsten%2C%20elasticiteit%20en%20surplus/edities/chat-2026/bronnen/H1/2.1%20Kosten%20en%20opbrengsten%20%E2%80%93%20antwoorden.md</a:t>
             </a:r>
           </a:p>
           <a:p xmlns:a="http://schemas.openxmlformats.org/drawingml/2006/main">
@@ -4039,7 +4039,7 @@
   </p:cSld>
   <p:clrMap bg1="lt1" tx1="dk1" bg2="lt2" tx2="dk2" accent1="accent1" accent2="accent2" accent3="accent3" accent4="accent4" accent5="accent5" accent6="accent6" hlink="hlink" folHlink="folHlink"/>
   <p:sldLayoutIdLst>
-    <p:sldLayoutId xmlns:r="http://schemas.openxmlformats.org/officeDocument/2006/relationships" id="2147483649" r:id="Rd4de3ba369e94b61"/>
+    <p:sldLayoutId xmlns:r="http://schemas.openxmlformats.org/officeDocument/2006/relationships" id="2147483649" r:id="Rce13a8df1d2a46eb"/>
   </p:sldLayoutIdLst>
   <p:txStyles>
     <p:titleStyle>
@@ -4590,7 +4590,7 @@
           <p:cNvPr id="29" name="Deze les: §2.1.3 Marginale kosten en marginale opbrengsten">
             <a:extLst xmlns:a="http://schemas.openxmlformats.org/drawingml/2006/main">
               <a:ext uri="{FF2B5EF4-FFF2-40B4-BE49-F238E27FC236}">
-                <a16:creationId xmlns:a16="http://schemas.microsoft.com/office/drawing/2014/main" id="{2DDE432B-8C2D-47FD-879D-13126F1A5AA4}"/>
+                <a16:creationId xmlns:a16="http://schemas.microsoft.com/office/drawing/2014/main" id="{2ACB1F82-D504-4CDC-A8CE-D257C04312DC}"/>
               </a:ext>
             </a:extLst>
           </p:cNvPr>
@@ -4647,7 +4647,7 @@
           <p:cNvPr id="2" name="">
             <a:extLst xmlns:a="http://schemas.openxmlformats.org/drawingml/2006/main">
               <a:ext uri="{FF2B5EF4-FFF2-40B4-BE49-F238E27FC236}">
-                <a16:creationId xmlns:a16="http://schemas.microsoft.com/office/drawing/2014/main" id="{219C3019-FF73-4412-A4C4-9F9B00F79F99}"/>
+                <a16:creationId xmlns:a16="http://schemas.microsoft.com/office/drawing/2014/main" id="{B77064CF-DCBD-40C6-B6ED-6B4BF29B836B}"/>
               </a:ext>
             </a:extLst>
           </p:cNvPr>
@@ -4676,7 +4676,7 @@
           <p:cNvPr id="3" name="§2.1.3 Marginale kosten en marginale opbrengsten">
             <a:extLst xmlns:a="http://schemas.openxmlformats.org/drawingml/2006/main">
               <a:ext uri="{FF2B5EF4-FFF2-40B4-BE49-F238E27FC236}">
-                <a16:creationId xmlns:a16="http://schemas.microsoft.com/office/drawing/2014/main" id="{982463E5-BDDA-43F7-9F75-36D5574F5B00}"/>
+                <a16:creationId xmlns:a16="http://schemas.microsoft.com/office/drawing/2014/main" id="{C884383E-C5ED-485A-AC97-A994117454FE}"/>
               </a:ext>
             </a:extLst>
           </p:cNvPr>
@@ -4733,7 +4733,7 @@
           <p:cNvPr id="4" name="slide-number">
             <a:extLst xmlns:a="http://schemas.openxmlformats.org/drawingml/2006/main">
               <a:ext uri="{FF2B5EF4-FFF2-40B4-BE49-F238E27FC236}">
-                <a16:creationId xmlns:a16="http://schemas.microsoft.com/office/drawing/2014/main" id="{CBDEC459-19DC-430E-8B7A-E5655D36D2AB}"/>
+                <a16:creationId xmlns:a16="http://schemas.microsoft.com/office/drawing/2014/main" id="{8B081A72-DB59-4497-801F-B1083A5CCEEC}"/>
               </a:ext>
             </a:extLst>
           </p:cNvPr>
@@ -4790,7 +4790,7 @@
           <p:cNvPr id="5" name="phase">
             <a:extLst xmlns:a="http://schemas.openxmlformats.org/drawingml/2006/main">
               <a:ext uri="{FF2B5EF4-FFF2-40B4-BE49-F238E27FC236}">
-                <a16:creationId xmlns:a16="http://schemas.microsoft.com/office/drawing/2014/main" id="{18C2A3AF-8931-420C-9242-CEEBC539AADF}"/>
+                <a16:creationId xmlns:a16="http://schemas.microsoft.com/office/drawing/2014/main" id="{E76CD7F6-71C0-4A47-9BDE-4F8B939B945B}"/>
               </a:ext>
             </a:extLst>
           </p:cNvPr>
@@ -4847,7 +4847,7 @@
           <p:cNvPr id="6" name="Lesroute">
             <a:extLst xmlns:a="http://schemas.openxmlformats.org/drawingml/2006/main">
               <a:ext uri="{FF2B5EF4-FFF2-40B4-BE49-F238E27FC236}">
-                <a16:creationId xmlns:a16="http://schemas.microsoft.com/office/drawing/2014/main" id="{44239CC6-5F04-499E-BA22-4FC1C8512DA0}"/>
+                <a16:creationId xmlns:a16="http://schemas.microsoft.com/office/drawing/2014/main" id="{E17A7C4F-8090-47F3-90A2-018875126337}"/>
               </a:ext>
             </a:extLst>
           </p:cNvPr>
@@ -4904,7 +4904,7 @@
           <p:cNvPr id="7" name="route-number-1">
             <a:extLst xmlns:a="http://schemas.openxmlformats.org/drawingml/2006/main">
               <a:ext uri="{FF2B5EF4-FFF2-40B4-BE49-F238E27FC236}">
-                <a16:creationId xmlns:a16="http://schemas.microsoft.com/office/drawing/2014/main" id="{25E0221B-DDC0-4A08-B34A-90260453DB37}"/>
+                <a16:creationId xmlns:a16="http://schemas.microsoft.com/office/drawing/2014/main" id="{D22A6982-032F-4A26-95B1-E73924546EDE}"/>
               </a:ext>
             </a:extLst>
           </p:cNvPr>
@@ -4961,7 +4961,7 @@
           <p:cNvPr id="8" name="route-1">
             <a:extLst xmlns:a="http://schemas.openxmlformats.org/drawingml/2006/main">
               <a:ext uri="{FF2B5EF4-FFF2-40B4-BE49-F238E27FC236}">
-                <a16:creationId xmlns:a16="http://schemas.microsoft.com/office/drawing/2014/main" id="{9CC624F1-89A8-4315-8804-C57B830220E3}"/>
+                <a16:creationId xmlns:a16="http://schemas.microsoft.com/office/drawing/2014/main" id="{52B983A3-CF1D-42FD-8E61-F5949CCB7F2E}"/>
               </a:ext>
             </a:extLst>
           </p:cNvPr>
@@ -5018,7 +5018,7 @@
           <p:cNvPr id="9" name="route-number-2">
             <a:extLst xmlns:a="http://schemas.openxmlformats.org/drawingml/2006/main">
               <a:ext uri="{FF2B5EF4-FFF2-40B4-BE49-F238E27FC236}">
-                <a16:creationId xmlns:a16="http://schemas.microsoft.com/office/drawing/2014/main" id="{910C54EA-7E7C-4A72-8A34-79E3935CE8BD}"/>
+                <a16:creationId xmlns:a16="http://schemas.microsoft.com/office/drawing/2014/main" id="{1096F9A9-BA2F-4052-8298-5F40AD0AB4D7}"/>
               </a:ext>
             </a:extLst>
           </p:cNvPr>
@@ -5075,7 +5075,7 @@
           <p:cNvPr id="10" name="route-2">
             <a:extLst xmlns:a="http://schemas.openxmlformats.org/drawingml/2006/main">
               <a:ext uri="{FF2B5EF4-FFF2-40B4-BE49-F238E27FC236}">
-                <a16:creationId xmlns:a16="http://schemas.microsoft.com/office/drawing/2014/main" id="{BABB5312-1D53-4B27-B1BD-2F8EA3937F2A}"/>
+                <a16:creationId xmlns:a16="http://schemas.microsoft.com/office/drawing/2014/main" id="{599B09C3-4DEB-4E2D-A4D8-78139F67575D}"/>
               </a:ext>
             </a:extLst>
           </p:cNvPr>
@@ -5132,7 +5132,7 @@
           <p:cNvPr id="11" name="route-number-3">
             <a:extLst xmlns:a="http://schemas.openxmlformats.org/drawingml/2006/main">
               <a:ext uri="{FF2B5EF4-FFF2-40B4-BE49-F238E27FC236}">
-                <a16:creationId xmlns:a16="http://schemas.microsoft.com/office/drawing/2014/main" id="{B645935D-A3C4-4EB2-9214-FCDF77CB9321}"/>
+                <a16:creationId xmlns:a16="http://schemas.microsoft.com/office/drawing/2014/main" id="{6A30770E-029C-4FB6-A2A8-9DE458EC936A}"/>
               </a:ext>
             </a:extLst>
           </p:cNvPr>
@@ -5189,7 +5189,7 @@
           <p:cNvPr id="12" name="route-3">
             <a:extLst xmlns:a="http://schemas.openxmlformats.org/drawingml/2006/main">
               <a:ext uri="{FF2B5EF4-FFF2-40B4-BE49-F238E27FC236}">
-                <a16:creationId xmlns:a16="http://schemas.microsoft.com/office/drawing/2014/main" id="{40530565-5E74-4E8A-AB71-9F8FEDFECBA1}"/>
+                <a16:creationId xmlns:a16="http://schemas.microsoft.com/office/drawing/2014/main" id="{CA17C12D-DC87-4D89-BE23-26FA5DB6AE86}"/>
               </a:ext>
             </a:extLst>
           </p:cNvPr>
@@ -5246,7 +5246,7 @@
           <p:cNvPr id="13" name="route-number-4">
             <a:extLst xmlns:a="http://schemas.openxmlformats.org/drawingml/2006/main">
               <a:ext uri="{FF2B5EF4-FFF2-40B4-BE49-F238E27FC236}">
-                <a16:creationId xmlns:a16="http://schemas.microsoft.com/office/drawing/2014/main" id="{39C20D84-B341-451C-A3BA-E0186619EBAC}"/>
+                <a16:creationId xmlns:a16="http://schemas.microsoft.com/office/drawing/2014/main" id="{9A852035-A17F-4EDB-97EA-422DEBBE33E3}"/>
               </a:ext>
             </a:extLst>
           </p:cNvPr>
@@ -5303,7 +5303,7 @@
           <p:cNvPr id="14" name="route-4">
             <a:extLst xmlns:a="http://schemas.openxmlformats.org/drawingml/2006/main">
               <a:ext uri="{FF2B5EF4-FFF2-40B4-BE49-F238E27FC236}">
-                <a16:creationId xmlns:a16="http://schemas.microsoft.com/office/drawing/2014/main" id="{17F95989-BAD4-4F19-9C63-84B0415CAE88}"/>
+                <a16:creationId xmlns:a16="http://schemas.microsoft.com/office/drawing/2014/main" id="{2E10BDF7-7DCE-4B62-85AA-6192B2541747}"/>
               </a:ext>
             </a:extLst>
           </p:cNvPr>
@@ -5360,7 +5360,7 @@
           <p:cNvPr id="15" name="route-number-5">
             <a:extLst xmlns:a="http://schemas.openxmlformats.org/drawingml/2006/main">
               <a:ext uri="{FF2B5EF4-FFF2-40B4-BE49-F238E27FC236}">
-                <a16:creationId xmlns:a16="http://schemas.microsoft.com/office/drawing/2014/main" id="{6E4B62EA-2E49-4B2A-A034-1E69F8F18A2A}"/>
+                <a16:creationId xmlns:a16="http://schemas.microsoft.com/office/drawing/2014/main" id="{B2559353-9EDE-496B-886B-D12898A1D12C}"/>
               </a:ext>
             </a:extLst>
           </p:cNvPr>
@@ -5417,7 +5417,7 @@
           <p:cNvPr id="16" name="route-5">
             <a:extLst xmlns:a="http://schemas.openxmlformats.org/drawingml/2006/main">
               <a:ext uri="{FF2B5EF4-FFF2-40B4-BE49-F238E27FC236}">
-                <a16:creationId xmlns:a16="http://schemas.microsoft.com/office/drawing/2014/main" id="{E21FC1E6-96BE-4F45-B961-D6EBA77209BF}"/>
+                <a16:creationId xmlns:a16="http://schemas.microsoft.com/office/drawing/2014/main" id="{D9FB5346-42B6-43BB-9E05-E574FB863D3D}"/>
               </a:ext>
             </a:extLst>
           </p:cNvPr>
@@ -5474,7 +5474,7 @@
           <p:cNvPr id="17" name="route-number-6">
             <a:extLst xmlns:a="http://schemas.openxmlformats.org/drawingml/2006/main">
               <a:ext uri="{FF2B5EF4-FFF2-40B4-BE49-F238E27FC236}">
-                <a16:creationId xmlns:a16="http://schemas.microsoft.com/office/drawing/2014/main" id="{E84D78BC-0CBF-4B20-9A16-EF8017ED4844}"/>
+                <a16:creationId xmlns:a16="http://schemas.microsoft.com/office/drawing/2014/main" id="{CE9B8F0F-D1A3-48D1-B657-FB20AF38FC08}"/>
               </a:ext>
             </a:extLst>
           </p:cNvPr>
@@ -5531,7 +5531,7 @@
           <p:cNvPr id="18" name="route-6">
             <a:extLst xmlns:a="http://schemas.openxmlformats.org/drawingml/2006/main">
               <a:ext uri="{FF2B5EF4-FFF2-40B4-BE49-F238E27FC236}">
-                <a16:creationId xmlns:a16="http://schemas.microsoft.com/office/drawing/2014/main" id="{76843162-DC2C-4155-943B-FF9A90731E48}"/>
+                <a16:creationId xmlns:a16="http://schemas.microsoft.com/office/drawing/2014/main" id="{434773D8-DEFE-44CB-B520-665CD087DE3D}"/>
               </a:ext>
             </a:extLst>
           </p:cNvPr>
@@ -5588,7 +5588,7 @@
           <p:cNvPr id="19" name="route-number-7">
             <a:extLst xmlns:a="http://schemas.openxmlformats.org/drawingml/2006/main">
               <a:ext uri="{FF2B5EF4-FFF2-40B4-BE49-F238E27FC236}">
-                <a16:creationId xmlns:a16="http://schemas.microsoft.com/office/drawing/2014/main" id="{A963A5EB-A0AF-42BE-8538-A93F11CD9604}"/>
+                <a16:creationId xmlns:a16="http://schemas.microsoft.com/office/drawing/2014/main" id="{452FBF28-6FAA-49C9-A60F-4C0BA05A357A}"/>
               </a:ext>
             </a:extLst>
           </p:cNvPr>
@@ -5645,7 +5645,7 @@
           <p:cNvPr id="20" name="route-7">
             <a:extLst xmlns:a="http://schemas.openxmlformats.org/drawingml/2006/main">
               <a:ext uri="{FF2B5EF4-FFF2-40B4-BE49-F238E27FC236}">
-                <a16:creationId xmlns:a16="http://schemas.microsoft.com/office/drawing/2014/main" id="{8B839F37-4193-475F-8AD9-FDA7651FB53B}"/>
+                <a16:creationId xmlns:a16="http://schemas.microsoft.com/office/drawing/2014/main" id="{7FE879C0-FF9C-43A4-9B73-264A926260AD}"/>
               </a:ext>
             </a:extLst>
           </p:cNvPr>
@@ -5702,7 +5702,7 @@
           <p:cNvPr id="21" name="Lesdoelen">
             <a:extLst xmlns:a="http://schemas.openxmlformats.org/drawingml/2006/main">
               <a:ext uri="{FF2B5EF4-FFF2-40B4-BE49-F238E27FC236}">
-                <a16:creationId xmlns:a16="http://schemas.microsoft.com/office/drawing/2014/main" id="{3DA3C7F9-AC93-4615-B843-A68C2A5AC9AE}"/>
+                <a16:creationId xmlns:a16="http://schemas.microsoft.com/office/drawing/2014/main" id="{2A5C9656-96FB-412E-900E-E8449CBFCBE9}"/>
               </a:ext>
             </a:extLst>
           </p:cNvPr>
@@ -5759,7 +5759,7 @@
           <p:cNvPr id="22" name="overview-goals">
             <a:extLst xmlns:a="http://schemas.openxmlformats.org/drawingml/2006/main">
               <a:ext uri="{FF2B5EF4-FFF2-40B4-BE49-F238E27FC236}">
-                <a16:creationId xmlns:a16="http://schemas.microsoft.com/office/drawing/2014/main" id="{117F2E00-B7B5-4FE9-8631-476C517D7A64}"/>
+                <a16:creationId xmlns:a16="http://schemas.microsoft.com/office/drawing/2014/main" id="{31692FEE-88E5-4CB4-9986-E0C817662E11}"/>
               </a:ext>
             </a:extLst>
           </p:cNvPr>
@@ -5862,7 +5862,7 @@
           <p:cNvPr id="23" name="">
             <a:extLst xmlns:a="http://schemas.openxmlformats.org/drawingml/2006/main">
               <a:ext uri="{FF2B5EF4-FFF2-40B4-BE49-F238E27FC236}">
-                <a16:creationId xmlns:a16="http://schemas.microsoft.com/office/drawing/2014/main" id="{3B5D72DD-91BE-482A-9F3C-0ED734266202}"/>
+                <a16:creationId xmlns:a16="http://schemas.microsoft.com/office/drawing/2014/main" id="{D399DBB8-F743-4CD1-89C6-CB0183D8B20F}"/>
               </a:ext>
             </a:extLst>
           </p:cNvPr>
@@ -5891,7 +5891,7 @@
           <p:cNvPr id="24" name="Startopdracht">
             <a:extLst xmlns:a="http://schemas.openxmlformats.org/drawingml/2006/main">
               <a:ext uri="{FF2B5EF4-FFF2-40B4-BE49-F238E27FC236}">
-                <a16:creationId xmlns:a16="http://schemas.microsoft.com/office/drawing/2014/main" id="{58606E1F-E4C1-404F-9702-577BFD62BC5E}"/>
+                <a16:creationId xmlns:a16="http://schemas.microsoft.com/office/drawing/2014/main" id="{C050184A-4F26-4A7A-8EFF-BB56C440E283}"/>
               </a:ext>
             </a:extLst>
           </p:cNvPr>
@@ -5948,7 +5948,7 @@
           <p:cNvPr id="25" name="overview-start">
             <a:extLst xmlns:a="http://schemas.openxmlformats.org/drawingml/2006/main">
               <a:ext uri="{FF2B5EF4-FFF2-40B4-BE49-F238E27FC236}">
-                <a16:creationId xmlns:a16="http://schemas.microsoft.com/office/drawing/2014/main" id="{70F8CED9-B847-4869-8CCF-B87823E8ADCB}"/>
+                <a16:creationId xmlns:a16="http://schemas.microsoft.com/office/drawing/2014/main" id="{53772DA2-DD94-45CF-8A22-9CACED23639D}"/>
               </a:ext>
             </a:extLst>
           </p:cNvPr>
@@ -5995,7 +5995,7 @@
                 <a:ea typeface="Arial"/>
                 <a:cs typeface="Arial"/>
               </a:rPr>
-              <a:t>Pagina 23 · Opgaven 1 en 2</a:t>
+              <a:t>Pagina 24 · Opgaven 1 en 2</a:t>
             </a:r>
           </a:p>
           <a:p xmlns:a="http://schemas.openxmlformats.org/drawingml/2006/main">
@@ -6028,7 +6028,7 @@
           <p:cNvPr id="26" name="">
             <a:extLst xmlns:a="http://schemas.openxmlformats.org/drawingml/2006/main">
               <a:ext uri="{FF2B5EF4-FFF2-40B4-BE49-F238E27FC236}">
-                <a16:creationId xmlns:a16="http://schemas.microsoft.com/office/drawing/2014/main" id="{4C7E35C5-3C70-45A6-AD4F-090872151E06}"/>
+                <a16:creationId xmlns:a16="http://schemas.microsoft.com/office/drawing/2014/main" id="{AE0B2100-48C6-455F-B607-9309382C0720}"/>
               </a:ext>
             </a:extLst>
           </p:cNvPr>
@@ -6057,7 +6057,7 @@
           <p:cNvPr id="27" name="Huiswerk">
             <a:extLst xmlns:a="http://schemas.openxmlformats.org/drawingml/2006/main">
               <a:ext uri="{FF2B5EF4-FFF2-40B4-BE49-F238E27FC236}">
-                <a16:creationId xmlns:a16="http://schemas.microsoft.com/office/drawing/2014/main" id="{9F66AA7B-F445-4304-A847-616915A67700}"/>
+                <a16:creationId xmlns:a16="http://schemas.microsoft.com/office/drawing/2014/main" id="{CCDC3069-09E2-4E60-929A-4FBF5DC11772}"/>
               </a:ext>
             </a:extLst>
           </p:cNvPr>
@@ -6114,7 +6114,7 @@
           <p:cNvPr id="28" name="overview-homework">
             <a:extLst xmlns:a="http://schemas.openxmlformats.org/drawingml/2006/main">
               <a:ext uri="{FF2B5EF4-FFF2-40B4-BE49-F238E27FC236}">
-                <a16:creationId xmlns:a16="http://schemas.microsoft.com/office/drawing/2014/main" id="{92CD3700-C487-441B-AECC-CC65421E6A29}"/>
+                <a16:creationId xmlns:a16="http://schemas.microsoft.com/office/drawing/2014/main" id="{18C8ABC5-5920-4CCD-99A9-7C779388D97D}"/>
               </a:ext>
             </a:extLst>
           </p:cNvPr>
@@ -6261,7 +6261,7 @@
     </p:spTree>
     <p:extLst>
       <p:ext uri="{BB962C8B-B14F-4D97-AF65-F5344CB8AC3E}">
-        <p14:creationId xmlns:p14="http://schemas.microsoft.com/office/powerpoint/2010/main" val="1167688785"/>
+        <p14:creationId xmlns:p14="http://schemas.microsoft.com/office/powerpoint/2010/main" val="968826066"/>
       </p:ext>
     </p:extLst>
   </p:cSld>
@@ -6292,7 +6292,7 @@
           <p:cNvPr id="9" name="Even grote stappen · Stijgende MK">
             <a:extLst xmlns:a="http://schemas.openxmlformats.org/drawingml/2006/main">
               <a:ext uri="{FF2B5EF4-FFF2-40B4-BE49-F238E27FC236}">
-                <a16:creationId xmlns:a16="http://schemas.microsoft.com/office/drawing/2014/main" id="{BF85DE45-76DD-41B2-B421-D204CB2C0FD8}"/>
+                <a16:creationId xmlns:a16="http://schemas.microsoft.com/office/drawing/2014/main" id="{60438D4F-A802-4A56-9398-DF280196DB22}"/>
               </a:ext>
             </a:extLst>
           </p:cNvPr>
@@ -6349,7 +6349,7 @@
           <p:cNvPr id="2" name="">
             <a:extLst xmlns:a="http://schemas.openxmlformats.org/drawingml/2006/main">
               <a:ext uri="{FF2B5EF4-FFF2-40B4-BE49-F238E27FC236}">
-                <a16:creationId xmlns:a16="http://schemas.microsoft.com/office/drawing/2014/main" id="{FA4ECBC3-52FD-4046-B795-F66656A8E496}"/>
+                <a16:creationId xmlns:a16="http://schemas.microsoft.com/office/drawing/2014/main" id="{05C48EFE-7EDE-4BD4-80C9-621E09E8E6DC}"/>
               </a:ext>
             </a:extLst>
           </p:cNvPr>
@@ -6378,7 +6378,7 @@
           <p:cNvPr id="3" name="§2.1.3 Marginale kosten en marginale opbrengsten">
             <a:extLst xmlns:a="http://schemas.openxmlformats.org/drawingml/2006/main">
               <a:ext uri="{FF2B5EF4-FFF2-40B4-BE49-F238E27FC236}">
-                <a16:creationId xmlns:a16="http://schemas.microsoft.com/office/drawing/2014/main" id="{6BFB883B-CCDF-445E-9903-D7D2A0C8B571}"/>
+                <a16:creationId xmlns:a16="http://schemas.microsoft.com/office/drawing/2014/main" id="{48AB2E7E-F01F-4315-B0BC-21B84F1EC14E}"/>
               </a:ext>
             </a:extLst>
           </p:cNvPr>
@@ -6435,7 +6435,7 @@
           <p:cNvPr id="4" name="slide-number">
             <a:extLst xmlns:a="http://schemas.openxmlformats.org/drawingml/2006/main">
               <a:ext uri="{FF2B5EF4-FFF2-40B4-BE49-F238E27FC236}">
-                <a16:creationId xmlns:a16="http://schemas.microsoft.com/office/drawing/2014/main" id="{9D694183-98EF-4B82-9DE7-F5D86B27B859}"/>
+                <a16:creationId xmlns:a16="http://schemas.microsoft.com/office/drawing/2014/main" id="{AEAC9D16-D85B-449E-AD16-2EED42FCCDC8}"/>
               </a:ext>
             </a:extLst>
           </p:cNvPr>
@@ -6492,7 +6492,7 @@
           <p:cNvPr id="5" name="Uitlegvoorbeeld — niet uit het boek · Studio Reliëf">
             <a:extLst xmlns:a="http://schemas.openxmlformats.org/drawingml/2006/main">
               <a:ext uri="{FF2B5EF4-FFF2-40B4-BE49-F238E27FC236}">
-                <a16:creationId xmlns:a16="http://schemas.microsoft.com/office/drawing/2014/main" id="{6881A3FB-5F74-46E6-9DA9-DA17EB3ACDAB}"/>
+                <a16:creationId xmlns:a16="http://schemas.microsoft.com/office/drawing/2014/main" id="{96D86A66-94F0-4D23-B13E-B0456AADA1C8}"/>
               </a:ext>
             </a:extLst>
           </p:cNvPr>
@@ -6868,7 +6868,7 @@
           <p:cNvPr id="7" name="MK: € 4 → € 12 → € 20 per extra tegel">
             <a:extLst xmlns:a="http://schemas.openxmlformats.org/drawingml/2006/main">
               <a:ext uri="{FF2B5EF4-FFF2-40B4-BE49-F238E27FC236}">
-                <a16:creationId xmlns:a16="http://schemas.microsoft.com/office/drawing/2014/main" id="{F1C6623F-05B9-4660-B574-789419279677}"/>
+                <a16:creationId xmlns:a16="http://schemas.microsoft.com/office/drawing/2014/main" id="{FEEE4844-5496-4919-B120-51388E7231C1}"/>
               </a:ext>
             </a:extLst>
           </p:cNvPr>
@@ -6925,7 +6925,7 @@
           <p:cNvPr id="8" name="MO: steeds 52 / 2 = € 26 per extra tegel">
             <a:extLst xmlns:a="http://schemas.openxmlformats.org/drawingml/2006/main">
               <a:ext uri="{FF2B5EF4-FFF2-40B4-BE49-F238E27FC236}">
-                <a16:creationId xmlns:a16="http://schemas.microsoft.com/office/drawing/2014/main" id="{307D4F2A-9BA8-4167-8D8F-2204FF8DE0D9}"/>
+                <a16:creationId xmlns:a16="http://schemas.microsoft.com/office/drawing/2014/main" id="{0B0AF0B4-1194-4DC5-935E-9B70794A6422}"/>
               </a:ext>
             </a:extLst>
           </p:cNvPr>
@@ -6980,7 +6980,7 @@
     </p:spTree>
     <p:extLst>
       <p:ext uri="{BB962C8B-B14F-4D97-AF65-F5344CB8AC3E}">
-        <p14:creationId xmlns:p14="http://schemas.microsoft.com/office/powerpoint/2010/main" val="241841256"/>
+        <p14:creationId xmlns:p14="http://schemas.microsoft.com/office/powerpoint/2010/main" val="18542284"/>
       </p:ext>
     </p:extLst>
   </p:cSld>
@@ -7011,7 +7011,7 @@
           <p:cNvPr id="8" name="GTK en MK · Alle tegels of extra tegels">
             <a:extLst xmlns:a="http://schemas.openxmlformats.org/drawingml/2006/main">
               <a:ext uri="{FF2B5EF4-FFF2-40B4-BE49-F238E27FC236}">
-                <a16:creationId xmlns:a16="http://schemas.microsoft.com/office/drawing/2014/main" id="{D96C1F93-6E3C-483A-89F8-0B2FD588B1D1}"/>
+                <a16:creationId xmlns:a16="http://schemas.microsoft.com/office/drawing/2014/main" id="{78383B74-0D28-4856-B368-9E6D51C723F6}"/>
               </a:ext>
             </a:extLst>
           </p:cNvPr>
@@ -7068,7 +7068,7 @@
           <p:cNvPr id="2" name="">
             <a:extLst xmlns:a="http://schemas.openxmlformats.org/drawingml/2006/main">
               <a:ext uri="{FF2B5EF4-FFF2-40B4-BE49-F238E27FC236}">
-                <a16:creationId xmlns:a16="http://schemas.microsoft.com/office/drawing/2014/main" id="{0D844BCB-9CAF-42FF-B7C3-118893087F6B}"/>
+                <a16:creationId xmlns:a16="http://schemas.microsoft.com/office/drawing/2014/main" id="{88D95D16-A329-4892-AD7F-0EBE186922C4}"/>
               </a:ext>
             </a:extLst>
           </p:cNvPr>
@@ -7097,7 +7097,7 @@
           <p:cNvPr id="3" name="§2.1.3 Marginale kosten en marginale opbrengsten">
             <a:extLst xmlns:a="http://schemas.openxmlformats.org/drawingml/2006/main">
               <a:ext uri="{FF2B5EF4-FFF2-40B4-BE49-F238E27FC236}">
-                <a16:creationId xmlns:a16="http://schemas.microsoft.com/office/drawing/2014/main" id="{4F9A85CA-92C7-413C-B903-3C2522D8BDDD}"/>
+                <a16:creationId xmlns:a16="http://schemas.microsoft.com/office/drawing/2014/main" id="{9A393A8C-2966-4F11-B516-593A4ADA793D}"/>
               </a:ext>
             </a:extLst>
           </p:cNvPr>
@@ -7154,7 +7154,7 @@
           <p:cNvPr id="4" name="slide-number">
             <a:extLst xmlns:a="http://schemas.openxmlformats.org/drawingml/2006/main">
               <a:ext uri="{FF2B5EF4-FFF2-40B4-BE49-F238E27FC236}">
-                <a16:creationId xmlns:a16="http://schemas.microsoft.com/office/drawing/2014/main" id="{A52FD3DC-339A-458F-B6E7-ABDD4E9DD537}"/>
+                <a16:creationId xmlns:a16="http://schemas.microsoft.com/office/drawing/2014/main" id="{53C75CA4-CEBE-4D11-AAC7-84073546897D}"/>
               </a:ext>
             </a:extLst>
           </p:cNvPr>
@@ -7211,7 +7211,7 @@
           <p:cNvPr id="5" name="Uitlegvoorbeeld — niet uit het boek · Studio Reliëf">
             <a:extLst xmlns:a="http://schemas.openxmlformats.org/drawingml/2006/main">
               <a:ext uri="{FF2B5EF4-FFF2-40B4-BE49-F238E27FC236}">
-                <a16:creationId xmlns:a16="http://schemas.microsoft.com/office/drawing/2014/main" id="{04324AA9-108E-4203-B0A1-5126CCCF85B8}"/>
+                <a16:creationId xmlns:a16="http://schemas.microsoft.com/office/drawing/2014/main" id="{05F6B418-8042-4613-9F6C-A1ECB5DA686A}"/>
               </a:ext>
             </a:extLst>
           </p:cNvPr>
@@ -7661,7 +7661,7 @@
           <p:cNvPr id="7" name="€ 20 per extra tegel: gemiddeld over de stap 4 → 6.">
             <a:extLst xmlns:a="http://schemas.openxmlformats.org/drawingml/2006/main">
               <a:ext uri="{FF2B5EF4-FFF2-40B4-BE49-F238E27FC236}">
-                <a16:creationId xmlns:a16="http://schemas.microsoft.com/office/drawing/2014/main" id="{A0A70FC4-651C-4822-8188-8FDE8097B661}"/>
+                <a16:creationId xmlns:a16="http://schemas.microsoft.com/office/drawing/2014/main" id="{9E1BA1F1-DE48-417D-BC87-819A723D2BC3}"/>
               </a:ext>
             </a:extLst>
           </p:cNvPr>
@@ -7716,7 +7716,7 @@
     </p:spTree>
     <p:extLst>
       <p:ext uri="{BB962C8B-B14F-4D97-AF65-F5344CB8AC3E}">
-        <p14:creationId xmlns:p14="http://schemas.microsoft.com/office/powerpoint/2010/main" val="1670918897"/>
+        <p14:creationId xmlns:p14="http://schemas.microsoft.com/office/powerpoint/2010/main" val="74340982"/>
       </p:ext>
     </p:extLst>
   </p:cSld>
@@ -7747,7 +7747,7 @@
           <p:cNvPr id="9" name="Korte controle · Welke betekenis klopt?">
             <a:extLst xmlns:a="http://schemas.openxmlformats.org/drawingml/2006/main">
               <a:ext uri="{FF2B5EF4-FFF2-40B4-BE49-F238E27FC236}">
-                <a16:creationId xmlns:a16="http://schemas.microsoft.com/office/drawing/2014/main" id="{FFD74181-6977-4679-A3CC-BC039CEEE481}"/>
+                <a16:creationId xmlns:a16="http://schemas.microsoft.com/office/drawing/2014/main" id="{2AEBDA04-838E-4802-B2C9-E7D868CB0517}"/>
               </a:ext>
             </a:extLst>
           </p:cNvPr>
@@ -7804,7 +7804,7 @@
           <p:cNvPr id="2" name="">
             <a:extLst xmlns:a="http://schemas.openxmlformats.org/drawingml/2006/main">
               <a:ext uri="{FF2B5EF4-FFF2-40B4-BE49-F238E27FC236}">
-                <a16:creationId xmlns:a16="http://schemas.microsoft.com/office/drawing/2014/main" id="{A476B542-088D-40BA-9C1C-521A76A6D442}"/>
+                <a16:creationId xmlns:a16="http://schemas.microsoft.com/office/drawing/2014/main" id="{D4E415C8-F770-4BC3-A98A-C0DA1EF55D6E}"/>
               </a:ext>
             </a:extLst>
           </p:cNvPr>
@@ -7833,7 +7833,7 @@
           <p:cNvPr id="3" name="§2.1.3 Marginale kosten en marginale opbrengsten">
             <a:extLst xmlns:a="http://schemas.openxmlformats.org/drawingml/2006/main">
               <a:ext uri="{FF2B5EF4-FFF2-40B4-BE49-F238E27FC236}">
-                <a16:creationId xmlns:a16="http://schemas.microsoft.com/office/drawing/2014/main" id="{9B789911-5EBA-4C0A-9973-C4FEE4B2EA57}"/>
+                <a16:creationId xmlns:a16="http://schemas.microsoft.com/office/drawing/2014/main" id="{74A94523-3FAF-408F-AAE2-644BC1E56DFE}"/>
               </a:ext>
             </a:extLst>
           </p:cNvPr>
@@ -7890,7 +7890,7 @@
           <p:cNvPr id="4" name="slide-number">
             <a:extLst xmlns:a="http://schemas.openxmlformats.org/drawingml/2006/main">
               <a:ext uri="{FF2B5EF4-FFF2-40B4-BE49-F238E27FC236}">
-                <a16:creationId xmlns:a16="http://schemas.microsoft.com/office/drawing/2014/main" id="{2E5DC022-6495-40F0-93FF-C43C43CEB2EA}"/>
+                <a16:creationId xmlns:a16="http://schemas.microsoft.com/office/drawing/2014/main" id="{A2B4D4D4-50CB-4D06-9FB3-A167BD422ED4}"/>
               </a:ext>
             </a:extLst>
           </p:cNvPr>
@@ -7947,7 +7947,7 @@
           <p:cNvPr id="5" name="Uitlegvoorbeeld — niet uit het boek · Studio Reliëf">
             <a:extLst xmlns:a="http://schemas.openxmlformats.org/drawingml/2006/main">
               <a:ext uri="{FF2B5EF4-FFF2-40B4-BE49-F238E27FC236}">
-                <a16:creationId xmlns:a16="http://schemas.microsoft.com/office/drawing/2014/main" id="{8B5A13AE-9305-490E-A10F-74D77F5A6725}"/>
+                <a16:creationId xmlns:a16="http://schemas.microsoft.com/office/drawing/2014/main" id="{8FD2D938-DB4D-447D-A663-9AFC35C198B5}"/>
               </a:ext>
             </a:extLst>
           </p:cNvPr>
@@ -8004,7 +8004,7 @@
           <p:cNvPr id="6" name="Bij Q = 6 staat MK = € 20.">
             <a:extLst xmlns:a="http://schemas.openxmlformats.org/drawingml/2006/main">
               <a:ext uri="{FF2B5EF4-FFF2-40B4-BE49-F238E27FC236}">
-                <a16:creationId xmlns:a16="http://schemas.microsoft.com/office/drawing/2014/main" id="{1059CCA6-6628-4223-815C-BA65DAD6D1B8}"/>
+                <a16:creationId xmlns:a16="http://schemas.microsoft.com/office/drawing/2014/main" id="{0B87198C-B1B8-46B1-95EB-632EB6BD2776}"/>
               </a:ext>
             </a:extLst>
           </p:cNvPr>
@@ -8061,7 +8061,7 @@
           <p:cNvPr id="7" name="“Dus de zesde tegel kost precies € 20 extra.”">
             <a:extLst xmlns:a="http://schemas.openxmlformats.org/drawingml/2006/main">
               <a:ext uri="{FF2B5EF4-FFF2-40B4-BE49-F238E27FC236}">
-                <a16:creationId xmlns:a16="http://schemas.microsoft.com/office/drawing/2014/main" id="{EAEE49EF-3D17-4325-9A21-7E643CF5166B}"/>
+                <a16:creationId xmlns:a16="http://schemas.microsoft.com/office/drawing/2014/main" id="{7650A042-D37F-4E38-A996-056CD3DB102C}"/>
               </a:ext>
             </a:extLst>
           </p:cNvPr>
@@ -8118,7 +8118,7 @@
           <p:cNvPr id="8" name="Klopt dit? Noem de stap, het extra totaal&#10;en het aantal extra teg">
             <a:extLst xmlns:a="http://schemas.openxmlformats.org/drawingml/2006/main">
               <a:ext uri="{FF2B5EF4-FFF2-40B4-BE49-F238E27FC236}">
-                <a16:creationId xmlns:a16="http://schemas.microsoft.com/office/drawing/2014/main" id="{9B31AF20-5758-42C6-BA1B-A555183DBA7A}"/>
+                <a16:creationId xmlns:a16="http://schemas.microsoft.com/office/drawing/2014/main" id="{CB8FF010-A453-44D9-966F-CC20A84910D7}"/>
               </a:ext>
             </a:extLst>
           </p:cNvPr>
@@ -8196,7 +8196,7 @@
     </p:spTree>
     <p:extLst>
       <p:ext uri="{BB962C8B-B14F-4D97-AF65-F5344CB8AC3E}">
-        <p14:creationId xmlns:p14="http://schemas.microsoft.com/office/powerpoint/2010/main" val="1934426172"/>
+        <p14:creationId xmlns:p14="http://schemas.microsoft.com/office/powerpoint/2010/main" val="1167677825"/>
       </p:ext>
     </p:extLst>
   </p:cSld>
@@ -8227,7 +8227,7 @@
           <p:cNvPr id="10" name="Korte controle · Welke betekenis klopt?">
             <a:extLst xmlns:a="http://schemas.openxmlformats.org/drawingml/2006/main">
               <a:ext uri="{FF2B5EF4-FFF2-40B4-BE49-F238E27FC236}">
-                <a16:creationId xmlns:a16="http://schemas.microsoft.com/office/drawing/2014/main" id="{9441BE48-2CD3-4A2E-86D7-D2F594633B2B}"/>
+                <a16:creationId xmlns:a16="http://schemas.microsoft.com/office/drawing/2014/main" id="{DC3E56C7-45D9-46A2-B059-50E43EE45EB6}"/>
               </a:ext>
             </a:extLst>
           </p:cNvPr>
@@ -8284,7 +8284,7 @@
           <p:cNvPr id="2" name="">
             <a:extLst xmlns:a="http://schemas.openxmlformats.org/drawingml/2006/main">
               <a:ext uri="{FF2B5EF4-FFF2-40B4-BE49-F238E27FC236}">
-                <a16:creationId xmlns:a16="http://schemas.microsoft.com/office/drawing/2014/main" id="{283C9866-6D87-4B8A-A183-2AAF5D481E0E}"/>
+                <a16:creationId xmlns:a16="http://schemas.microsoft.com/office/drawing/2014/main" id="{65C1FD84-B19C-47EB-83B4-DF5256BAB9CF}"/>
               </a:ext>
             </a:extLst>
           </p:cNvPr>
@@ -8313,7 +8313,7 @@
           <p:cNvPr id="3" name="§2.1.3 Marginale kosten en marginale opbrengsten">
             <a:extLst xmlns:a="http://schemas.openxmlformats.org/drawingml/2006/main">
               <a:ext uri="{FF2B5EF4-FFF2-40B4-BE49-F238E27FC236}">
-                <a16:creationId xmlns:a16="http://schemas.microsoft.com/office/drawing/2014/main" id="{E28A96D9-F627-49C6-B80C-7C6CECA23FFC}"/>
+                <a16:creationId xmlns:a16="http://schemas.microsoft.com/office/drawing/2014/main" id="{7BF6DF4A-1758-474C-9376-E50984875E63}"/>
               </a:ext>
             </a:extLst>
           </p:cNvPr>
@@ -8370,7 +8370,7 @@
           <p:cNvPr id="4" name="slide-number">
             <a:extLst xmlns:a="http://schemas.openxmlformats.org/drawingml/2006/main">
               <a:ext uri="{FF2B5EF4-FFF2-40B4-BE49-F238E27FC236}">
-                <a16:creationId xmlns:a16="http://schemas.microsoft.com/office/drawing/2014/main" id="{81A71277-A060-496D-B898-DD9E44313F47}"/>
+                <a16:creationId xmlns:a16="http://schemas.microsoft.com/office/drawing/2014/main" id="{925E8B16-B268-47AF-BA6F-6E86C07565AA}"/>
               </a:ext>
             </a:extLst>
           </p:cNvPr>
@@ -8427,7 +8427,7 @@
           <p:cNvPr id="5" name="Uitlegvoorbeeld — niet uit het boek · Studio Reliëf">
             <a:extLst xmlns:a="http://schemas.openxmlformats.org/drawingml/2006/main">
               <a:ext uri="{FF2B5EF4-FFF2-40B4-BE49-F238E27FC236}">
-                <a16:creationId xmlns:a16="http://schemas.microsoft.com/office/drawing/2014/main" id="{3ACD019D-B148-4E39-ADF8-F4EEF4A841C0}"/>
+                <a16:creationId xmlns:a16="http://schemas.microsoft.com/office/drawing/2014/main" id="{94352894-AE5C-467F-B21E-60B77369C315}"/>
               </a:ext>
             </a:extLst>
           </p:cNvPr>
@@ -8484,7 +8484,7 @@
           <p:cNvPr id="6" name="Bij Q = 6 staat MK = € 20.">
             <a:extLst xmlns:a="http://schemas.openxmlformats.org/drawingml/2006/main">
               <a:ext uri="{FF2B5EF4-FFF2-40B4-BE49-F238E27FC236}">
-                <a16:creationId xmlns:a16="http://schemas.microsoft.com/office/drawing/2014/main" id="{C82553DE-38AE-4395-ADF3-DB90E6DFC91A}"/>
+                <a16:creationId xmlns:a16="http://schemas.microsoft.com/office/drawing/2014/main" id="{DB591588-1188-4469-ABA2-60BA4956A673}"/>
               </a:ext>
             </a:extLst>
           </p:cNvPr>
@@ -8541,7 +8541,7 @@
           <p:cNvPr id="7" name="“Dus de zesde tegel kost precies € 20 extra.”">
             <a:extLst xmlns:a="http://schemas.openxmlformats.org/drawingml/2006/main">
               <a:ext uri="{FF2B5EF4-FFF2-40B4-BE49-F238E27FC236}">
-                <a16:creationId xmlns:a16="http://schemas.microsoft.com/office/drawing/2014/main" id="{7F6A9831-D50B-45CA-9E17-9056B01782FC}"/>
+                <a16:creationId xmlns:a16="http://schemas.microsoft.com/office/drawing/2014/main" id="{8A07D7F0-BF6E-4116-BFB2-6391E197D7E4}"/>
               </a:ext>
             </a:extLst>
           </p:cNvPr>
@@ -8598,7 +8598,7 @@
           <p:cNvPr id="8" name="Onjuist: de stap loopt van 4 naar 6 tegels.">
             <a:extLst xmlns:a="http://schemas.openxmlformats.org/drawingml/2006/main">
               <a:ext uri="{FF2B5EF4-FFF2-40B4-BE49-F238E27FC236}">
-                <a16:creationId xmlns:a16="http://schemas.microsoft.com/office/drawing/2014/main" id="{4DF65401-20CB-401F-A3F4-1D87972E0650}"/>
+                <a16:creationId xmlns:a16="http://schemas.microsoft.com/office/drawing/2014/main" id="{4F56506E-1D89-46F6-BC54-2606A43EF718}"/>
               </a:ext>
             </a:extLst>
           </p:cNvPr>
@@ -8655,7 +8655,7 @@
           <p:cNvPr id="9" name="Samen € 40 extra kosten voor twee extra tegels:&#10;gemiddeld € 20 pe">
             <a:extLst xmlns:a="http://schemas.openxmlformats.org/drawingml/2006/main">
               <a:ext uri="{FF2B5EF4-FFF2-40B4-BE49-F238E27FC236}">
-                <a16:creationId xmlns:a16="http://schemas.microsoft.com/office/drawing/2014/main" id="{15CFEC38-EDF6-47CF-802A-8BA3AEEE5049}"/>
+                <a16:creationId xmlns:a16="http://schemas.microsoft.com/office/drawing/2014/main" id="{798FC6E2-AE05-4524-8AEA-A7B578DC0336}"/>
               </a:ext>
             </a:extLst>
           </p:cNvPr>
@@ -8733,7 +8733,7 @@
     </p:spTree>
     <p:extLst>
       <p:ext uri="{BB962C8B-B14F-4D97-AF65-F5344CB8AC3E}">
-        <p14:creationId xmlns:p14="http://schemas.microsoft.com/office/powerpoint/2010/main" val="2057701331"/>
+        <p14:creationId xmlns:p14="http://schemas.microsoft.com/office/powerpoint/2010/main" val="1581810238"/>
       </p:ext>
     </p:extLst>
   </p:cSld>
@@ -8764,7 +8764,7 @@
           <p:cNvPr id="29" name="Deze les: §2.1.3 Marginale kosten en marginale opbrengsten">
             <a:extLst xmlns:a="http://schemas.openxmlformats.org/drawingml/2006/main">
               <a:ext uri="{FF2B5EF4-FFF2-40B4-BE49-F238E27FC236}">
-                <a16:creationId xmlns:a16="http://schemas.microsoft.com/office/drawing/2014/main" id="{A764E4F1-C4DE-4B1B-A2FB-D14CAD886419}"/>
+                <a16:creationId xmlns:a16="http://schemas.microsoft.com/office/drawing/2014/main" id="{9C5BBF0D-F4F1-4539-8491-826C5A584FCB}"/>
               </a:ext>
             </a:extLst>
           </p:cNvPr>
@@ -8821,7 +8821,7 @@
           <p:cNvPr id="2" name="">
             <a:extLst xmlns:a="http://schemas.openxmlformats.org/drawingml/2006/main">
               <a:ext uri="{FF2B5EF4-FFF2-40B4-BE49-F238E27FC236}">
-                <a16:creationId xmlns:a16="http://schemas.microsoft.com/office/drawing/2014/main" id="{81A9EBF0-F972-4AA0-96F7-8CEEEB5B2D4A}"/>
+                <a16:creationId xmlns:a16="http://schemas.microsoft.com/office/drawing/2014/main" id="{AAEFF431-AD02-43B8-8E70-45E16F85D681}"/>
               </a:ext>
             </a:extLst>
           </p:cNvPr>
@@ -8850,7 +8850,7 @@
           <p:cNvPr id="3" name="§2.1.3 Marginale kosten en marginale opbrengsten">
             <a:extLst xmlns:a="http://schemas.openxmlformats.org/drawingml/2006/main">
               <a:ext uri="{FF2B5EF4-FFF2-40B4-BE49-F238E27FC236}">
-                <a16:creationId xmlns:a16="http://schemas.microsoft.com/office/drawing/2014/main" id="{663F2E55-F5A5-418E-A1CC-9556D7AC3F0F}"/>
+                <a16:creationId xmlns:a16="http://schemas.microsoft.com/office/drawing/2014/main" id="{C41510E0-F317-4681-B6D3-4F009E024E27}"/>
               </a:ext>
             </a:extLst>
           </p:cNvPr>
@@ -8907,7 +8907,7 @@
           <p:cNvPr id="4" name="slide-number">
             <a:extLst xmlns:a="http://schemas.openxmlformats.org/drawingml/2006/main">
               <a:ext uri="{FF2B5EF4-FFF2-40B4-BE49-F238E27FC236}">
-                <a16:creationId xmlns:a16="http://schemas.microsoft.com/office/drawing/2014/main" id="{0AF723A9-D245-4DE8-B422-4B92D8BA1F7C}"/>
+                <a16:creationId xmlns:a16="http://schemas.microsoft.com/office/drawing/2014/main" id="{441E72C9-0EFD-45A1-B95F-BAEE85B78D69}"/>
               </a:ext>
             </a:extLst>
           </p:cNvPr>
@@ -8964,7 +8964,7 @@
           <p:cNvPr id="5" name="phase">
             <a:extLst xmlns:a="http://schemas.openxmlformats.org/drawingml/2006/main">
               <a:ext uri="{FF2B5EF4-FFF2-40B4-BE49-F238E27FC236}">
-                <a16:creationId xmlns:a16="http://schemas.microsoft.com/office/drawing/2014/main" id="{043B7F52-5ED9-4AB4-9E7D-FE6B66D0DCE2}"/>
+                <a16:creationId xmlns:a16="http://schemas.microsoft.com/office/drawing/2014/main" id="{260303A1-40EB-4AC6-BBB6-3F74026765C7}"/>
               </a:ext>
             </a:extLst>
           </p:cNvPr>
@@ -9021,7 +9021,7 @@
           <p:cNvPr id="6" name="Lesroute">
             <a:extLst xmlns:a="http://schemas.openxmlformats.org/drawingml/2006/main">
               <a:ext uri="{FF2B5EF4-FFF2-40B4-BE49-F238E27FC236}">
-                <a16:creationId xmlns:a16="http://schemas.microsoft.com/office/drawing/2014/main" id="{C6342001-4897-4106-8F25-28EC12AC8CA3}"/>
+                <a16:creationId xmlns:a16="http://schemas.microsoft.com/office/drawing/2014/main" id="{98A30991-9176-4E50-816B-1A6E9D700891}"/>
               </a:ext>
             </a:extLst>
           </p:cNvPr>
@@ -9078,7 +9078,7 @@
           <p:cNvPr id="7" name="route-number-1">
             <a:extLst xmlns:a="http://schemas.openxmlformats.org/drawingml/2006/main">
               <a:ext uri="{FF2B5EF4-FFF2-40B4-BE49-F238E27FC236}">
-                <a16:creationId xmlns:a16="http://schemas.microsoft.com/office/drawing/2014/main" id="{09F96DD0-9A81-4479-AB89-630AA60DFCC1}"/>
+                <a16:creationId xmlns:a16="http://schemas.microsoft.com/office/drawing/2014/main" id="{0C08B9CE-A98E-45E5-9DA7-12E3E1E908A1}"/>
               </a:ext>
             </a:extLst>
           </p:cNvPr>
@@ -9135,7 +9135,7 @@
           <p:cNvPr id="8" name="route-1">
             <a:extLst xmlns:a="http://schemas.openxmlformats.org/drawingml/2006/main">
               <a:ext uri="{FF2B5EF4-FFF2-40B4-BE49-F238E27FC236}">
-                <a16:creationId xmlns:a16="http://schemas.microsoft.com/office/drawing/2014/main" id="{28B4EC71-5D05-4363-A9A3-D58211F9ED92}"/>
+                <a16:creationId xmlns:a16="http://schemas.microsoft.com/office/drawing/2014/main" id="{F94701D0-A6CC-49CF-B608-D8AEA1AF887C}"/>
               </a:ext>
             </a:extLst>
           </p:cNvPr>
@@ -9192,7 +9192,7 @@
           <p:cNvPr id="9" name="route-number-2">
             <a:extLst xmlns:a="http://schemas.openxmlformats.org/drawingml/2006/main">
               <a:ext uri="{FF2B5EF4-FFF2-40B4-BE49-F238E27FC236}">
-                <a16:creationId xmlns:a16="http://schemas.microsoft.com/office/drawing/2014/main" id="{74F85B36-2D39-4F51-BB68-C3B42E3B7FF9}"/>
+                <a16:creationId xmlns:a16="http://schemas.microsoft.com/office/drawing/2014/main" id="{721DB479-0EEE-438C-9B55-56B47ADA00A7}"/>
               </a:ext>
             </a:extLst>
           </p:cNvPr>
@@ -9249,7 +9249,7 @@
           <p:cNvPr id="10" name="route-2">
             <a:extLst xmlns:a="http://schemas.openxmlformats.org/drawingml/2006/main">
               <a:ext uri="{FF2B5EF4-FFF2-40B4-BE49-F238E27FC236}">
-                <a16:creationId xmlns:a16="http://schemas.microsoft.com/office/drawing/2014/main" id="{5658AF74-A9F8-46CF-A2A1-4CCCB9B6140A}"/>
+                <a16:creationId xmlns:a16="http://schemas.microsoft.com/office/drawing/2014/main" id="{8C809C38-CF69-4DCA-80D7-CFB68B70FA0F}"/>
               </a:ext>
             </a:extLst>
           </p:cNvPr>
@@ -9306,7 +9306,7 @@
           <p:cNvPr id="11" name="route-number-3">
             <a:extLst xmlns:a="http://schemas.openxmlformats.org/drawingml/2006/main">
               <a:ext uri="{FF2B5EF4-FFF2-40B4-BE49-F238E27FC236}">
-                <a16:creationId xmlns:a16="http://schemas.microsoft.com/office/drawing/2014/main" id="{0B8F34D0-A041-4039-9971-BC0DBBEAC102}"/>
+                <a16:creationId xmlns:a16="http://schemas.microsoft.com/office/drawing/2014/main" id="{162861A5-4896-4F73-8CAB-E63FF7C64F7C}"/>
               </a:ext>
             </a:extLst>
           </p:cNvPr>
@@ -9363,7 +9363,7 @@
           <p:cNvPr id="12" name="route-3">
             <a:extLst xmlns:a="http://schemas.openxmlformats.org/drawingml/2006/main">
               <a:ext uri="{FF2B5EF4-FFF2-40B4-BE49-F238E27FC236}">
-                <a16:creationId xmlns:a16="http://schemas.microsoft.com/office/drawing/2014/main" id="{776EC612-A565-48E7-B8FA-24E3C1A1684F}"/>
+                <a16:creationId xmlns:a16="http://schemas.microsoft.com/office/drawing/2014/main" id="{DA24E913-51E0-4BB1-88FE-1135D222D6F7}"/>
               </a:ext>
             </a:extLst>
           </p:cNvPr>
@@ -9420,7 +9420,7 @@
           <p:cNvPr id="13" name="route-number-4">
             <a:extLst xmlns:a="http://schemas.openxmlformats.org/drawingml/2006/main">
               <a:ext uri="{FF2B5EF4-FFF2-40B4-BE49-F238E27FC236}">
-                <a16:creationId xmlns:a16="http://schemas.microsoft.com/office/drawing/2014/main" id="{F9834616-CC0C-4B39-BA3F-84A24D16C0DB}"/>
+                <a16:creationId xmlns:a16="http://schemas.microsoft.com/office/drawing/2014/main" id="{7D7E32EA-8162-41A7-833A-E3650C0EA3F0}"/>
               </a:ext>
             </a:extLst>
           </p:cNvPr>
@@ -9477,7 +9477,7 @@
           <p:cNvPr id="14" name="route-4">
             <a:extLst xmlns:a="http://schemas.openxmlformats.org/drawingml/2006/main">
               <a:ext uri="{FF2B5EF4-FFF2-40B4-BE49-F238E27FC236}">
-                <a16:creationId xmlns:a16="http://schemas.microsoft.com/office/drawing/2014/main" id="{1A2DE0FD-648C-4378-AFF3-17BD4CAAEBE1}"/>
+                <a16:creationId xmlns:a16="http://schemas.microsoft.com/office/drawing/2014/main" id="{0E9313F0-7872-4C67-B15F-33D3ABE9EA0C}"/>
               </a:ext>
             </a:extLst>
           </p:cNvPr>
@@ -9534,7 +9534,7 @@
           <p:cNvPr id="15" name="route-number-5">
             <a:extLst xmlns:a="http://schemas.openxmlformats.org/drawingml/2006/main">
               <a:ext uri="{FF2B5EF4-FFF2-40B4-BE49-F238E27FC236}">
-                <a16:creationId xmlns:a16="http://schemas.microsoft.com/office/drawing/2014/main" id="{FFF3EAFC-8976-46C0-A751-5DD872A19570}"/>
+                <a16:creationId xmlns:a16="http://schemas.microsoft.com/office/drawing/2014/main" id="{84653A4E-A420-4960-A452-9EFC4585755B}"/>
               </a:ext>
             </a:extLst>
           </p:cNvPr>
@@ -9591,7 +9591,7 @@
           <p:cNvPr id="16" name="route-5">
             <a:extLst xmlns:a="http://schemas.openxmlformats.org/drawingml/2006/main">
               <a:ext uri="{FF2B5EF4-FFF2-40B4-BE49-F238E27FC236}">
-                <a16:creationId xmlns:a16="http://schemas.microsoft.com/office/drawing/2014/main" id="{27605702-F571-44DC-B6E4-15E7756B4F65}"/>
+                <a16:creationId xmlns:a16="http://schemas.microsoft.com/office/drawing/2014/main" id="{D3183C29-0A8A-48CA-9DD8-34FB1A4D50E7}"/>
               </a:ext>
             </a:extLst>
           </p:cNvPr>
@@ -9648,7 +9648,7 @@
           <p:cNvPr id="17" name="route-number-6">
             <a:extLst xmlns:a="http://schemas.openxmlformats.org/drawingml/2006/main">
               <a:ext uri="{FF2B5EF4-FFF2-40B4-BE49-F238E27FC236}">
-                <a16:creationId xmlns:a16="http://schemas.microsoft.com/office/drawing/2014/main" id="{532DE08E-D644-444D-B8BC-8DD458A46A0C}"/>
+                <a16:creationId xmlns:a16="http://schemas.microsoft.com/office/drawing/2014/main" id="{A70AD0D2-9D49-4D91-AFF0-ACE3C661C65C}"/>
               </a:ext>
             </a:extLst>
           </p:cNvPr>
@@ -9705,7 +9705,7 @@
           <p:cNvPr id="18" name="route-6">
             <a:extLst xmlns:a="http://schemas.openxmlformats.org/drawingml/2006/main">
               <a:ext uri="{FF2B5EF4-FFF2-40B4-BE49-F238E27FC236}">
-                <a16:creationId xmlns:a16="http://schemas.microsoft.com/office/drawing/2014/main" id="{C2AA9260-22D1-4B7A-9EEA-0638FA6AF686}"/>
+                <a16:creationId xmlns:a16="http://schemas.microsoft.com/office/drawing/2014/main" id="{DEFA89C6-C5C1-4F47-8E34-AD522009CEA4}"/>
               </a:ext>
             </a:extLst>
           </p:cNvPr>
@@ -9762,7 +9762,7 @@
           <p:cNvPr id="19" name="route-number-7">
             <a:extLst xmlns:a="http://schemas.openxmlformats.org/drawingml/2006/main">
               <a:ext uri="{FF2B5EF4-FFF2-40B4-BE49-F238E27FC236}">
-                <a16:creationId xmlns:a16="http://schemas.microsoft.com/office/drawing/2014/main" id="{397B1D54-07E6-439E-B7DA-92D1425ADA9D}"/>
+                <a16:creationId xmlns:a16="http://schemas.microsoft.com/office/drawing/2014/main" id="{3D7ECFF8-0A75-41D3-BD6F-B2333FDAF5DA}"/>
               </a:ext>
             </a:extLst>
           </p:cNvPr>
@@ -9819,7 +9819,7 @@
           <p:cNvPr id="20" name="route-7">
             <a:extLst xmlns:a="http://schemas.openxmlformats.org/drawingml/2006/main">
               <a:ext uri="{FF2B5EF4-FFF2-40B4-BE49-F238E27FC236}">
-                <a16:creationId xmlns:a16="http://schemas.microsoft.com/office/drawing/2014/main" id="{3A925FF2-A123-4924-9B97-FA519675AFA5}"/>
+                <a16:creationId xmlns:a16="http://schemas.microsoft.com/office/drawing/2014/main" id="{6904C05F-CF04-4945-A216-821C27748867}"/>
               </a:ext>
             </a:extLst>
           </p:cNvPr>
@@ -9876,7 +9876,7 @@
           <p:cNvPr id="21" name="Lesdoelen">
             <a:extLst xmlns:a="http://schemas.openxmlformats.org/drawingml/2006/main">
               <a:ext uri="{FF2B5EF4-FFF2-40B4-BE49-F238E27FC236}">
-                <a16:creationId xmlns:a16="http://schemas.microsoft.com/office/drawing/2014/main" id="{60D7F8BA-131D-4ACA-A6B7-126730A49754}"/>
+                <a16:creationId xmlns:a16="http://schemas.microsoft.com/office/drawing/2014/main" id="{3CB8AB2E-EA5E-4D45-8DA0-CF57E820E9F1}"/>
               </a:ext>
             </a:extLst>
           </p:cNvPr>
@@ -9933,7 +9933,7 @@
           <p:cNvPr id="22" name="overview-goals">
             <a:extLst xmlns:a="http://schemas.openxmlformats.org/drawingml/2006/main">
               <a:ext uri="{FF2B5EF4-FFF2-40B4-BE49-F238E27FC236}">
-                <a16:creationId xmlns:a16="http://schemas.microsoft.com/office/drawing/2014/main" id="{07626E5B-0198-411D-AB43-4C46754629FC}"/>
+                <a16:creationId xmlns:a16="http://schemas.microsoft.com/office/drawing/2014/main" id="{64188C21-59D8-4FEF-9093-2BDEDCCDE8B8}"/>
               </a:ext>
             </a:extLst>
           </p:cNvPr>
@@ -10036,7 +10036,7 @@
           <p:cNvPr id="23" name="">
             <a:extLst xmlns:a="http://schemas.openxmlformats.org/drawingml/2006/main">
               <a:ext uri="{FF2B5EF4-FFF2-40B4-BE49-F238E27FC236}">
-                <a16:creationId xmlns:a16="http://schemas.microsoft.com/office/drawing/2014/main" id="{F9EF4444-DFBE-4FF6-B092-ECD4080B1435}"/>
+                <a16:creationId xmlns:a16="http://schemas.microsoft.com/office/drawing/2014/main" id="{997423DB-B905-4777-B26E-FAA071AADA22}"/>
               </a:ext>
             </a:extLst>
           </p:cNvPr>
@@ -10065,7 +10065,7 @@
           <p:cNvPr id="24" name="Startopdracht">
             <a:extLst xmlns:a="http://schemas.openxmlformats.org/drawingml/2006/main">
               <a:ext uri="{FF2B5EF4-FFF2-40B4-BE49-F238E27FC236}">
-                <a16:creationId xmlns:a16="http://schemas.microsoft.com/office/drawing/2014/main" id="{6B6AA147-B820-44FD-BF2A-9ED6534B7D98}"/>
+                <a16:creationId xmlns:a16="http://schemas.microsoft.com/office/drawing/2014/main" id="{2D4A4F4F-38DE-472E-880F-6B2B2229B908}"/>
               </a:ext>
             </a:extLst>
           </p:cNvPr>
@@ -10122,7 +10122,7 @@
           <p:cNvPr id="25" name="overview-start">
             <a:extLst xmlns:a="http://schemas.openxmlformats.org/drawingml/2006/main">
               <a:ext uri="{FF2B5EF4-FFF2-40B4-BE49-F238E27FC236}">
-                <a16:creationId xmlns:a16="http://schemas.microsoft.com/office/drawing/2014/main" id="{FD0FD248-1FE7-4C52-B11B-E16524B79761}"/>
+                <a16:creationId xmlns:a16="http://schemas.microsoft.com/office/drawing/2014/main" id="{2FB73020-CD6D-4D78-B059-024E043D4647}"/>
               </a:ext>
             </a:extLst>
           </p:cNvPr>
@@ -10169,7 +10169,7 @@
                 <a:ea typeface="Arial"/>
                 <a:cs typeface="Arial"/>
               </a:rPr>
-              <a:t>Pagina 23 · Opgaven 1 en 2</a:t>
+              <a:t>Pagina 24 · Opgaven 1 en 2</a:t>
             </a:r>
           </a:p>
           <a:p xmlns:a="http://schemas.openxmlformats.org/drawingml/2006/main">
@@ -10202,7 +10202,7 @@
           <p:cNvPr id="26" name="">
             <a:extLst xmlns:a="http://schemas.openxmlformats.org/drawingml/2006/main">
               <a:ext uri="{FF2B5EF4-FFF2-40B4-BE49-F238E27FC236}">
-                <a16:creationId xmlns:a16="http://schemas.microsoft.com/office/drawing/2014/main" id="{449D41BA-F9DD-43CC-8A8A-9A4346C259D8}"/>
+                <a16:creationId xmlns:a16="http://schemas.microsoft.com/office/drawing/2014/main" id="{C406F1A6-D1BE-46C8-BCF9-52680B898E64}"/>
               </a:ext>
             </a:extLst>
           </p:cNvPr>
@@ -10231,7 +10231,7 @@
           <p:cNvPr id="27" name="Huiswerk">
             <a:extLst xmlns:a="http://schemas.openxmlformats.org/drawingml/2006/main">
               <a:ext uri="{FF2B5EF4-FFF2-40B4-BE49-F238E27FC236}">
-                <a16:creationId xmlns:a16="http://schemas.microsoft.com/office/drawing/2014/main" id="{A5617DD7-6697-408F-B80E-E18D5E8148F3}"/>
+                <a16:creationId xmlns:a16="http://schemas.microsoft.com/office/drawing/2014/main" id="{45FA2F71-72D7-4181-A151-80304E3CA425}"/>
               </a:ext>
             </a:extLst>
           </p:cNvPr>
@@ -10288,7 +10288,7 @@
           <p:cNvPr id="28" name="overview-homework">
             <a:extLst xmlns:a="http://schemas.openxmlformats.org/drawingml/2006/main">
               <a:ext uri="{FF2B5EF4-FFF2-40B4-BE49-F238E27FC236}">
-                <a16:creationId xmlns:a16="http://schemas.microsoft.com/office/drawing/2014/main" id="{E3F9C741-7F13-4BC6-A7B8-4571D161DAE2}"/>
+                <a16:creationId xmlns:a16="http://schemas.microsoft.com/office/drawing/2014/main" id="{22C122D8-9C70-4478-8591-077DB01A6CC6}"/>
               </a:ext>
             </a:extLst>
           </p:cNvPr>
@@ -10435,7 +10435,7 @@
     </p:spTree>
     <p:extLst>
       <p:ext uri="{BB962C8B-B14F-4D97-AF65-F5344CB8AC3E}">
-        <p14:creationId xmlns:p14="http://schemas.microsoft.com/office/powerpoint/2010/main" val="911134334"/>
+        <p14:creationId xmlns:p14="http://schemas.microsoft.com/office/powerpoint/2010/main" val="1913387218"/>
       </p:ext>
     </p:extLst>
   </p:cSld>
@@ -10466,7 +10466,7 @@
           <p:cNvPr id="8" name="Opgave 7 · Linea en Curva">
             <a:extLst xmlns:a="http://schemas.openxmlformats.org/drawingml/2006/main">
               <a:ext uri="{FF2B5EF4-FFF2-40B4-BE49-F238E27FC236}">
-                <a16:creationId xmlns:a16="http://schemas.microsoft.com/office/drawing/2014/main" id="{2B5AE212-3FF1-41FF-A870-9A3A33963857}"/>
+                <a16:creationId xmlns:a16="http://schemas.microsoft.com/office/drawing/2014/main" id="{D8869596-B577-433D-8A1A-38EDF084E6E7}"/>
               </a:ext>
             </a:extLst>
           </p:cNvPr>
@@ -10523,7 +10523,7 @@
           <p:cNvPr id="2" name="">
             <a:extLst xmlns:a="http://schemas.openxmlformats.org/drawingml/2006/main">
               <a:ext uri="{FF2B5EF4-FFF2-40B4-BE49-F238E27FC236}">
-                <a16:creationId xmlns:a16="http://schemas.microsoft.com/office/drawing/2014/main" id="{7BC001A1-5C5A-422D-AAED-704E601FBDD6}"/>
+                <a16:creationId xmlns:a16="http://schemas.microsoft.com/office/drawing/2014/main" id="{4B978C9F-F162-47FE-82B2-F818867DE820}"/>
               </a:ext>
             </a:extLst>
           </p:cNvPr>
@@ -10549,10 +10549,10 @@
       </p:sp>
       <p:sp>
         <p:nvSpPr>
-          <p:cNvPr id="3" name="§2.1.3 · Opgave 7 · Linea en Curva · Boekpagina 26">
+          <p:cNvPr id="3" name="§2.1.3 · Opgave 7 · Linea en Curva · Boekpagina 27">
             <a:extLst xmlns:a="http://schemas.openxmlformats.org/drawingml/2006/main">
               <a:ext uri="{FF2B5EF4-FFF2-40B4-BE49-F238E27FC236}">
-                <a16:creationId xmlns:a16="http://schemas.microsoft.com/office/drawing/2014/main" id="{08B87F96-077A-450B-9663-8890B2677904}"/>
+                <a16:creationId xmlns:a16="http://schemas.microsoft.com/office/drawing/2014/main" id="{A1EE2F1C-7746-48F9-9E05-220BD2ABC75C}"/>
               </a:ext>
             </a:extLst>
           </p:cNvPr>
@@ -10599,7 +10599,7 @@
                 <a:ea typeface="Arial"/>
                 <a:cs typeface="Arial"/>
               </a:rPr>
-              <a:t>§2.1.3 · Opgave 7 · Linea en Curva · Boekpagina 26</a:t>
+              <a:t>§2.1.3 · Opgave 7 · Linea en Curva · Boekpagina 27</a:t>
             </a:r>
           </a:p>
         </p:txBody>
@@ -10609,7 +10609,7 @@
           <p:cNvPr id="4" name="slide-number">
             <a:extLst xmlns:a="http://schemas.openxmlformats.org/drawingml/2006/main">
               <a:ext uri="{FF2B5EF4-FFF2-40B4-BE49-F238E27FC236}">
-                <a16:creationId xmlns:a16="http://schemas.microsoft.com/office/drawing/2014/main" id="{D4524162-9969-4D88-BBA6-9695646FCF1C}"/>
+                <a16:creationId xmlns:a16="http://schemas.microsoft.com/office/drawing/2014/main" id="{04978CC2-A13B-4DFA-8B21-45B5B6532A8B}"/>
               </a:ext>
             </a:extLst>
           </p:cNvPr>
@@ -10937,7 +10937,7 @@
           <p:cNvPr id="6" name="Q: producten per week. Totale bedragen: euro per week.">
             <a:extLst xmlns:a="http://schemas.openxmlformats.org/drawingml/2006/main">
               <a:ext uri="{FF2B5EF4-FFF2-40B4-BE49-F238E27FC236}">
-                <a16:creationId xmlns:a16="http://schemas.microsoft.com/office/drawing/2014/main" id="{02194C7C-F725-4D95-8778-485941EC5D6D}"/>
+                <a16:creationId xmlns:a16="http://schemas.microsoft.com/office/drawing/2014/main" id="{72A4E2A2-52FA-4D8F-A8BA-CAEFBDAC93E8}"/>
               </a:ext>
             </a:extLst>
           </p:cNvPr>
@@ -10994,7 +10994,7 @@
           <p:cNvPr id="7" name="Bereken MK en MO per extra product over iedere tabelstap.&#10;Zet de ">
             <a:extLst xmlns:a="http://schemas.openxmlformats.org/drawingml/2006/main">
               <a:ext uri="{FF2B5EF4-FFF2-40B4-BE49-F238E27FC236}">
-                <a16:creationId xmlns:a16="http://schemas.microsoft.com/office/drawing/2014/main" id="{67597A33-D748-425F-8336-6A34567845D0}"/>
+                <a16:creationId xmlns:a16="http://schemas.microsoft.com/office/drawing/2014/main" id="{BB993B5F-E851-4B84-9D0C-5E52E92B0607}"/>
               </a:ext>
             </a:extLst>
           </p:cNvPr>
@@ -11095,7 +11095,7 @@
     </p:spTree>
     <p:extLst>
       <p:ext uri="{BB962C8B-B14F-4D97-AF65-F5344CB8AC3E}">
-        <p14:creationId xmlns:p14="http://schemas.microsoft.com/office/powerpoint/2010/main" val="54276767"/>
+        <p14:creationId xmlns:p14="http://schemas.microsoft.com/office/powerpoint/2010/main" val="773343236"/>
       </p:ext>
     </p:extLst>
   </p:cSld>
@@ -11126,7 +11126,7 @@
           <p:cNvPr id="9" name="Opgave 7 · Invultabel Linea">
             <a:extLst xmlns:a="http://schemas.openxmlformats.org/drawingml/2006/main">
               <a:ext uri="{FF2B5EF4-FFF2-40B4-BE49-F238E27FC236}">
-                <a16:creationId xmlns:a16="http://schemas.microsoft.com/office/drawing/2014/main" id="{CFB01969-2F4D-4C92-BDAF-F18C1160C1A1}"/>
+                <a16:creationId xmlns:a16="http://schemas.microsoft.com/office/drawing/2014/main" id="{4566BC79-D2D1-49F2-B579-9099E9B47C40}"/>
               </a:ext>
             </a:extLst>
           </p:cNvPr>
@@ -11183,7 +11183,7 @@
           <p:cNvPr id="2" name="">
             <a:extLst xmlns:a="http://schemas.openxmlformats.org/drawingml/2006/main">
               <a:ext uri="{FF2B5EF4-FFF2-40B4-BE49-F238E27FC236}">
-                <a16:creationId xmlns:a16="http://schemas.microsoft.com/office/drawing/2014/main" id="{D41E5C4B-0912-4061-9B91-B7093D98565C}"/>
+                <a16:creationId xmlns:a16="http://schemas.microsoft.com/office/drawing/2014/main" id="{26E7BAD4-6C8C-4103-A770-079E2AEC978A}"/>
               </a:ext>
             </a:extLst>
           </p:cNvPr>
@@ -11209,10 +11209,10 @@
       </p:sp>
       <p:sp>
         <p:nvSpPr>
-          <p:cNvPr id="3" name="§2.1.3 · Opgave 7 · Linea en Curva · Boekpagina 26">
+          <p:cNvPr id="3" name="§2.1.3 · Opgave 7 · Linea en Curva · Boekpagina 27">
             <a:extLst xmlns:a="http://schemas.openxmlformats.org/drawingml/2006/main">
               <a:ext uri="{FF2B5EF4-FFF2-40B4-BE49-F238E27FC236}">
-                <a16:creationId xmlns:a16="http://schemas.microsoft.com/office/drawing/2014/main" id="{FF5393B7-2236-495F-B8D9-EDE20E89333B}"/>
+                <a16:creationId xmlns:a16="http://schemas.microsoft.com/office/drawing/2014/main" id="{7D483E60-DFBF-4F90-914A-07C7F1855F94}"/>
               </a:ext>
             </a:extLst>
           </p:cNvPr>
@@ -11259,7 +11259,7 @@
                 <a:ea typeface="Arial"/>
                 <a:cs typeface="Arial"/>
               </a:rPr>
-              <a:t>§2.1.3 · Opgave 7 · Linea en Curva · Boekpagina 26</a:t>
+              <a:t>§2.1.3 · Opgave 7 · Linea en Curva · Boekpagina 27</a:t>
             </a:r>
           </a:p>
         </p:txBody>
@@ -11269,7 +11269,7 @@
           <p:cNvPr id="4" name="slide-number">
             <a:extLst xmlns:a="http://schemas.openxmlformats.org/drawingml/2006/main">
               <a:ext uri="{FF2B5EF4-FFF2-40B4-BE49-F238E27FC236}">
-                <a16:creationId xmlns:a16="http://schemas.microsoft.com/office/drawing/2014/main" id="{72CD6A72-C1BF-4AE1-9FA1-54E76DC7ECE0}"/>
+                <a16:creationId xmlns:a16="http://schemas.microsoft.com/office/drawing/2014/main" id="{AC0EC65D-7F37-4B4B-B1FA-72B3DCD2149C}"/>
               </a:ext>
             </a:extLst>
           </p:cNvPr>
@@ -11326,7 +11326,7 @@
           <p:cNvPr id="5" name="TK = 200 + 3Q     TO = 8Q">
             <a:extLst xmlns:a="http://schemas.openxmlformats.org/drawingml/2006/main">
               <a:ext uri="{FF2B5EF4-FFF2-40B4-BE49-F238E27FC236}">
-                <a16:creationId xmlns:a16="http://schemas.microsoft.com/office/drawing/2014/main" id="{64C8B5A0-CE30-4DD8-A401-D5417E91BF4C}"/>
+                <a16:creationId xmlns:a16="http://schemas.microsoft.com/office/drawing/2014/main" id="{546E928C-077B-4B09-97CD-0E1F2D03C82B}"/>
               </a:ext>
             </a:extLst>
           </p:cNvPr>
@@ -11383,7 +11383,7 @@
           <p:cNvPr id="6" name="Q: producten per week · TK, TO en winst: euro per week">
             <a:extLst xmlns:a="http://schemas.openxmlformats.org/drawingml/2006/main">
               <a:ext uri="{FF2B5EF4-FFF2-40B4-BE49-F238E27FC236}">
-                <a16:creationId xmlns:a16="http://schemas.microsoft.com/office/drawing/2014/main" id="{B8D5A8D6-ED49-4456-B764-F4AAABBDD152}"/>
+                <a16:creationId xmlns:a16="http://schemas.microsoft.com/office/drawing/2014/main" id="{8B920756-E6F3-4210-ABEF-6450BBBFD3BE}"/>
               </a:ext>
             </a:extLst>
           </p:cNvPr>
@@ -12222,7 +12222,7 @@
           <p:cNvPr id="8" name="MK en MO: per extra product, vanaf de vorige tabelrij.">
             <a:extLst xmlns:a="http://schemas.openxmlformats.org/drawingml/2006/main">
               <a:ext uri="{FF2B5EF4-FFF2-40B4-BE49-F238E27FC236}">
-                <a16:creationId xmlns:a16="http://schemas.microsoft.com/office/drawing/2014/main" id="{BE77D747-0348-419D-ACD5-B40276F48E82}"/>
+                <a16:creationId xmlns:a16="http://schemas.microsoft.com/office/drawing/2014/main" id="{462EBB37-8170-451B-9588-E52B69AB26EE}"/>
               </a:ext>
             </a:extLst>
           </p:cNvPr>
@@ -12277,7 +12277,7 @@
     </p:spTree>
     <p:extLst>
       <p:ext uri="{BB962C8B-B14F-4D97-AF65-F5344CB8AC3E}">
-        <p14:creationId xmlns:p14="http://schemas.microsoft.com/office/powerpoint/2010/main" val="1635028388"/>
+        <p14:creationId xmlns:p14="http://schemas.microsoft.com/office/powerpoint/2010/main" val="709274927"/>
       </p:ext>
     </p:extLst>
   </p:cSld>
@@ -12308,7 +12308,7 @@
           <p:cNvPr id="9" name="Opgave 7 · Invultabel Curva">
             <a:extLst xmlns:a="http://schemas.openxmlformats.org/drawingml/2006/main">
               <a:ext uri="{FF2B5EF4-FFF2-40B4-BE49-F238E27FC236}">
-                <a16:creationId xmlns:a16="http://schemas.microsoft.com/office/drawing/2014/main" id="{67741AF7-1C16-4CD4-B046-73F74718AFB9}"/>
+                <a16:creationId xmlns:a16="http://schemas.microsoft.com/office/drawing/2014/main" id="{C2717AC0-9EF2-4267-B513-FF5E405A7EB1}"/>
               </a:ext>
             </a:extLst>
           </p:cNvPr>
@@ -12365,7 +12365,7 @@
           <p:cNvPr id="2" name="">
             <a:extLst xmlns:a="http://schemas.openxmlformats.org/drawingml/2006/main">
               <a:ext uri="{FF2B5EF4-FFF2-40B4-BE49-F238E27FC236}">
-                <a16:creationId xmlns:a16="http://schemas.microsoft.com/office/drawing/2014/main" id="{165AC46C-1285-4E5C-B2AE-CD13C0E56CB3}"/>
+                <a16:creationId xmlns:a16="http://schemas.microsoft.com/office/drawing/2014/main" id="{4B0382AC-673D-4BFC-B62C-08FE8592C133}"/>
               </a:ext>
             </a:extLst>
           </p:cNvPr>
@@ -12391,10 +12391,10 @@
       </p:sp>
       <p:sp>
         <p:nvSpPr>
-          <p:cNvPr id="3" name="§2.1.3 · Opgave 7 · Linea en Curva · Boekpagina 26">
+          <p:cNvPr id="3" name="§2.1.3 · Opgave 7 · Linea en Curva · Boekpagina 27">
             <a:extLst xmlns:a="http://schemas.openxmlformats.org/drawingml/2006/main">
               <a:ext uri="{FF2B5EF4-FFF2-40B4-BE49-F238E27FC236}">
-                <a16:creationId xmlns:a16="http://schemas.microsoft.com/office/drawing/2014/main" id="{A147D764-7FC5-49FF-8F75-8549F6FEAF79}"/>
+                <a16:creationId xmlns:a16="http://schemas.microsoft.com/office/drawing/2014/main" id="{E1F064EF-C756-458A-ACD9-FAA434AE1945}"/>
               </a:ext>
             </a:extLst>
           </p:cNvPr>
@@ -12441,7 +12441,7 @@
                 <a:ea typeface="Arial"/>
                 <a:cs typeface="Arial"/>
               </a:rPr>
-              <a:t>§2.1.3 · Opgave 7 · Linea en Curva · Boekpagina 26</a:t>
+              <a:t>§2.1.3 · Opgave 7 · Linea en Curva · Boekpagina 27</a:t>
             </a:r>
           </a:p>
         </p:txBody>
@@ -12451,7 +12451,7 @@
           <p:cNvPr id="4" name="slide-number">
             <a:extLst xmlns:a="http://schemas.openxmlformats.org/drawingml/2006/main">
               <a:ext uri="{FF2B5EF4-FFF2-40B4-BE49-F238E27FC236}">
-                <a16:creationId xmlns:a16="http://schemas.microsoft.com/office/drawing/2014/main" id="{81769645-F8D4-4BEC-8C6E-67AF5270149E}"/>
+                <a16:creationId xmlns:a16="http://schemas.microsoft.com/office/drawing/2014/main" id="{A75676B7-F984-43F9-B3B4-0ECB776B719E}"/>
               </a:ext>
             </a:extLst>
           </p:cNvPr>
@@ -12508,7 +12508,7 @@
           <p:cNvPr id="5" name="TK = 100 + Q²     TO = 30Q">
             <a:extLst xmlns:a="http://schemas.openxmlformats.org/drawingml/2006/main">
               <a:ext uri="{FF2B5EF4-FFF2-40B4-BE49-F238E27FC236}">
-                <a16:creationId xmlns:a16="http://schemas.microsoft.com/office/drawing/2014/main" id="{FDFC95EE-89F0-417B-9EDE-8D39F3883BD5}"/>
+                <a16:creationId xmlns:a16="http://schemas.microsoft.com/office/drawing/2014/main" id="{3B7C1391-989F-4600-A36E-E0227BE3BA03}"/>
               </a:ext>
             </a:extLst>
           </p:cNvPr>
@@ -12565,7 +12565,7 @@
           <p:cNvPr id="6" name="Q: producten per week · TK, TO en winst: euro per week">
             <a:extLst xmlns:a="http://schemas.openxmlformats.org/drawingml/2006/main">
               <a:ext uri="{FF2B5EF4-FFF2-40B4-BE49-F238E27FC236}">
-                <a16:creationId xmlns:a16="http://schemas.microsoft.com/office/drawing/2014/main" id="{6F14A278-029B-48D0-AC74-6ECB5CAD6E81}"/>
+                <a16:creationId xmlns:a16="http://schemas.microsoft.com/office/drawing/2014/main" id="{ACDA105C-0643-4D55-BCF8-5920062C3799}"/>
               </a:ext>
             </a:extLst>
           </p:cNvPr>
@@ -13404,7 +13404,7 @@
           <p:cNvPr id="8" name="MK en MO: per extra product, vanaf de vorige tabelrij.">
             <a:extLst xmlns:a="http://schemas.openxmlformats.org/drawingml/2006/main">
               <a:ext uri="{FF2B5EF4-FFF2-40B4-BE49-F238E27FC236}">
-                <a16:creationId xmlns:a16="http://schemas.microsoft.com/office/drawing/2014/main" id="{CE9846FF-C626-4BFF-81C8-72C614BC796C}"/>
+                <a16:creationId xmlns:a16="http://schemas.microsoft.com/office/drawing/2014/main" id="{33B86402-E4D2-4B43-9F5B-88B1B81DB301}"/>
               </a:ext>
             </a:extLst>
           </p:cNvPr>
@@ -13459,7 +13459,7 @@
     </p:spTree>
     <p:extLst>
       <p:ext uri="{BB962C8B-B14F-4D97-AF65-F5344CB8AC3E}">
-        <p14:creationId xmlns:p14="http://schemas.microsoft.com/office/powerpoint/2010/main" val="1038953858"/>
+        <p14:creationId xmlns:p14="http://schemas.microsoft.com/office/powerpoint/2010/main" val="1844530880"/>
       </p:ext>
     </p:extLst>
   </p:cSld>
@@ -13490,7 +13490,7 @@
           <p:cNvPr id="10" name="Opgave 7 · Deelvragen a, b en c">
             <a:extLst xmlns:a="http://schemas.openxmlformats.org/drawingml/2006/main">
               <a:ext uri="{FF2B5EF4-FFF2-40B4-BE49-F238E27FC236}">
-                <a16:creationId xmlns:a16="http://schemas.microsoft.com/office/drawing/2014/main" id="{991FA4C1-14FB-459B-A91B-23A210B84DFA}"/>
+                <a16:creationId xmlns:a16="http://schemas.microsoft.com/office/drawing/2014/main" id="{161FAA8B-E43F-4A4E-8082-F2CDBEFE2E35}"/>
               </a:ext>
             </a:extLst>
           </p:cNvPr>
@@ -13547,7 +13547,7 @@
           <p:cNvPr id="2" name="">
             <a:extLst xmlns:a="http://schemas.openxmlformats.org/drawingml/2006/main">
               <a:ext uri="{FF2B5EF4-FFF2-40B4-BE49-F238E27FC236}">
-                <a16:creationId xmlns:a16="http://schemas.microsoft.com/office/drawing/2014/main" id="{951F4F9F-373F-4DF9-9E6C-BCF1A9360FA0}"/>
+                <a16:creationId xmlns:a16="http://schemas.microsoft.com/office/drawing/2014/main" id="{55C042B6-4187-4D83-946F-9BA2B3F501F6}"/>
               </a:ext>
             </a:extLst>
           </p:cNvPr>
@@ -13573,10 +13573,10 @@
       </p:sp>
       <p:sp>
         <p:nvSpPr>
-          <p:cNvPr id="3" name="§2.1.3 · Opgave 7 · Linea en Curva · Boekpagina 26">
+          <p:cNvPr id="3" name="§2.1.3 · Opgave 7 · Linea en Curva · Boekpagina 27">
             <a:extLst xmlns:a="http://schemas.openxmlformats.org/drawingml/2006/main">
               <a:ext uri="{FF2B5EF4-FFF2-40B4-BE49-F238E27FC236}">
-                <a16:creationId xmlns:a16="http://schemas.microsoft.com/office/drawing/2014/main" id="{C41AE917-4AC6-4BC1-93CF-B8EB1785550D}"/>
+                <a16:creationId xmlns:a16="http://schemas.microsoft.com/office/drawing/2014/main" id="{CF0EF694-8E89-4BD9-9B67-EBCF164CA3F0}"/>
               </a:ext>
             </a:extLst>
           </p:cNvPr>
@@ -13623,7 +13623,7 @@
                 <a:ea typeface="Arial"/>
                 <a:cs typeface="Arial"/>
               </a:rPr>
-              <a:t>§2.1.3 · Opgave 7 · Linea en Curva · Boekpagina 26</a:t>
+              <a:t>§2.1.3 · Opgave 7 · Linea en Curva · Boekpagina 27</a:t>
             </a:r>
           </a:p>
         </p:txBody>
@@ -13633,7 +13633,7 @@
           <p:cNvPr id="4" name="slide-number">
             <a:extLst xmlns:a="http://schemas.openxmlformats.org/drawingml/2006/main">
               <a:ext uri="{FF2B5EF4-FFF2-40B4-BE49-F238E27FC236}">
-                <a16:creationId xmlns:a16="http://schemas.microsoft.com/office/drawing/2014/main" id="{A2A185F8-33E1-4503-BFFA-90D0BC9A6284}"/>
+                <a16:creationId xmlns:a16="http://schemas.microsoft.com/office/drawing/2014/main" id="{31B7B415-1022-42D3-AA3E-C3E99CEAC3BA}"/>
               </a:ext>
             </a:extLst>
           </p:cNvPr>
@@ -13690,7 +13690,7 @@
           <p:cNvPr id="5" name="a) Vul bij Linea de winstkolom in.">
             <a:extLst xmlns:a="http://schemas.openxmlformats.org/drawingml/2006/main">
               <a:ext uri="{FF2B5EF4-FFF2-40B4-BE49-F238E27FC236}">
-                <a16:creationId xmlns:a16="http://schemas.microsoft.com/office/drawing/2014/main" id="{F9F9BB17-85BF-4B34-A3A5-247974913580}"/>
+                <a16:creationId xmlns:a16="http://schemas.microsoft.com/office/drawing/2014/main" id="{2CE1A38F-E78B-4B1A-BF11-44112A5B13F6}"/>
               </a:ext>
             </a:extLst>
           </p:cNvPr>
@@ -13747,7 +13747,7 @@
           <p:cNvPr id="6" name="">
             <a:extLst xmlns:a="http://schemas.openxmlformats.org/drawingml/2006/main">
               <a:ext uri="{FF2B5EF4-FFF2-40B4-BE49-F238E27FC236}">
-                <a16:creationId xmlns:a16="http://schemas.microsoft.com/office/drawing/2014/main" id="{41AE312F-E95F-43F7-8930-0F27023308C0}"/>
+                <a16:creationId xmlns:a16="http://schemas.microsoft.com/office/drawing/2014/main" id="{650B7D1F-7DF9-483A-A386-92729AF328F7}"/>
               </a:ext>
             </a:extLst>
           </p:cNvPr>
@@ -13776,7 +13776,7 @@
           <p:cNvPr id="7" name="b) Bereken voor Linea MK en MO over de eerste stap. Laat teller e">
             <a:extLst xmlns:a="http://schemas.openxmlformats.org/drawingml/2006/main">
               <a:ext uri="{FF2B5EF4-FFF2-40B4-BE49-F238E27FC236}">
-                <a16:creationId xmlns:a16="http://schemas.microsoft.com/office/drawing/2014/main" id="{85721137-3807-41D7-9D16-8E61486E1270}"/>
+                <a16:creationId xmlns:a16="http://schemas.microsoft.com/office/drawing/2014/main" id="{80A47434-02E0-4A29-96DD-1FF794C37E88}"/>
               </a:ext>
             </a:extLst>
           </p:cNvPr>
@@ -13833,7 +13833,7 @@
           <p:cNvPr id="8" name="">
             <a:extLst xmlns:a="http://schemas.openxmlformats.org/drawingml/2006/main">
               <a:ext uri="{FF2B5EF4-FFF2-40B4-BE49-F238E27FC236}">
-                <a16:creationId xmlns:a16="http://schemas.microsoft.com/office/drawing/2014/main" id="{CD15D23F-2A5E-4D89-BBB4-5D19B78AF9EC}"/>
+                <a16:creationId xmlns:a16="http://schemas.microsoft.com/office/drawing/2014/main" id="{A5A9F09B-E591-42F8-92F4-931B8265BC36}"/>
               </a:ext>
             </a:extLst>
           </p:cNvPr>
@@ -13862,7 +13862,7 @@
           <p:cNvPr id="9" name="c) Leg uit waarom MO bij Linea constant is.">
             <a:extLst xmlns:a="http://schemas.openxmlformats.org/drawingml/2006/main">
               <a:ext uri="{FF2B5EF4-FFF2-40B4-BE49-F238E27FC236}">
-                <a16:creationId xmlns:a16="http://schemas.microsoft.com/office/drawing/2014/main" id="{1E441F2B-F609-4A8E-B193-D5822C5D0B29}"/>
+                <a16:creationId xmlns:a16="http://schemas.microsoft.com/office/drawing/2014/main" id="{8DC97642-5B60-4B7F-AD37-3E40E530ACF8}"/>
               </a:ext>
             </a:extLst>
           </p:cNvPr>
@@ -13917,7 +13917,7 @@
     </p:spTree>
     <p:extLst>
       <p:ext uri="{BB962C8B-B14F-4D97-AF65-F5344CB8AC3E}">
-        <p14:creationId xmlns:p14="http://schemas.microsoft.com/office/powerpoint/2010/main" val="2008792917"/>
+        <p14:creationId xmlns:p14="http://schemas.microsoft.com/office/powerpoint/2010/main" val="1740027455"/>
       </p:ext>
     </p:extLst>
   </p:cSld>
@@ -13948,7 +13948,7 @@
           <p:cNvPr id="8" name="Opgave 7 · Deelvragen d en e">
             <a:extLst xmlns:a="http://schemas.openxmlformats.org/drawingml/2006/main">
               <a:ext uri="{FF2B5EF4-FFF2-40B4-BE49-F238E27FC236}">
-                <a16:creationId xmlns:a16="http://schemas.microsoft.com/office/drawing/2014/main" id="{DE12B090-D601-46FD-956B-90DB2E88AA80}"/>
+                <a16:creationId xmlns:a16="http://schemas.microsoft.com/office/drawing/2014/main" id="{DF631FFE-AA49-441D-84F7-1A480EF51782}"/>
               </a:ext>
             </a:extLst>
           </p:cNvPr>
@@ -14005,7 +14005,7 @@
           <p:cNvPr id="2" name="">
             <a:extLst xmlns:a="http://schemas.openxmlformats.org/drawingml/2006/main">
               <a:ext uri="{FF2B5EF4-FFF2-40B4-BE49-F238E27FC236}">
-                <a16:creationId xmlns:a16="http://schemas.microsoft.com/office/drawing/2014/main" id="{52F57AB4-3472-4746-A5AB-B1FD234FF361}"/>
+                <a16:creationId xmlns:a16="http://schemas.microsoft.com/office/drawing/2014/main" id="{0E499E2D-0EAE-442A-9555-B3E65B6224DC}"/>
               </a:ext>
             </a:extLst>
           </p:cNvPr>
@@ -14031,10 +14031,10 @@
       </p:sp>
       <p:sp>
         <p:nvSpPr>
-          <p:cNvPr id="3" name="§2.1.3 · Opgave 7 · Linea en Curva · Boekpagina 26">
+          <p:cNvPr id="3" name="§2.1.3 · Opgave 7 · Linea en Curva · Boekpagina 27">
             <a:extLst xmlns:a="http://schemas.openxmlformats.org/drawingml/2006/main">
               <a:ext uri="{FF2B5EF4-FFF2-40B4-BE49-F238E27FC236}">
-                <a16:creationId xmlns:a16="http://schemas.microsoft.com/office/drawing/2014/main" id="{4B1F9703-A398-449F-8D8F-843040139C7F}"/>
+                <a16:creationId xmlns:a16="http://schemas.microsoft.com/office/drawing/2014/main" id="{EDB9CF05-EBD4-4642-9EDE-036A9D3EB5BA}"/>
               </a:ext>
             </a:extLst>
           </p:cNvPr>
@@ -14081,7 +14081,7 @@
                 <a:ea typeface="Arial"/>
                 <a:cs typeface="Arial"/>
               </a:rPr>
-              <a:t>§2.1.3 · Opgave 7 · Linea en Curva · Boekpagina 26</a:t>
+              <a:t>§2.1.3 · Opgave 7 · Linea en Curva · Boekpagina 27</a:t>
             </a:r>
           </a:p>
         </p:txBody>
@@ -14091,7 +14091,7 @@
           <p:cNvPr id="4" name="slide-number">
             <a:extLst xmlns:a="http://schemas.openxmlformats.org/drawingml/2006/main">
               <a:ext uri="{FF2B5EF4-FFF2-40B4-BE49-F238E27FC236}">
-                <a16:creationId xmlns:a16="http://schemas.microsoft.com/office/drawing/2014/main" id="{16477A72-B85D-4336-97D5-45D7FD870154}"/>
+                <a16:creationId xmlns:a16="http://schemas.microsoft.com/office/drawing/2014/main" id="{F612FC59-AEF9-4F4C-AAC2-4559CD335BE7}"/>
               </a:ext>
             </a:extLst>
           </p:cNvPr>
@@ -14148,7 +14148,7 @@
           <p:cNvPr id="5" name="d) Bereken voor Curva MK over de drie stappen en MO over de eerst">
             <a:extLst xmlns:a="http://schemas.openxmlformats.org/drawingml/2006/main">
               <a:ext uri="{FF2B5EF4-FFF2-40B4-BE49-F238E27FC236}">
-                <a16:creationId xmlns:a16="http://schemas.microsoft.com/office/drawing/2014/main" id="{D21E2ACB-49EC-4AC6-8FCB-03B69F9229F5}"/>
+                <a16:creationId xmlns:a16="http://schemas.microsoft.com/office/drawing/2014/main" id="{E61EB431-4805-4BF7-88B3-B9727B490667}"/>
               </a:ext>
             </a:extLst>
           </p:cNvPr>
@@ -14205,7 +14205,7 @@
           <p:cNvPr id="6" name="">
             <a:extLst xmlns:a="http://schemas.openxmlformats.org/drawingml/2006/main">
               <a:ext uri="{FF2B5EF4-FFF2-40B4-BE49-F238E27FC236}">
-                <a16:creationId xmlns:a16="http://schemas.microsoft.com/office/drawing/2014/main" id="{E8975481-EFE2-4DF7-B5A7-1B7A843BA10C}"/>
+                <a16:creationId xmlns:a16="http://schemas.microsoft.com/office/drawing/2014/main" id="{4AC807BD-C555-4698-AF90-77F10C0A1B83}"/>
               </a:ext>
             </a:extLst>
           </p:cNvPr>
@@ -14234,7 +14234,7 @@
           <p:cNvPr id="7" name="e) Vergelijk de MK-patronen. Leg uit wat MK en MO per extra produ">
             <a:extLst xmlns:a="http://schemas.openxmlformats.org/drawingml/2006/main">
               <a:ext uri="{FF2B5EF4-FFF2-40B4-BE49-F238E27FC236}">
-                <a16:creationId xmlns:a16="http://schemas.microsoft.com/office/drawing/2014/main" id="{F0595668-8A7D-4599-8A40-2C1C3D583482}"/>
+                <a16:creationId xmlns:a16="http://schemas.microsoft.com/office/drawing/2014/main" id="{58CA49E8-C345-4942-B9C4-D9DA456712D5}"/>
               </a:ext>
             </a:extLst>
           </p:cNvPr>
@@ -14289,7 +14289,7 @@
     </p:spTree>
     <p:extLst>
       <p:ext uri="{BB962C8B-B14F-4D97-AF65-F5344CB8AC3E}">
-        <p14:creationId xmlns:p14="http://schemas.microsoft.com/office/powerpoint/2010/main" val="367201983"/>
+        <p14:creationId xmlns:p14="http://schemas.microsoft.com/office/powerpoint/2010/main" val="298370358"/>
       </p:ext>
     </p:extLst>
   </p:cSld>
@@ -14320,7 +14320,7 @@
           <p:cNvPr id="13" name="Wat kun je na deze les?">
             <a:extLst xmlns:a="http://schemas.openxmlformats.org/drawingml/2006/main">
               <a:ext uri="{FF2B5EF4-FFF2-40B4-BE49-F238E27FC236}">
-                <a16:creationId xmlns:a16="http://schemas.microsoft.com/office/drawing/2014/main" id="{CCA20E45-64DD-4CED-9513-C0DAD09FAE5A}"/>
+                <a16:creationId xmlns:a16="http://schemas.microsoft.com/office/drawing/2014/main" id="{778D94F4-B26C-4DD5-8BE1-BC1D319A89CC}"/>
               </a:ext>
             </a:extLst>
           </p:cNvPr>
@@ -14377,7 +14377,7 @@
           <p:cNvPr id="2" name="">
             <a:extLst xmlns:a="http://schemas.openxmlformats.org/drawingml/2006/main">
               <a:ext uri="{FF2B5EF4-FFF2-40B4-BE49-F238E27FC236}">
-                <a16:creationId xmlns:a16="http://schemas.microsoft.com/office/drawing/2014/main" id="{58255C21-A2DA-41A1-A8AD-B8FD0CC7B22E}"/>
+                <a16:creationId xmlns:a16="http://schemas.microsoft.com/office/drawing/2014/main" id="{5C8781F4-0FD4-485F-9CE4-379B30A529F6}"/>
               </a:ext>
             </a:extLst>
           </p:cNvPr>
@@ -14406,7 +14406,7 @@
           <p:cNvPr id="3" name="§2.1.3 Marginale kosten en marginale opbrengsten">
             <a:extLst xmlns:a="http://schemas.openxmlformats.org/drawingml/2006/main">
               <a:ext uri="{FF2B5EF4-FFF2-40B4-BE49-F238E27FC236}">
-                <a16:creationId xmlns:a16="http://schemas.microsoft.com/office/drawing/2014/main" id="{17666149-4007-42F9-8D4B-1B2F4B89D91B}"/>
+                <a16:creationId xmlns:a16="http://schemas.microsoft.com/office/drawing/2014/main" id="{0DE7C968-FFAA-4B8E-87AD-9B8AA2BFD4C6}"/>
               </a:ext>
             </a:extLst>
           </p:cNvPr>
@@ -14463,7 +14463,7 @@
           <p:cNvPr id="4" name="slide-number">
             <a:extLst xmlns:a="http://schemas.openxmlformats.org/drawingml/2006/main">
               <a:ext uri="{FF2B5EF4-FFF2-40B4-BE49-F238E27FC236}">
-                <a16:creationId xmlns:a16="http://schemas.microsoft.com/office/drawing/2014/main" id="{1A9A4A3C-F130-48D7-A6A5-9B5BCECC2FED}"/>
+                <a16:creationId xmlns:a16="http://schemas.microsoft.com/office/drawing/2014/main" id="{BFBF259D-8A8C-4A0B-9117-83D3A6AE6DE0}"/>
               </a:ext>
             </a:extLst>
           </p:cNvPr>
@@ -14520,7 +14520,7 @@
           <p:cNvPr id="5" name="Berekenen">
             <a:extLst xmlns:a="http://schemas.openxmlformats.org/drawingml/2006/main">
               <a:ext uri="{FF2B5EF4-FFF2-40B4-BE49-F238E27FC236}">
-                <a16:creationId xmlns:a16="http://schemas.microsoft.com/office/drawing/2014/main" id="{632C1880-5606-434A-AD5A-67D432FF6A89}"/>
+                <a16:creationId xmlns:a16="http://schemas.microsoft.com/office/drawing/2014/main" id="{9B373628-5E5B-4131-A404-5DDCD50D3899}"/>
               </a:ext>
             </a:extLst>
           </p:cNvPr>
@@ -14577,7 +14577,7 @@
           <p:cNvPr id="6" name="Winst binnen één rij; MK en MO tussen twee rijen.">
             <a:extLst xmlns:a="http://schemas.openxmlformats.org/drawingml/2006/main">
               <a:ext uri="{FF2B5EF4-FFF2-40B4-BE49-F238E27FC236}">
-                <a16:creationId xmlns:a16="http://schemas.microsoft.com/office/drawing/2014/main" id="{D882CEC8-A0DD-4513-AD42-B4A3F10FB682}"/>
+                <a16:creationId xmlns:a16="http://schemas.microsoft.com/office/drawing/2014/main" id="{E6209088-D944-4AE8-B86C-E34E5EC4B0EA}"/>
               </a:ext>
             </a:extLst>
           </p:cNvPr>
@@ -14634,7 +14634,7 @@
           <p:cNvPr id="7" name="">
             <a:extLst xmlns:a="http://schemas.openxmlformats.org/drawingml/2006/main">
               <a:ext uri="{FF2B5EF4-FFF2-40B4-BE49-F238E27FC236}">
-                <a16:creationId xmlns:a16="http://schemas.microsoft.com/office/drawing/2014/main" id="{CE58325B-A27C-473D-9465-8CDA76BD0A60}"/>
+                <a16:creationId xmlns:a16="http://schemas.microsoft.com/office/drawing/2014/main" id="{9BA8AC75-45A3-4164-8D7A-2BFE2E4971AE}"/>
               </a:ext>
             </a:extLst>
           </p:cNvPr>
@@ -14663,7 +14663,7 @@
           <p:cNvPr id="8" name="Vergelijken">
             <a:extLst xmlns:a="http://schemas.openxmlformats.org/drawingml/2006/main">
               <a:ext uri="{FF2B5EF4-FFF2-40B4-BE49-F238E27FC236}">
-                <a16:creationId xmlns:a16="http://schemas.microsoft.com/office/drawing/2014/main" id="{AAAE11FA-D6AD-4CB3-84E9-E62FD0BE9939}"/>
+                <a16:creationId xmlns:a16="http://schemas.microsoft.com/office/drawing/2014/main" id="{2940D716-DCE4-444E-AE5A-5FA339D54C5B}"/>
               </a:ext>
             </a:extLst>
           </p:cNvPr>
@@ -14720,7 +14720,7 @@
           <p:cNvPr id="9" name="Constante en stijgende MK herkennen; constante MO verklaren.">
             <a:extLst xmlns:a="http://schemas.openxmlformats.org/drawingml/2006/main">
               <a:ext uri="{FF2B5EF4-FFF2-40B4-BE49-F238E27FC236}">
-                <a16:creationId xmlns:a16="http://schemas.microsoft.com/office/drawing/2014/main" id="{10C9B2F3-C59E-4015-BE12-7AC73864EE2A}"/>
+                <a16:creationId xmlns:a16="http://schemas.microsoft.com/office/drawing/2014/main" id="{5B63545E-5695-47F7-8118-8A967133F2A8}"/>
               </a:ext>
             </a:extLst>
           </p:cNvPr>
@@ -14777,7 +14777,7 @@
           <p:cNvPr id="10" name="">
             <a:extLst xmlns:a="http://schemas.openxmlformats.org/drawingml/2006/main">
               <a:ext uri="{FF2B5EF4-FFF2-40B4-BE49-F238E27FC236}">
-                <a16:creationId xmlns:a16="http://schemas.microsoft.com/office/drawing/2014/main" id="{69A0B3CA-A539-407A-BBB4-57D10310D1F0}"/>
+                <a16:creationId xmlns:a16="http://schemas.microsoft.com/office/drawing/2014/main" id="{8E1AEB2D-CD82-4BA8-9CA4-4E91A5CC62CE}"/>
               </a:ext>
             </a:extLst>
           </p:cNvPr>
@@ -14806,7 +14806,7 @@
           <p:cNvPr id="11" name="Uitleggen">
             <a:extLst xmlns:a="http://schemas.openxmlformats.org/drawingml/2006/main">
               <a:ext uri="{FF2B5EF4-FFF2-40B4-BE49-F238E27FC236}">
-                <a16:creationId xmlns:a16="http://schemas.microsoft.com/office/drawing/2014/main" id="{91BC54AA-453D-411D-86EA-DEF1D1C29074}"/>
+                <a16:creationId xmlns:a16="http://schemas.microsoft.com/office/drawing/2014/main" id="{5570888C-5EBD-4C8D-8073-B1E719150DB3}"/>
               </a:ext>
             </a:extLst>
           </p:cNvPr>
@@ -14863,7 +14863,7 @@
           <p:cNvPr id="12" name="De hele tabelstap en de eenheid noemen; gemiddeld van marginaal o">
             <a:extLst xmlns:a="http://schemas.openxmlformats.org/drawingml/2006/main">
               <a:ext uri="{FF2B5EF4-FFF2-40B4-BE49-F238E27FC236}">
-                <a16:creationId xmlns:a16="http://schemas.microsoft.com/office/drawing/2014/main" id="{A172D2E7-0F32-4F51-ABAD-4512FB0468C9}"/>
+                <a16:creationId xmlns:a16="http://schemas.microsoft.com/office/drawing/2014/main" id="{BE68BB55-676E-41EC-8524-94D82690C331}"/>
               </a:ext>
             </a:extLst>
           </p:cNvPr>
@@ -14918,7 +14918,7 @@
     </p:spTree>
     <p:extLst>
       <p:ext uri="{BB962C8B-B14F-4D97-AF65-F5344CB8AC3E}">
-        <p14:creationId xmlns:p14="http://schemas.microsoft.com/office/powerpoint/2010/main" val="1061659902"/>
+        <p14:creationId xmlns:p14="http://schemas.microsoft.com/office/powerpoint/2010/main" val="1337529460"/>
       </p:ext>
     </p:extLst>
   </p:cSld>
@@ -14949,7 +14949,7 @@
           <p:cNvPr id="8" name="Opgave 7a · Winst bij Linea">
             <a:extLst xmlns:a="http://schemas.openxmlformats.org/drawingml/2006/main">
               <a:ext uri="{FF2B5EF4-FFF2-40B4-BE49-F238E27FC236}">
-                <a16:creationId xmlns:a16="http://schemas.microsoft.com/office/drawing/2014/main" id="{F3F400CC-92DA-4181-A9F7-4CB6E072670C}"/>
+                <a16:creationId xmlns:a16="http://schemas.microsoft.com/office/drawing/2014/main" id="{67E64798-9E2A-4B92-A86C-32B722392873}"/>
               </a:ext>
             </a:extLst>
           </p:cNvPr>
@@ -15006,7 +15006,7 @@
           <p:cNvPr id="2" name="">
             <a:extLst xmlns:a="http://schemas.openxmlformats.org/drawingml/2006/main">
               <a:ext uri="{FF2B5EF4-FFF2-40B4-BE49-F238E27FC236}">
-                <a16:creationId xmlns:a16="http://schemas.microsoft.com/office/drawing/2014/main" id="{A430856D-22F4-479B-A673-6721B71B6285}"/>
+                <a16:creationId xmlns:a16="http://schemas.microsoft.com/office/drawing/2014/main" id="{A4E8E60C-4920-4F54-9620-D2510B63E58D}"/>
               </a:ext>
             </a:extLst>
           </p:cNvPr>
@@ -15032,10 +15032,10 @@
       </p:sp>
       <p:sp>
         <p:nvSpPr>
-          <p:cNvPr id="3" name="§2.1.3 · Opgave 7 · Linea en Curva · Boekpagina 26">
+          <p:cNvPr id="3" name="§2.1.3 · Opgave 7 · Linea en Curva · Boekpagina 27">
             <a:extLst xmlns:a="http://schemas.openxmlformats.org/drawingml/2006/main">
               <a:ext uri="{FF2B5EF4-FFF2-40B4-BE49-F238E27FC236}">
-                <a16:creationId xmlns:a16="http://schemas.microsoft.com/office/drawing/2014/main" id="{B658340C-9FE4-476B-96CA-22EE6984465D}"/>
+                <a16:creationId xmlns:a16="http://schemas.microsoft.com/office/drawing/2014/main" id="{506A6381-5F2A-4A88-B252-4A3CA820836B}"/>
               </a:ext>
             </a:extLst>
           </p:cNvPr>
@@ -15082,7 +15082,7 @@
                 <a:ea typeface="Arial"/>
                 <a:cs typeface="Arial"/>
               </a:rPr>
-              <a:t>§2.1.3 · Opgave 7 · Linea en Curva · Boekpagina 26</a:t>
+              <a:t>§2.1.3 · Opgave 7 · Linea en Curva · Boekpagina 27</a:t>
             </a:r>
           </a:p>
         </p:txBody>
@@ -15092,7 +15092,7 @@
           <p:cNvPr id="4" name="slide-number">
             <a:extLst xmlns:a="http://schemas.openxmlformats.org/drawingml/2006/main">
               <a:ext uri="{FF2B5EF4-FFF2-40B4-BE49-F238E27FC236}">
-                <a16:creationId xmlns:a16="http://schemas.microsoft.com/office/drawing/2014/main" id="{9BBD1E86-983B-4BE7-9343-92350FB87B6E}"/>
+                <a16:creationId xmlns:a16="http://schemas.microsoft.com/office/drawing/2014/main" id="{B4B467A3-823E-488B-A641-233FDC77BD9D}"/>
               </a:ext>
             </a:extLst>
           </p:cNvPr>
@@ -15149,7 +15149,7 @@
           <p:cNvPr id="5" name="Winst = TO − TK">
             <a:extLst xmlns:a="http://schemas.openxmlformats.org/drawingml/2006/main">
               <a:ext uri="{FF2B5EF4-FFF2-40B4-BE49-F238E27FC236}">
-                <a16:creationId xmlns:a16="http://schemas.microsoft.com/office/drawing/2014/main" id="{6A5880C4-80BF-4E2C-95D1-34E798D00FAB}"/>
+                <a16:creationId xmlns:a16="http://schemas.microsoft.com/office/drawing/2014/main" id="{D242604C-688E-4D04-95E6-C3B8E361B29E}"/>
               </a:ext>
             </a:extLst>
           </p:cNvPr>
@@ -15599,7 +15599,7 @@
           <p:cNvPr id="7" name="In elke getoonde rij: TO &lt; TK, dus verlies.">
             <a:extLst xmlns:a="http://schemas.openxmlformats.org/drawingml/2006/main">
               <a:ext uri="{FF2B5EF4-FFF2-40B4-BE49-F238E27FC236}">
-                <a16:creationId xmlns:a16="http://schemas.microsoft.com/office/drawing/2014/main" id="{0DC96574-0568-4EFA-B1C2-666EAE597221}"/>
+                <a16:creationId xmlns:a16="http://schemas.microsoft.com/office/drawing/2014/main" id="{EDB6C7C7-7E95-4351-8970-9E3C23F2BA83}"/>
               </a:ext>
             </a:extLst>
           </p:cNvPr>
@@ -15654,7 +15654,7 @@
     </p:spTree>
     <p:extLst>
       <p:ext uri="{BB962C8B-B14F-4D97-AF65-F5344CB8AC3E}">
-        <p14:creationId xmlns:p14="http://schemas.microsoft.com/office/powerpoint/2010/main" val="1554430333"/>
+        <p14:creationId xmlns:p14="http://schemas.microsoft.com/office/powerpoint/2010/main" val="2065558809"/>
       </p:ext>
     </p:extLst>
   </p:cSld>
@@ -15685,7 +15685,7 @@
           <p:cNvPr id="12" name="Opgave 7b · Linea, stap 0 → 10">
             <a:extLst xmlns:a="http://schemas.openxmlformats.org/drawingml/2006/main">
               <a:ext uri="{FF2B5EF4-FFF2-40B4-BE49-F238E27FC236}">
-                <a16:creationId xmlns:a16="http://schemas.microsoft.com/office/drawing/2014/main" id="{1FB4CCFC-E50C-42D3-99A9-A87197FB8B4C}"/>
+                <a16:creationId xmlns:a16="http://schemas.microsoft.com/office/drawing/2014/main" id="{583253D1-F65E-4CBE-819F-9AAB341CCBA2}"/>
               </a:ext>
             </a:extLst>
           </p:cNvPr>
@@ -15742,7 +15742,7 @@
           <p:cNvPr id="2" name="">
             <a:extLst xmlns:a="http://schemas.openxmlformats.org/drawingml/2006/main">
               <a:ext uri="{FF2B5EF4-FFF2-40B4-BE49-F238E27FC236}">
-                <a16:creationId xmlns:a16="http://schemas.microsoft.com/office/drawing/2014/main" id="{DA24E712-B457-4727-9B24-05A0D3AF58D0}"/>
+                <a16:creationId xmlns:a16="http://schemas.microsoft.com/office/drawing/2014/main" id="{0E95C3ED-8708-4C26-B0B1-C6E5625317AE}"/>
               </a:ext>
             </a:extLst>
           </p:cNvPr>
@@ -15768,10 +15768,10 @@
       </p:sp>
       <p:sp>
         <p:nvSpPr>
-          <p:cNvPr id="3" name="§2.1.3 · Opgave 7 · Linea en Curva · Boekpagina 26">
+          <p:cNvPr id="3" name="§2.1.3 · Opgave 7 · Linea en Curva · Boekpagina 27">
             <a:extLst xmlns:a="http://schemas.openxmlformats.org/drawingml/2006/main">
               <a:ext uri="{FF2B5EF4-FFF2-40B4-BE49-F238E27FC236}">
-                <a16:creationId xmlns:a16="http://schemas.microsoft.com/office/drawing/2014/main" id="{CFE383D8-6504-44E0-8296-63F30BF0C196}"/>
+                <a16:creationId xmlns:a16="http://schemas.microsoft.com/office/drawing/2014/main" id="{CEB84A99-0E61-4A8B-BA35-57E0B522BFA5}"/>
               </a:ext>
             </a:extLst>
           </p:cNvPr>
@@ -15818,7 +15818,7 @@
                 <a:ea typeface="Arial"/>
                 <a:cs typeface="Arial"/>
               </a:rPr>
-              <a:t>§2.1.3 · Opgave 7 · Linea en Curva · Boekpagina 26</a:t>
+              <a:t>§2.1.3 · Opgave 7 · Linea en Curva · Boekpagina 27</a:t>
             </a:r>
           </a:p>
         </p:txBody>
@@ -15828,7 +15828,7 @@
           <p:cNvPr id="4" name="slide-number">
             <a:extLst xmlns:a="http://schemas.openxmlformats.org/drawingml/2006/main">
               <a:ext uri="{FF2B5EF4-FFF2-40B4-BE49-F238E27FC236}">
-                <a16:creationId xmlns:a16="http://schemas.microsoft.com/office/drawing/2014/main" id="{CAF3BB4E-E7C6-4E30-A4D0-AB7ACBCAB4B5}"/>
+                <a16:creationId xmlns:a16="http://schemas.microsoft.com/office/drawing/2014/main" id="{85748BD4-A2D3-4187-AD48-D9D06536CB67}"/>
               </a:ext>
             </a:extLst>
           </p:cNvPr>
@@ -15885,7 +15885,7 @@
           <p:cNvPr id="5" name="ΔQ = 10 − 0 = 10 extra producten">
             <a:extLst xmlns:a="http://schemas.openxmlformats.org/drawingml/2006/main">
               <a:ext uri="{FF2B5EF4-FFF2-40B4-BE49-F238E27FC236}">
-                <a16:creationId xmlns:a16="http://schemas.microsoft.com/office/drawing/2014/main" id="{B1675C85-C9F4-4496-9194-E9F823F93526}"/>
+                <a16:creationId xmlns:a16="http://schemas.microsoft.com/office/drawing/2014/main" id="{285E113C-DD92-4B38-A616-C6361039C1D7}"/>
               </a:ext>
             </a:extLst>
           </p:cNvPr>
@@ -15942,7 +15942,7 @@
           <p:cNvPr id="6" name="MK = ΔTK / ΔQ">
             <a:extLst xmlns:a="http://schemas.openxmlformats.org/drawingml/2006/main">
               <a:ext uri="{FF2B5EF4-FFF2-40B4-BE49-F238E27FC236}">
-                <a16:creationId xmlns:a16="http://schemas.microsoft.com/office/drawing/2014/main" id="{388794F0-F769-4C78-B6B4-4F6E2B2577C3}"/>
+                <a16:creationId xmlns:a16="http://schemas.microsoft.com/office/drawing/2014/main" id="{8C52CD36-F0AD-4067-8D55-6239B4FAA5CB}"/>
               </a:ext>
             </a:extLst>
           </p:cNvPr>
@@ -15999,7 +15999,7 @@
           <p:cNvPr id="7" name="= (230 − 200) / (10 − 0) = 30 / 10">
             <a:extLst xmlns:a="http://schemas.openxmlformats.org/drawingml/2006/main">
               <a:ext uri="{FF2B5EF4-FFF2-40B4-BE49-F238E27FC236}">
-                <a16:creationId xmlns:a16="http://schemas.microsoft.com/office/drawing/2014/main" id="{A9B286CD-E8E5-4882-9C3A-100BC5E62D0B}"/>
+                <a16:creationId xmlns:a16="http://schemas.microsoft.com/office/drawing/2014/main" id="{88F283F5-4B3A-4F89-8356-E14B32151BE5}"/>
               </a:ext>
             </a:extLst>
           </p:cNvPr>
@@ -16056,7 +16056,7 @@
           <p:cNvPr id="8" name="= € 3 per extra product">
             <a:extLst xmlns:a="http://schemas.openxmlformats.org/drawingml/2006/main">
               <a:ext uri="{FF2B5EF4-FFF2-40B4-BE49-F238E27FC236}">
-                <a16:creationId xmlns:a16="http://schemas.microsoft.com/office/drawing/2014/main" id="{2AA983FD-6407-4412-B560-72A1BDC16976}"/>
+                <a16:creationId xmlns:a16="http://schemas.microsoft.com/office/drawing/2014/main" id="{3F485106-6E99-4D03-B056-57E126014274}"/>
               </a:ext>
             </a:extLst>
           </p:cNvPr>
@@ -16113,7 +16113,7 @@
           <p:cNvPr id="9" name="">
             <a:extLst xmlns:a="http://schemas.openxmlformats.org/drawingml/2006/main">
               <a:ext uri="{FF2B5EF4-FFF2-40B4-BE49-F238E27FC236}">
-                <a16:creationId xmlns:a16="http://schemas.microsoft.com/office/drawing/2014/main" id="{81D7083D-AAD6-4C49-BADB-F09F0B68BFC7}"/>
+                <a16:creationId xmlns:a16="http://schemas.microsoft.com/office/drawing/2014/main" id="{CC502A30-4A2F-4472-8DAB-E207826EFAD2}"/>
               </a:ext>
             </a:extLst>
           </p:cNvPr>
@@ -16142,7 +16142,7 @@
           <p:cNvPr id="10" name="MO = ΔTO / ΔQ">
             <a:extLst xmlns:a="http://schemas.openxmlformats.org/drawingml/2006/main">
               <a:ext uri="{FF2B5EF4-FFF2-40B4-BE49-F238E27FC236}">
-                <a16:creationId xmlns:a16="http://schemas.microsoft.com/office/drawing/2014/main" id="{3E85CAE2-B0E1-455B-A679-3718FB520831}"/>
+                <a16:creationId xmlns:a16="http://schemas.microsoft.com/office/drawing/2014/main" id="{FB5296EC-1C9B-4465-81BD-E27B37575A68}"/>
               </a:ext>
             </a:extLst>
           </p:cNvPr>
@@ -16199,7 +16199,7 @@
           <p:cNvPr id="11" name="= (80 − 0) / (10 − 0) = € 8 per extra product">
             <a:extLst xmlns:a="http://schemas.openxmlformats.org/drawingml/2006/main">
               <a:ext uri="{FF2B5EF4-FFF2-40B4-BE49-F238E27FC236}">
-                <a16:creationId xmlns:a16="http://schemas.microsoft.com/office/drawing/2014/main" id="{C64F365D-8D8D-4CD4-8712-F1633B77B2CB}"/>
+                <a16:creationId xmlns:a16="http://schemas.microsoft.com/office/drawing/2014/main" id="{4AE24AE7-0421-401F-9079-695E0714C4D1}"/>
               </a:ext>
             </a:extLst>
           </p:cNvPr>
@@ -16254,7 +16254,7 @@
     </p:spTree>
     <p:extLst>
       <p:ext uri="{BB962C8B-B14F-4D97-AF65-F5344CB8AC3E}">
-        <p14:creationId xmlns:p14="http://schemas.microsoft.com/office/powerpoint/2010/main" val="2070321507"/>
+        <p14:creationId xmlns:p14="http://schemas.microsoft.com/office/powerpoint/2010/main" val="1209666373"/>
       </p:ext>
     </p:extLst>
   </p:cSld>
@@ -16285,7 +16285,7 @@
           <p:cNvPr id="9" name="Opgave 7b–c · Linea volledig">
             <a:extLst xmlns:a="http://schemas.openxmlformats.org/drawingml/2006/main">
               <a:ext uri="{FF2B5EF4-FFF2-40B4-BE49-F238E27FC236}">
-                <a16:creationId xmlns:a16="http://schemas.microsoft.com/office/drawing/2014/main" id="{131CEB2E-0528-46C3-B512-8E7688147900}"/>
+                <a16:creationId xmlns:a16="http://schemas.microsoft.com/office/drawing/2014/main" id="{728BFF6B-8EA1-409A-B445-2C5A7E341CDD}"/>
               </a:ext>
             </a:extLst>
           </p:cNvPr>
@@ -16342,7 +16342,7 @@
           <p:cNvPr id="2" name="">
             <a:extLst xmlns:a="http://schemas.openxmlformats.org/drawingml/2006/main">
               <a:ext uri="{FF2B5EF4-FFF2-40B4-BE49-F238E27FC236}">
-                <a16:creationId xmlns:a16="http://schemas.microsoft.com/office/drawing/2014/main" id="{B9F86CE5-D58B-4C87-B997-F96271F7C3A1}"/>
+                <a16:creationId xmlns:a16="http://schemas.microsoft.com/office/drawing/2014/main" id="{387DA755-0C1B-4381-BFEE-46FFB793604D}"/>
               </a:ext>
             </a:extLst>
           </p:cNvPr>
@@ -16368,10 +16368,10 @@
       </p:sp>
       <p:sp>
         <p:nvSpPr>
-          <p:cNvPr id="3" name="§2.1.3 · Opgave 7 · Linea en Curva · Boekpagina 26">
+          <p:cNvPr id="3" name="§2.1.3 · Opgave 7 · Linea en Curva · Boekpagina 27">
             <a:extLst xmlns:a="http://schemas.openxmlformats.org/drawingml/2006/main">
               <a:ext uri="{FF2B5EF4-FFF2-40B4-BE49-F238E27FC236}">
-                <a16:creationId xmlns:a16="http://schemas.microsoft.com/office/drawing/2014/main" id="{33FFC839-48F6-4D00-91C8-91C3F166B034}"/>
+                <a16:creationId xmlns:a16="http://schemas.microsoft.com/office/drawing/2014/main" id="{AAD3F994-3865-407F-BADB-00F116EDAA31}"/>
               </a:ext>
             </a:extLst>
           </p:cNvPr>
@@ -16418,7 +16418,7 @@
                 <a:ea typeface="Arial"/>
                 <a:cs typeface="Arial"/>
               </a:rPr>
-              <a:t>§2.1.3 · Opgave 7 · Linea en Curva · Boekpagina 26</a:t>
+              <a:t>§2.1.3 · Opgave 7 · Linea en Curva · Boekpagina 27</a:t>
             </a:r>
           </a:p>
         </p:txBody>
@@ -16428,7 +16428,7 @@
           <p:cNvPr id="4" name="slide-number">
             <a:extLst xmlns:a="http://schemas.openxmlformats.org/drawingml/2006/main">
               <a:ext uri="{FF2B5EF4-FFF2-40B4-BE49-F238E27FC236}">
-                <a16:creationId xmlns:a16="http://schemas.microsoft.com/office/drawing/2014/main" id="{E72ECEF8-0F03-4C72-A184-3B2700DB03A8}"/>
+                <a16:creationId xmlns:a16="http://schemas.microsoft.com/office/drawing/2014/main" id="{6D34ECFC-6DBA-4291-B7CA-59091368AE1B}"/>
               </a:ext>
             </a:extLst>
           </p:cNvPr>
@@ -16485,7 +16485,7 @@
           <p:cNvPr id="5" name="Q: producten per week · TK, TO en winst: euro per week">
             <a:extLst xmlns:a="http://schemas.openxmlformats.org/drawingml/2006/main">
               <a:ext uri="{FF2B5EF4-FFF2-40B4-BE49-F238E27FC236}">
-                <a16:creationId xmlns:a16="http://schemas.microsoft.com/office/drawing/2014/main" id="{0B8C07D1-0329-461D-B09A-473406C6172B}"/>
+                <a16:creationId xmlns:a16="http://schemas.microsoft.com/office/drawing/2014/main" id="{4AE6EADB-402D-4BA1-A059-7F9BF1A62412}"/>
               </a:ext>
             </a:extLst>
           </p:cNvPr>
@@ -17324,7 +17324,7 @@
           <p:cNvPr id="7" name="Elke stap: MK = 30 / 10 = 3 en MO = 80 / 10 = 8">
             <a:extLst xmlns:a="http://schemas.openxmlformats.org/drawingml/2006/main">
               <a:ext uri="{FF2B5EF4-FFF2-40B4-BE49-F238E27FC236}">
-                <a16:creationId xmlns:a16="http://schemas.microsoft.com/office/drawing/2014/main" id="{0D18CBA2-49E6-4F79-9ABC-C4EE8AFE9BEF}"/>
+                <a16:creationId xmlns:a16="http://schemas.microsoft.com/office/drawing/2014/main" id="{F7B9BBCC-D340-4BA2-8841-807C31D7F2B3}"/>
               </a:ext>
             </a:extLst>
           </p:cNvPr>
@@ -17381,7 +17381,7 @@
           <p:cNvPr id="8" name="MO blijft € 8: ieder extra product wordt voor € 8 verkocht.">
             <a:extLst xmlns:a="http://schemas.openxmlformats.org/drawingml/2006/main">
               <a:ext uri="{FF2B5EF4-FFF2-40B4-BE49-F238E27FC236}">
-                <a16:creationId xmlns:a16="http://schemas.microsoft.com/office/drawing/2014/main" id="{F04EC868-1873-47E6-86C9-D3556E9776FA}"/>
+                <a16:creationId xmlns:a16="http://schemas.microsoft.com/office/drawing/2014/main" id="{662EA9AE-4FEA-4510-975D-BD051F312B4C}"/>
               </a:ext>
             </a:extLst>
           </p:cNvPr>
@@ -17436,7 +17436,7 @@
     </p:spTree>
     <p:extLst>
       <p:ext uri="{BB962C8B-B14F-4D97-AF65-F5344CB8AC3E}">
-        <p14:creationId xmlns:p14="http://schemas.microsoft.com/office/powerpoint/2010/main" val="2048027322"/>
+        <p14:creationId xmlns:p14="http://schemas.microsoft.com/office/powerpoint/2010/main" val="290455108"/>
       </p:ext>
     </p:extLst>
   </p:cSld>
@@ -17467,7 +17467,7 @@
           <p:cNvPr id="8" name="Opgave 7d · Drie MK-berekeningen bij Curva">
             <a:extLst xmlns:a="http://schemas.openxmlformats.org/drawingml/2006/main">
               <a:ext uri="{FF2B5EF4-FFF2-40B4-BE49-F238E27FC236}">
-                <a16:creationId xmlns:a16="http://schemas.microsoft.com/office/drawing/2014/main" id="{718A5711-3F5E-478C-A681-7D0898256A44}"/>
+                <a16:creationId xmlns:a16="http://schemas.microsoft.com/office/drawing/2014/main" id="{97B7498A-6F69-47AD-9598-7C6AE80426C8}"/>
               </a:ext>
             </a:extLst>
           </p:cNvPr>
@@ -17524,7 +17524,7 @@
           <p:cNvPr id="2" name="">
             <a:extLst xmlns:a="http://schemas.openxmlformats.org/drawingml/2006/main">
               <a:ext uri="{FF2B5EF4-FFF2-40B4-BE49-F238E27FC236}">
-                <a16:creationId xmlns:a16="http://schemas.microsoft.com/office/drawing/2014/main" id="{FD382662-5C99-434D-B5DE-163914A2D7D6}"/>
+                <a16:creationId xmlns:a16="http://schemas.microsoft.com/office/drawing/2014/main" id="{59B5FB04-8BB7-46A6-8CCB-A9B97EE26A97}"/>
               </a:ext>
             </a:extLst>
           </p:cNvPr>
@@ -17550,10 +17550,10 @@
       </p:sp>
       <p:sp>
         <p:nvSpPr>
-          <p:cNvPr id="3" name="§2.1.3 · Opgave 7 · Linea en Curva · Boekpagina 26">
+          <p:cNvPr id="3" name="§2.1.3 · Opgave 7 · Linea en Curva · Boekpagina 27">
             <a:extLst xmlns:a="http://schemas.openxmlformats.org/drawingml/2006/main">
               <a:ext uri="{FF2B5EF4-FFF2-40B4-BE49-F238E27FC236}">
-                <a16:creationId xmlns:a16="http://schemas.microsoft.com/office/drawing/2014/main" id="{B3161E36-4A7C-4155-8DC6-35F9A1820574}"/>
+                <a16:creationId xmlns:a16="http://schemas.microsoft.com/office/drawing/2014/main" id="{196E0561-D7AC-4899-9492-B9208C0941D8}"/>
               </a:ext>
             </a:extLst>
           </p:cNvPr>
@@ -17600,7 +17600,7 @@
                 <a:ea typeface="Arial"/>
                 <a:cs typeface="Arial"/>
               </a:rPr>
-              <a:t>§2.1.3 · Opgave 7 · Linea en Curva · Boekpagina 26</a:t>
+              <a:t>§2.1.3 · Opgave 7 · Linea en Curva · Boekpagina 27</a:t>
             </a:r>
           </a:p>
         </p:txBody>
@@ -17610,7 +17610,7 @@
           <p:cNvPr id="4" name="slide-number">
             <a:extLst xmlns:a="http://schemas.openxmlformats.org/drawingml/2006/main">
               <a:ext uri="{FF2B5EF4-FFF2-40B4-BE49-F238E27FC236}">
-                <a16:creationId xmlns:a16="http://schemas.microsoft.com/office/drawing/2014/main" id="{7FCE1215-7F2F-4E41-A91D-64459C071158}"/>
+                <a16:creationId xmlns:a16="http://schemas.microsoft.com/office/drawing/2014/main" id="{17A33F1E-60F7-45A2-8F22-D2475098FD5E}"/>
               </a:ext>
             </a:extLst>
           </p:cNvPr>
@@ -17667,7 +17667,7 @@
           <p:cNvPr id="5" name="MK = ΔTK / ΔQ · elke stap bevat 5 extra producten">
             <a:extLst xmlns:a="http://schemas.openxmlformats.org/drawingml/2006/main">
               <a:ext uri="{FF2B5EF4-FFF2-40B4-BE49-F238E27FC236}">
-                <a16:creationId xmlns:a16="http://schemas.microsoft.com/office/drawing/2014/main" id="{0D2134F0-DDB3-4713-BDDC-ECAF5192442F}"/>
+                <a16:creationId xmlns:a16="http://schemas.microsoft.com/office/drawing/2014/main" id="{0AD58141-369B-4F42-8B8D-0C8D7E8A5723}"/>
               </a:ext>
             </a:extLst>
           </p:cNvPr>
@@ -18043,7 +18043,7 @@
           <p:cNvPr id="7" name="Extra kosten per groep: € 25 → € 75 → € 125">
             <a:extLst xmlns:a="http://schemas.openxmlformats.org/drawingml/2006/main">
               <a:ext uri="{FF2B5EF4-FFF2-40B4-BE49-F238E27FC236}">
-                <a16:creationId xmlns:a16="http://schemas.microsoft.com/office/drawing/2014/main" id="{019734C3-46C8-49CB-A282-9EA1DD5B0F91}"/>
+                <a16:creationId xmlns:a16="http://schemas.microsoft.com/office/drawing/2014/main" id="{07F87D90-8AC9-4B5B-A685-94BF24F93674}"/>
               </a:ext>
             </a:extLst>
           </p:cNvPr>
@@ -18098,7 +18098,7 @@
     </p:spTree>
     <p:extLst>
       <p:ext uri="{BB962C8B-B14F-4D97-AF65-F5344CB8AC3E}">
-        <p14:creationId xmlns:p14="http://schemas.microsoft.com/office/powerpoint/2010/main" val="1397134243"/>
+        <p14:creationId xmlns:p14="http://schemas.microsoft.com/office/powerpoint/2010/main" val="1476123164"/>
       </p:ext>
     </p:extLst>
   </p:cSld>
@@ -18129,7 +18129,7 @@
           <p:cNvPr id="10" name="Opgave 7d · MO bij Curva">
             <a:extLst xmlns:a="http://schemas.openxmlformats.org/drawingml/2006/main">
               <a:ext uri="{FF2B5EF4-FFF2-40B4-BE49-F238E27FC236}">
-                <a16:creationId xmlns:a16="http://schemas.microsoft.com/office/drawing/2014/main" id="{445059E4-2EB2-4DD1-AADA-93D81725D398}"/>
+                <a16:creationId xmlns:a16="http://schemas.microsoft.com/office/drawing/2014/main" id="{A1D01019-664D-4C64-889D-075F642E53BB}"/>
               </a:ext>
             </a:extLst>
           </p:cNvPr>
@@ -18186,7 +18186,7 @@
           <p:cNvPr id="2" name="">
             <a:extLst xmlns:a="http://schemas.openxmlformats.org/drawingml/2006/main">
               <a:ext uri="{FF2B5EF4-FFF2-40B4-BE49-F238E27FC236}">
-                <a16:creationId xmlns:a16="http://schemas.microsoft.com/office/drawing/2014/main" id="{AAEED014-EE3E-4AE9-8697-0CCB8512A4CB}"/>
+                <a16:creationId xmlns:a16="http://schemas.microsoft.com/office/drawing/2014/main" id="{0D6B99A3-F031-4EC9-95A5-76B7A3A33337}"/>
               </a:ext>
             </a:extLst>
           </p:cNvPr>
@@ -18212,10 +18212,10 @@
       </p:sp>
       <p:sp>
         <p:nvSpPr>
-          <p:cNvPr id="3" name="§2.1.3 · Opgave 7 · Linea en Curva · Boekpagina 26">
+          <p:cNvPr id="3" name="§2.1.3 · Opgave 7 · Linea en Curva · Boekpagina 27">
             <a:extLst xmlns:a="http://schemas.openxmlformats.org/drawingml/2006/main">
               <a:ext uri="{FF2B5EF4-FFF2-40B4-BE49-F238E27FC236}">
-                <a16:creationId xmlns:a16="http://schemas.microsoft.com/office/drawing/2014/main" id="{FB8971AE-8C26-4148-BFCF-DAF3979F38B0}"/>
+                <a16:creationId xmlns:a16="http://schemas.microsoft.com/office/drawing/2014/main" id="{2DAF8141-698A-41BB-9710-22961BDCC6B9}"/>
               </a:ext>
             </a:extLst>
           </p:cNvPr>
@@ -18262,7 +18262,7 @@
                 <a:ea typeface="Arial"/>
                 <a:cs typeface="Arial"/>
               </a:rPr>
-              <a:t>§2.1.3 · Opgave 7 · Linea en Curva · Boekpagina 26</a:t>
+              <a:t>§2.1.3 · Opgave 7 · Linea en Curva · Boekpagina 27</a:t>
             </a:r>
           </a:p>
         </p:txBody>
@@ -18272,7 +18272,7 @@
           <p:cNvPr id="4" name="slide-number">
             <a:extLst xmlns:a="http://schemas.openxmlformats.org/drawingml/2006/main">
               <a:ext uri="{FF2B5EF4-FFF2-40B4-BE49-F238E27FC236}">
-                <a16:creationId xmlns:a16="http://schemas.microsoft.com/office/drawing/2014/main" id="{E844E834-8335-4697-9A97-D2FEA365CEA4}"/>
+                <a16:creationId xmlns:a16="http://schemas.microsoft.com/office/drawing/2014/main" id="{496954DF-331D-4370-B9E8-DF19330D6B04}"/>
               </a:ext>
             </a:extLst>
           </p:cNvPr>
@@ -18329,7 +18329,7 @@
           <p:cNvPr id="5" name="Eerste stap: 0 → 5 producten per week">
             <a:extLst xmlns:a="http://schemas.openxmlformats.org/drawingml/2006/main">
               <a:ext uri="{FF2B5EF4-FFF2-40B4-BE49-F238E27FC236}">
-                <a16:creationId xmlns:a16="http://schemas.microsoft.com/office/drawing/2014/main" id="{8E25C3B6-1907-45DB-91A5-79D8BDF0FDFC}"/>
+                <a16:creationId xmlns:a16="http://schemas.microsoft.com/office/drawing/2014/main" id="{516F2DEA-C17D-4D1B-8A40-C7D0E69AA017}"/>
               </a:ext>
             </a:extLst>
           </p:cNvPr>
@@ -18386,7 +18386,7 @@
           <p:cNvPr id="6" name="MO = ΔTO / ΔQ">
             <a:extLst xmlns:a="http://schemas.openxmlformats.org/drawingml/2006/main">
               <a:ext uri="{FF2B5EF4-FFF2-40B4-BE49-F238E27FC236}">
-                <a16:creationId xmlns:a16="http://schemas.microsoft.com/office/drawing/2014/main" id="{962BCD69-237B-43BA-A7EB-731179378396}"/>
+                <a16:creationId xmlns:a16="http://schemas.microsoft.com/office/drawing/2014/main" id="{7B2A3702-4077-4B56-BEF2-4DF8656F85D9}"/>
               </a:ext>
             </a:extLst>
           </p:cNvPr>
@@ -18443,7 +18443,7 @@
           <p:cNvPr id="7" name="= (150 − 0) / (5 − 0) = 150 / 5">
             <a:extLst xmlns:a="http://schemas.openxmlformats.org/drawingml/2006/main">
               <a:ext uri="{FF2B5EF4-FFF2-40B4-BE49-F238E27FC236}">
-                <a16:creationId xmlns:a16="http://schemas.microsoft.com/office/drawing/2014/main" id="{D334CF08-4F04-428B-92AF-3F7A28286626}"/>
+                <a16:creationId xmlns:a16="http://schemas.microsoft.com/office/drawing/2014/main" id="{508DA86E-B4BD-4473-8A78-6C599658A82A}"/>
               </a:ext>
             </a:extLst>
           </p:cNvPr>
@@ -18500,7 +18500,7 @@
           <p:cNvPr id="8" name="= € 30 per extra product">
             <a:extLst xmlns:a="http://schemas.openxmlformats.org/drawingml/2006/main">
               <a:ext uri="{FF2B5EF4-FFF2-40B4-BE49-F238E27FC236}">
-                <a16:creationId xmlns:a16="http://schemas.microsoft.com/office/drawing/2014/main" id="{7894F875-A1E6-4076-87D6-E02C1E2F10D6}"/>
+                <a16:creationId xmlns:a16="http://schemas.microsoft.com/office/drawing/2014/main" id="{E1030BBA-DA55-4474-BBBD-9B12AB40C0BC}"/>
               </a:ext>
             </a:extLst>
           </p:cNvPr>
@@ -18557,7 +18557,7 @@
           <p:cNvPr id="9" name="Ook in de volgende stappen: € 150 extra voor 5 extra producten.">
             <a:extLst xmlns:a="http://schemas.openxmlformats.org/drawingml/2006/main">
               <a:ext uri="{FF2B5EF4-FFF2-40B4-BE49-F238E27FC236}">
-                <a16:creationId xmlns:a16="http://schemas.microsoft.com/office/drawing/2014/main" id="{674B1D9F-B2E1-407A-941B-A7A3CFA4FC93}"/>
+                <a16:creationId xmlns:a16="http://schemas.microsoft.com/office/drawing/2014/main" id="{710DEDF9-9B90-4605-A4C2-DC69E76EADBF}"/>
               </a:ext>
             </a:extLst>
           </p:cNvPr>
@@ -18612,7 +18612,7 @@
     </p:spTree>
     <p:extLst>
       <p:ext uri="{BB962C8B-B14F-4D97-AF65-F5344CB8AC3E}">
-        <p14:creationId xmlns:p14="http://schemas.microsoft.com/office/powerpoint/2010/main" val="781397519"/>
+        <p14:creationId xmlns:p14="http://schemas.microsoft.com/office/powerpoint/2010/main" val="909695968"/>
       </p:ext>
     </p:extLst>
   </p:cSld>
@@ -18643,7 +18643,7 @@
           <p:cNvPr id="9" name="Opgave 7d · Curva volledig">
             <a:extLst xmlns:a="http://schemas.openxmlformats.org/drawingml/2006/main">
               <a:ext uri="{FF2B5EF4-FFF2-40B4-BE49-F238E27FC236}">
-                <a16:creationId xmlns:a16="http://schemas.microsoft.com/office/drawing/2014/main" id="{12F282BB-626A-4EB9-A8C1-EB1373AF4450}"/>
+                <a16:creationId xmlns:a16="http://schemas.microsoft.com/office/drawing/2014/main" id="{B034AA39-7F74-4F32-A816-696E9026934A}"/>
               </a:ext>
             </a:extLst>
           </p:cNvPr>
@@ -18700,7 +18700,7 @@
           <p:cNvPr id="2" name="">
             <a:extLst xmlns:a="http://schemas.openxmlformats.org/drawingml/2006/main">
               <a:ext uri="{FF2B5EF4-FFF2-40B4-BE49-F238E27FC236}">
-                <a16:creationId xmlns:a16="http://schemas.microsoft.com/office/drawing/2014/main" id="{83FEA671-8DB8-4508-8FE8-F7CCFB744850}"/>
+                <a16:creationId xmlns:a16="http://schemas.microsoft.com/office/drawing/2014/main" id="{32A18503-68CD-44E8-ABDD-06687B53C69D}"/>
               </a:ext>
             </a:extLst>
           </p:cNvPr>
@@ -18726,10 +18726,10 @@
       </p:sp>
       <p:sp>
         <p:nvSpPr>
-          <p:cNvPr id="3" name="§2.1.3 · Opgave 7 · Linea en Curva · Boekpagina 26">
+          <p:cNvPr id="3" name="§2.1.3 · Opgave 7 · Linea en Curva · Boekpagina 27">
             <a:extLst xmlns:a="http://schemas.openxmlformats.org/drawingml/2006/main">
               <a:ext uri="{FF2B5EF4-FFF2-40B4-BE49-F238E27FC236}">
-                <a16:creationId xmlns:a16="http://schemas.microsoft.com/office/drawing/2014/main" id="{BAD2D99B-557A-49F8-AC34-D3D7E1174DFE}"/>
+                <a16:creationId xmlns:a16="http://schemas.microsoft.com/office/drawing/2014/main" id="{D15C89F2-85C7-471C-870B-126954713279}"/>
               </a:ext>
             </a:extLst>
           </p:cNvPr>
@@ -18776,7 +18776,7 @@
                 <a:ea typeface="Arial"/>
                 <a:cs typeface="Arial"/>
               </a:rPr>
-              <a:t>§2.1.3 · Opgave 7 · Linea en Curva · Boekpagina 26</a:t>
+              <a:t>§2.1.3 · Opgave 7 · Linea en Curva · Boekpagina 27</a:t>
             </a:r>
           </a:p>
         </p:txBody>
@@ -18786,7 +18786,7 @@
           <p:cNvPr id="4" name="slide-number">
             <a:extLst xmlns:a="http://schemas.openxmlformats.org/drawingml/2006/main">
               <a:ext uri="{FF2B5EF4-FFF2-40B4-BE49-F238E27FC236}">
-                <a16:creationId xmlns:a16="http://schemas.microsoft.com/office/drawing/2014/main" id="{5BB49289-AD47-4E8B-A8EC-A2F390FB004E}"/>
+                <a16:creationId xmlns:a16="http://schemas.microsoft.com/office/drawing/2014/main" id="{DC94192A-8506-43A1-9F42-BEC0C799E553}"/>
               </a:ext>
             </a:extLst>
           </p:cNvPr>
@@ -18843,7 +18843,7 @@
           <p:cNvPr id="5" name="Q: producten per week · TK, TO en winst: euro per week">
             <a:extLst xmlns:a="http://schemas.openxmlformats.org/drawingml/2006/main">
               <a:ext uri="{FF2B5EF4-FFF2-40B4-BE49-F238E27FC236}">
-                <a16:creationId xmlns:a16="http://schemas.microsoft.com/office/drawing/2014/main" id="{FC28CCC2-0442-4B2F-B5CE-F2A64566E44A}"/>
+                <a16:creationId xmlns:a16="http://schemas.microsoft.com/office/drawing/2014/main" id="{20B466C5-73A2-4C54-B992-D341F9385996}"/>
               </a:ext>
             </a:extLst>
           </p:cNvPr>
@@ -19682,7 +19682,7 @@
           <p:cNvPr id="7" name="Bij Q = 15 staat de uitkomst van de stap 10 → 15.">
             <a:extLst xmlns:a="http://schemas.openxmlformats.org/drawingml/2006/main">
               <a:ext uri="{FF2B5EF4-FFF2-40B4-BE49-F238E27FC236}">
-                <a16:creationId xmlns:a16="http://schemas.microsoft.com/office/drawing/2014/main" id="{66977B9F-79C0-44F1-89B3-EE977525E0E6}"/>
+                <a16:creationId xmlns:a16="http://schemas.microsoft.com/office/drawing/2014/main" id="{D7538208-B474-4718-A79B-06A4FDAB11F7}"/>
               </a:ext>
             </a:extLst>
           </p:cNvPr>
@@ -19739,7 +19739,7 @@
           <p:cNvPr id="8" name="Controle: 5 × € 25 = € 125 extra kosten in die stap.">
             <a:extLst xmlns:a="http://schemas.openxmlformats.org/drawingml/2006/main">
               <a:ext uri="{FF2B5EF4-FFF2-40B4-BE49-F238E27FC236}">
-                <a16:creationId xmlns:a16="http://schemas.microsoft.com/office/drawing/2014/main" id="{63142DD2-F580-48BF-ABD6-3F2617C9E5A6}"/>
+                <a16:creationId xmlns:a16="http://schemas.microsoft.com/office/drawing/2014/main" id="{C5D8AD16-1362-4970-97D6-3CD9A19C7E21}"/>
               </a:ext>
             </a:extLst>
           </p:cNvPr>
@@ -19794,7 +19794,7 @@
     </p:spTree>
     <p:extLst>
       <p:ext uri="{BB962C8B-B14F-4D97-AF65-F5344CB8AC3E}">
-        <p14:creationId xmlns:p14="http://schemas.microsoft.com/office/powerpoint/2010/main" val="1365677912"/>
+        <p14:creationId xmlns:p14="http://schemas.microsoft.com/office/powerpoint/2010/main" val="2138689852"/>
       </p:ext>
     </p:extLst>
   </p:cSld>
@@ -19825,7 +19825,7 @@
           <p:cNvPr id="9" name="Opgave 7e · Patronen en betekenis">
             <a:extLst xmlns:a="http://schemas.openxmlformats.org/drawingml/2006/main">
               <a:ext uri="{FF2B5EF4-FFF2-40B4-BE49-F238E27FC236}">
-                <a16:creationId xmlns:a16="http://schemas.microsoft.com/office/drawing/2014/main" id="{2D62BC89-27CA-4A94-8E21-A6B45AA2A8E8}"/>
+                <a16:creationId xmlns:a16="http://schemas.microsoft.com/office/drawing/2014/main" id="{B9012979-BF4A-45CA-B7D9-1A6C34F22944}"/>
               </a:ext>
             </a:extLst>
           </p:cNvPr>
@@ -19882,7 +19882,7 @@
           <p:cNvPr id="2" name="">
             <a:extLst xmlns:a="http://schemas.openxmlformats.org/drawingml/2006/main">
               <a:ext uri="{FF2B5EF4-FFF2-40B4-BE49-F238E27FC236}">
-                <a16:creationId xmlns:a16="http://schemas.microsoft.com/office/drawing/2014/main" id="{028FADD2-9A79-4B78-AB1C-80E3C24DBDBB}"/>
+                <a16:creationId xmlns:a16="http://schemas.microsoft.com/office/drawing/2014/main" id="{2619117C-C644-487D-A0A6-F11450917F28}"/>
               </a:ext>
             </a:extLst>
           </p:cNvPr>
@@ -19908,10 +19908,10 @@
       </p:sp>
       <p:sp>
         <p:nvSpPr>
-          <p:cNvPr id="3" name="§2.1.3 · Opgave 7 · Linea en Curva · Boekpagina 26">
+          <p:cNvPr id="3" name="§2.1.3 · Opgave 7 · Linea en Curva · Boekpagina 27">
             <a:extLst xmlns:a="http://schemas.openxmlformats.org/drawingml/2006/main">
               <a:ext uri="{FF2B5EF4-FFF2-40B4-BE49-F238E27FC236}">
-                <a16:creationId xmlns:a16="http://schemas.microsoft.com/office/drawing/2014/main" id="{93DDBD74-DBA2-4BFE-876C-84190CDDC8B4}"/>
+                <a16:creationId xmlns:a16="http://schemas.microsoft.com/office/drawing/2014/main" id="{E6B97FD0-0EDF-4AF3-81F6-A4F3461486D4}"/>
               </a:ext>
             </a:extLst>
           </p:cNvPr>
@@ -19958,7 +19958,7 @@
                 <a:ea typeface="Arial"/>
                 <a:cs typeface="Arial"/>
               </a:rPr>
-              <a:t>§2.1.3 · Opgave 7 · Linea en Curva · Boekpagina 26</a:t>
+              <a:t>§2.1.3 · Opgave 7 · Linea en Curva · Boekpagina 27</a:t>
             </a:r>
           </a:p>
         </p:txBody>
@@ -19968,7 +19968,7 @@
           <p:cNvPr id="4" name="slide-number">
             <a:extLst xmlns:a="http://schemas.openxmlformats.org/drawingml/2006/main">
               <a:ext uri="{FF2B5EF4-FFF2-40B4-BE49-F238E27FC236}">
-                <a16:creationId xmlns:a16="http://schemas.microsoft.com/office/drawing/2014/main" id="{CEEE607C-47AB-4B70-A62C-80BE9BBDE297}"/>
+                <a16:creationId xmlns:a16="http://schemas.microsoft.com/office/drawing/2014/main" id="{61C45E29-1C78-456C-8898-429F6BE89E22}"/>
               </a:ext>
             </a:extLst>
           </p:cNvPr>
@@ -20270,7 +20270,7 @@
           <p:cNvPr id="6" name="MK: extra totale kosten / extra producten">
             <a:extLst xmlns:a="http://schemas.openxmlformats.org/drawingml/2006/main">
               <a:ext uri="{FF2B5EF4-FFF2-40B4-BE49-F238E27FC236}">
-                <a16:creationId xmlns:a16="http://schemas.microsoft.com/office/drawing/2014/main" id="{989C0663-BA75-4E67-994D-B5E8B94ADD01}"/>
+                <a16:creationId xmlns:a16="http://schemas.microsoft.com/office/drawing/2014/main" id="{AE0D42F0-87D7-4509-9B40-0BB5BB70F8F9}"/>
               </a:ext>
             </a:extLst>
           </p:cNvPr>
@@ -20327,7 +20327,7 @@
           <p:cNvPr id="7" name="MO: extra totale opbrengst / extra verkochte producten">
             <a:extLst xmlns:a="http://schemas.openxmlformats.org/drawingml/2006/main">
               <a:ext uri="{FF2B5EF4-FFF2-40B4-BE49-F238E27FC236}">
-                <a16:creationId xmlns:a16="http://schemas.microsoft.com/office/drawing/2014/main" id="{C693EDED-E565-44B9-9E3F-732F56C566D1}"/>
+                <a16:creationId xmlns:a16="http://schemas.microsoft.com/office/drawing/2014/main" id="{9CCC4DA0-D886-4838-BABC-9AB56F09BCAB}"/>
               </a:ext>
             </a:extLst>
           </p:cNvPr>
@@ -20384,7 +20384,7 @@
           <p:cNvPr id="8" name="Beide uitkomsten beschrijven de hele genoemde tabelstap.">
             <a:extLst xmlns:a="http://schemas.openxmlformats.org/drawingml/2006/main">
               <a:ext uri="{FF2B5EF4-FFF2-40B4-BE49-F238E27FC236}">
-                <a16:creationId xmlns:a16="http://schemas.microsoft.com/office/drawing/2014/main" id="{8382A37C-2B8C-4CFE-902A-67D30F11B85E}"/>
+                <a16:creationId xmlns:a16="http://schemas.microsoft.com/office/drawing/2014/main" id="{D7EF4BBA-DA21-4E6F-8F92-4E64D2CE1E4E}"/>
               </a:ext>
             </a:extLst>
           </p:cNvPr>
@@ -20439,7 +20439,7 @@
     </p:spTree>
     <p:extLst>
       <p:ext uri="{BB962C8B-B14F-4D97-AF65-F5344CB8AC3E}">
-        <p14:creationId xmlns:p14="http://schemas.microsoft.com/office/powerpoint/2010/main" val="112250354"/>
+        <p14:creationId xmlns:p14="http://schemas.microsoft.com/office/powerpoint/2010/main" val="1654943831"/>
       </p:ext>
     </p:extLst>
   </p:cSld>
@@ -20470,7 +20470,7 @@
           <p:cNvPr id="29" name="Deze les: §2.1.3 Marginale kosten en marginale opbrengsten">
             <a:extLst xmlns:a="http://schemas.openxmlformats.org/drawingml/2006/main">
               <a:ext uri="{FF2B5EF4-FFF2-40B4-BE49-F238E27FC236}">
-                <a16:creationId xmlns:a16="http://schemas.microsoft.com/office/drawing/2014/main" id="{0C5BCF3C-1376-4FAB-B59C-D6E3D134E349}"/>
+                <a16:creationId xmlns:a16="http://schemas.microsoft.com/office/drawing/2014/main" id="{E073A284-EC7F-4ECE-A960-DBFD4370291C}"/>
               </a:ext>
             </a:extLst>
           </p:cNvPr>
@@ -20527,7 +20527,7 @@
           <p:cNvPr id="2" name="">
             <a:extLst xmlns:a="http://schemas.openxmlformats.org/drawingml/2006/main">
               <a:ext uri="{FF2B5EF4-FFF2-40B4-BE49-F238E27FC236}">
-                <a16:creationId xmlns:a16="http://schemas.microsoft.com/office/drawing/2014/main" id="{89DD467D-3627-4B82-BB5C-08879D57B226}"/>
+                <a16:creationId xmlns:a16="http://schemas.microsoft.com/office/drawing/2014/main" id="{1A96F562-9B15-4205-8C88-C1E81C8778E5}"/>
               </a:ext>
             </a:extLst>
           </p:cNvPr>
@@ -20556,7 +20556,7 @@
           <p:cNvPr id="3" name="§2.1.3 Marginale kosten en marginale opbrengsten">
             <a:extLst xmlns:a="http://schemas.openxmlformats.org/drawingml/2006/main">
               <a:ext uri="{FF2B5EF4-FFF2-40B4-BE49-F238E27FC236}">
-                <a16:creationId xmlns:a16="http://schemas.microsoft.com/office/drawing/2014/main" id="{91E14084-046D-4200-9A03-B00033E3D1F6}"/>
+                <a16:creationId xmlns:a16="http://schemas.microsoft.com/office/drawing/2014/main" id="{199241CD-0EA9-406F-9FFE-996779C3CBDF}"/>
               </a:ext>
             </a:extLst>
           </p:cNvPr>
@@ -20613,7 +20613,7 @@
           <p:cNvPr id="4" name="slide-number">
             <a:extLst xmlns:a="http://schemas.openxmlformats.org/drawingml/2006/main">
               <a:ext uri="{FF2B5EF4-FFF2-40B4-BE49-F238E27FC236}">
-                <a16:creationId xmlns:a16="http://schemas.microsoft.com/office/drawing/2014/main" id="{5B4E4921-4148-4625-AC42-A1D743C95DDB}"/>
+                <a16:creationId xmlns:a16="http://schemas.microsoft.com/office/drawing/2014/main" id="{13D0FC39-FDC7-4CA6-9A44-2899A45BB687}"/>
               </a:ext>
             </a:extLst>
           </p:cNvPr>
@@ -20670,7 +20670,7 @@
           <p:cNvPr id="5" name="phase">
             <a:extLst xmlns:a="http://schemas.openxmlformats.org/drawingml/2006/main">
               <a:ext uri="{FF2B5EF4-FFF2-40B4-BE49-F238E27FC236}">
-                <a16:creationId xmlns:a16="http://schemas.microsoft.com/office/drawing/2014/main" id="{2260C801-7320-4DFE-966F-76E7AF2C620B}"/>
+                <a16:creationId xmlns:a16="http://schemas.microsoft.com/office/drawing/2014/main" id="{918CAAB0-57F1-4971-88B7-AE3E831F3459}"/>
               </a:ext>
             </a:extLst>
           </p:cNvPr>
@@ -20727,7 +20727,7 @@
           <p:cNvPr id="6" name="Lesroute">
             <a:extLst xmlns:a="http://schemas.openxmlformats.org/drawingml/2006/main">
               <a:ext uri="{FF2B5EF4-FFF2-40B4-BE49-F238E27FC236}">
-                <a16:creationId xmlns:a16="http://schemas.microsoft.com/office/drawing/2014/main" id="{94B3177A-0B3C-40C6-AD43-05007135139B}"/>
+                <a16:creationId xmlns:a16="http://schemas.microsoft.com/office/drawing/2014/main" id="{85F926D1-808C-444C-AEF1-0F29D4E4EE7F}"/>
               </a:ext>
             </a:extLst>
           </p:cNvPr>
@@ -20784,7 +20784,7 @@
           <p:cNvPr id="7" name="route-number-1">
             <a:extLst xmlns:a="http://schemas.openxmlformats.org/drawingml/2006/main">
               <a:ext uri="{FF2B5EF4-FFF2-40B4-BE49-F238E27FC236}">
-                <a16:creationId xmlns:a16="http://schemas.microsoft.com/office/drawing/2014/main" id="{B061E072-9D3E-40A3-AAF9-01BE354384F7}"/>
+                <a16:creationId xmlns:a16="http://schemas.microsoft.com/office/drawing/2014/main" id="{1DA544A3-5056-4993-83CE-5A73579F8B30}"/>
               </a:ext>
             </a:extLst>
           </p:cNvPr>
@@ -20841,7 +20841,7 @@
           <p:cNvPr id="8" name="route-1">
             <a:extLst xmlns:a="http://schemas.openxmlformats.org/drawingml/2006/main">
               <a:ext uri="{FF2B5EF4-FFF2-40B4-BE49-F238E27FC236}">
-                <a16:creationId xmlns:a16="http://schemas.microsoft.com/office/drawing/2014/main" id="{3518B66C-DA56-4D71-9AB4-BDBA543F5E18}"/>
+                <a16:creationId xmlns:a16="http://schemas.microsoft.com/office/drawing/2014/main" id="{D65BF8A2-59A2-452B-A89D-3E890F27622C}"/>
               </a:ext>
             </a:extLst>
           </p:cNvPr>
@@ -20898,7 +20898,7 @@
           <p:cNvPr id="9" name="route-number-2">
             <a:extLst xmlns:a="http://schemas.openxmlformats.org/drawingml/2006/main">
               <a:ext uri="{FF2B5EF4-FFF2-40B4-BE49-F238E27FC236}">
-                <a16:creationId xmlns:a16="http://schemas.microsoft.com/office/drawing/2014/main" id="{9BC75BC8-B086-4C4A-AA04-08C38AC8AC0B}"/>
+                <a16:creationId xmlns:a16="http://schemas.microsoft.com/office/drawing/2014/main" id="{4686E10C-F9EB-4845-8DB6-AB3EF0ACA365}"/>
               </a:ext>
             </a:extLst>
           </p:cNvPr>
@@ -20955,7 +20955,7 @@
           <p:cNvPr id="10" name="route-2">
             <a:extLst xmlns:a="http://schemas.openxmlformats.org/drawingml/2006/main">
               <a:ext uri="{FF2B5EF4-FFF2-40B4-BE49-F238E27FC236}">
-                <a16:creationId xmlns:a16="http://schemas.microsoft.com/office/drawing/2014/main" id="{25A26268-E054-4C50-95F8-69AC079A50BC}"/>
+                <a16:creationId xmlns:a16="http://schemas.microsoft.com/office/drawing/2014/main" id="{54466F51-94B5-4BA1-80FD-491799FE4CD7}"/>
               </a:ext>
             </a:extLst>
           </p:cNvPr>
@@ -21012,7 +21012,7 @@
           <p:cNvPr id="11" name="route-number-3">
             <a:extLst xmlns:a="http://schemas.openxmlformats.org/drawingml/2006/main">
               <a:ext uri="{FF2B5EF4-FFF2-40B4-BE49-F238E27FC236}">
-                <a16:creationId xmlns:a16="http://schemas.microsoft.com/office/drawing/2014/main" id="{13CC00B1-B2F6-4A26-9CCB-4D70F729DFFC}"/>
+                <a16:creationId xmlns:a16="http://schemas.microsoft.com/office/drawing/2014/main" id="{54F1AC3D-410E-4593-A24B-943DA83387B1}"/>
               </a:ext>
             </a:extLst>
           </p:cNvPr>
@@ -21069,7 +21069,7 @@
           <p:cNvPr id="12" name="route-3">
             <a:extLst xmlns:a="http://schemas.openxmlformats.org/drawingml/2006/main">
               <a:ext uri="{FF2B5EF4-FFF2-40B4-BE49-F238E27FC236}">
-                <a16:creationId xmlns:a16="http://schemas.microsoft.com/office/drawing/2014/main" id="{F129F067-CFC3-4540-918E-7B60B513951A}"/>
+                <a16:creationId xmlns:a16="http://schemas.microsoft.com/office/drawing/2014/main" id="{A492B537-1D11-45AC-A963-C0DFFC5CC00D}"/>
               </a:ext>
             </a:extLst>
           </p:cNvPr>
@@ -21126,7 +21126,7 @@
           <p:cNvPr id="13" name="route-number-4">
             <a:extLst xmlns:a="http://schemas.openxmlformats.org/drawingml/2006/main">
               <a:ext uri="{FF2B5EF4-FFF2-40B4-BE49-F238E27FC236}">
-                <a16:creationId xmlns:a16="http://schemas.microsoft.com/office/drawing/2014/main" id="{F3A804A4-F92A-4C2A-A2B6-CD57961766BD}"/>
+                <a16:creationId xmlns:a16="http://schemas.microsoft.com/office/drawing/2014/main" id="{BC495334-D02A-4FBE-8991-99B838D3EE87}"/>
               </a:ext>
             </a:extLst>
           </p:cNvPr>
@@ -21183,7 +21183,7 @@
           <p:cNvPr id="14" name="route-4">
             <a:extLst xmlns:a="http://schemas.openxmlformats.org/drawingml/2006/main">
               <a:ext uri="{FF2B5EF4-FFF2-40B4-BE49-F238E27FC236}">
-                <a16:creationId xmlns:a16="http://schemas.microsoft.com/office/drawing/2014/main" id="{A389006E-F224-47E8-B467-2EF78B69A51C}"/>
+                <a16:creationId xmlns:a16="http://schemas.microsoft.com/office/drawing/2014/main" id="{A4E40B2D-1C0E-462D-839B-CA9F1910F44C}"/>
               </a:ext>
             </a:extLst>
           </p:cNvPr>
@@ -21240,7 +21240,7 @@
           <p:cNvPr id="15" name="route-number-5">
             <a:extLst xmlns:a="http://schemas.openxmlformats.org/drawingml/2006/main">
               <a:ext uri="{FF2B5EF4-FFF2-40B4-BE49-F238E27FC236}">
-                <a16:creationId xmlns:a16="http://schemas.microsoft.com/office/drawing/2014/main" id="{8B273A04-6EDD-45D8-9EB0-C0E96C6E0E13}"/>
+                <a16:creationId xmlns:a16="http://schemas.microsoft.com/office/drawing/2014/main" id="{E6A14AFF-258C-4692-93AA-1222B36671E5}"/>
               </a:ext>
             </a:extLst>
           </p:cNvPr>
@@ -21297,7 +21297,7 @@
           <p:cNvPr id="16" name="route-5">
             <a:extLst xmlns:a="http://schemas.openxmlformats.org/drawingml/2006/main">
               <a:ext uri="{FF2B5EF4-FFF2-40B4-BE49-F238E27FC236}">
-                <a16:creationId xmlns:a16="http://schemas.microsoft.com/office/drawing/2014/main" id="{B79C89A7-BE0D-4611-9A36-A1A4240BC8AD}"/>
+                <a16:creationId xmlns:a16="http://schemas.microsoft.com/office/drawing/2014/main" id="{38BF5B1B-AF0F-40B5-B26F-3EA26B63542C}"/>
               </a:ext>
             </a:extLst>
           </p:cNvPr>
@@ -21354,7 +21354,7 @@
           <p:cNvPr id="17" name="route-number-6">
             <a:extLst xmlns:a="http://schemas.openxmlformats.org/drawingml/2006/main">
               <a:ext uri="{FF2B5EF4-FFF2-40B4-BE49-F238E27FC236}">
-                <a16:creationId xmlns:a16="http://schemas.microsoft.com/office/drawing/2014/main" id="{C3ADF5C1-BCCC-4B74-B1C8-75604F03F657}"/>
+                <a16:creationId xmlns:a16="http://schemas.microsoft.com/office/drawing/2014/main" id="{31B8F58E-1E24-4107-9894-2BDCEA8E3868}"/>
               </a:ext>
             </a:extLst>
           </p:cNvPr>
@@ -21411,7 +21411,7 @@
           <p:cNvPr id="18" name="route-6">
             <a:extLst xmlns:a="http://schemas.openxmlformats.org/drawingml/2006/main">
               <a:ext uri="{FF2B5EF4-FFF2-40B4-BE49-F238E27FC236}">
-                <a16:creationId xmlns:a16="http://schemas.microsoft.com/office/drawing/2014/main" id="{C3B1F2B4-3BAF-45DE-AE11-7CAFFAC09A2B}"/>
+                <a16:creationId xmlns:a16="http://schemas.microsoft.com/office/drawing/2014/main" id="{E9E945A1-5791-40A1-9D0A-F2C089272B1E}"/>
               </a:ext>
             </a:extLst>
           </p:cNvPr>
@@ -21468,7 +21468,7 @@
           <p:cNvPr id="19" name="route-number-7">
             <a:extLst xmlns:a="http://schemas.openxmlformats.org/drawingml/2006/main">
               <a:ext uri="{FF2B5EF4-FFF2-40B4-BE49-F238E27FC236}">
-                <a16:creationId xmlns:a16="http://schemas.microsoft.com/office/drawing/2014/main" id="{E9D83D55-AAFC-4B03-9F37-0CD7070E4FC4}"/>
+                <a16:creationId xmlns:a16="http://schemas.microsoft.com/office/drawing/2014/main" id="{4FDA15D1-147B-40CC-B2F2-80430457AF50}"/>
               </a:ext>
             </a:extLst>
           </p:cNvPr>
@@ -21525,7 +21525,7 @@
           <p:cNvPr id="20" name="route-7">
             <a:extLst xmlns:a="http://schemas.openxmlformats.org/drawingml/2006/main">
               <a:ext uri="{FF2B5EF4-FFF2-40B4-BE49-F238E27FC236}">
-                <a16:creationId xmlns:a16="http://schemas.microsoft.com/office/drawing/2014/main" id="{B0B0A06C-3F09-42D9-82ED-B79B0220CF93}"/>
+                <a16:creationId xmlns:a16="http://schemas.microsoft.com/office/drawing/2014/main" id="{38ACFED2-6889-48CD-A7A1-9F989361DB70}"/>
               </a:ext>
             </a:extLst>
           </p:cNvPr>
@@ -21582,7 +21582,7 @@
           <p:cNvPr id="21" name="Lesdoelen">
             <a:extLst xmlns:a="http://schemas.openxmlformats.org/drawingml/2006/main">
               <a:ext uri="{FF2B5EF4-FFF2-40B4-BE49-F238E27FC236}">
-                <a16:creationId xmlns:a16="http://schemas.microsoft.com/office/drawing/2014/main" id="{60ACF909-E449-487F-A785-8B58152D0F1D}"/>
+                <a16:creationId xmlns:a16="http://schemas.microsoft.com/office/drawing/2014/main" id="{B0F57FB8-9BA3-49F3-B3F2-8DF5BF008C8A}"/>
               </a:ext>
             </a:extLst>
           </p:cNvPr>
@@ -21639,7 +21639,7 @@
           <p:cNvPr id="22" name="overview-goals">
             <a:extLst xmlns:a="http://schemas.openxmlformats.org/drawingml/2006/main">
               <a:ext uri="{FF2B5EF4-FFF2-40B4-BE49-F238E27FC236}">
-                <a16:creationId xmlns:a16="http://schemas.microsoft.com/office/drawing/2014/main" id="{0A256A6A-3CEA-4F70-86C2-EDA85BACDD84}"/>
+                <a16:creationId xmlns:a16="http://schemas.microsoft.com/office/drawing/2014/main" id="{E6B2F651-7F2D-4F04-97F1-535E6AE0697C}"/>
               </a:ext>
             </a:extLst>
           </p:cNvPr>
@@ -21742,7 +21742,7 @@
           <p:cNvPr id="23" name="">
             <a:extLst xmlns:a="http://schemas.openxmlformats.org/drawingml/2006/main">
               <a:ext uri="{FF2B5EF4-FFF2-40B4-BE49-F238E27FC236}">
-                <a16:creationId xmlns:a16="http://schemas.microsoft.com/office/drawing/2014/main" id="{FAC1C7FD-902E-4AF6-A55A-C2BC311AC803}"/>
+                <a16:creationId xmlns:a16="http://schemas.microsoft.com/office/drawing/2014/main" id="{65E6C384-372E-4307-8016-4D8CBD5EB15C}"/>
               </a:ext>
             </a:extLst>
           </p:cNvPr>
@@ -21771,7 +21771,7 @@
           <p:cNvPr id="24" name="Startopdracht">
             <a:extLst xmlns:a="http://schemas.openxmlformats.org/drawingml/2006/main">
               <a:ext uri="{FF2B5EF4-FFF2-40B4-BE49-F238E27FC236}">
-                <a16:creationId xmlns:a16="http://schemas.microsoft.com/office/drawing/2014/main" id="{74A4BE80-0761-4DC8-A328-F16EDE3507BF}"/>
+                <a16:creationId xmlns:a16="http://schemas.microsoft.com/office/drawing/2014/main" id="{FD53C08D-F718-4A1C-BBC8-A85D93BCF167}"/>
               </a:ext>
             </a:extLst>
           </p:cNvPr>
@@ -21828,7 +21828,7 @@
           <p:cNvPr id="25" name="overview-start">
             <a:extLst xmlns:a="http://schemas.openxmlformats.org/drawingml/2006/main">
               <a:ext uri="{FF2B5EF4-FFF2-40B4-BE49-F238E27FC236}">
-                <a16:creationId xmlns:a16="http://schemas.microsoft.com/office/drawing/2014/main" id="{AFA24F10-B6E6-43AC-9771-CE7EA4E293A3}"/>
+                <a16:creationId xmlns:a16="http://schemas.microsoft.com/office/drawing/2014/main" id="{A2DBA964-26D0-4A4F-8F73-B76CB78DDB27}"/>
               </a:ext>
             </a:extLst>
           </p:cNvPr>
@@ -21875,7 +21875,7 @@
                 <a:ea typeface="Arial"/>
                 <a:cs typeface="Arial"/>
               </a:rPr>
-              <a:t>Pagina 23 · Opgaven 1 en 2</a:t>
+              <a:t>Pagina 24 · Opgaven 1 en 2</a:t>
             </a:r>
           </a:p>
           <a:p xmlns:a="http://schemas.openxmlformats.org/drawingml/2006/main">
@@ -21908,7 +21908,7 @@
           <p:cNvPr id="26" name="">
             <a:extLst xmlns:a="http://schemas.openxmlformats.org/drawingml/2006/main">
               <a:ext uri="{FF2B5EF4-FFF2-40B4-BE49-F238E27FC236}">
-                <a16:creationId xmlns:a16="http://schemas.microsoft.com/office/drawing/2014/main" id="{237FB9C8-2FC3-487E-9E6E-135C7CEFE2C6}"/>
+                <a16:creationId xmlns:a16="http://schemas.microsoft.com/office/drawing/2014/main" id="{C1D17FC2-7458-479B-9A0B-710866E809A6}"/>
               </a:ext>
             </a:extLst>
           </p:cNvPr>
@@ -21937,7 +21937,7 @@
           <p:cNvPr id="27" name="Huiswerk">
             <a:extLst xmlns:a="http://schemas.openxmlformats.org/drawingml/2006/main">
               <a:ext uri="{FF2B5EF4-FFF2-40B4-BE49-F238E27FC236}">
-                <a16:creationId xmlns:a16="http://schemas.microsoft.com/office/drawing/2014/main" id="{8F59D4E0-38F2-41A4-8B60-17418A2C5B81}"/>
+                <a16:creationId xmlns:a16="http://schemas.microsoft.com/office/drawing/2014/main" id="{A5A304D0-42E5-46B8-9030-5786E7B3EB32}"/>
               </a:ext>
             </a:extLst>
           </p:cNvPr>
@@ -21994,7 +21994,7 @@
           <p:cNvPr id="28" name="overview-homework">
             <a:extLst xmlns:a="http://schemas.openxmlformats.org/drawingml/2006/main">
               <a:ext uri="{FF2B5EF4-FFF2-40B4-BE49-F238E27FC236}">
-                <a16:creationId xmlns:a16="http://schemas.microsoft.com/office/drawing/2014/main" id="{410A5A11-A189-4818-9A83-2991D749194E}"/>
+                <a16:creationId xmlns:a16="http://schemas.microsoft.com/office/drawing/2014/main" id="{BF3CC86D-43D7-426D-AA13-BA14E568A902}"/>
               </a:ext>
             </a:extLst>
           </p:cNvPr>
@@ -22141,7 +22141,7 @@
     </p:spTree>
     <p:extLst>
       <p:ext uri="{BB962C8B-B14F-4D97-AF65-F5344CB8AC3E}">
-        <p14:creationId xmlns:p14="http://schemas.microsoft.com/office/powerpoint/2010/main" val="735021047"/>
+        <p14:creationId xmlns:p14="http://schemas.microsoft.com/office/powerpoint/2010/main" val="1108392127"/>
       </p:ext>
     </p:extLst>
   </p:cSld>
@@ -22172,7 +22172,7 @@
           <p:cNvPr id="8" name="Marginaal: het bedrag per extra product">
             <a:extLst xmlns:a="http://schemas.openxmlformats.org/drawingml/2006/main">
               <a:ext uri="{FF2B5EF4-FFF2-40B4-BE49-F238E27FC236}">
-                <a16:creationId xmlns:a16="http://schemas.microsoft.com/office/drawing/2014/main" id="{712D401A-D6FF-4436-8553-1E2FE1E3C2E4}"/>
+                <a16:creationId xmlns:a16="http://schemas.microsoft.com/office/drawing/2014/main" id="{76C91972-E3D1-4679-8B4A-E2767194F661}"/>
               </a:ext>
             </a:extLst>
           </p:cNvPr>
@@ -22229,7 +22229,7 @@
           <p:cNvPr id="2" name="">
             <a:extLst xmlns:a="http://schemas.openxmlformats.org/drawingml/2006/main">
               <a:ext uri="{FF2B5EF4-FFF2-40B4-BE49-F238E27FC236}">
-                <a16:creationId xmlns:a16="http://schemas.microsoft.com/office/drawing/2014/main" id="{1D86F0CD-6036-4898-97CD-FD4B78C1972A}"/>
+                <a16:creationId xmlns:a16="http://schemas.microsoft.com/office/drawing/2014/main" id="{6FE645A1-650D-4806-B03E-A38B52F3BEA3}"/>
               </a:ext>
             </a:extLst>
           </p:cNvPr>
@@ -22258,7 +22258,7 @@
           <p:cNvPr id="3" name="§2.1.3 Marginale kosten en marginale opbrengsten">
             <a:extLst xmlns:a="http://schemas.openxmlformats.org/drawingml/2006/main">
               <a:ext uri="{FF2B5EF4-FFF2-40B4-BE49-F238E27FC236}">
-                <a16:creationId xmlns:a16="http://schemas.microsoft.com/office/drawing/2014/main" id="{6A07B7CF-3D50-46E0-A409-BDB1FF42D13C}"/>
+                <a16:creationId xmlns:a16="http://schemas.microsoft.com/office/drawing/2014/main" id="{D7120CFC-B415-4E36-B96C-F415270E4289}"/>
               </a:ext>
             </a:extLst>
           </p:cNvPr>
@@ -22315,7 +22315,7 @@
           <p:cNvPr id="4" name="slide-number">
             <a:extLst xmlns:a="http://schemas.openxmlformats.org/drawingml/2006/main">
               <a:ext uri="{FF2B5EF4-FFF2-40B4-BE49-F238E27FC236}">
-                <a16:creationId xmlns:a16="http://schemas.microsoft.com/office/drawing/2014/main" id="{0DEA2FE2-8F68-481F-B62B-87229BA62667}"/>
+                <a16:creationId xmlns:a16="http://schemas.microsoft.com/office/drawing/2014/main" id="{FBFB5C5D-97D4-48A2-B70E-E69604613198}"/>
               </a:ext>
             </a:extLst>
           </p:cNvPr>
@@ -22617,7 +22617,7 @@
           <p:cNvPr id="6" name="Δ = verandering = nieuw − oud">
             <a:extLst xmlns:a="http://schemas.openxmlformats.org/drawingml/2006/main">
               <a:ext uri="{FF2B5EF4-FFF2-40B4-BE49-F238E27FC236}">
-                <a16:creationId xmlns:a16="http://schemas.microsoft.com/office/drawing/2014/main" id="{B6E3CBAA-CEE4-49D6-87F8-76EB18F09FCD}"/>
+                <a16:creationId xmlns:a16="http://schemas.microsoft.com/office/drawing/2014/main" id="{309B895A-F0BC-45D2-8D2E-DB629E5BD61C}"/>
               </a:ext>
             </a:extLst>
           </p:cNvPr>
@@ -22674,7 +22674,7 @@
           <p:cNvPr id="7" name="Dezelfde periode · dezelfde tabelstap">
             <a:extLst xmlns:a="http://schemas.openxmlformats.org/drawingml/2006/main">
               <a:ext uri="{FF2B5EF4-FFF2-40B4-BE49-F238E27FC236}">
-                <a16:creationId xmlns:a16="http://schemas.microsoft.com/office/drawing/2014/main" id="{0A62408C-9AE6-4615-B7F0-2B82C2D962C7}"/>
+                <a16:creationId xmlns:a16="http://schemas.microsoft.com/office/drawing/2014/main" id="{4206A6AD-B4DB-4837-A017-15E161A39EF7}"/>
               </a:ext>
             </a:extLst>
           </p:cNvPr>
@@ -22729,7 +22729,7 @@
     </p:spTree>
     <p:extLst>
       <p:ext uri="{BB962C8B-B14F-4D97-AF65-F5344CB8AC3E}">
-        <p14:creationId xmlns:p14="http://schemas.microsoft.com/office/powerpoint/2010/main" val="120005115"/>
+        <p14:creationId xmlns:p14="http://schemas.microsoft.com/office/powerpoint/2010/main" val="1470777410"/>
       </p:ext>
     </p:extLst>
   </p:cSld>
@@ -22760,7 +22760,7 @@
           <p:cNvPr id="10" name="TasDruk · De gegevens">
             <a:extLst xmlns:a="http://schemas.openxmlformats.org/drawingml/2006/main">
               <a:ext uri="{FF2B5EF4-FFF2-40B4-BE49-F238E27FC236}">
-                <a16:creationId xmlns:a16="http://schemas.microsoft.com/office/drawing/2014/main" id="{FD6B6126-C963-4E1C-9782-8BACE5BE859F}"/>
+                <a16:creationId xmlns:a16="http://schemas.microsoft.com/office/drawing/2014/main" id="{CCD12385-0BEC-49FB-B7B8-D8539EE570B9}"/>
               </a:ext>
             </a:extLst>
           </p:cNvPr>
@@ -22817,7 +22817,7 @@
           <p:cNvPr id="2" name="">
             <a:extLst xmlns:a="http://schemas.openxmlformats.org/drawingml/2006/main">
               <a:ext uri="{FF2B5EF4-FFF2-40B4-BE49-F238E27FC236}">
-                <a16:creationId xmlns:a16="http://schemas.microsoft.com/office/drawing/2014/main" id="{76ACBD82-42C0-41C4-947B-B42B79EBE174}"/>
+                <a16:creationId xmlns:a16="http://schemas.microsoft.com/office/drawing/2014/main" id="{43682D8F-8C33-4031-8025-27B76E290B62}"/>
               </a:ext>
             </a:extLst>
           </p:cNvPr>
@@ -22846,7 +22846,7 @@
           <p:cNvPr id="3" name="§2.1.3 Marginale kosten en marginale opbrengsten">
             <a:extLst xmlns:a="http://schemas.openxmlformats.org/drawingml/2006/main">
               <a:ext uri="{FF2B5EF4-FFF2-40B4-BE49-F238E27FC236}">
-                <a16:creationId xmlns:a16="http://schemas.microsoft.com/office/drawing/2014/main" id="{199F60F1-2B63-4E9F-A444-6A6067D9B0B6}"/>
+                <a16:creationId xmlns:a16="http://schemas.microsoft.com/office/drawing/2014/main" id="{1162F9AB-B39C-430C-8023-ED83C45ADDA5}"/>
               </a:ext>
             </a:extLst>
           </p:cNvPr>
@@ -22903,7 +22903,7 @@
           <p:cNvPr id="4" name="slide-number">
             <a:extLst xmlns:a="http://schemas.openxmlformats.org/drawingml/2006/main">
               <a:ext uri="{FF2B5EF4-FFF2-40B4-BE49-F238E27FC236}">
-                <a16:creationId xmlns:a16="http://schemas.microsoft.com/office/drawing/2014/main" id="{0C03EBEA-395A-486A-8ED6-F7AD356D46B7}"/>
+                <a16:creationId xmlns:a16="http://schemas.microsoft.com/office/drawing/2014/main" id="{331575EB-79A1-4DDA-9364-AA9EF117809E}"/>
               </a:ext>
             </a:extLst>
           </p:cNvPr>
@@ -22960,7 +22960,7 @@
           <p:cNvPr id="5" name="Uitlegvoorbeeld — niet uit het boek · TasDruk">
             <a:extLst xmlns:a="http://schemas.openxmlformats.org/drawingml/2006/main">
               <a:ext uri="{FF2B5EF4-FFF2-40B4-BE49-F238E27FC236}">
-                <a16:creationId xmlns:a16="http://schemas.microsoft.com/office/drawing/2014/main" id="{3F587A39-721A-4889-985F-22821A2566FD}"/>
+                <a16:creationId xmlns:a16="http://schemas.microsoft.com/office/drawing/2014/main" id="{8BEC2D85-37F9-4E20-86BF-1426EA484C0E}"/>
               </a:ext>
             </a:extLst>
           </p:cNvPr>
@@ -23017,7 +23017,7 @@
           <p:cNvPr id="6" name="Bedrukte tassen: TK = 72 + 4Q en TO = 11Q">
             <a:extLst xmlns:a="http://schemas.openxmlformats.org/drawingml/2006/main">
               <a:ext uri="{FF2B5EF4-FFF2-40B4-BE49-F238E27FC236}">
-                <a16:creationId xmlns:a16="http://schemas.microsoft.com/office/drawing/2014/main" id="{68671FC5-2D5C-451E-97A3-E6EF6D40CBC6}"/>
+                <a16:creationId xmlns:a16="http://schemas.microsoft.com/office/drawing/2014/main" id="{69AB1835-D004-4EE1-922C-466B4E58C7B8}"/>
               </a:ext>
             </a:extLst>
           </p:cNvPr>
@@ -23074,7 +23074,7 @@
           <p:cNvPr id="7" name="Q: tassen per week. Capaciteit: 12. Alle tassen worden verkocht.">
             <a:extLst xmlns:a="http://schemas.openxmlformats.org/drawingml/2006/main">
               <a:ext uri="{FF2B5EF4-FFF2-40B4-BE49-F238E27FC236}">
-                <a16:creationId xmlns:a16="http://schemas.microsoft.com/office/drawing/2014/main" id="{D18DF81F-5F91-47FC-8980-79949355B8BD}"/>
+                <a16:creationId xmlns:a16="http://schemas.microsoft.com/office/drawing/2014/main" id="{1A5E7460-1B0E-43EA-9BA3-6477E6F8C4E9}"/>
               </a:ext>
             </a:extLst>
           </p:cNvPr>
@@ -23450,7 +23450,7 @@
           <p:cNvPr id="9" name="Let op: eerst 4 extra tassen, daarna 8 extra tassen.">
             <a:extLst xmlns:a="http://schemas.openxmlformats.org/drawingml/2006/main">
               <a:ext uri="{FF2B5EF4-FFF2-40B4-BE49-F238E27FC236}">
-                <a16:creationId xmlns:a16="http://schemas.microsoft.com/office/drawing/2014/main" id="{B07F837F-EDFB-4E5E-A4BB-778629345594}"/>
+                <a16:creationId xmlns:a16="http://schemas.microsoft.com/office/drawing/2014/main" id="{C5B0623C-4601-4D02-B812-61DDC045B66B}"/>
               </a:ext>
             </a:extLst>
           </p:cNvPr>
@@ -23505,7 +23505,7 @@
     </p:spTree>
     <p:extLst>
       <p:ext uri="{BB962C8B-B14F-4D97-AF65-F5344CB8AC3E}">
-        <p14:creationId xmlns:p14="http://schemas.microsoft.com/office/powerpoint/2010/main" val="422225986"/>
+        <p14:creationId xmlns:p14="http://schemas.microsoft.com/office/powerpoint/2010/main" val="1633975538"/>
       </p:ext>
     </p:extLst>
   </p:cSld>
@@ -23536,7 +23536,7 @@
           <p:cNvPr id="10" name="Winst · Opbrengst min alle kosten">
             <a:extLst xmlns:a="http://schemas.openxmlformats.org/drawingml/2006/main">
               <a:ext uri="{FF2B5EF4-FFF2-40B4-BE49-F238E27FC236}">
-                <a16:creationId xmlns:a16="http://schemas.microsoft.com/office/drawing/2014/main" id="{BC8B236E-260A-4814-BBC5-EB2EBF234D1B}"/>
+                <a16:creationId xmlns:a16="http://schemas.microsoft.com/office/drawing/2014/main" id="{519D6ADF-19D4-42AF-899E-534D028E0457}"/>
               </a:ext>
             </a:extLst>
           </p:cNvPr>
@@ -23593,7 +23593,7 @@
           <p:cNvPr id="2" name="">
             <a:extLst xmlns:a="http://schemas.openxmlformats.org/drawingml/2006/main">
               <a:ext uri="{FF2B5EF4-FFF2-40B4-BE49-F238E27FC236}">
-                <a16:creationId xmlns:a16="http://schemas.microsoft.com/office/drawing/2014/main" id="{97B16CB2-5798-4D77-A73E-0AAD533F0B61}"/>
+                <a16:creationId xmlns:a16="http://schemas.microsoft.com/office/drawing/2014/main" id="{A598681B-44FF-4455-8BA2-4AA8C6F812F0}"/>
               </a:ext>
             </a:extLst>
           </p:cNvPr>
@@ -23622,7 +23622,7 @@
           <p:cNvPr id="3" name="§2.1.3 Marginale kosten en marginale opbrengsten">
             <a:extLst xmlns:a="http://schemas.openxmlformats.org/drawingml/2006/main">
               <a:ext uri="{FF2B5EF4-FFF2-40B4-BE49-F238E27FC236}">
-                <a16:creationId xmlns:a16="http://schemas.microsoft.com/office/drawing/2014/main" id="{995DEF34-427A-419F-9792-A4E0CC629A56}"/>
+                <a16:creationId xmlns:a16="http://schemas.microsoft.com/office/drawing/2014/main" id="{E989A7E0-E010-4E0E-A042-2333B3C78F44}"/>
               </a:ext>
             </a:extLst>
           </p:cNvPr>
@@ -23679,7 +23679,7 @@
           <p:cNvPr id="4" name="slide-number">
             <a:extLst xmlns:a="http://schemas.openxmlformats.org/drawingml/2006/main">
               <a:ext uri="{FF2B5EF4-FFF2-40B4-BE49-F238E27FC236}">
-                <a16:creationId xmlns:a16="http://schemas.microsoft.com/office/drawing/2014/main" id="{8111BFC0-D590-44B5-9A1D-2EEFD21787E9}"/>
+                <a16:creationId xmlns:a16="http://schemas.microsoft.com/office/drawing/2014/main" id="{178C54DE-263C-4938-96AF-BC28E3A7E278}"/>
               </a:ext>
             </a:extLst>
           </p:cNvPr>
@@ -23736,7 +23736,7 @@
           <p:cNvPr id="5" name="Uitlegvoorbeeld — niet uit het boek · TasDruk">
             <a:extLst xmlns:a="http://schemas.openxmlformats.org/drawingml/2006/main">
               <a:ext uri="{FF2B5EF4-FFF2-40B4-BE49-F238E27FC236}">
-                <a16:creationId xmlns:a16="http://schemas.microsoft.com/office/drawing/2014/main" id="{B23D037E-19CF-445A-925F-E29981A2ECFD}"/>
+                <a16:creationId xmlns:a16="http://schemas.microsoft.com/office/drawing/2014/main" id="{4A168ABA-96F9-4CEE-895D-4B4C26A18DAF}"/>
               </a:ext>
             </a:extLst>
           </p:cNvPr>
@@ -23793,7 +23793,7 @@
           <p:cNvPr id="6" name="Bij 4 tassen per week">
             <a:extLst xmlns:a="http://schemas.openxmlformats.org/drawingml/2006/main">
               <a:ext uri="{FF2B5EF4-FFF2-40B4-BE49-F238E27FC236}">
-                <a16:creationId xmlns:a16="http://schemas.microsoft.com/office/drawing/2014/main" id="{E942DEF7-F554-459F-A6FE-C38DAA6F4D80}"/>
+                <a16:creationId xmlns:a16="http://schemas.microsoft.com/office/drawing/2014/main" id="{6C8FF3C6-74EE-4D4B-AB25-463B674F3966}"/>
               </a:ext>
             </a:extLst>
           </p:cNvPr>
@@ -23850,7 +23850,7 @@
           <p:cNvPr id="7" name="Winst = TO − TK">
             <a:extLst xmlns:a="http://schemas.openxmlformats.org/drawingml/2006/main">
               <a:ext uri="{FF2B5EF4-FFF2-40B4-BE49-F238E27FC236}">
-                <a16:creationId xmlns:a16="http://schemas.microsoft.com/office/drawing/2014/main" id="{1AE6381B-2662-458A-A6C6-E8B09FD29165}"/>
+                <a16:creationId xmlns:a16="http://schemas.microsoft.com/office/drawing/2014/main" id="{97BD241C-451D-4BF7-A0E0-7B7368F6D97A}"/>
               </a:ext>
             </a:extLst>
           </p:cNvPr>
@@ -23907,7 +23907,7 @@
           <p:cNvPr id="8" name="= 44 − 88 = −€ 44 per week">
             <a:extLst xmlns:a="http://schemas.openxmlformats.org/drawingml/2006/main">
               <a:ext uri="{FF2B5EF4-FFF2-40B4-BE49-F238E27FC236}">
-                <a16:creationId xmlns:a16="http://schemas.microsoft.com/office/drawing/2014/main" id="{4D22658E-770A-4063-A036-20A002497084}"/>
+                <a16:creationId xmlns:a16="http://schemas.microsoft.com/office/drawing/2014/main" id="{35681482-1C63-46A3-8CDD-B0866F1F0D4D}"/>
               </a:ext>
             </a:extLst>
           </p:cNvPr>
@@ -24378,7 +24378,7 @@
     </p:spTree>
     <p:extLst>
       <p:ext uri="{BB962C8B-B14F-4D97-AF65-F5344CB8AC3E}">
-        <p14:creationId xmlns:p14="http://schemas.microsoft.com/office/powerpoint/2010/main" val="1513222279"/>
+        <p14:creationId xmlns:p14="http://schemas.microsoft.com/office/powerpoint/2010/main" val="1475830977"/>
       </p:ext>
     </p:extLst>
   </p:cSld>
@@ -24409,7 +24409,7 @@
           <p:cNvPr id="10" name="MK · Eerst het verschil, dan delen">
             <a:extLst xmlns:a="http://schemas.openxmlformats.org/drawingml/2006/main">
               <a:ext uri="{FF2B5EF4-FFF2-40B4-BE49-F238E27FC236}">
-                <a16:creationId xmlns:a16="http://schemas.microsoft.com/office/drawing/2014/main" id="{A493BA8A-C1CD-404D-B2B5-9262E00CA5AE}"/>
+                <a16:creationId xmlns:a16="http://schemas.microsoft.com/office/drawing/2014/main" id="{53CEA3A7-A668-4E86-8569-8DD17C2FCB05}"/>
               </a:ext>
             </a:extLst>
           </p:cNvPr>
@@ -24466,7 +24466,7 @@
           <p:cNvPr id="2" name="">
             <a:extLst xmlns:a="http://schemas.openxmlformats.org/drawingml/2006/main">
               <a:ext uri="{FF2B5EF4-FFF2-40B4-BE49-F238E27FC236}">
-                <a16:creationId xmlns:a16="http://schemas.microsoft.com/office/drawing/2014/main" id="{50AA86A4-0BEE-4F8A-96DC-4727C08EEC53}"/>
+                <a16:creationId xmlns:a16="http://schemas.microsoft.com/office/drawing/2014/main" id="{7D0CC3EB-94D4-4272-9CBD-9C37893D8687}"/>
               </a:ext>
             </a:extLst>
           </p:cNvPr>
@@ -24495,7 +24495,7 @@
           <p:cNvPr id="3" name="§2.1.3 Marginale kosten en marginale opbrengsten">
             <a:extLst xmlns:a="http://schemas.openxmlformats.org/drawingml/2006/main">
               <a:ext uri="{FF2B5EF4-FFF2-40B4-BE49-F238E27FC236}">
-                <a16:creationId xmlns:a16="http://schemas.microsoft.com/office/drawing/2014/main" id="{2CF857AF-179F-4EA3-8694-0D6ABC2FDD01}"/>
+                <a16:creationId xmlns:a16="http://schemas.microsoft.com/office/drawing/2014/main" id="{7EADBF4A-BE36-4F11-A8A9-5704211242EE}"/>
               </a:ext>
             </a:extLst>
           </p:cNvPr>
@@ -24552,7 +24552,7 @@
           <p:cNvPr id="4" name="slide-number">
             <a:extLst xmlns:a="http://schemas.openxmlformats.org/drawingml/2006/main">
               <a:ext uri="{FF2B5EF4-FFF2-40B4-BE49-F238E27FC236}">
-                <a16:creationId xmlns:a16="http://schemas.microsoft.com/office/drawing/2014/main" id="{88DAD610-D5A7-4656-9037-6AE7B26F874A}"/>
+                <a16:creationId xmlns:a16="http://schemas.microsoft.com/office/drawing/2014/main" id="{5DCC09FD-CCD4-431D-9223-CE7678DFF494}"/>
               </a:ext>
             </a:extLst>
           </p:cNvPr>
@@ -24609,7 +24609,7 @@
           <p:cNvPr id="5" name="Uitlegvoorbeeld — niet uit het boek · TasDruk">
             <a:extLst xmlns:a="http://schemas.openxmlformats.org/drawingml/2006/main">
               <a:ext uri="{FF2B5EF4-FFF2-40B4-BE49-F238E27FC236}">
-                <a16:creationId xmlns:a16="http://schemas.microsoft.com/office/drawing/2014/main" id="{0F36C285-C109-4B06-BDC7-27C5AB1243F9}"/>
+                <a16:creationId xmlns:a16="http://schemas.microsoft.com/office/drawing/2014/main" id="{D5AC4A60-A416-4B96-9D33-24EED88437D6}"/>
               </a:ext>
             </a:extLst>
           </p:cNvPr>
@@ -24911,7 +24911,7 @@
           <p:cNvPr id="7" name="MK = ΔTK / ΔQ = 32 / 8">
             <a:extLst xmlns:a="http://schemas.openxmlformats.org/drawingml/2006/main">
               <a:ext uri="{FF2B5EF4-FFF2-40B4-BE49-F238E27FC236}">
-                <a16:creationId xmlns:a16="http://schemas.microsoft.com/office/drawing/2014/main" id="{22440DE3-B171-4782-9622-451BF80E3F50}"/>
+                <a16:creationId xmlns:a16="http://schemas.microsoft.com/office/drawing/2014/main" id="{CDFECD1C-B6BE-45C9-B9A2-C42D783CC687}"/>
               </a:ext>
             </a:extLst>
           </p:cNvPr>
@@ -24968,7 +24968,7 @@
           <p:cNvPr id="8" name="= € 4 per extra tas in de stap 4 → 12">
             <a:extLst xmlns:a="http://schemas.openxmlformats.org/drawingml/2006/main">
               <a:ext uri="{FF2B5EF4-FFF2-40B4-BE49-F238E27FC236}">
-                <a16:creationId xmlns:a16="http://schemas.microsoft.com/office/drawing/2014/main" id="{4C969763-F317-4C36-B26C-EE846DD443CE}"/>
+                <a16:creationId xmlns:a16="http://schemas.microsoft.com/office/drawing/2014/main" id="{692F5ACE-A8CA-4BCC-96A0-A6AD6366314D}"/>
               </a:ext>
             </a:extLst>
           </p:cNvPr>
@@ -25025,7 +25025,7 @@
           <p:cNvPr id="9" name="De acht extra tassen kosten samen € 32.">
             <a:extLst xmlns:a="http://schemas.openxmlformats.org/drawingml/2006/main">
               <a:ext uri="{FF2B5EF4-FFF2-40B4-BE49-F238E27FC236}">
-                <a16:creationId xmlns:a16="http://schemas.microsoft.com/office/drawing/2014/main" id="{6075ED78-E8EC-47C4-9D3C-DE1E135B6FB4}"/>
+                <a16:creationId xmlns:a16="http://schemas.microsoft.com/office/drawing/2014/main" id="{B1B64968-50C4-4E26-A888-AC7187C10688}"/>
               </a:ext>
             </a:extLst>
           </p:cNvPr>
@@ -25080,7 +25080,7 @@
     </p:spTree>
     <p:extLst>
       <p:ext uri="{BB962C8B-B14F-4D97-AF65-F5344CB8AC3E}">
-        <p14:creationId xmlns:p14="http://schemas.microsoft.com/office/powerpoint/2010/main" val="2066740335"/>
+        <p14:creationId xmlns:p14="http://schemas.microsoft.com/office/powerpoint/2010/main" val="986919704"/>
       </p:ext>
     </p:extLst>
   </p:cSld>
@@ -25111,7 +25111,7 @@
           <p:cNvPr id="12" name="MO · De extra opbrengst per extra tas">
             <a:extLst xmlns:a="http://schemas.openxmlformats.org/drawingml/2006/main">
               <a:ext uri="{FF2B5EF4-FFF2-40B4-BE49-F238E27FC236}">
-                <a16:creationId xmlns:a16="http://schemas.microsoft.com/office/drawing/2014/main" id="{6C9490E5-7486-4751-8834-BB8EB26D4839}"/>
+                <a16:creationId xmlns:a16="http://schemas.microsoft.com/office/drawing/2014/main" id="{B72558ED-C858-41B6-99BD-E096E02EA7D5}"/>
               </a:ext>
             </a:extLst>
           </p:cNvPr>
@@ -25168,7 +25168,7 @@
           <p:cNvPr id="2" name="">
             <a:extLst xmlns:a="http://schemas.openxmlformats.org/drawingml/2006/main">
               <a:ext uri="{FF2B5EF4-FFF2-40B4-BE49-F238E27FC236}">
-                <a16:creationId xmlns:a16="http://schemas.microsoft.com/office/drawing/2014/main" id="{7AB21E31-5145-4532-9F91-347B61ADA279}"/>
+                <a16:creationId xmlns:a16="http://schemas.microsoft.com/office/drawing/2014/main" id="{C7A8B8D7-0316-4507-A389-095D0A101852}"/>
               </a:ext>
             </a:extLst>
           </p:cNvPr>
@@ -25197,7 +25197,7 @@
           <p:cNvPr id="3" name="§2.1.3 Marginale kosten en marginale opbrengsten">
             <a:extLst xmlns:a="http://schemas.openxmlformats.org/drawingml/2006/main">
               <a:ext uri="{FF2B5EF4-FFF2-40B4-BE49-F238E27FC236}">
-                <a16:creationId xmlns:a16="http://schemas.microsoft.com/office/drawing/2014/main" id="{DFFE2FB1-3662-41B8-BD14-EA10A0451ACE}"/>
+                <a16:creationId xmlns:a16="http://schemas.microsoft.com/office/drawing/2014/main" id="{B02557CB-62A3-48B5-A78D-CE1A06C4D92E}"/>
               </a:ext>
             </a:extLst>
           </p:cNvPr>
@@ -25254,7 +25254,7 @@
           <p:cNvPr id="4" name="slide-number">
             <a:extLst xmlns:a="http://schemas.openxmlformats.org/drawingml/2006/main">
               <a:ext uri="{FF2B5EF4-FFF2-40B4-BE49-F238E27FC236}">
-                <a16:creationId xmlns:a16="http://schemas.microsoft.com/office/drawing/2014/main" id="{9B5B240F-2F1A-4A98-B033-086B973D2198}"/>
+                <a16:creationId xmlns:a16="http://schemas.microsoft.com/office/drawing/2014/main" id="{4C645C40-4900-41AD-8EF4-FB942CBC92E6}"/>
               </a:ext>
             </a:extLst>
           </p:cNvPr>
@@ -25311,7 +25311,7 @@
           <p:cNvPr id="5" name="Uitlegvoorbeeld — niet uit het boek · TasDruk">
             <a:extLst xmlns:a="http://schemas.openxmlformats.org/drawingml/2006/main">
               <a:ext uri="{FF2B5EF4-FFF2-40B4-BE49-F238E27FC236}">
-                <a16:creationId xmlns:a16="http://schemas.microsoft.com/office/drawing/2014/main" id="{317C677E-3FE4-4FA0-A4C6-89D84822F6E0}"/>
+                <a16:creationId xmlns:a16="http://schemas.microsoft.com/office/drawing/2014/main" id="{3629D53B-3632-432C-86B7-7A8514905716}"/>
               </a:ext>
             </a:extLst>
           </p:cNvPr>
@@ -25368,7 +25368,7 @@
           <p:cNvPr id="6" name="Dezelfde stap: 4 → 12 tassen per week">
             <a:extLst xmlns:a="http://schemas.openxmlformats.org/drawingml/2006/main">
               <a:ext uri="{FF2B5EF4-FFF2-40B4-BE49-F238E27FC236}">
-                <a16:creationId xmlns:a16="http://schemas.microsoft.com/office/drawing/2014/main" id="{7D58DA52-DAEC-415D-A84B-1B90D8651430}"/>
+                <a16:creationId xmlns:a16="http://schemas.microsoft.com/office/drawing/2014/main" id="{1AE48C35-B3C4-4CF2-9EE4-D096B231913A}"/>
               </a:ext>
             </a:extLst>
           </p:cNvPr>
@@ -25425,7 +25425,7 @@
           <p:cNvPr id="7" name="ΔTO = 132 − 44 = € 88">
             <a:extLst xmlns:a="http://schemas.openxmlformats.org/drawingml/2006/main">
               <a:ext uri="{FF2B5EF4-FFF2-40B4-BE49-F238E27FC236}">
-                <a16:creationId xmlns:a16="http://schemas.microsoft.com/office/drawing/2014/main" id="{5EDF3392-0593-418F-84EC-FAD3C5A18363}"/>
+                <a16:creationId xmlns:a16="http://schemas.microsoft.com/office/drawing/2014/main" id="{98A89395-CFA7-4A95-89AA-BF15C4129854}"/>
               </a:ext>
             </a:extLst>
           </p:cNvPr>
@@ -25482,7 +25482,7 @@
           <p:cNvPr id="8" name="MO = ΔTO / ΔQ = 88 / 8">
             <a:extLst xmlns:a="http://schemas.openxmlformats.org/drawingml/2006/main">
               <a:ext uri="{FF2B5EF4-FFF2-40B4-BE49-F238E27FC236}">
-                <a16:creationId xmlns:a16="http://schemas.microsoft.com/office/drawing/2014/main" id="{92C3C0E9-A710-4B98-A23F-04892F066FCC}"/>
+                <a16:creationId xmlns:a16="http://schemas.microsoft.com/office/drawing/2014/main" id="{41BA30F1-6F3E-479B-B177-26AAE93B940F}"/>
               </a:ext>
             </a:extLst>
           </p:cNvPr>
@@ -25539,7 +25539,7 @@
           <p:cNvPr id="9" name="= € 11 per extra verkochte tas">
             <a:extLst xmlns:a="http://schemas.openxmlformats.org/drawingml/2006/main">
               <a:ext uri="{FF2B5EF4-FFF2-40B4-BE49-F238E27FC236}">
-                <a16:creationId xmlns:a16="http://schemas.microsoft.com/office/drawing/2014/main" id="{EF1AFF9C-2B08-4AFD-8339-5B5EAA1A656B}"/>
+                <a16:creationId xmlns:a16="http://schemas.microsoft.com/office/drawing/2014/main" id="{8510D6EE-77BF-4B0C-9DFE-D0B1A1D7440B}"/>
               </a:ext>
             </a:extLst>
           </p:cNvPr>
@@ -25596,7 +25596,7 @@
           <p:cNvPr id="10" name="">
             <a:extLst xmlns:a="http://schemas.openxmlformats.org/drawingml/2006/main">
               <a:ext uri="{FF2B5EF4-FFF2-40B4-BE49-F238E27FC236}">
-                <a16:creationId xmlns:a16="http://schemas.microsoft.com/office/drawing/2014/main" id="{2C79E74E-7B47-40E7-AB34-B24735672621}"/>
+                <a16:creationId xmlns:a16="http://schemas.microsoft.com/office/drawing/2014/main" id="{B906F6C5-1CE6-4E75-BD95-FF24F5B01E6A}"/>
               </a:ext>
             </a:extLst>
           </p:cNvPr>
@@ -25625,7 +25625,7 @@
           <p:cNvPr id="11" name="Vaste verkoopprijs → constante MO">
             <a:extLst xmlns:a="http://schemas.openxmlformats.org/drawingml/2006/main">
               <a:ext uri="{FF2B5EF4-FFF2-40B4-BE49-F238E27FC236}">
-                <a16:creationId xmlns:a16="http://schemas.microsoft.com/office/drawing/2014/main" id="{D6088D8F-4B96-42AB-BEFE-F4A76426D6D8}"/>
+                <a16:creationId xmlns:a16="http://schemas.microsoft.com/office/drawing/2014/main" id="{62F1E180-94F8-4BA0-970B-682A3CC4D6AD}"/>
               </a:ext>
             </a:extLst>
           </p:cNvPr>
@@ -25680,7 +25680,7 @@
     </p:spTree>
     <p:extLst>
       <p:ext uri="{BB962C8B-B14F-4D97-AF65-F5344CB8AC3E}">
-        <p14:creationId xmlns:p14="http://schemas.microsoft.com/office/powerpoint/2010/main" val="1625705347"/>
+        <p14:creationId xmlns:p14="http://schemas.microsoft.com/office/powerpoint/2010/main" val="221318592"/>
       </p:ext>
     </p:extLst>
   </p:cSld>
@@ -25711,7 +25711,7 @@
           <p:cNvPr id="9" name="Elke uitkomst hoort bij een tabelstap">
             <a:extLst xmlns:a="http://schemas.openxmlformats.org/drawingml/2006/main">
               <a:ext uri="{FF2B5EF4-FFF2-40B4-BE49-F238E27FC236}">
-                <a16:creationId xmlns:a16="http://schemas.microsoft.com/office/drawing/2014/main" id="{94C790E3-F46E-4B95-A634-1CA54DDDE9AA}"/>
+                <a16:creationId xmlns:a16="http://schemas.microsoft.com/office/drawing/2014/main" id="{A0FC3344-6525-458F-B38A-1BAB2A9BC0E5}"/>
               </a:ext>
             </a:extLst>
           </p:cNvPr>
@@ -25768,7 +25768,7 @@
           <p:cNvPr id="2" name="">
             <a:extLst xmlns:a="http://schemas.openxmlformats.org/drawingml/2006/main">
               <a:ext uri="{FF2B5EF4-FFF2-40B4-BE49-F238E27FC236}">
-                <a16:creationId xmlns:a16="http://schemas.microsoft.com/office/drawing/2014/main" id="{0DDD276D-4F82-43C8-AEE0-C443901AB4B4}"/>
+                <a16:creationId xmlns:a16="http://schemas.microsoft.com/office/drawing/2014/main" id="{59E88A96-E4CF-4C44-BB73-E3FD0205FA28}"/>
               </a:ext>
             </a:extLst>
           </p:cNvPr>
@@ -25797,7 +25797,7 @@
           <p:cNvPr id="3" name="§2.1.3 Marginale kosten en marginale opbrengsten">
             <a:extLst xmlns:a="http://schemas.openxmlformats.org/drawingml/2006/main">
               <a:ext uri="{FF2B5EF4-FFF2-40B4-BE49-F238E27FC236}">
-                <a16:creationId xmlns:a16="http://schemas.microsoft.com/office/drawing/2014/main" id="{066BC84E-E1B4-4D8A-B3B0-833A8973E74B}"/>
+                <a16:creationId xmlns:a16="http://schemas.microsoft.com/office/drawing/2014/main" id="{41273416-D821-4321-AED9-9CEB273C9681}"/>
               </a:ext>
             </a:extLst>
           </p:cNvPr>
@@ -25854,7 +25854,7 @@
           <p:cNvPr id="4" name="slide-number">
             <a:extLst xmlns:a="http://schemas.openxmlformats.org/drawingml/2006/main">
               <a:ext uri="{FF2B5EF4-FFF2-40B4-BE49-F238E27FC236}">
-                <a16:creationId xmlns:a16="http://schemas.microsoft.com/office/drawing/2014/main" id="{A095D077-AD6E-44CC-B828-3E290A0E35C6}"/>
+                <a16:creationId xmlns:a16="http://schemas.microsoft.com/office/drawing/2014/main" id="{1A21362B-243C-430F-91E4-C4003650C8A6}"/>
               </a:ext>
             </a:extLst>
           </p:cNvPr>
@@ -25911,7 +25911,7 @@
           <p:cNvPr id="5" name="Uitlegvoorbeeld — niet uit het boek · TasDruk">
             <a:extLst xmlns:a="http://schemas.openxmlformats.org/drawingml/2006/main">
               <a:ext uri="{FF2B5EF4-FFF2-40B4-BE49-F238E27FC236}">
-                <a16:creationId xmlns:a16="http://schemas.microsoft.com/office/drawing/2014/main" id="{F3E6C7A8-F6B2-476B-8BBA-3B98DF2C7CF6}"/>
+                <a16:creationId xmlns:a16="http://schemas.microsoft.com/office/drawing/2014/main" id="{BB678A4D-63E5-4EEE-90EE-D92F636D4DE5}"/>
               </a:ext>
             </a:extLst>
           </p:cNvPr>
@@ -26481,7 +26481,7 @@
           <p:cNvPr id="7" name="Grotere stap, dezelfde MK en MO">
             <a:extLst xmlns:a="http://schemas.openxmlformats.org/drawingml/2006/main">
               <a:ext uri="{FF2B5EF4-FFF2-40B4-BE49-F238E27FC236}">
-                <a16:creationId xmlns:a16="http://schemas.microsoft.com/office/drawing/2014/main" id="{0E007353-E3C6-42D6-B779-F34E0E7595A2}"/>
+                <a16:creationId xmlns:a16="http://schemas.microsoft.com/office/drawing/2014/main" id="{D11A9C06-0778-42D9-BC9D-2482ED8987C3}"/>
               </a:ext>
             </a:extLst>
           </p:cNvPr>
@@ -26538,7 +26538,7 @@
           <p:cNvPr id="8" name="Bij de eerste rij: — betekent “geen vorige tabelrij”.">
             <a:extLst xmlns:a="http://schemas.openxmlformats.org/drawingml/2006/main">
               <a:ext uri="{FF2B5EF4-FFF2-40B4-BE49-F238E27FC236}">
-                <a16:creationId xmlns:a16="http://schemas.microsoft.com/office/drawing/2014/main" id="{233261AE-E21C-4064-AF17-B1E3710B75DE}"/>
+                <a16:creationId xmlns:a16="http://schemas.microsoft.com/office/drawing/2014/main" id="{4E05FAA5-02C7-4F13-95A7-7104D99EAFA9}"/>
               </a:ext>
             </a:extLst>
           </p:cNvPr>
@@ -26593,7 +26593,7 @@
     </p:spTree>
     <p:extLst>
       <p:ext uri="{BB962C8B-B14F-4D97-AF65-F5344CB8AC3E}">
-        <p14:creationId xmlns:p14="http://schemas.microsoft.com/office/powerpoint/2010/main" val="782682730"/>
+        <p14:creationId xmlns:p14="http://schemas.microsoft.com/office/powerpoint/2010/main" val="1493766877"/>
       </p:ext>
     </p:extLst>
   </p:cSld>
@@ -26624,7 +26624,7 @@
           <p:cNvPr id="10" name="Studio Reliëf · Kosten die sneller stijgen">
             <a:extLst xmlns:a="http://schemas.openxmlformats.org/drawingml/2006/main">
               <a:ext uri="{FF2B5EF4-FFF2-40B4-BE49-F238E27FC236}">
-                <a16:creationId xmlns:a16="http://schemas.microsoft.com/office/drawing/2014/main" id="{602EEB4C-DE7E-495A-BA16-58E3072844A5}"/>
+                <a16:creationId xmlns:a16="http://schemas.microsoft.com/office/drawing/2014/main" id="{CF92B3A5-3973-439F-A63A-57B4C24CB99C}"/>
               </a:ext>
             </a:extLst>
           </p:cNvPr>
@@ -26681,7 +26681,7 @@
           <p:cNvPr id="2" name="">
             <a:extLst xmlns:a="http://schemas.openxmlformats.org/drawingml/2006/main">
               <a:ext uri="{FF2B5EF4-FFF2-40B4-BE49-F238E27FC236}">
-                <a16:creationId xmlns:a16="http://schemas.microsoft.com/office/drawing/2014/main" id="{9B28982B-7335-48D5-9F2C-DD74B56F822A}"/>
+                <a16:creationId xmlns:a16="http://schemas.microsoft.com/office/drawing/2014/main" id="{7C1E9951-6941-47E2-B5DD-3ADF96B70C32}"/>
               </a:ext>
             </a:extLst>
           </p:cNvPr>
@@ -26710,7 +26710,7 @@
           <p:cNvPr id="3" name="§2.1.3 Marginale kosten en marginale opbrengsten">
             <a:extLst xmlns:a="http://schemas.openxmlformats.org/drawingml/2006/main">
               <a:ext uri="{FF2B5EF4-FFF2-40B4-BE49-F238E27FC236}">
-                <a16:creationId xmlns:a16="http://schemas.microsoft.com/office/drawing/2014/main" id="{A34E1A6B-5FC1-4715-A328-E952E6B914CD}"/>
+                <a16:creationId xmlns:a16="http://schemas.microsoft.com/office/drawing/2014/main" id="{763CA078-345A-4088-9D94-2BCB008A8461}"/>
               </a:ext>
             </a:extLst>
           </p:cNvPr>
@@ -26767,7 +26767,7 @@
           <p:cNvPr id="4" name="slide-number">
             <a:extLst xmlns:a="http://schemas.openxmlformats.org/drawingml/2006/main">
               <a:ext uri="{FF2B5EF4-FFF2-40B4-BE49-F238E27FC236}">
-                <a16:creationId xmlns:a16="http://schemas.microsoft.com/office/drawing/2014/main" id="{88876502-4F30-4FF4-812B-D31905F2D26E}"/>
+                <a16:creationId xmlns:a16="http://schemas.microsoft.com/office/drawing/2014/main" id="{DF3B0650-E8E2-4D15-8FBC-CBDDB85C218F}"/>
               </a:ext>
             </a:extLst>
           </p:cNvPr>
@@ -26824,7 +26824,7 @@
           <p:cNvPr id="5" name="Uitlegvoorbeeld — niet uit het boek · Studio Reliëf">
             <a:extLst xmlns:a="http://schemas.openxmlformats.org/drawingml/2006/main">
               <a:ext uri="{FF2B5EF4-FFF2-40B4-BE49-F238E27FC236}">
-                <a16:creationId xmlns:a16="http://schemas.microsoft.com/office/drawing/2014/main" id="{FBAABF6D-13A9-4339-9B0C-911C60A7CC08}"/>
+                <a16:creationId xmlns:a16="http://schemas.microsoft.com/office/drawing/2014/main" id="{9D027824-F91A-48BF-BE23-96CC24FC505F}"/>
               </a:ext>
             </a:extLst>
           </p:cNvPr>
@@ -26881,7 +26881,7 @@
           <p:cNvPr id="6" name="TK = 32 + 2Q²     TO = 26Q">
             <a:extLst xmlns:a="http://schemas.openxmlformats.org/drawingml/2006/main">
               <a:ext uri="{FF2B5EF4-FFF2-40B4-BE49-F238E27FC236}">
-                <a16:creationId xmlns:a16="http://schemas.microsoft.com/office/drawing/2014/main" id="{9EAC4D3A-CAE8-41CC-88E2-28F78149F600}"/>
+                <a16:creationId xmlns:a16="http://schemas.microsoft.com/office/drawing/2014/main" id="{6F9D42E7-A6D8-4D27-B390-347FB871BBF4}"/>
               </a:ext>
             </a:extLst>
           </p:cNvPr>
@@ -26938,7 +26938,7 @@
           <p:cNvPr id="7" name="Q: tegels per week. Capaciteit: 6. Alle tegels worden verkocht.">
             <a:extLst xmlns:a="http://schemas.openxmlformats.org/drawingml/2006/main">
               <a:ext uri="{FF2B5EF4-FFF2-40B4-BE49-F238E27FC236}">
-                <a16:creationId xmlns:a16="http://schemas.microsoft.com/office/drawing/2014/main" id="{4BD1E598-12D0-4ABB-B90D-3B0123D7AE19}"/>
+                <a16:creationId xmlns:a16="http://schemas.microsoft.com/office/drawing/2014/main" id="{E1102B31-4099-47E4-8CD8-4B7607FC502E}"/>
               </a:ext>
             </a:extLst>
           </p:cNvPr>
@@ -27388,7 +27388,7 @@
           <p:cNvPr id="9" name="Bij Q = 4: TK = 32 + 2 × 4² = 32 + 32 = € 64">
             <a:extLst xmlns:a="http://schemas.openxmlformats.org/drawingml/2006/main">
               <a:ext uri="{FF2B5EF4-FFF2-40B4-BE49-F238E27FC236}">
-                <a16:creationId xmlns:a16="http://schemas.microsoft.com/office/drawing/2014/main" id="{0D69E1D2-4214-4BA0-BFFF-8CD6A81022F9}"/>
+                <a16:creationId xmlns:a16="http://schemas.microsoft.com/office/drawing/2014/main" id="{1BC9A228-1555-40F1-AD83-DEC486A96B34}"/>
               </a:ext>
             </a:extLst>
           </p:cNvPr>
@@ -27443,7 +27443,7 @@
     </p:spTree>
     <p:extLst>
       <p:ext uri="{BB962C8B-B14F-4D97-AF65-F5344CB8AC3E}">
-        <p14:creationId xmlns:p14="http://schemas.microsoft.com/office/powerpoint/2010/main" val="349644981"/>
+        <p14:creationId xmlns:p14="http://schemas.microsoft.com/office/powerpoint/2010/main" val="1040673236"/>
       </p:ext>
     </p:extLst>
   </p:cSld>

</xml_diff>